<commit_message>
Rewrite slide 11 appendix and speaker notes in a plainer spoken voice
Co-Authored-By: Claude Sonnet 5.5 <noreply@anthropic.com>
Claude-Session: https://claude.ai/code/session_017KdnwN2qyuF8wMBvTngErS
</commit_message>
<xml_diff>
--- a/ENTR_4501_Gate_2_deck_readable.pptx
+++ b/ENTR_4501_Gate_2_deck_readable.pptx
@@ -803,15 +803,59 @@
                 <a:spcPts val="0"/>
               </a:spcBef>
               <a:spcAft>
-                <a:spcPts val="0"/>
+                <a:spcPts val="600"/>
               </a:spcAft>
               <a:buNone/>
             </a:pPr>
             <a:r>
               <a:rPr lang="en-US"/>
-              <a:t>This is the whole idea. For students and young professionals in Boston who want great places to eat but can't compare scattered reviews or trust the ratings, our app is a free, all-in-one guide. It puts the reviews, posts, hours and booking for each place on one page. Unlike checking Google Maps, Instagram, TikTok and Beli one by one, you research, save and share in one app, and our score only counts people who proved they ate there. Next: why people need it.</a:t>
-            </a:r>
-            <a:endParaRPr/>
+              <a:t>We’re building a free app that tells you where to eat in Boston. We’re starting at Northeastern.</a:t>
+            </a:r>
+          </a:p>
+          <a:p>
+            <a:pPr indent="0" lvl="0" marL="0" rtl="0" algn="l">
+              <a:spcBef>
+                <a:spcPts val="0"/>
+              </a:spcBef>
+              <a:spcAft>
+                <a:spcPts val="600"/>
+              </a:spcAft>
+              <a:buNone/>
+            </a:pPr>
+            <a:r>
+              <a:rPr lang="en-US"/>
+              <a:t>It’s for students and young professionals who want a great meal but can’t trust the ratings. Right now you check Google Maps, then Yelp, then Instagram, then TikTok, then Beli, and you still end up guessing.</a:t>
+            </a:r>
+          </a:p>
+          <a:p>
+            <a:pPr indent="0" lvl="0" marL="0" rtl="0" algn="l">
+              <a:spcBef>
+                <a:spcPts val="0"/>
+              </a:spcBef>
+              <a:spcAft>
+                <a:spcPts val="600"/>
+              </a:spcAft>
+              <a:buNone/>
+            </a:pPr>
+            <a:r>
+              <a:rPr lang="en-US"/>
+              <a:t>Our app puts the reviews, the posts, the hours and booking for a place on one page. And our score only counts people who proved they ate there.</a:t>
+            </a:r>
+          </a:p>
+          <a:p>
+            <a:pPr indent="0" lvl="0" marL="0" rtl="0" algn="l">
+              <a:spcBef>
+                <a:spcPts val="0"/>
+              </a:spcBef>
+              <a:spcAft>
+                <a:spcPts val="600"/>
+              </a:spcAft>
+              <a:buNone/>
+            </a:pPr>
+            <a:r>
+              <a:rPr lang="en-US"/>
+              <a:t>We don’t have a name yet. Here’s why we think it’s worth building.</a:t>
+            </a:r>
           </a:p>
         </p:txBody>
       </p:sp>
@@ -954,15 +998,74 @@
                 <a:spcPts val="0"/>
               </a:spcBef>
               <a:spcAft>
-                <a:spcPts val="0"/>
+                <a:spcPts val="600"/>
               </a:spcAft>
               <a:buNone/>
             </a:pPr>
             <a:r>
               <a:rPr lang="en-US"/>
-              <a:t>We start on grants, the way Beli did: Northeastern's IDEA Gap Fund and pitch competitions across Boston, about $74K to cover Years 1 and 2, and we cover any gap ourselves. At the end of Year 2, with restaurants already paying, we raise one angel round of about $166K. What lets us raise: about 31,000 Boston users and a year of restaurants paying for diners we sent. We'd ask angels we meet through IDEA, competition judges and our own networks. At $356K of Year 5 revenue we're too small for venture funds. Thank you. We're happy to take questions.</a:t>
-            </a:r>
-            <a:endParaRPr/>
+              <a:t>Last piece: how we pay for it.</a:t>
+            </a:r>
+          </a:p>
+          <a:p>
+            <a:pPr indent="0" lvl="0" marL="0" rtl="0" algn="l">
+              <a:spcBef>
+                <a:spcPts val="0"/>
+              </a:spcBef>
+              <a:spcAft>
+                <a:spcPts val="600"/>
+              </a:spcAft>
+              <a:buNone/>
+            </a:pPr>
+            <a:r>
+              <a:rPr lang="en-US"/>
+              <a:t>We start with grants, the way Beli did. Northeastern’s IDEA Gap Fund and pitch competitions around Boston, about $74,000, cover Years 1 and 2. If we fall short, we cover the gap ourselves.</a:t>
+            </a:r>
+          </a:p>
+          <a:p>
+            <a:pPr indent="0" lvl="0" marL="0" rtl="0" algn="l">
+              <a:spcBef>
+                <a:spcPts val="0"/>
+              </a:spcBef>
+              <a:spcAft>
+                <a:spcPts val="600"/>
+              </a:spcAft>
+              <a:buNone/>
+            </a:pPr>
+            <a:r>
+              <a:rPr lang="en-US"/>
+              <a:t>At the end of Year 2 we raise one angel round, about $166,000. What we’ll show them is about 31,000 Boston users, a year of restaurants paying for diners we sent, and visits proven by receipts. We’d look for angels through IDEA, competition judges and our own networks.</a:t>
+            </a:r>
+          </a:p>
+          <a:p>
+            <a:pPr indent="0" lvl="0" marL="0" rtl="0" algn="l">
+              <a:spcBef>
+                <a:spcPts val="0"/>
+              </a:spcBef>
+              <a:spcAft>
+                <a:spcPts val="600"/>
+              </a:spcAft>
+              <a:buNone/>
+            </a:pPr>
+            <a:r>
+              <a:rPr lang="en-US"/>
+              <a:t>Together that’s the $240,000. At $356,000 of revenue in Year 5 we’re too small for venture funds, so the angels’ way out is a sale to a bigger platform or a card company, the way Resy sold to American Express.</a:t>
+            </a:r>
+          </a:p>
+          <a:p>
+            <a:pPr indent="0" lvl="0" marL="0" rtl="0" algn="l">
+              <a:spcBef>
+                <a:spcPts val="0"/>
+              </a:spcBef>
+              <a:spcAft>
+                <a:spcPts val="600"/>
+              </a:spcAft>
+              <a:buNone/>
+            </a:pPr>
+            <a:r>
+              <a:rPr lang="en-US"/>
+              <a:t>Thank you. We’re happy to take questions.</a:t>
+            </a:r>
           </a:p>
         </p:txBody>
       </p:sp>
@@ -1105,15 +1208,59 @@
                 <a:spcPts val="0"/>
               </a:spcBef>
               <a:spcAft>
-                <a:spcPts val="0"/>
+                <a:spcPts val="600"/>
               </a:spcAft>
               <a:buNone/>
             </a:pPr>
             <a:r>
               <a:rPr lang="en-US"/>
-              <a:t>Appendix, for questions only: where each price comes from.</a:t>
-            </a:r>
-            <a:endParaRPr/>
+              <a:t>This one is for questions. It shows where each price comes from.</a:t>
+            </a:r>
+          </a:p>
+          <a:p>
+            <a:pPr indent="0" lvl="0" marL="0" rtl="0" algn="l">
+              <a:spcBef>
+                <a:spcPts val="0"/>
+              </a:spcBef>
+              <a:spcAft>
+                <a:spcPts val="600"/>
+              </a:spcAft>
+              <a:buNone/>
+            </a:pPr>
+            <a:r>
+              <a:rPr lang="en-US"/>
+              <a:t>Businesses pay $288,000 in Year 5: $156,000 for diners we send, $54,000 for tables booked and $78,000 for area insights for chains. About 90 cents a diner sits under OpenTable’s $1 to $1.50. Bookings are a quarter of Tabelog’s rate, and chains pay a quarter of what Placer.ai charges.</a:t>
+            </a:r>
+          </a:p>
+          <a:p>
+            <a:pPr indent="0" lvl="0" marL="0" rtl="0" algn="l">
+              <a:spcBef>
+                <a:spcPts val="0"/>
+              </a:spcBef>
+              <a:spcAft>
+                <a:spcPts val="600"/>
+              </a:spcAft>
+              <a:buNone/>
+            </a:pPr>
+            <a:r>
+              <a:rPr lang="en-US"/>
+              <a:t>Users pay $67,000 for the optional $5 a month membership. About 0.3% sign up, the same share as Tabelog’s users.</a:t>
+            </a:r>
+          </a:p>
+          <a:p>
+            <a:pPr indent="0" lvl="0" marL="0" rtl="0" algn="l">
+              <a:spcBef>
+                <a:spcPts val="0"/>
+              </a:spcBef>
+              <a:spcAft>
+                <a:spcPts val="600"/>
+              </a:spcAft>
+              <a:buNone/>
+            </a:pPr>
+            <a:r>
+              <a:rPr lang="en-US"/>
+              <a:t>Every price starts from a real company’s number. How many we sell is our guess.</a:t>
+            </a:r>
           </a:p>
         </p:txBody>
       </p:sp>
@@ -1256,15 +1403,59 @@
                 <a:spcPts val="0"/>
               </a:spcBef>
               <a:spcAft>
-                <a:spcPts val="0"/>
+                <a:spcPts val="600"/>
               </a:spcAft>
               <a:buNone/>
             </a:pPr>
             <a:r>
               <a:rPr lang="en-US"/>
-              <a:t>We interviewed 35 students and young professionals, and almost everyone described the same routine. Google Maps to see what's nearby. Instagram or TikTok to see the food. A friend to check it's good. Then they go, and it's still a miss. Nobody had one place to save where they want to go. So the problem isn't a lack of information. It's that it takes too much work to trust any of it.</a:t>
-            </a:r>
-            <a:endParaRPr/>
+              <a:t>We talked to 35 students and young professionals this fall. Almost all of them described the same routine.</a:t>
+            </a:r>
+          </a:p>
+          <a:p>
+            <a:pPr indent="0" lvl="0" marL="0" rtl="0" algn="l">
+              <a:spcBef>
+                <a:spcPts val="0"/>
+              </a:spcBef>
+              <a:spcAft>
+                <a:spcPts val="600"/>
+              </a:spcAft>
+              <a:buNone/>
+            </a:pPr>
+            <a:r>
+              <a:rPr lang="en-US"/>
+              <a:t>They open Google Maps to see what’s nearby. Then Instagram or TikTok to see the food. Then they ask a friend if it’s good. Then they go, and it’s still a miss.</a:t>
+            </a:r>
+          </a:p>
+          <a:p>
+            <a:pPr indent="0" lvl="0" marL="0" rtl="0" algn="l">
+              <a:spcBef>
+                <a:spcPts val="0"/>
+              </a:spcBef>
+              <a:spcAft>
+                <a:spcPts val="600"/>
+              </a:spcAft>
+              <a:buNone/>
+            </a:pPr>
+            <a:r>
+              <a:rPr lang="en-US"/>
+              <a:t>Two things came up again and again. Nobody has one place to save where they want to go. And they want one app they can trust.</a:t>
+            </a:r>
+          </a:p>
+          <a:p>
+            <a:pPr indent="0" lvl="0" marL="0" rtl="0" algn="l">
+              <a:spcBef>
+                <a:spcPts val="0"/>
+              </a:spcBef>
+              <a:spcAft>
+                <a:spcPts val="600"/>
+              </a:spcAft>
+              <a:buNone/>
+            </a:pPr>
+            <a:r>
+              <a:rPr lang="en-US"/>
+              <a:t>There’s plenty of information out there. Knowing which of it to trust is the hard part.</a:t>
+            </a:r>
           </a:p>
         </p:txBody>
       </p:sp>
@@ -1407,15 +1598,74 @@
                 <a:spcPts val="0"/>
               </a:spcBef>
               <a:spcAft>
-                <a:spcPts val="0"/>
+                <a:spcPts val="600"/>
               </a:spcAft>
               <a:buNone/>
             </a:pPr>
             <a:r>
               <a:rPr lang="en-US"/>
-              <a:t>Three things you do in the app. Find: a map of what's open near you, filtered by cuisine, diet, price and distance, plus new places people are talking about. Compare: every rating and post on one page, next to our own score, which only counts verified visits. Nobody can pay to rank higher. Keep: your history and lists, and booking a table. All of it is free. You asked whether people would pay for a dietary filter. We think they shouldn't. Restaurants pay for the diners it sends them.</a:t>
-            </a:r>
-            <a:endParaRPr/>
+              <a:t>The app does three things: find, compare and keep.</a:t>
+            </a:r>
+          </a:p>
+          <a:p>
+            <a:pPr indent="0" lvl="0" marL="0" rtl="0" algn="l">
+              <a:spcBef>
+                <a:spcPts val="0"/>
+              </a:spcBef>
+              <a:spcAft>
+                <a:spcPts val="600"/>
+              </a:spcAft>
+              <a:buNone/>
+            </a:pPr>
+            <a:r>
+              <a:rPr lang="en-US"/>
+              <a:t>Find: what’s open near you, filtered by diet, price and distance, plus new places people are talking about.</a:t>
+            </a:r>
+          </a:p>
+          <a:p>
+            <a:pPr indent="0" lvl="0" marL="0" rtl="0" algn="l">
+              <a:spcBef>
+                <a:spcPts val="0"/>
+              </a:spcBef>
+              <a:spcAft>
+                <a:spcPts val="600"/>
+              </a:spcAft>
+              <a:buNone/>
+            </a:pPr>
+            <a:r>
+              <a:rPr lang="en-US"/>
+              <a:t>Compare: every rating and post for a place on one page, next to our own score. Our score only counts diners who scanned a receipt, and nobody can pay to rank higher.</a:t>
+            </a:r>
+          </a:p>
+          <a:p>
+            <a:pPr indent="0" lvl="0" marL="0" rtl="0" algn="l">
+              <a:spcBef>
+                <a:spcPts val="0"/>
+              </a:spcBef>
+              <a:spcAft>
+                <a:spcPts val="600"/>
+              </a:spcAft>
+              <a:buNone/>
+            </a:pPr>
+            <a:r>
+              <a:rPr lang="en-US"/>
+              <a:t>Keep: your history, your lists, and booking a table.</a:t>
+            </a:r>
+          </a:p>
+          <a:p>
+            <a:pPr indent="0" lvl="0" marL="0" rtl="0" algn="l">
+              <a:spcBef>
+                <a:spcPts val="0"/>
+              </a:spcBef>
+              <a:spcAft>
+                <a:spcPts val="600"/>
+              </a:spcAft>
+              <a:buNone/>
+            </a:pPr>
+            <a:r>
+              <a:rPr lang="en-US"/>
+              <a:t>All of it is free. You asked whether people would pay for a dietary filter. We think they shouldn’t. A halal or nut-free search is what sends a restaurant the diner it pays for, so it stays free.</a:t>
+            </a:r>
           </a:p>
         </p:txBody>
       </p:sp>
@@ -1558,15 +1808,89 @@
                 <a:spcPts val="0"/>
               </a:spcBef>
               <a:spcAft>
-                <a:spcPts val="0"/>
+                <a:spcPts val="600"/>
               </a:spcAft>
               <a:buNone/>
             </a:pPr>
             <a:r>
               <a:rPr lang="en-US"/>
-              <a:t>Here's what that looks like: four screens from our concept. One, start nearby: what's open around you. Two, let it pick: one best bet that's open, close, in budget and fits your diet, and which friends went. Three, see why: three picks for the occasion, each with a reason. Four, check every rating: our verified score next to Google, Yelp, Beli, Reddit and TikTok. It's a concept, and every score on screen is made up. Next we test it with students on campus. Hand-off: how big this can get.</a:t>
-            </a:r>
-            <a:endParaRPr/>
+              <a:t>These are four screens from our concept. Every score and person on them is made up.</a:t>
+            </a:r>
+          </a:p>
+          <a:p>
+            <a:pPr indent="0" lvl="0" marL="0" rtl="0" algn="l">
+              <a:spcBef>
+                <a:spcPts val="0"/>
+              </a:spcBef>
+              <a:spcAft>
+                <a:spcPts val="600"/>
+              </a:spcAft>
+              <a:buNone/>
+            </a:pPr>
+            <a:r>
+              <a:rPr lang="en-US"/>
+              <a:t>One, start nearby. You open the app and see what’s open around you.</a:t>
+            </a:r>
+          </a:p>
+          <a:p>
+            <a:pPr indent="0" lvl="0" marL="0" rtl="0" algn="l">
+              <a:spcBef>
+                <a:spcPts val="0"/>
+              </a:spcBef>
+              <a:spcAft>
+                <a:spcPts val="600"/>
+              </a:spcAft>
+              <a:buNone/>
+            </a:pPr>
+            <a:r>
+              <a:rPr lang="en-US"/>
+              <a:t>Two, let it pick. You get one best bet that’s open, close, in your budget and fits your diet, and you see which friends have been.</a:t>
+            </a:r>
+          </a:p>
+          <a:p>
+            <a:pPr indent="0" lvl="0" marL="0" rtl="0" algn="l">
+              <a:spcBef>
+                <a:spcPts val="0"/>
+              </a:spcBef>
+              <a:spcAft>
+                <a:spcPts val="600"/>
+              </a:spcAft>
+              <a:buNone/>
+            </a:pPr>
+            <a:r>
+              <a:rPr lang="en-US"/>
+              <a:t>Three, see why. Three picks for the occasion, each with a reason.</a:t>
+            </a:r>
+          </a:p>
+          <a:p>
+            <a:pPr indent="0" lvl="0" marL="0" rtl="0" algn="l">
+              <a:spcBef>
+                <a:spcPts val="0"/>
+              </a:spcBef>
+              <a:spcAft>
+                <a:spcPts val="600"/>
+              </a:spcAft>
+              <a:buNone/>
+            </a:pPr>
+            <a:r>
+              <a:rPr lang="en-US"/>
+              <a:t>Four, check every rating. Our verified score sits next to Google, Yelp, Beli, Reddit and TikTok, and creators’ paid posts are flagged.</a:t>
+            </a:r>
+          </a:p>
+          <a:p>
+            <a:pPr indent="0" lvl="0" marL="0" rtl="0" algn="l">
+              <a:spcBef>
+                <a:spcPts val="0"/>
+              </a:spcBef>
+              <a:spcAft>
+                <a:spcPts val="600"/>
+              </a:spcAft>
+              <a:buNone/>
+            </a:pPr>
+            <a:r>
+              <a:rPr lang="en-US"/>
+              <a:t>Next we put this in front of students on campus.</a:t>
+            </a:r>
           </a:p>
         </p:txBody>
       </p:sp>
@@ -1709,15 +2033,74 @@
                 <a:spcPts val="0"/>
               </a:spcBef>
               <a:spcAft>
-                <a:spcPts val="0"/>
+                <a:spcPts val="600"/>
               </a:spcAft>
               <a:buNone/>
             </a:pPr>
             <a:r>
               <a:rPr lang="en-US"/>
-              <a:t>Grey: Everyone 18 to 34 in the US is about 78 million people. We can reach US college students, 19 million, one campus at a time. We plan to win 540,000 active users by Year 5, 2.8% of those students, inside the 2 to 5% range from class. We start with Boston's 162,000 students, and Year 1 is 12,000 of them. The side that pays is Boston's 3,350 licensed places to eat. And nothing today puts maps, food posts and rankings together.</a:t>
-            </a:r>
-            <a:endParaRPr/>
+              <a:t>Start with the smallest number. Boston has 162,000 college students, and we want 12,000 of them in Year 1.</a:t>
+            </a:r>
+          </a:p>
+          <a:p>
+            <a:pPr indent="0" lvl="0" marL="0" rtl="0" algn="l">
+              <a:spcBef>
+                <a:spcPts val="0"/>
+              </a:spcBef>
+              <a:spcAft>
+                <a:spcPts val="600"/>
+              </a:spcAft>
+              <a:buNone/>
+            </a:pPr>
+            <a:r>
+              <a:rPr lang="en-US"/>
+              <a:t>Zoom out and there are about 19 million college students in the US. That’s who we can reach, one campus at a time. The bigger pool is 77.8 million people between 18 and 34.</a:t>
+            </a:r>
+          </a:p>
+          <a:p>
+            <a:pPr indent="0" lvl="0" marL="0" rtl="0" algn="l">
+              <a:spcBef>
+                <a:spcPts val="0"/>
+              </a:spcBef>
+              <a:spcAft>
+                <a:spcPts val="600"/>
+              </a:spcAft>
+              <a:buNone/>
+            </a:pPr>
+            <a:r>
+              <a:rPr lang="en-US"/>
+              <a:t>By Year 5 we want 540,000 active users. That’s 2.8% of US college students, inside the 2 to 5% range we talked about in class.</a:t>
+            </a:r>
+          </a:p>
+          <a:p>
+            <a:pPr indent="0" lvl="0" marL="0" rtl="0" algn="l">
+              <a:spcBef>
+                <a:spcPts val="0"/>
+              </a:spcBef>
+              <a:spcAft>
+                <a:spcPts val="600"/>
+              </a:spcAft>
+              <a:buNone/>
+            </a:pPr>
+            <a:r>
+              <a:rPr lang="en-US"/>
+              <a:t>On the other side, Boston has 3,350 licensed places to eat. Those are the businesses that will pay us.</a:t>
+            </a:r>
+          </a:p>
+          <a:p>
+            <a:pPr indent="0" lvl="0" marL="0" rtl="0" algn="l">
+              <a:spcBef>
+                <a:spcPts val="0"/>
+              </a:spcBef>
+              <a:spcAft>
+                <a:spcPts val="600"/>
+              </a:spcAft>
+              <a:buNone/>
+            </a:pPr>
+            <a:r>
+              <a:rPr lang="en-US"/>
+              <a:t>People ask why not Beli. Beli ranks where you’ve been. We tell you where to go right now, with scores people proved.</a:t>
+            </a:r>
           </a:p>
         </p:txBody>
       </p:sp>
@@ -1860,15 +2243,89 @@
                 <a:spcPts val="0"/>
               </a:spcBef>
               <a:spcAft>
-                <a:spcPts val="0"/>
+                <a:spcPts val="600"/>
               </a:spcAft>
               <a:buNone/>
             </a:pPr>
             <a:r>
               <a:rPr lang="en-US"/>
-              <a:t>Grey: The first 10 users are people we interviewed and our friends, testing the prototype this semester. The first 100 are Northeastern students they invite, plus clubs and group chats. The first 1,000 come from other Boston campuses, through student ambassadors and food posts. It's the same loop every time: a friend tells you, you download, you save a place, you invite someone. Beli grew about 80% that way. Users come first and never pay. Once they're here, restaurants pay for the diners we send. Hand-off: why a restaurant would pay.</a:t>
-            </a:r>
-            <a:endParaRPr/>
+              <a:t>How do we get our first users? One friend at a time.</a:t>
+            </a:r>
+          </a:p>
+          <a:p>
+            <a:pPr indent="0" lvl="0" marL="0" rtl="0" algn="l">
+              <a:spcBef>
+                <a:spcPts val="0"/>
+              </a:spcBef>
+              <a:spcAft>
+                <a:spcPts val="600"/>
+              </a:spcAft>
+              <a:buNone/>
+            </a:pPr>
+            <a:r>
+              <a:rPr lang="en-US"/>
+              <a:t>The first ten are people we interviewed, plus our friends. They test the prototype this semester, and what we tell them is: help us build it.</a:t>
+            </a:r>
+          </a:p>
+          <a:p>
+            <a:pPr indent="0" lvl="0" marL="0" rtl="0" algn="l">
+              <a:spcBef>
+                <a:spcPts val="0"/>
+              </a:spcBef>
+              <a:spcAft>
+                <a:spcPts val="600"/>
+              </a:spcAft>
+              <a:buNone/>
+            </a:pPr>
+            <a:r>
+              <a:rPr lang="en-US"/>
+              <a:t>The first hundred are Northeastern students they invite, plus clubs and group chats. Now the pitch is every rating for a place, in one app.</a:t>
+            </a:r>
+          </a:p>
+          <a:p>
+            <a:pPr indent="0" lvl="0" marL="0" rtl="0" algn="l">
+              <a:spcBef>
+                <a:spcPts val="0"/>
+              </a:spcBef>
+              <a:spcAft>
+                <a:spcPts val="600"/>
+              </a:spcAft>
+              <a:buNone/>
+            </a:pPr>
+            <a:r>
+              <a:rPr lang="en-US"/>
+              <a:t>The first thousand come from other Boston campuses, through student ambassadors and food posts. One app instead of five tabs.</a:t>
+            </a:r>
+          </a:p>
+          <a:p>
+            <a:pPr indent="0" lvl="0" marL="0" rtl="0" algn="l">
+              <a:spcBef>
+                <a:spcPts val="0"/>
+              </a:spcBef>
+              <a:spcAft>
+                <a:spcPts val="600"/>
+              </a:spcAft>
+              <a:buNone/>
+            </a:pPr>
+            <a:r>
+              <a:rPr lang="en-US"/>
+              <a:t>It’s the same loop every time. A friend tells you, you download, you save a place, you invite someone. About 80% of Beli’s users arrived that way, and it’s how we get to 12,000 by the end of Year 1.</a:t>
+            </a:r>
+          </a:p>
+          <a:p>
+            <a:pPr indent="0" lvl="0" marL="0" rtl="0" algn="l">
+              <a:spcBef>
+                <a:spcPts val="0"/>
+              </a:spcBef>
+              <a:spcAft>
+                <a:spcPts val="600"/>
+              </a:spcAft>
+              <a:buNone/>
+            </a:pPr>
+            <a:r>
+              <a:rPr lang="en-US"/>
+              <a:t>Users never pay. Restaurants do, and that’s next.</a:t>
+            </a:r>
           </a:p>
         </p:txBody>
       </p:sp>
@@ -2011,15 +2468,89 @@
                 <a:spcPts val="0"/>
               </a:spcBef>
               <a:spcAft>
-                <a:spcPts val="0"/>
+                <a:spcPts val="600"/>
               </a:spcAft>
               <a:buNone/>
             </a:pPr>
             <a:r>
               <a:rPr lang="en-US"/>
-              <a:t>Today a restaurant pays for ads and boosted posts before it knows whether anyone walks in. We flip that. It pays about 90 cents only for a diner we sent, once a receipt shows they came. That's below the $1 to $1.50 OpenTable charges. From Year 3, chains pay $6,000 a year per area to see what our users there eat. On the user side, a few people pay $5 a month for extras. Nothing a restaurant pays changes its score or where it shows up. We haven't talked to owners yet, so five owner calls are next.</a:t>
-            </a:r>
-            <a:endParaRPr/>
+              <a:t>Here’s how we make money. Restaurants pay for the diners we send them, not for ads.</a:t>
+            </a:r>
+          </a:p>
+          <a:p>
+            <a:pPr indent="0" lvl="0" marL="0" rtl="0" algn="l">
+              <a:spcBef>
+                <a:spcPts val="0"/>
+              </a:spcBef>
+              <a:spcAft>
+                <a:spcPts val="600"/>
+              </a:spcAft>
+              <a:buNone/>
+            </a:pPr>
+            <a:r>
+              <a:rPr lang="en-US"/>
+              <a:t>Today a restaurant pays for ads and boosted posts before it knows if anyone will walk in. We flip that. It pays about 90 cents, and only after a receipt shows the diner came. OpenTable charges $1 to $1.50 a diner.</a:t>
+            </a:r>
+          </a:p>
+          <a:p>
+            <a:pPr indent="0" lvl="0" marL="0" rtl="0" algn="l">
+              <a:spcBef>
+                <a:spcPts val="0"/>
+              </a:spcBef>
+              <a:spcAft>
+                <a:spcPts val="600"/>
+              </a:spcAft>
+              <a:buNone/>
+            </a:pPr>
+            <a:r>
+              <a:rPr lang="en-US"/>
+              <a:t>Booking sites pay per table. And from Year 3, chains pay $6,000 a year per neighborhood to see what people there eat. All of that adds up to $288,000 in Year 5.</a:t>
+            </a:r>
+          </a:p>
+          <a:p>
+            <a:pPr indent="0" lvl="0" marL="0" rtl="0" algn="l">
+              <a:spcBef>
+                <a:spcPts val="0"/>
+              </a:spcBef>
+              <a:spcAft>
+                <a:spcPts val="600"/>
+              </a:spcAft>
+              <a:buNone/>
+            </a:pPr>
+            <a:r>
+              <a:rPr lang="en-US"/>
+              <a:t>On the user side the app is free. About 3 in 1,000 pay $5 a month for extras, and that’s another $67,000.</a:t>
+            </a:r>
+          </a:p>
+          <a:p>
+            <a:pPr indent="0" lvl="0" marL="0" rtl="0" algn="l">
+              <a:spcBef>
+                <a:spcPts val="0"/>
+              </a:spcBef>
+              <a:spcAft>
+                <a:spcPts val="600"/>
+              </a:spcAft>
+              <a:buNone/>
+            </a:pPr>
+            <a:r>
+              <a:rPr lang="en-US"/>
+              <a:t>So $356,000 in Year 5. Nothing anyone pays changes a score or a ranking.</a:t>
+            </a:r>
+          </a:p>
+          <a:p>
+            <a:pPr indent="0" lvl="0" marL="0" rtl="0" algn="l">
+              <a:spcBef>
+                <a:spcPts val="0"/>
+              </a:spcBef>
+              <a:spcAft>
+                <a:spcPts val="600"/>
+              </a:spcAft>
+              <a:buNone/>
+            </a:pPr>
+            <a:r>
+              <a:rPr lang="en-US"/>
+              <a:t>We haven’t talked to restaurant owners yet. Five owner calls are next, each with a free 30-day pilot and a report on the diners we sent.</a:t>
+            </a:r>
           </a:p>
         </p:txBody>
       </p:sp>
@@ -2162,15 +2693,59 @@
                 <a:spcPts val="0"/>
               </a:spcBef>
               <a:spcAft>
-                <a:spcPts val="0"/>
+                <a:spcPts val="600"/>
               </a:spcAft>
               <a:buNone/>
             </a:pPr>
             <a:r>
               <a:rPr lang="en-US"/>
-              <a:t>Before building the numbers we looked at the apps closest to us. OpenTable took nine years to turn a profit. Resy ran on $45 million and was sold. Beli reached 1.1 million monthly users, mostly through friends, with five people and almost no revenue. So we made three choices: no salaries and co-ops before hires, costs low enough to need about $240K, and Beli as our yardstick, a quarter of its size at the same age, but with restaurants paying from Year 2. Hand-off: here's what that looks like in numbers.</a:t>
-            </a:r>
-            <a:endParaRPr/>
+              <a:t>Before we built our numbers, we looked at the apps closest to us. None of them made money early.</a:t>
+            </a:r>
+          </a:p>
+          <a:p>
+            <a:pPr indent="0" lvl="0" marL="0" rtl="0" algn="l">
+              <a:spcBef>
+                <a:spcPts val="0"/>
+              </a:spcBef>
+              <a:spcAft>
+                <a:spcPts val="600"/>
+              </a:spcAft>
+              <a:buNone/>
+            </a:pPr>
+            <a:r>
+              <a:rPr lang="en-US"/>
+              <a:t>OpenTable took nine years to turn a profit and lost $57 million getting there. Resy ran on $45 million of investor money and then sold. Beli has 1.1 million monthly users, mostly through friends, with five people and almost no revenue.</a:t>
+            </a:r>
+          </a:p>
+          <a:p>
+            <a:pPr indent="0" lvl="0" marL="0" rtl="0" algn="l">
+              <a:spcBef>
+                <a:spcPts val="0"/>
+              </a:spcBef>
+              <a:spcAft>
+                <a:spcPts val="600"/>
+              </a:spcAft>
+              <a:buNone/>
+            </a:pPr>
+            <a:r>
+              <a:rPr lang="en-US"/>
+              <a:t>So we made three choices. No salaries, and co-op students before hires. Costs low enough that we only need about $240,000, starting with grants. And Beli as our yardstick: a quarter of its size, almost no ads, and restaurants paying from Year 2.</a:t>
+            </a:r>
+          </a:p>
+          <a:p>
+            <a:pPr indent="0" lvl="0" marL="0" rtl="0" algn="l">
+              <a:spcBef>
+                <a:spcPts val="0"/>
+              </a:spcBef>
+              <a:spcAft>
+                <a:spcPts val="600"/>
+              </a:spcAft>
+              <a:buNone/>
+            </a:pPr>
+            <a:r>
+              <a:rPr lang="en-US"/>
+              <a:t>The trade-off is a smaller team, and it only works if restaurants sign up.</a:t>
+            </a:r>
           </a:p>
         </p:txBody>
       </p:sp>
@@ -2313,15 +2888,74 @@
                 <a:spcPts val="0"/>
               </a:spcBef>
               <a:spcAft>
-                <a:spcPts val="0"/>
+                <a:spcPts val="600"/>
               </a:spcAft>
               <a:buNone/>
             </a:pPr>
             <a:r>
               <a:rPr lang="en-US"/>
-              <a:t>Look at the three highlighted numbers. Years 1 and 2 are flat on purpose, about $10,500 a quarter: one contract developer, a little campus marketing, legal and insurance. Nobody else gets paid until restaurants do. Money first comes in during Year 2, the first highlight. From Year 3, co-ops join as users grow. The lowest point is about $192K down in Year 4, which is why we raise $240K. And Year 5 is the first profitable year, about $72K.</a:t>
-            </a:r>
-            <a:endParaRPr/>
+              <a:t>These are our numbers. Look at the three highlighted ones.</a:t>
+            </a:r>
+          </a:p>
+          <a:p>
+            <a:pPr indent="0" lvl="0" marL="0" rtl="0" algn="l">
+              <a:spcBef>
+                <a:spcPts val="0"/>
+              </a:spcBef>
+              <a:spcAft>
+                <a:spcPts val="600"/>
+              </a:spcAft>
+              <a:buNone/>
+            </a:pPr>
+            <a:r>
+              <a:rPr lang="en-US"/>
+              <a:t>Years 1 and 2 are flat on purpose, about $11,000 a quarter. That’s a contract developer at $7,500, $1,500 for marketing, $1,500 for legal and insurance, and a little hosting. Nobody else gets paid until restaurants do.</a:t>
+            </a:r>
+          </a:p>
+          <a:p>
+            <a:pPr indent="0" lvl="0" marL="0" rtl="0" algn="l">
+              <a:spcBef>
+                <a:spcPts val="0"/>
+              </a:spcBef>
+              <a:spcAft>
+                <a:spcPts val="600"/>
+              </a:spcAft>
+              <a:buNone/>
+            </a:pPr>
+            <a:r>
+              <a:rPr lang="en-US"/>
+              <a:t>The first highlight is Year 2, when the first revenue comes in. From Year 3, co-op students join as our users grow.</a:t>
+            </a:r>
+          </a:p>
+          <a:p>
+            <a:pPr indent="0" lvl="0" marL="0" rtl="0" algn="l">
+              <a:spcBef>
+                <a:spcPts val="0"/>
+              </a:spcBef>
+              <a:spcAft>
+                <a:spcPts val="600"/>
+              </a:spcAft>
+              <a:buNone/>
+            </a:pPr>
+            <a:r>
+              <a:rPr lang="en-US"/>
+              <a:t>The second is the low point, about $192,000 down in Year 4. That’s why we’re raising $240,000: the low point plus a 25% cushion.</a:t>
+            </a:r>
+          </a:p>
+          <a:p>
+            <a:pPr indent="0" lvl="0" marL="0" rtl="0" algn="l">
+              <a:spcBef>
+                <a:spcPts val="0"/>
+              </a:spcBef>
+              <a:spcAft>
+                <a:spcPts val="600"/>
+              </a:spcAft>
+              <a:buNone/>
+            </a:pPr>
+            <a:r>
+              <a:rPr lang="en-US"/>
+              <a:t>The third is Year 5, our first profitable year, at about $72,000.</a:t>
+            </a:r>
           </a:p>
         </p:txBody>
       </p:sp>
@@ -14332,7 +14966,7 @@
                 <a:cs typeface="Poppins"/>
                 <a:sym typeface="Poppins"/>
               </a:rPr>
-              <a:t>Every line starts from a real company's number. </a:t>
+              <a:t>Two sides pay, and every price starts from a real company’s number. </a:t>
             </a:r>
             <a:r>
               <a:rPr b="0" i="0" lang="en-US" sz="4400" u="none" cap="none" strike="noStrike">
@@ -14405,14 +15039,67 @@
       </p:sp>
       <p:sp>
         <p:nvSpPr>
+          <p:cNvPr id="341" name="Google Shape;341;p11"/>
+          <p:cNvSpPr txBox="1"/>
+          <p:nvPr/>
+        </p:nvSpPr>
+        <p:spPr>
+          <a:xfrm>
+            <a:off x="822960" y="3657600"/>
+            <a:ext cx="3931920" cy="365760"/>
+          </a:xfrm>
+          <a:prstGeom prst="rect">
+            <a:avLst/>
+          </a:prstGeom>
+          <a:noFill/>
+          <a:ln>
+            <a:noFill/>
+          </a:ln>
+        </p:spPr>
+        <p:txBody>
+          <a:bodyPr anchorCtr="0" anchor="t" bIns="0" lIns="0" spcFirstLastPara="1" rIns="0" wrap="square" tIns="0">
+            <a:spAutoFit/>
+          </a:bodyPr>
+          <a:lstStyle/>
+          <a:p>
+            <a:pPr indent="0" lvl="0" marL="0" marR="0" rtl="0" algn="l">
+              <a:lnSpc>
+                <a:spcPct val="110000"/>
+              </a:lnSpc>
+              <a:spcBef>
+                <a:spcPts val="0"/>
+              </a:spcBef>
+              <a:spcAft>
+                <a:spcPts val="0"/>
+              </a:spcAft>
+              <a:buNone/>
+            </a:pPr>
+            <a:r>
+              <a:rPr b="1" i="0" lang="en-US" sz="2400" u="none" cap="none" strike="noStrike">
+                <a:solidFill>
+                  <a:srgbClr val="6F6B34"/>
+                </a:solidFill>
+                <a:latin typeface="Poppins"/>
+                <a:ea typeface="Poppins"/>
+                <a:cs typeface="Poppins"/>
+                <a:sym typeface="Poppins"/>
+              </a:rPr>
+              <a:t>Stream</a:t>
+            </a:r>
+            <a:endParaRPr/>
+          </a:p>
+        </p:txBody>
+      </p:sp>
+      <p:sp>
+        <p:nvSpPr>
           <p:cNvPr id="322" name="Google Shape;322;p11"/>
           <p:cNvSpPr txBox="1"/>
           <p:nvPr/>
         </p:nvSpPr>
         <p:spPr>
           <a:xfrm>
-            <a:off x="7315200" y="3657600"/>
-            <a:ext cx="1828800" cy="365760"/>
+            <a:off x="4937760" y="3657600"/>
+            <a:ext cx="1737360" cy="365760"/>
           </a:xfrm>
           <a:prstGeom prst="rect">
             <a:avLst/>
@@ -14464,8 +15151,8 @@
         </p:nvSpPr>
         <p:spPr>
           <a:xfrm>
-            <a:off x="9326880" y="3657600"/>
-            <a:ext cx="8138160" cy="365760"/>
+            <a:off x="6949440" y="3657600"/>
+            <a:ext cx="10515600" cy="365760"/>
           </a:xfrm>
           <a:prstGeom prst="rect">
             <a:avLst/>
@@ -14503,7 +15190,7 @@
                 <a:cs typeface="Poppins"/>
                 <a:sym typeface="Poppins"/>
               </a:rPr>
-              <a:t>What we based it on</a:t>
+              <a:t>What they pay for and why</a:t>
             </a:r>
             <a:endParaRPr/>
           </a:p>
@@ -14576,7 +15263,7 @@
         <p:spPr>
           <a:xfrm>
             <a:off x="822960" y="4343400"/>
-            <a:ext cx="6309360" cy="548640"/>
+            <a:ext cx="3931920" cy="548640"/>
           </a:xfrm>
           <a:prstGeom prst="rect">
             <a:avLst/>
@@ -14614,7 +15301,7 @@
                 <a:cs typeface="Poppins"/>
                 <a:sym typeface="Poppins"/>
               </a:rPr>
-              <a:t>Verified diners we send</a:t>
+              <a:t>Businesses</a:t>
             </a:r>
             <a:endParaRPr/>
           </a:p>
@@ -14628,8 +15315,8 @@
         </p:nvSpPr>
         <p:spPr>
           <a:xfrm>
-            <a:off x="7315200" y="4343400"/>
-            <a:ext cx="1828800" cy="548640"/>
+            <a:off x="4937760" y="4343400"/>
+            <a:ext cx="1737360" cy="548640"/>
           </a:xfrm>
           <a:prstGeom prst="rect">
             <a:avLst/>
@@ -14667,7 +15354,7 @@
                 <a:cs typeface="Poppins"/>
                 <a:sym typeface="Poppins"/>
               </a:rPr>
-              <a:t>$156K</a:t>
+              <a:t>$288K</a:t>
             </a:r>
             <a:endParaRPr/>
           </a:p>
@@ -14681,8 +15368,8 @@
         </p:nvSpPr>
         <p:spPr>
           <a:xfrm>
-            <a:off x="9326880" y="4343400"/>
-            <a:ext cx="8138160" cy="914400"/>
+            <a:off x="6949440" y="4343400"/>
+            <a:ext cx="10515600" cy="1463040"/>
           </a:xfrm>
           <a:prstGeom prst="rect">
             <a:avLst/>
@@ -14720,7 +15407,7 @@
                 <a:cs typeface="Poppins"/>
                 <a:sym typeface="Poppins"/>
               </a:rPr>
-              <a:t>OpenTable charges $1.00 to $1.50 a diner; Ibotta, a cash-back app, earns $0.87. We charge about $0.90.</a:t>
+              <a:t>Diners we send ($156K), tables booked ($54K) and area insights for chains ($78K). They pay for customers, not for ads. About $0.90 a diner sits under OpenTable’s $1.00 to $1.50, bookings are a quarter of Tabelog’s rate, and chains pay a quarter of Placer.ai’s.</a:t>
             </a:r>
             <a:endParaRPr/>
           </a:p>
@@ -14734,7 +15421,7 @@
         </p:nvSpPr>
         <p:spPr>
           <a:xfrm>
-            <a:off x="822960" y="5340096"/>
+            <a:off x="822960" y="6172200"/>
             <a:ext cx="16642080" cy="10972"/>
           </a:xfrm>
           <a:prstGeom prst="rect">
@@ -14792,8 +15479,8 @@
         </p:nvSpPr>
         <p:spPr>
           <a:xfrm>
-            <a:off x="822960" y="5532120"/>
-            <a:ext cx="6309360" cy="548640"/>
+            <a:off x="822960" y="6355080"/>
+            <a:ext cx="3931920" cy="548640"/>
           </a:xfrm>
           <a:prstGeom prst="rect">
             <a:avLst/>
@@ -14831,7 +15518,7 @@
                 <a:cs typeface="Poppins"/>
                 <a:sym typeface="Poppins"/>
               </a:rPr>
-              <a:t>Bookings</a:t>
+              <a:t>Users</a:t>
             </a:r>
             <a:endParaRPr/>
           </a:p>
@@ -14845,442 +15532,8 @@
         </p:nvSpPr>
         <p:spPr>
           <a:xfrm>
-            <a:off x="7315200" y="5532120"/>
-            <a:ext cx="1828800" cy="548640"/>
-          </a:xfrm>
-          <a:prstGeom prst="rect">
-            <a:avLst/>
-          </a:prstGeom>
-          <a:noFill/>
-          <a:ln>
-            <a:noFill/>
-          </a:ln>
-        </p:spPr>
-        <p:txBody>
-          <a:bodyPr anchorCtr="0" anchor="t" bIns="0" lIns="0" spcFirstLastPara="1" rIns="0" wrap="square" tIns="0">
-            <a:spAutoFit/>
-          </a:bodyPr>
-          <a:lstStyle/>
-          <a:p>
-            <a:pPr indent="0" lvl="0" marL="0" marR="0" rtl="0" algn="l">
-              <a:lnSpc>
-                <a:spcPct val="110000"/>
-              </a:lnSpc>
-              <a:spcBef>
-                <a:spcPts val="0"/>
-              </a:spcBef>
-              <a:spcAft>
-                <a:spcPts val="0"/>
-              </a:spcAft>
-              <a:buNone/>
-            </a:pPr>
-            <a:r>
-              <a:rPr b="0" i="0" lang="en-US" sz="2400" u="none" cap="none" strike="noStrike">
-                <a:solidFill>
-                  <a:srgbClr val="000000"/>
-                </a:solidFill>
-                <a:latin typeface="Poppins"/>
-                <a:ea typeface="Poppins"/>
-                <a:cs typeface="Poppins"/>
-                <a:sym typeface="Poppins"/>
-              </a:rPr>
-              <a:t>$54K</a:t>
-            </a:r>
-            <a:endParaRPr/>
-          </a:p>
-        </p:txBody>
-      </p:sp>
-      <p:sp>
-        <p:nvSpPr>
-          <p:cNvPr id="331" name="Google Shape;331;p11"/>
-          <p:cNvSpPr txBox="1"/>
-          <p:nvPr/>
-        </p:nvSpPr>
-        <p:spPr>
-          <a:xfrm>
-            <a:off x="9326880" y="5532120"/>
-            <a:ext cx="8138160" cy="914400"/>
-          </a:xfrm>
-          <a:prstGeom prst="rect">
-            <a:avLst/>
-          </a:prstGeom>
-          <a:noFill/>
-          <a:ln>
-            <a:noFill/>
-          </a:ln>
-        </p:spPr>
-        <p:txBody>
-          <a:bodyPr anchorCtr="0" anchor="t" bIns="0" lIns="0" spcFirstLastPara="1" rIns="0" wrap="square" tIns="0">
-            <a:spAutoFit/>
-          </a:bodyPr>
-          <a:lstStyle/>
-          <a:p>
-            <a:pPr indent="0" lvl="0" marL="0" marR="0" rtl="0" algn="l">
-              <a:lnSpc>
-                <a:spcPct val="110000"/>
-              </a:lnSpc>
-              <a:spcBef>
-                <a:spcPts val="0"/>
-              </a:spcBef>
-              <a:spcAft>
-                <a:spcPts val="0"/>
-              </a:spcAft>
-              <a:buNone/>
-            </a:pPr>
-            <a:r>
-              <a:rPr b="0" i="0" lang="en-US" sz="2200" u="none" cap="none" strike="noStrike">
-                <a:solidFill>
-                  <a:srgbClr val="434343"/>
-                </a:solidFill>
-                <a:latin typeface="Poppins"/>
-                <a:ea typeface="Poppins"/>
-                <a:cs typeface="Poppins"/>
-                <a:sym typeface="Poppins"/>
-              </a:rPr>
-              <a:t>A quarter of the rate people book through Tabelog, Japan's largest restaurant site.</a:t>
-            </a:r>
-            <a:endParaRPr/>
-          </a:p>
-        </p:txBody>
-      </p:sp>
-      <p:sp>
-        <p:nvSpPr>
-          <p:cNvPr id="332" name="Google Shape;332;p11"/>
-          <p:cNvSpPr/>
-          <p:nvPr/>
-        </p:nvSpPr>
-        <p:spPr>
-          <a:xfrm>
-            <a:off x="822960" y="6528816"/>
-            <a:ext cx="16642080" cy="10972"/>
-          </a:xfrm>
-          <a:prstGeom prst="rect">
-            <a:avLst/>
-          </a:prstGeom>
-          <a:solidFill>
-            <a:srgbClr val="D9D9D9"/>
-          </a:solidFill>
-          <a:ln>
-            <a:noFill/>
-          </a:ln>
-          <a:effectLst>
-            <a:outerShdw blurRad="40000" rotWithShape="0" dir="5400000" dist="23000">
-              <a:srgbClr val="000000">
-                <a:alpha val="34902"/>
-              </a:srgbClr>
-            </a:outerShdw>
-          </a:effectLst>
-        </p:spPr>
-        <p:txBody>
-          <a:bodyPr anchorCtr="0" anchor="ctr" bIns="45700" lIns="91425" spcFirstLastPara="1" rIns="91425" wrap="square" tIns="45700">
-            <a:noAutofit/>
-          </a:bodyPr>
-          <a:lstStyle/>
-          <a:p>
-            <a:pPr indent="0" lvl="0" marL="0" marR="0" rtl="0" algn="ctr">
-              <a:spcBef>
-                <a:spcPts val="0"/>
-              </a:spcBef>
-              <a:spcAft>
-                <a:spcPts val="0"/>
-              </a:spcAft>
-              <a:buNone/>
-            </a:pPr>
-            <a:r>
-              <a:t/>
-            </a:r>
-            <a:endParaRPr b="0" i="0" sz="1800" u="none" cap="none" strike="noStrike">
-              <a:solidFill>
-                <a:schemeClr val="dk1"/>
-              </a:solidFill>
-              <a:latin typeface="Calibri"/>
-              <a:ea typeface="Calibri"/>
-              <a:cs typeface="Calibri"/>
-              <a:sym typeface="Calibri"/>
-            </a:endParaRPr>
-          </a:p>
-        </p:txBody>
-      </p:sp>
-      <p:sp>
-        <p:nvSpPr>
-          <p:cNvPr id="333" name="Google Shape;333;p11"/>
-          <p:cNvSpPr txBox="1"/>
-          <p:nvPr/>
-        </p:nvSpPr>
-        <p:spPr>
-          <a:xfrm>
-            <a:off x="822960" y="6720840"/>
-            <a:ext cx="6309360" cy="548640"/>
-          </a:xfrm>
-          <a:prstGeom prst="rect">
-            <a:avLst/>
-          </a:prstGeom>
-          <a:noFill/>
-          <a:ln>
-            <a:noFill/>
-          </a:ln>
-        </p:spPr>
-        <p:txBody>
-          <a:bodyPr anchorCtr="0" anchor="t" bIns="0" lIns="0" spcFirstLastPara="1" rIns="0" wrap="square" tIns="0">
-            <a:spAutoFit/>
-          </a:bodyPr>
-          <a:lstStyle/>
-          <a:p>
-            <a:pPr indent="0" lvl="0" marL="0" marR="0" rtl="0" algn="l">
-              <a:lnSpc>
-                <a:spcPct val="110000"/>
-              </a:lnSpc>
-              <a:spcBef>
-                <a:spcPts val="0"/>
-              </a:spcBef>
-              <a:spcAft>
-                <a:spcPts val="0"/>
-              </a:spcAft>
-              <a:buNone/>
-            </a:pPr>
-            <a:r>
-              <a:rPr b="0" i="0" lang="en-US" sz="2400" u="none" cap="none" strike="noStrike">
-                <a:solidFill>
-                  <a:srgbClr val="000000"/>
-                </a:solidFill>
-                <a:latin typeface="Poppins"/>
-                <a:ea typeface="Poppins"/>
-                <a:cs typeface="Poppins"/>
-                <a:sym typeface="Poppins"/>
-              </a:rPr>
-              <a:t>Area-level insights for chains</a:t>
-            </a:r>
-            <a:endParaRPr/>
-          </a:p>
-        </p:txBody>
-      </p:sp>
-      <p:sp>
-        <p:nvSpPr>
-          <p:cNvPr id="334" name="Google Shape;334;p11"/>
-          <p:cNvSpPr txBox="1"/>
-          <p:nvPr/>
-        </p:nvSpPr>
-        <p:spPr>
-          <a:xfrm>
-            <a:off x="7315200" y="6720840"/>
-            <a:ext cx="1828800" cy="548640"/>
-          </a:xfrm>
-          <a:prstGeom prst="rect">
-            <a:avLst/>
-          </a:prstGeom>
-          <a:noFill/>
-          <a:ln>
-            <a:noFill/>
-          </a:ln>
-        </p:spPr>
-        <p:txBody>
-          <a:bodyPr anchorCtr="0" anchor="t" bIns="0" lIns="0" spcFirstLastPara="1" rIns="0" wrap="square" tIns="0">
-            <a:spAutoFit/>
-          </a:bodyPr>
-          <a:lstStyle/>
-          <a:p>
-            <a:pPr indent="0" lvl="0" marL="0" marR="0" rtl="0" algn="l">
-              <a:lnSpc>
-                <a:spcPct val="110000"/>
-              </a:lnSpc>
-              <a:spcBef>
-                <a:spcPts val="0"/>
-              </a:spcBef>
-              <a:spcAft>
-                <a:spcPts val="0"/>
-              </a:spcAft>
-              <a:buNone/>
-            </a:pPr>
-            <a:r>
-              <a:rPr b="0" i="0" lang="en-US" sz="2400" u="none" cap="none" strike="noStrike">
-                <a:solidFill>
-                  <a:srgbClr val="000000"/>
-                </a:solidFill>
-                <a:latin typeface="Poppins"/>
-                <a:ea typeface="Poppins"/>
-                <a:cs typeface="Poppins"/>
-                <a:sym typeface="Poppins"/>
-              </a:rPr>
-              <a:t>$78K</a:t>
-            </a:r>
-            <a:endParaRPr/>
-          </a:p>
-        </p:txBody>
-      </p:sp>
-      <p:sp>
-        <p:nvSpPr>
-          <p:cNvPr id="335" name="Google Shape;335;p11"/>
-          <p:cNvSpPr txBox="1"/>
-          <p:nvPr/>
-        </p:nvSpPr>
-        <p:spPr>
-          <a:xfrm>
-            <a:off x="9326880" y="6720840"/>
-            <a:ext cx="8138160" cy="914400"/>
-          </a:xfrm>
-          <a:prstGeom prst="rect">
-            <a:avLst/>
-          </a:prstGeom>
-          <a:noFill/>
-          <a:ln>
-            <a:noFill/>
-          </a:ln>
-        </p:spPr>
-        <p:txBody>
-          <a:bodyPr anchorCtr="0" anchor="t" bIns="0" lIns="0" spcFirstLastPara="1" rIns="0" wrap="square" tIns="0">
-            <a:spAutoFit/>
-          </a:bodyPr>
-          <a:lstStyle/>
-          <a:p>
-            <a:pPr indent="0" lvl="0" marL="0" marR="0" rtl="0" algn="l">
-              <a:lnSpc>
-                <a:spcPct val="110000"/>
-              </a:lnSpc>
-              <a:spcBef>
-                <a:spcPts val="0"/>
-              </a:spcBef>
-              <a:spcAft>
-                <a:spcPts val="0"/>
-              </a:spcAft>
-              <a:buNone/>
-            </a:pPr>
-            <a:r>
-              <a:rPr b="0" i="0" lang="en-US" sz="2200" u="none" cap="none" strike="noStrike">
-                <a:solidFill>
-                  <a:srgbClr val="434343"/>
-                </a:solidFill>
-                <a:latin typeface="Poppins"/>
-                <a:ea typeface="Poppins"/>
-                <a:cs typeface="Poppins"/>
-                <a:sym typeface="Poppins"/>
-              </a:rPr>
-              <a:t>A quarter of what Placer.ai, which sells foot-traffic data, charges its average customer.</a:t>
-            </a:r>
-            <a:endParaRPr/>
-          </a:p>
-        </p:txBody>
-      </p:sp>
-      <p:sp>
-        <p:nvSpPr>
-          <p:cNvPr id="336" name="Google Shape;336;p11"/>
-          <p:cNvSpPr/>
-          <p:nvPr/>
-        </p:nvSpPr>
-        <p:spPr>
-          <a:xfrm>
-            <a:off x="822960" y="7717536"/>
-            <a:ext cx="16642080" cy="10972"/>
-          </a:xfrm>
-          <a:prstGeom prst="rect">
-            <a:avLst/>
-          </a:prstGeom>
-          <a:solidFill>
-            <a:srgbClr val="D9D9D9"/>
-          </a:solidFill>
-          <a:ln>
-            <a:noFill/>
-          </a:ln>
-          <a:effectLst>
-            <a:outerShdw blurRad="40000" rotWithShape="0" dir="5400000" dist="23000">
-              <a:srgbClr val="000000">
-                <a:alpha val="34902"/>
-              </a:srgbClr>
-            </a:outerShdw>
-          </a:effectLst>
-        </p:spPr>
-        <p:txBody>
-          <a:bodyPr anchorCtr="0" anchor="ctr" bIns="45700" lIns="91425" spcFirstLastPara="1" rIns="91425" wrap="square" tIns="45700">
-            <a:noAutofit/>
-          </a:bodyPr>
-          <a:lstStyle/>
-          <a:p>
-            <a:pPr indent="0" lvl="0" marL="0" marR="0" rtl="0" algn="ctr">
-              <a:spcBef>
-                <a:spcPts val="0"/>
-              </a:spcBef>
-              <a:spcAft>
-                <a:spcPts val="0"/>
-              </a:spcAft>
-              <a:buNone/>
-            </a:pPr>
-            <a:r>
-              <a:t/>
-            </a:r>
-            <a:endParaRPr b="0" i="0" sz="1800" u="none" cap="none" strike="noStrike">
-              <a:solidFill>
-                <a:schemeClr val="dk1"/>
-              </a:solidFill>
-              <a:latin typeface="Calibri"/>
-              <a:ea typeface="Calibri"/>
-              <a:cs typeface="Calibri"/>
-              <a:sym typeface="Calibri"/>
-            </a:endParaRPr>
-          </a:p>
-        </p:txBody>
-      </p:sp>
-      <p:sp>
-        <p:nvSpPr>
-          <p:cNvPr id="337" name="Google Shape;337;p11"/>
-          <p:cNvSpPr txBox="1"/>
-          <p:nvPr/>
-        </p:nvSpPr>
-        <p:spPr>
-          <a:xfrm>
-            <a:off x="822960" y="7909560"/>
-            <a:ext cx="6309360" cy="548640"/>
-          </a:xfrm>
-          <a:prstGeom prst="rect">
-            <a:avLst/>
-          </a:prstGeom>
-          <a:noFill/>
-          <a:ln>
-            <a:noFill/>
-          </a:ln>
-        </p:spPr>
-        <p:txBody>
-          <a:bodyPr anchorCtr="0" anchor="t" bIns="0" lIns="0" spcFirstLastPara="1" rIns="0" wrap="square" tIns="0">
-            <a:spAutoFit/>
-          </a:bodyPr>
-          <a:lstStyle/>
-          <a:p>
-            <a:pPr indent="0" lvl="0" marL="0" marR="0" rtl="0" algn="l">
-              <a:lnSpc>
-                <a:spcPct val="110000"/>
-              </a:lnSpc>
-              <a:spcBef>
-                <a:spcPts val="0"/>
-              </a:spcBef>
-              <a:spcAft>
-                <a:spcPts val="0"/>
-              </a:spcAft>
-              <a:buNone/>
-            </a:pPr>
-            <a:r>
-              <a:rPr b="0" i="0" lang="en-US" sz="2400" u="none" cap="none" strike="noStrike">
-                <a:solidFill>
-                  <a:srgbClr val="000000"/>
-                </a:solidFill>
-                <a:latin typeface="Poppins"/>
-                <a:ea typeface="Poppins"/>
-                <a:cs typeface="Poppins"/>
-                <a:sym typeface="Poppins"/>
-              </a:rPr>
-              <a:t>User memberships at $5 a month</a:t>
-            </a:r>
-            <a:endParaRPr/>
-          </a:p>
-        </p:txBody>
-      </p:sp>
-      <p:sp>
-        <p:nvSpPr>
-          <p:cNvPr id="338" name="Google Shape;338;p11"/>
-          <p:cNvSpPr txBox="1"/>
-          <p:nvPr/>
-        </p:nvSpPr>
-        <p:spPr>
-          <a:xfrm>
-            <a:off x="7315200" y="7909560"/>
-            <a:ext cx="1828800" cy="548640"/>
+            <a:off x="4937760" y="6355080"/>
+            <a:ext cx="1737360" cy="548640"/>
           </a:xfrm>
           <a:prstGeom prst="rect">
             <a:avLst/>
@@ -15326,14 +15579,14 @@
       </p:sp>
       <p:sp>
         <p:nvSpPr>
-          <p:cNvPr id="339" name="Google Shape;339;p11"/>
+          <p:cNvPr id="331" name="Google Shape;331;p11"/>
           <p:cNvSpPr txBox="1"/>
           <p:nvPr/>
         </p:nvSpPr>
         <p:spPr>
           <a:xfrm>
-            <a:off x="9326880" y="7909560"/>
-            <a:ext cx="8138160" cy="914400"/>
+            <a:off x="6949440" y="6355080"/>
+            <a:ext cx="10515600" cy="1463040"/>
           </a:xfrm>
           <a:prstGeom prst="rect">
             <a:avLst/>
@@ -15371,7 +15624,7 @@
                 <a:cs typeface="Poppins"/>
                 <a:sym typeface="Poppins"/>
               </a:rPr>
-              <a:t>The share of Tabelog's users who pay, about 0.3%.</a:t>
+              <a:t>The optional $5 a month membership: extras on top of a free app, such as taste match with friends. About 0.3% pay, the same share as Tabelog’s users.</a:t>
             </a:r>
             <a:endParaRPr/>
           </a:p>
@@ -15379,13 +15632,13 @@
       </p:sp>
       <p:sp>
         <p:nvSpPr>
-          <p:cNvPr id="340" name="Google Shape;340;p11"/>
+          <p:cNvPr id="332" name="Google Shape;332;p11"/>
           <p:cNvSpPr/>
           <p:nvPr/>
         </p:nvSpPr>
         <p:spPr>
           <a:xfrm>
-            <a:off x="822960" y="8906256"/>
+            <a:off x="822960" y="7772400"/>
             <a:ext cx="16642080" cy="10972"/>
           </a:xfrm>
           <a:prstGeom prst="rect">

</xml_diff>

<commit_message>
Restructure Gate 2 deck along Ashley Cheung's storytelling principles
Co-Authored-By: Claude Opus 5.5 <noreply@anthropic.com>
Claude-Session: https://claude.ai/code/session_017KdnwN2qyuF8wMBvTngErS
</commit_message>
<xml_diff>
--- a/ENTR_4501_Gate_2_deck_readable.pptx
+++ b/ENTR_4501_Gate_2_deck_readable.pptx
@@ -16,8 +16,10 @@
     <p:sldId id="261" r:id="rId12"/>
     <p:sldId id="262" r:id="rId13"/>
     <p:sldId id="263" r:id="rId14"/>
+    <p:sldId id="267" r:id="rId27"/>
     <p:sldId id="264" r:id="rId15"/>
     <p:sldId id="265" r:id="rId16"/>
+    <p:sldId id="268" r:id="rId28"/>
     <p:sldId id="266" r:id="rId17"/>
   </p:sldIdLst>
   <p:sldSz cy="10287000" cx="18288000"/>
@@ -1064,7 +1066,7 @@
             </a:pPr>
             <a:r>
               <a:rPr lang="en-US"/>
-              <a:t>Thank you. We’re happy to take questions.</a:t>
+              <a:t>That’s the plan. Let me sum it up.</a:t>
             </a:r>
           </a:p>
         </p:txBody>
@@ -1315,6 +1317,411 @@
 </p:notes>
 </file>
 
+<file path=ppt/notesSlides/notesSlide12.xml><?xml version="1.0" encoding="utf-8"?>
+<p:notes xmlns:a="http://schemas.openxmlformats.org/drawingml/2006/main" xmlns:r="http://schemas.openxmlformats.org/officeDocument/2006/relationships" xmlns:mc="http://schemas.openxmlformats.org/markup-compatibility/2006" xmlns:mv="urn:schemas-microsoft-com:mac:vml" xmlns:p="http://schemas.openxmlformats.org/presentationml/2006/main" xmlns:c="http://schemas.openxmlformats.org/drawingml/2006/chart" xmlns:dgm="http://schemas.openxmlformats.org/drawingml/2006/diagram" xmlns:o="urn:schemas-microsoft-com:office:office" xmlns:v="urn:schemas-microsoft-com:vml" xmlns:pvml="urn:schemas-microsoft-com:office:powerpoint" xmlns:com="http://schemas.openxmlformats.org/drawingml/2006/compatibility" xmlns:p14="http://schemas.microsoft.com/office/powerpoint/2010/main" xmlns:p15="http://schemas.microsoft.com/office/powerpoint/2012/main" xmlns:ahyp="http://schemas.microsoft.com/office/drawing/2018/hyperlinkcolor" showMasterPhAnim="0" showMasterSp="0">
+  <p:cSld>
+    <p:spTree>
+      <p:nvGrpSpPr>
+        <p:cNvPr id="108" name="Shape 108"/>
+        <p:cNvGrpSpPr/>
+        <p:nvPr/>
+      </p:nvGrpSpPr>
+      <p:grpSpPr>
+        <a:xfrm>
+          <a:off x="0" y="0"/>
+          <a:ext cx="0" cy="0"/>
+          <a:chOff x="0" y="0"/>
+          <a:chExt cx="0" cy="0"/>
+        </a:xfrm>
+      </p:grpSpPr>
+      <p:sp>
+        <p:nvSpPr>
+          <p:cNvPr id="109" name="Google Shape;109;p2:notes"/>
+          <p:cNvSpPr/>
+          <p:nvPr>
+            <p:ph idx="2" type="sldImg"/>
+          </p:nvPr>
+        </p:nvSpPr>
+        <p:spPr>
+          <a:xfrm>
+            <a:off x="0" y="0"/>
+            <a:ext cx="3000000" cy="3000000"/>
+          </a:xfrm>
+          <a:custGeom>
+            <a:rect b="b" l="l" r="r" t="t"/>
+            <a:pathLst>
+              <a:path extrusionOk="0" h="120000" w="120000">
+                <a:moveTo>
+                  <a:pt x="0" y="0"/>
+                </a:moveTo>
+                <a:lnTo>
+                  <a:pt x="120000" y="0"/>
+                </a:lnTo>
+                <a:lnTo>
+                  <a:pt x="120000" y="120000"/>
+                </a:lnTo>
+                <a:lnTo>
+                  <a:pt x="0" y="120000"/>
+                </a:lnTo>
+                <a:close/>
+              </a:path>
+            </a:pathLst>
+          </a:custGeom>
+          <a:noFill/>
+          <a:ln>
+            <a:noFill/>
+          </a:ln>
+        </p:spPr>
+      </p:sp>
+      <p:sp>
+        <p:nvSpPr>
+          <p:cNvPr id="110" name="Google Shape;110;p2:notes"/>
+          <p:cNvSpPr txBox="1"/>
+          <p:nvPr>
+            <p:ph idx="1" type="body"/>
+          </p:nvPr>
+        </p:nvSpPr>
+        <p:spPr>
+          <a:xfrm>
+            <a:off x="0" y="0"/>
+            <a:ext cx="3000000" cy="3000000"/>
+          </a:xfrm>
+          <a:prstGeom prst="rect">
+            <a:avLst/>
+          </a:prstGeom>
+          <a:noFill/>
+          <a:ln>
+            <a:noFill/>
+          </a:ln>
+        </p:spPr>
+        <p:txBody>
+          <a:bodyPr anchorCtr="0" anchor="t" bIns="45700" lIns="91425" spcFirstLastPara="1" rIns="91425" wrap="square" tIns="45700">
+            <a:noAutofit/>
+          </a:bodyPr>
+          <a:lstStyle/>
+          <a:p>
+            <a:pPr indent="0" lvl="0" marL="0" rtl="0" algn="l">
+              <a:spcBef>
+                <a:spcPts val="0"/>
+              </a:spcBef>
+              <a:spcAft>
+                <a:spcPts val="600"/>
+              </a:spcAft>
+              <a:buNone/>
+            </a:pPr>
+            <a:r>
+              <a:rPr lang="en-US"/>
+              <a:t>So what does that add up to?</a:t>
+            </a:r>
+          </a:p>
+          <a:p>
+            <a:pPr indent="0" lvl="0" marL="0" rtl="0" algn="l">
+              <a:spcBef>
+                <a:spcPts val="0"/>
+              </a:spcBef>
+              <a:spcAft>
+                <a:spcPts val="600"/>
+              </a:spcAft>
+              <a:buNone/>
+            </a:pPr>
+            <a:r>
+              <a:rPr lang="en-US"/>
+              <a:t>Restaurants start paying us in Year 2, and Year 5 is our first profitable year.</a:t>
+            </a:r>
+          </a:p>
+          <a:p>
+            <a:pPr indent="0" lvl="0" marL="0" rtl="0" algn="l">
+              <a:spcBef>
+                <a:spcPts val="0"/>
+              </a:spcBef>
+              <a:spcAft>
+                <a:spcPts val="600"/>
+              </a:spcAft>
+              <a:buNone/>
+            </a:pPr>
+            <a:r>
+              <a:rPr lang="en-US"/>
+              <a:t>Here’s how the numbers get there.</a:t>
+            </a:r>
+          </a:p>
+        </p:txBody>
+      </p:sp>
+      <p:sp>
+        <p:nvSpPr>
+          <p:cNvPr id="111" name="Google Shape;111;p2:notes"/>
+          <p:cNvSpPr txBox="1"/>
+          <p:nvPr>
+            <p:ph idx="12" type="sldNum"/>
+          </p:nvPr>
+        </p:nvSpPr>
+        <p:spPr>
+          <a:xfrm>
+            <a:off x="0" y="0"/>
+            <a:ext cx="3000000" cy="3000000"/>
+          </a:xfrm>
+          <a:prstGeom prst="rect">
+            <a:avLst/>
+          </a:prstGeom>
+          <a:noFill/>
+          <a:ln>
+            <a:noFill/>
+          </a:ln>
+        </p:spPr>
+        <p:txBody>
+          <a:bodyPr anchorCtr="0" anchor="ctr" bIns="91425" lIns="91425" spcFirstLastPara="1" rIns="91425" wrap="square" tIns="91425">
+            <a:noAutofit/>
+          </a:bodyPr>
+          <a:lstStyle/>
+          <a:p>
+            <a:pPr indent="0" lvl="0" marL="0" rtl="0" algn="l">
+              <a:spcBef>
+                <a:spcPts val="0"/>
+              </a:spcBef>
+              <a:spcAft>
+                <a:spcPts val="0"/>
+              </a:spcAft>
+              <a:buNone/>
+            </a:pPr>
+            <a:r>
+              <a:t/>
+            </a:r>
+            <a:endParaRPr/>
+          </a:p>
+        </p:txBody>
+      </p:sp>
+    </p:spTree>
+  </p:cSld>
+  <p:clrMapOvr>
+    <a:masterClrMapping/>
+  </p:clrMapOvr>
+</p:notes>
+</file>
+
+<file path=ppt/notesSlides/notesSlide13.xml><?xml version="1.0" encoding="utf-8"?>
+<p:notes xmlns:a="http://schemas.openxmlformats.org/drawingml/2006/main" xmlns:r="http://schemas.openxmlformats.org/officeDocument/2006/relationships" xmlns:mc="http://schemas.openxmlformats.org/markup-compatibility/2006" xmlns:mv="urn:schemas-microsoft-com:mac:vml" xmlns:p="http://schemas.openxmlformats.org/presentationml/2006/main" xmlns:c="http://schemas.openxmlformats.org/drawingml/2006/chart" xmlns:dgm="http://schemas.openxmlformats.org/drawingml/2006/diagram" xmlns:o="urn:schemas-microsoft-com:office:office" xmlns:v="urn:schemas-microsoft-com:vml" xmlns:pvml="urn:schemas-microsoft-com:office:powerpoint" xmlns:com="http://schemas.openxmlformats.org/drawingml/2006/compatibility" xmlns:p14="http://schemas.microsoft.com/office/powerpoint/2010/main" xmlns:p15="http://schemas.microsoft.com/office/powerpoint/2012/main" xmlns:ahyp="http://schemas.microsoft.com/office/drawing/2018/hyperlinkcolor" showMasterPhAnim="0" showMasterSp="0">
+  <p:cSld>
+    <p:spTree>
+      <p:nvGrpSpPr>
+        <p:cNvPr id="108" name="Shape 108"/>
+        <p:cNvGrpSpPr/>
+        <p:nvPr/>
+      </p:nvGrpSpPr>
+      <p:grpSpPr>
+        <a:xfrm>
+          <a:off x="0" y="0"/>
+          <a:ext cx="0" cy="0"/>
+          <a:chOff x="0" y="0"/>
+          <a:chExt cx="0" cy="0"/>
+        </a:xfrm>
+      </p:grpSpPr>
+      <p:sp>
+        <p:nvSpPr>
+          <p:cNvPr id="109" name="Google Shape;109;p2:notes"/>
+          <p:cNvSpPr/>
+          <p:nvPr>
+            <p:ph idx="2" type="sldImg"/>
+          </p:nvPr>
+        </p:nvSpPr>
+        <p:spPr>
+          <a:xfrm>
+            <a:off x="0" y="0"/>
+            <a:ext cx="3000000" cy="3000000"/>
+          </a:xfrm>
+          <a:custGeom>
+            <a:rect b="b" l="l" r="r" t="t"/>
+            <a:pathLst>
+              <a:path extrusionOk="0" h="120000" w="120000">
+                <a:moveTo>
+                  <a:pt x="0" y="0"/>
+                </a:moveTo>
+                <a:lnTo>
+                  <a:pt x="120000" y="0"/>
+                </a:lnTo>
+                <a:lnTo>
+                  <a:pt x="120000" y="120000"/>
+                </a:lnTo>
+                <a:lnTo>
+                  <a:pt x="0" y="120000"/>
+                </a:lnTo>
+                <a:close/>
+              </a:path>
+            </a:pathLst>
+          </a:custGeom>
+          <a:noFill/>
+          <a:ln>
+            <a:noFill/>
+          </a:ln>
+        </p:spPr>
+      </p:sp>
+      <p:sp>
+        <p:nvSpPr>
+          <p:cNvPr id="110" name="Google Shape;110;p2:notes"/>
+          <p:cNvSpPr txBox="1"/>
+          <p:nvPr>
+            <p:ph idx="1" type="body"/>
+          </p:nvPr>
+        </p:nvSpPr>
+        <p:spPr>
+          <a:xfrm>
+            <a:off x="0" y="0"/>
+            <a:ext cx="3000000" cy="3000000"/>
+          </a:xfrm>
+          <a:prstGeom prst="rect">
+            <a:avLst/>
+          </a:prstGeom>
+          <a:noFill/>
+          <a:ln>
+            <a:noFill/>
+          </a:ln>
+        </p:spPr>
+        <p:txBody>
+          <a:bodyPr anchorCtr="0" anchor="t" bIns="45700" lIns="91425" spcFirstLastPara="1" rIns="91425" wrap="square" tIns="45700">
+            <a:noAutofit/>
+          </a:bodyPr>
+          <a:lstStyle/>
+          <a:p>
+            <a:pPr indent="0" lvl="0" marL="0" rtl="0" algn="l">
+              <a:spcBef>
+                <a:spcPts val="0"/>
+              </a:spcBef>
+              <a:spcAft>
+                <a:spcPts val="600"/>
+              </a:spcAft>
+              <a:buNone/>
+            </a:pPr>
+            <a:r>
+              <a:rPr lang="en-US"/>
+              <a:t>To sum up.</a:t>
+            </a:r>
+          </a:p>
+          <a:p>
+            <a:pPr indent="0" lvl="0" marL="0" rtl="0" algn="l">
+              <a:spcBef>
+                <a:spcPts val="0"/>
+              </a:spcBef>
+              <a:spcAft>
+                <a:spcPts val="600"/>
+              </a:spcAft>
+              <a:buNone/>
+            </a:pPr>
+            <a:r>
+              <a:rPr lang="en-US"/>
+              <a:t>Boston students don’t trust the ratings they see, and checking five apps doesn’t fix it.</a:t>
+            </a:r>
+          </a:p>
+          <a:p>
+            <a:pPr indent="0" lvl="0" marL="0" rtl="0" algn="l">
+              <a:spcBef>
+                <a:spcPts val="0"/>
+              </a:spcBef>
+              <a:spcAft>
+                <a:spcPts val="600"/>
+              </a:spcAft>
+              <a:buNone/>
+            </a:pPr>
+            <a:r>
+              <a:rPr lang="en-US"/>
+              <a:t>Trust: we’re building one free app that only counts people who proved they ate there.</a:t>
+            </a:r>
+          </a:p>
+          <a:p>
+            <a:pPr indent="0" lvl="0" marL="0" rtl="0" algn="l">
+              <a:spcBef>
+                <a:spcPts val="0"/>
+              </a:spcBef>
+              <a:spcAft>
+                <a:spcPts val="600"/>
+              </a:spcAft>
+              <a:buNone/>
+            </a:pPr>
+            <a:r>
+              <a:rPr lang="en-US"/>
+              <a:t>Money: restaurants pay for the diners we send, so users never pay.</a:t>
+            </a:r>
+          </a:p>
+          <a:p>
+            <a:pPr indent="0" lvl="0" marL="0" rtl="0" algn="l">
+              <a:spcBef>
+                <a:spcPts val="0"/>
+              </a:spcBef>
+              <a:spcAft>
+                <a:spcPts val="600"/>
+              </a:spcAft>
+              <a:buNone/>
+            </a:pPr>
+            <a:r>
+              <a:rPr lang="en-US"/>
+              <a:t>Path: we start on grants, raise one angel round, and reach a profit in Year 5.</a:t>
+            </a:r>
+          </a:p>
+          <a:p>
+            <a:pPr indent="0" lvl="0" marL="0" rtl="0" algn="l">
+              <a:spcBef>
+                <a:spcPts val="0"/>
+              </a:spcBef>
+              <a:spcAft>
+                <a:spcPts val="600"/>
+              </a:spcAft>
+              <a:buNone/>
+            </a:pPr>
+            <a:r>
+              <a:rPr lang="en-US"/>
+              <a:t>Thank you. We’re happy to take questions.</a:t>
+            </a:r>
+          </a:p>
+        </p:txBody>
+      </p:sp>
+      <p:sp>
+        <p:nvSpPr>
+          <p:cNvPr id="111" name="Google Shape;111;p2:notes"/>
+          <p:cNvSpPr txBox="1"/>
+          <p:nvPr>
+            <p:ph idx="12" type="sldNum"/>
+          </p:nvPr>
+        </p:nvSpPr>
+        <p:spPr>
+          <a:xfrm>
+            <a:off x="0" y="0"/>
+            <a:ext cx="3000000" cy="3000000"/>
+          </a:xfrm>
+          <a:prstGeom prst="rect">
+            <a:avLst/>
+          </a:prstGeom>
+          <a:noFill/>
+          <a:ln>
+            <a:noFill/>
+          </a:ln>
+        </p:spPr>
+        <p:txBody>
+          <a:bodyPr anchorCtr="0" anchor="ctr" bIns="91425" lIns="91425" spcFirstLastPara="1" rIns="91425" wrap="square" tIns="91425">
+            <a:noAutofit/>
+          </a:bodyPr>
+          <a:lstStyle/>
+          <a:p>
+            <a:pPr indent="0" lvl="0" marL="0" rtl="0" algn="l">
+              <a:spcBef>
+                <a:spcPts val="0"/>
+              </a:spcBef>
+              <a:spcAft>
+                <a:spcPts val="0"/>
+              </a:spcAft>
+              <a:buNone/>
+            </a:pPr>
+            <a:r>
+              <a:t/>
+            </a:r>
+            <a:endParaRPr/>
+          </a:p>
+        </p:txBody>
+      </p:sp>
+    </p:spTree>
+  </p:cSld>
+  <p:clrMapOvr>
+    <a:masterClrMapping/>
+  </p:clrMapOvr>
+</p:notes>
+</file>
+
 <file path=ppt/notesSlides/notesSlide2.xml><?xml version="1.0" encoding="utf-8"?>
 <p:notes xmlns:a="http://schemas.openxmlformats.org/drawingml/2006/main" xmlns:r="http://schemas.openxmlformats.org/officeDocument/2006/relationships" xmlns:mc="http://schemas.openxmlformats.org/markup-compatibility/2006" xmlns:mv="urn:schemas-microsoft-com:mac:vml" xmlns:p="http://schemas.openxmlformats.org/presentationml/2006/main" xmlns:c="http://schemas.openxmlformats.org/drawingml/2006/chart" xmlns:dgm="http://schemas.openxmlformats.org/drawingml/2006/diagram" xmlns:o="urn:schemas-microsoft-com:office:office" xmlns:v="urn:schemas-microsoft-com:vml" xmlns:pvml="urn:schemas-microsoft-com:office:powerpoint" xmlns:com="http://schemas.openxmlformats.org/drawingml/2006/compatibility" xmlns:p14="http://schemas.microsoft.com/office/powerpoint/2010/main" xmlns:p15="http://schemas.microsoft.com/office/powerpoint/2012/main" xmlns:ahyp="http://schemas.microsoft.com/office/drawing/2018/hyperlinkcolor" showMasterPhAnim="0" showMasterSp="0">
   <p:cSld>
@@ -2744,7 +3151,7 @@
             </a:pPr>
             <a:r>
               <a:rPr lang="en-US"/>
-              <a:t>The trade-off is a smaller team, and it only works if restaurants sign up.</a:t>
+              <a:t>The trade-off is a smaller team, and it only works if restaurants sign up. Here’s what that means for us.</a:t>
             </a:r>
           </a:p>
         </p:txBody>
@@ -2894,7 +3301,7 @@
             </a:pPr>
             <a:r>
               <a:rPr lang="en-US"/>
-              <a:t>These are our numbers. Look at the three highlighted ones.</a:t>
+              <a:t>Here’s the detail. Look at the three highlighted numbers.</a:t>
             </a:r>
           </a:p>
           <a:p>
@@ -12670,7 +13077,7 @@
                 <a:cs typeface="Poppins"/>
                 <a:sym typeface="Poppins"/>
               </a:rPr>
-              <a:t>What we offer</a:t>
+              <a:t>Our idea</a:t>
             </a:r>
             <a:endParaRPr/>
           </a:p>
@@ -12738,7 +13145,7 @@
         <p:spPr>
           <a:xfrm>
             <a:off x="822960" y="1234440"/>
-            <a:ext cx="15087600" cy="2011680"/>
+            <a:ext cx="15087600" cy="1463040"/>
           </a:xfrm>
           <a:prstGeom prst="rect">
             <a:avLst/>
@@ -12776,7 +13183,7 @@
                 <a:cs typeface="Poppins"/>
                 <a:sym typeface="Poppins"/>
               </a:rPr>
-              <a:t>A free app that recommends where to eat and go out, </a:t>
+              <a:t xml:space="preserve">One free app for deciding where to eat, </a:t>
             </a:r>
             <a:r>
               <a:rPr b="0" i="0" lang="en-US" sz="4400" u="none" cap="none" strike="noStrike">
@@ -12788,7 +13195,7 @@
                 <a:cs typeface="Poppins"/>
                 <a:sym typeface="Poppins"/>
               </a:rPr>
-              <a:t>all in one simple-to-use platform.</a:t>
+              <a:t>with ratings you can trust.</a:t>
             </a:r>
             <a:endParaRPr/>
           </a:p>
@@ -13961,7 +14368,7 @@
                 <a:cs typeface="Poppins"/>
                 <a:sym typeface="Poppins"/>
               </a:rPr>
-              <a:t>How we'd raise it</a:t>
+              <a:t>How we’d fund it</a:t>
             </a:r>
             <a:endParaRPr/>
           </a:p>
@@ -14014,7 +14421,7 @@
                 <a:cs typeface="Poppins"/>
                 <a:sym typeface="Poppins"/>
               </a:rPr>
-              <a:t>10</a:t>
+              <a:t>11</a:t>
             </a:r>
             <a:endParaRPr/>
           </a:p>
@@ -15696,9 +16103,17 @@
 </p:sld>
 </file>
 
-<file path=ppt/slides/slide2.xml><?xml version="1.0" encoding="utf-8"?>
+<file path=ppt/slides/slide12.xml><?xml version="1.0" encoding="utf-8"?>
 <p:sld xmlns:a="http://schemas.openxmlformats.org/drawingml/2006/main" xmlns:r="http://schemas.openxmlformats.org/officeDocument/2006/relationships" xmlns:mc="http://schemas.openxmlformats.org/markup-compatibility/2006" xmlns:mv="urn:schemas-microsoft-com:mac:vml" xmlns:p="http://schemas.openxmlformats.org/presentationml/2006/main" xmlns:c="http://schemas.openxmlformats.org/drawingml/2006/chart" xmlns:dgm="http://schemas.openxmlformats.org/drawingml/2006/diagram" xmlns:o="urn:schemas-microsoft-com:office:office" xmlns:v="urn:schemas-microsoft-com:vml" xmlns:pvml="urn:schemas-microsoft-com:office:powerpoint" xmlns:com="http://schemas.openxmlformats.org/drawingml/2006/compatibility" xmlns:p14="http://schemas.microsoft.com/office/powerpoint/2010/main" xmlns:p15="http://schemas.microsoft.com/office/powerpoint/2012/main" xmlns:ahyp="http://schemas.microsoft.com/office/drawing/2018/hyperlinkcolor">
   <p:cSld>
+    <p:bg>
+      <p:bgPr>
+        <a:solidFill>
+          <a:srgbClr val="000000"/>
+        </a:solidFill>
+        <a:effectLst/>
+      </p:bgPr>
+    </p:bg>
     <p:spTree>
       <p:nvGrpSpPr>
         <p:cNvPr id="112" name="Shape 112"/>
@@ -15721,7 +16136,7 @@
         </p:nvSpPr>
         <p:spPr>
           <a:xfrm>
-            <a:off x="822960" y="685800"/>
+            <a:off x="822960" y="3017520"/>
             <a:ext cx="10972800" cy="411480"/>
           </a:xfrm>
           <a:prstGeom prst="rect">
@@ -15751,9 +16166,735 @@
               <a:buNone/>
             </a:pPr>
             <a:r>
+              <a:rPr b="0" i="0" lang="en-US" sz="2400" u="none" cap="none" strike="noStrike">
+                <a:solidFill>
+                  <a:srgbClr val="AAA676"/>
+                </a:solidFill>
+                <a:latin typeface="Poppins"/>
+                <a:ea typeface="Poppins"/>
+                <a:cs typeface="Poppins"/>
+                <a:sym typeface="Poppins"/>
+              </a:rPr>
+              <a:t>What it means</a:t>
+            </a:r>
+            <a:endParaRPr/>
+          </a:p>
+        </p:txBody>
+      </p:sp>
+      <p:sp>
+        <p:nvSpPr>
+          <p:cNvPr id="114" name="Google Shape;114;p2"/>
+          <p:cNvSpPr txBox="1"/>
+          <p:nvPr/>
+        </p:nvSpPr>
+        <p:spPr>
+          <a:xfrm>
+            <a:off x="16093440" y="685800"/>
+            <a:ext cx="1371600" cy="365760"/>
+          </a:xfrm>
+          <a:prstGeom prst="rect">
+            <a:avLst/>
+          </a:prstGeom>
+          <a:noFill/>
+          <a:ln>
+            <a:noFill/>
+          </a:ln>
+        </p:spPr>
+        <p:txBody>
+          <a:bodyPr anchorCtr="0" anchor="t" bIns="0" lIns="0" spcFirstLastPara="1" rIns="0" wrap="square" tIns="0">
+            <a:spAutoFit/>
+          </a:bodyPr>
+          <a:lstStyle/>
+          <a:p>
+            <a:pPr indent="0" lvl="0" marL="0" marR="0" rtl="0" algn="r">
+              <a:lnSpc>
+                <a:spcPct val="110000"/>
+              </a:lnSpc>
+              <a:spcBef>
+                <a:spcPts val="0"/>
+              </a:spcBef>
+              <a:spcAft>
+                <a:spcPts val="0"/>
+              </a:spcAft>
+              <a:buNone/>
+            </a:pPr>
+            <a:r>
+              <a:rPr b="0" i="0" lang="en-US" sz="1400" u="none" cap="none" strike="noStrike">
+                <a:solidFill>
+                  <a:srgbClr val="8C8C8C"/>
+                </a:solidFill>
+                <a:latin typeface="Poppins"/>
+                <a:ea typeface="Poppins"/>
+                <a:cs typeface="Poppins"/>
+                <a:sym typeface="Poppins"/>
+              </a:rPr>
+              <a:t>9</a:t>
+            </a:r>
+            <a:endParaRPr/>
+          </a:p>
+        </p:txBody>
+      </p:sp>
+      <p:sp>
+        <p:nvSpPr>
+          <p:cNvPr id="115" name="Google Shape;115;p2"/>
+          <p:cNvSpPr txBox="1"/>
+          <p:nvPr/>
+        </p:nvSpPr>
+        <p:spPr>
+          <a:xfrm>
+            <a:off x="822960" y="3611880"/>
+            <a:ext cx="14173200" cy="2377440"/>
+          </a:xfrm>
+          <a:prstGeom prst="rect">
+            <a:avLst/>
+          </a:prstGeom>
+          <a:noFill/>
+          <a:ln>
+            <a:noFill/>
+          </a:ln>
+        </p:spPr>
+        <p:txBody>
+          <a:bodyPr anchorCtr="0" anchor="t" bIns="0" lIns="0" spcFirstLastPara="1" rIns="0" wrap="square" tIns="0">
+            <a:spAutoFit/>
+          </a:bodyPr>
+          <a:lstStyle/>
+          <a:p>
+            <a:pPr indent="0" lvl="0" marL="0" marR="0" rtl="0" algn="l">
+              <a:lnSpc>
+                <a:spcPct val="108000"/>
+              </a:lnSpc>
+              <a:spcBef>
+                <a:spcPts val="0"/>
+              </a:spcBef>
+              <a:spcAft>
+                <a:spcPts val="0"/>
+              </a:spcAft>
+              <a:buNone/>
+            </a:pPr>
+            <a:r>
+              <a:rPr b="0" i="0" lang="en-US" sz="6000" u="none" cap="none" strike="noStrike">
+                <a:solidFill>
+                  <a:srgbClr val="FFFFFF"/>
+                </a:solidFill>
+                <a:latin typeface="Poppins"/>
+                <a:ea typeface="Poppins"/>
+                <a:cs typeface="Poppins"/>
+                <a:sym typeface="Poppins"/>
+              </a:rPr>
+              <a:t xml:space="preserve">Restaurants start paying us in Year 2, </a:t>
+            </a:r>
+            <a:r>
+              <a:rPr b="0" i="0" lang="en-US" sz="6000" u="none" cap="none" strike="noStrike">
+                <a:solidFill>
+                  <a:srgbClr val="AAA676"/>
+                </a:solidFill>
+                <a:latin typeface="Poppins"/>
+                <a:ea typeface="Poppins"/>
+                <a:cs typeface="Poppins"/>
+                <a:sym typeface="Poppins"/>
+              </a:rPr>
+              <a:t>and Year 5 is our first profit.</a:t>
+            </a:r>
+            <a:endParaRPr/>
+          </a:p>
+        </p:txBody>
+      </p:sp>
+    </p:spTree>
+  </p:cSld>
+  <p:clrMapOvr>
+    <a:masterClrMapping/>
+  </p:clrMapOvr>
+</p:sld>
+</file>
+
+<file path=ppt/slides/slide13.xml><?xml version="1.0" encoding="utf-8"?>
+<p:sld xmlns:a="http://schemas.openxmlformats.org/drawingml/2006/main" xmlns:r="http://schemas.openxmlformats.org/officeDocument/2006/relationships" xmlns:mc="http://schemas.openxmlformats.org/markup-compatibility/2006" xmlns:mv="urn:schemas-microsoft-com:mac:vml" xmlns:p="http://schemas.openxmlformats.org/presentationml/2006/main" xmlns:c="http://schemas.openxmlformats.org/drawingml/2006/chart" xmlns:dgm="http://schemas.openxmlformats.org/drawingml/2006/diagram" xmlns:o="urn:schemas-microsoft-com:office:office" xmlns:v="urn:schemas-microsoft-com:vml" xmlns:pvml="urn:schemas-microsoft-com:office:powerpoint" xmlns:com="http://schemas.openxmlformats.org/drawingml/2006/compatibility" xmlns:p14="http://schemas.microsoft.com/office/powerpoint/2010/main" xmlns:p15="http://schemas.microsoft.com/office/powerpoint/2012/main" xmlns:ahyp="http://schemas.microsoft.com/office/drawing/2018/hyperlinkcolor">
+  <p:cSld>
+    <p:bg>
+      <p:bgPr>
+        <a:solidFill>
+          <a:srgbClr val="AAA676"/>
+        </a:solidFill>
+        <a:effectLst/>
+      </p:bgPr>
+    </p:bg>
+    <p:spTree>
+      <p:nvGrpSpPr>
+        <p:cNvPr id="112" name="Shape 112"/>
+        <p:cNvGrpSpPr/>
+        <p:nvPr/>
+      </p:nvGrpSpPr>
+      <p:grpSpPr>
+        <a:xfrm>
+          <a:off x="0" y="0"/>
+          <a:ext cx="0" cy="0"/>
+          <a:chOff x="0" y="0"/>
+          <a:chExt cx="0" cy="0"/>
+        </a:xfrm>
+      </p:grpSpPr>
+      <p:sp>
+        <p:nvSpPr>
+          <p:cNvPr id="113" name="Google Shape;113;p2"/>
+          <p:cNvSpPr txBox="1"/>
+          <p:nvPr/>
+        </p:nvSpPr>
+        <p:spPr>
+          <a:xfrm>
+            <a:off x="822960" y="685800"/>
+            <a:ext cx="10972800" cy="411480"/>
+          </a:xfrm>
+          <a:prstGeom prst="rect">
+            <a:avLst/>
+          </a:prstGeom>
+          <a:noFill/>
+          <a:ln>
+            <a:noFill/>
+          </a:ln>
+        </p:spPr>
+        <p:txBody>
+          <a:bodyPr anchorCtr="0" anchor="t" bIns="0" lIns="0" spcFirstLastPara="1" rIns="0" wrap="square" tIns="0">
+            <a:spAutoFit/>
+          </a:bodyPr>
+          <a:lstStyle/>
+          <a:p>
+            <a:pPr indent="0" lvl="0" marL="0" marR="0" rtl="0" algn="l">
+              <a:lnSpc>
+                <a:spcPct val="110000"/>
+              </a:lnSpc>
+              <a:spcBef>
+                <a:spcPts val="0"/>
+              </a:spcBef>
+              <a:spcAft>
+                <a:spcPts val="0"/>
+              </a:spcAft>
+              <a:buNone/>
+            </a:pPr>
+            <a:r>
               <a:rPr b="0" i="0" lang="en-US" sz="1800" u="none" cap="none" strike="noStrike">
                 <a:solidFill>
-                  <a:srgbClr val="6F6B34"/>
+                  <a:srgbClr val="2E2D12"/>
+                </a:solidFill>
+                <a:latin typeface="Poppins"/>
+                <a:ea typeface="Poppins"/>
+                <a:cs typeface="Poppins"/>
+                <a:sym typeface="Poppins"/>
+              </a:rPr>
+              <a:t>In summary</a:t>
+            </a:r>
+            <a:endParaRPr/>
+          </a:p>
+        </p:txBody>
+      </p:sp>
+      <p:sp>
+        <p:nvSpPr>
+          <p:cNvPr id="114" name="Google Shape;114;p2"/>
+          <p:cNvSpPr txBox="1"/>
+          <p:nvPr/>
+        </p:nvSpPr>
+        <p:spPr>
+          <a:xfrm>
+            <a:off x="16093440" y="685800"/>
+            <a:ext cx="1371600" cy="365760"/>
+          </a:xfrm>
+          <a:prstGeom prst="rect">
+            <a:avLst/>
+          </a:prstGeom>
+          <a:noFill/>
+          <a:ln>
+            <a:noFill/>
+          </a:ln>
+        </p:spPr>
+        <p:txBody>
+          <a:bodyPr anchorCtr="0" anchor="t" bIns="0" lIns="0" spcFirstLastPara="1" rIns="0" wrap="square" tIns="0">
+            <a:spAutoFit/>
+          </a:bodyPr>
+          <a:lstStyle/>
+          <a:p>
+            <a:pPr indent="0" lvl="0" marL="0" marR="0" rtl="0" algn="r">
+              <a:lnSpc>
+                <a:spcPct val="110000"/>
+              </a:lnSpc>
+              <a:spcBef>
+                <a:spcPts val="0"/>
+              </a:spcBef>
+              <a:spcAft>
+                <a:spcPts val="0"/>
+              </a:spcAft>
+              <a:buNone/>
+            </a:pPr>
+            <a:r>
+              <a:rPr b="0" i="0" lang="en-US" sz="1400" u="none" cap="none" strike="noStrike">
+                <a:solidFill>
+                  <a:srgbClr val="1F1F1F"/>
+                </a:solidFill>
+                <a:latin typeface="Poppins"/>
+                <a:ea typeface="Poppins"/>
+                <a:cs typeface="Poppins"/>
+                <a:sym typeface="Poppins"/>
+              </a:rPr>
+              <a:t>12</a:t>
+            </a:r>
+            <a:endParaRPr/>
+          </a:p>
+        </p:txBody>
+      </p:sp>
+      <p:sp>
+        <p:nvSpPr>
+          <p:cNvPr id="115" name="Google Shape;115;p2"/>
+          <p:cNvSpPr txBox="1"/>
+          <p:nvPr/>
+        </p:nvSpPr>
+        <p:spPr>
+          <a:xfrm>
+            <a:off x="822960" y="1234440"/>
+            <a:ext cx="15087600" cy="2011680"/>
+          </a:xfrm>
+          <a:prstGeom prst="rect">
+            <a:avLst/>
+          </a:prstGeom>
+          <a:noFill/>
+          <a:ln>
+            <a:noFill/>
+          </a:ln>
+        </p:spPr>
+        <p:txBody>
+          <a:bodyPr anchorCtr="0" anchor="t" bIns="0" lIns="0" spcFirstLastPara="1" rIns="0" wrap="square" tIns="0">
+            <a:spAutoFit/>
+          </a:bodyPr>
+          <a:lstStyle/>
+          <a:p>
+            <a:pPr indent="0" lvl="0" marL="0" marR="0" rtl="0" algn="l">
+              <a:lnSpc>
+                <a:spcPct val="108000"/>
+              </a:lnSpc>
+              <a:spcBef>
+                <a:spcPts val="0"/>
+              </a:spcBef>
+              <a:spcAft>
+                <a:spcPts val="0"/>
+              </a:spcAft>
+              <a:buNone/>
+            </a:pPr>
+            <a:r>
+              <a:rPr b="0" i="0" lang="en-US" sz="4400" u="none" cap="none" strike="noStrike">
+                <a:solidFill>
+                  <a:srgbClr val="000000"/>
+                </a:solidFill>
+                <a:latin typeface="Poppins"/>
+                <a:ea typeface="Poppins"/>
+                <a:cs typeface="Poppins"/>
+                <a:sym typeface="Poppins"/>
+              </a:rPr>
+              <a:t xml:space="preserve">Boston students can’t trust the ratings. </a:t>
+            </a:r>
+            <a:r>
+              <a:rPr b="0" i="0" lang="en-US" sz="4400" u="none" cap="none" strike="noStrike">
+                <a:solidFill>
+                  <a:srgbClr val="2E2D12"/>
+                </a:solidFill>
+                <a:latin typeface="Poppins"/>
+                <a:ea typeface="Poppins"/>
+                <a:cs typeface="Poppins"/>
+                <a:sym typeface="Poppins"/>
+              </a:rPr>
+              <a:t>We’re building the one app they can.</a:t>
+            </a:r>
+            <a:endParaRPr/>
+          </a:p>
+        </p:txBody>
+      </p:sp>
+      <p:sp>
+        <p:nvSpPr>
+          <p:cNvPr id="900" name="Google Shape;900;p2"/>
+          <p:cNvSpPr txBox="1"/>
+          <p:nvPr/>
+        </p:nvSpPr>
+        <p:spPr>
+          <a:xfrm>
+            <a:off x="822960" y="4206240"/>
+            <a:ext cx="5120640" cy="411480"/>
+          </a:xfrm>
+          <a:prstGeom prst="rect">
+            <a:avLst/>
+          </a:prstGeom>
+          <a:noFill/>
+          <a:ln>
+            <a:noFill/>
+          </a:ln>
+        </p:spPr>
+        <p:txBody>
+          <a:bodyPr anchorCtr="0" anchor="t" bIns="0" lIns="0" spcFirstLastPara="1" rIns="0" wrap="square" tIns="0">
+            <a:spAutoFit/>
+          </a:bodyPr>
+          <a:lstStyle/>
+          <a:p>
+            <a:pPr indent="0" lvl="0" marL="0" marR="0" rtl="0" algn="l">
+              <a:lnSpc>
+                <a:spcPct val="110000"/>
+              </a:lnSpc>
+              <a:spcBef>
+                <a:spcPts val="0"/>
+              </a:spcBef>
+              <a:spcAft>
+                <a:spcPts val="0"/>
+              </a:spcAft>
+              <a:buNone/>
+            </a:pPr>
+            <a:r>
+              <a:rPr b="1" i="0" lang="en-US" sz="2400" u="none" cap="none" strike="noStrike">
+                <a:solidFill>
+                  <a:srgbClr val="2E2D12"/>
+                </a:solidFill>
+                <a:latin typeface="Poppins"/>
+                <a:ea typeface="Poppins"/>
+                <a:cs typeface="Poppins"/>
+                <a:sym typeface="Poppins"/>
+              </a:rPr>
+              <a:t>Trust</a:t>
+            </a:r>
+            <a:endParaRPr/>
+          </a:p>
+        </p:txBody>
+      </p:sp>
+      <p:sp>
+        <p:nvSpPr>
+          <p:cNvPr id="901" name="Google Shape;901;p2"/>
+          <p:cNvSpPr txBox="1"/>
+          <p:nvPr/>
+        </p:nvSpPr>
+        <p:spPr>
+          <a:xfrm>
+            <a:off x="822960" y="4800600"/>
+            <a:ext cx="4937760" cy="1828800"/>
+          </a:xfrm>
+          <a:prstGeom prst="rect">
+            <a:avLst/>
+          </a:prstGeom>
+          <a:noFill/>
+          <a:ln>
+            <a:noFill/>
+          </a:ln>
+        </p:spPr>
+        <p:txBody>
+          <a:bodyPr anchorCtr="0" anchor="t" bIns="0" lIns="0" spcFirstLastPara="1" rIns="0" wrap="square" tIns="0">
+            <a:spAutoFit/>
+          </a:bodyPr>
+          <a:lstStyle/>
+          <a:p>
+            <a:pPr indent="0" lvl="0" marL="0" marR="0" rtl="0" algn="l">
+              <a:lnSpc>
+                <a:spcPct val="110000"/>
+              </a:lnSpc>
+              <a:spcBef>
+                <a:spcPts val="0"/>
+              </a:spcBef>
+              <a:spcAft>
+                <a:spcPts val="0"/>
+              </a:spcAft>
+              <a:buNone/>
+            </a:pPr>
+            <a:r>
+              <a:rPr b="0" i="0" lang="en-US" sz="3000" u="none" cap="none" strike="noStrike">
+                <a:solidFill>
+                  <a:srgbClr val="000000"/>
+                </a:solidFill>
+                <a:latin typeface="Poppins"/>
+                <a:ea typeface="Poppins"/>
+                <a:cs typeface="Poppins"/>
+                <a:sym typeface="Poppins"/>
+              </a:rPr>
+              <a:t>Only diners who proved they ate there count toward our score.</a:t>
+            </a:r>
+            <a:endParaRPr/>
+          </a:p>
+        </p:txBody>
+      </p:sp>
+      <p:sp>
+        <p:nvSpPr>
+          <p:cNvPr id="902" name="Google Shape;902;p2"/>
+          <p:cNvSpPr txBox="1"/>
+          <p:nvPr/>
+        </p:nvSpPr>
+        <p:spPr>
+          <a:xfrm>
+            <a:off x="6492240" y="4206240"/>
+            <a:ext cx="5120640" cy="411480"/>
+          </a:xfrm>
+          <a:prstGeom prst="rect">
+            <a:avLst/>
+          </a:prstGeom>
+          <a:noFill/>
+          <a:ln>
+            <a:noFill/>
+          </a:ln>
+        </p:spPr>
+        <p:txBody>
+          <a:bodyPr anchorCtr="0" anchor="t" bIns="0" lIns="0" spcFirstLastPara="1" rIns="0" wrap="square" tIns="0">
+            <a:spAutoFit/>
+          </a:bodyPr>
+          <a:lstStyle/>
+          <a:p>
+            <a:pPr indent="0" lvl="0" marL="0" marR="0" rtl="0" algn="l">
+              <a:lnSpc>
+                <a:spcPct val="110000"/>
+              </a:lnSpc>
+              <a:spcBef>
+                <a:spcPts val="0"/>
+              </a:spcBef>
+              <a:spcAft>
+                <a:spcPts val="0"/>
+              </a:spcAft>
+              <a:buNone/>
+            </a:pPr>
+            <a:r>
+              <a:rPr b="1" i="0" lang="en-US" sz="2400" u="none" cap="none" strike="noStrike">
+                <a:solidFill>
+                  <a:srgbClr val="2E2D12"/>
+                </a:solidFill>
+                <a:latin typeface="Poppins"/>
+                <a:ea typeface="Poppins"/>
+                <a:cs typeface="Poppins"/>
+                <a:sym typeface="Poppins"/>
+              </a:rPr>
+              <a:t>Money</a:t>
+            </a:r>
+            <a:endParaRPr/>
+          </a:p>
+        </p:txBody>
+      </p:sp>
+      <p:sp>
+        <p:nvSpPr>
+          <p:cNvPr id="903" name="Google Shape;903;p2"/>
+          <p:cNvSpPr txBox="1"/>
+          <p:nvPr/>
+        </p:nvSpPr>
+        <p:spPr>
+          <a:xfrm>
+            <a:off x="6492240" y="4800600"/>
+            <a:ext cx="4937760" cy="1828800"/>
+          </a:xfrm>
+          <a:prstGeom prst="rect">
+            <a:avLst/>
+          </a:prstGeom>
+          <a:noFill/>
+          <a:ln>
+            <a:noFill/>
+          </a:ln>
+        </p:spPr>
+        <p:txBody>
+          <a:bodyPr anchorCtr="0" anchor="t" bIns="0" lIns="0" spcFirstLastPara="1" rIns="0" wrap="square" tIns="0">
+            <a:spAutoFit/>
+          </a:bodyPr>
+          <a:lstStyle/>
+          <a:p>
+            <a:pPr indent="0" lvl="0" marL="0" marR="0" rtl="0" algn="l">
+              <a:lnSpc>
+                <a:spcPct val="110000"/>
+              </a:lnSpc>
+              <a:spcBef>
+                <a:spcPts val="0"/>
+              </a:spcBef>
+              <a:spcAft>
+                <a:spcPts val="0"/>
+              </a:spcAft>
+              <a:buNone/>
+            </a:pPr>
+            <a:r>
+              <a:rPr b="0" i="0" lang="en-US" sz="3000" u="none" cap="none" strike="noStrike">
+                <a:solidFill>
+                  <a:srgbClr val="000000"/>
+                </a:solidFill>
+                <a:latin typeface="Poppins"/>
+                <a:ea typeface="Poppins"/>
+                <a:cs typeface="Poppins"/>
+                <a:sym typeface="Poppins"/>
+              </a:rPr>
+              <a:t>Restaurants pay for the diners we send. Users never pay.</a:t>
+            </a:r>
+            <a:endParaRPr/>
+          </a:p>
+        </p:txBody>
+      </p:sp>
+      <p:sp>
+        <p:nvSpPr>
+          <p:cNvPr id="904" name="Google Shape;904;p2"/>
+          <p:cNvSpPr txBox="1"/>
+          <p:nvPr/>
+        </p:nvSpPr>
+        <p:spPr>
+          <a:xfrm>
+            <a:off x="12161520" y="4206240"/>
+            <a:ext cx="5120640" cy="411480"/>
+          </a:xfrm>
+          <a:prstGeom prst="rect">
+            <a:avLst/>
+          </a:prstGeom>
+          <a:noFill/>
+          <a:ln>
+            <a:noFill/>
+          </a:ln>
+        </p:spPr>
+        <p:txBody>
+          <a:bodyPr anchorCtr="0" anchor="t" bIns="0" lIns="0" spcFirstLastPara="1" rIns="0" wrap="square" tIns="0">
+            <a:spAutoFit/>
+          </a:bodyPr>
+          <a:lstStyle/>
+          <a:p>
+            <a:pPr indent="0" lvl="0" marL="0" marR="0" rtl="0" algn="l">
+              <a:lnSpc>
+                <a:spcPct val="110000"/>
+              </a:lnSpc>
+              <a:spcBef>
+                <a:spcPts val="0"/>
+              </a:spcBef>
+              <a:spcAft>
+                <a:spcPts val="0"/>
+              </a:spcAft>
+              <a:buNone/>
+            </a:pPr>
+            <a:r>
+              <a:rPr b="1" i="0" lang="en-US" sz="2400" u="none" cap="none" strike="noStrike">
+                <a:solidFill>
+                  <a:srgbClr val="2E2D12"/>
+                </a:solidFill>
+                <a:latin typeface="Poppins"/>
+                <a:ea typeface="Poppins"/>
+                <a:cs typeface="Poppins"/>
+                <a:sym typeface="Poppins"/>
+              </a:rPr>
+              <a:t>Path</a:t>
+            </a:r>
+            <a:endParaRPr/>
+          </a:p>
+        </p:txBody>
+      </p:sp>
+      <p:sp>
+        <p:nvSpPr>
+          <p:cNvPr id="905" name="Google Shape;905;p2"/>
+          <p:cNvSpPr txBox="1"/>
+          <p:nvPr/>
+        </p:nvSpPr>
+        <p:spPr>
+          <a:xfrm>
+            <a:off x="12161520" y="4800600"/>
+            <a:ext cx="4937760" cy="1828800"/>
+          </a:xfrm>
+          <a:prstGeom prst="rect">
+            <a:avLst/>
+          </a:prstGeom>
+          <a:noFill/>
+          <a:ln>
+            <a:noFill/>
+          </a:ln>
+        </p:spPr>
+        <p:txBody>
+          <a:bodyPr anchorCtr="0" anchor="t" bIns="0" lIns="0" spcFirstLastPara="1" rIns="0" wrap="square" tIns="0">
+            <a:spAutoFit/>
+          </a:bodyPr>
+          <a:lstStyle/>
+          <a:p>
+            <a:pPr indent="0" lvl="0" marL="0" marR="0" rtl="0" algn="l">
+              <a:lnSpc>
+                <a:spcPct val="110000"/>
+              </a:lnSpc>
+              <a:spcBef>
+                <a:spcPts val="0"/>
+              </a:spcBef>
+              <a:spcAft>
+                <a:spcPts val="0"/>
+              </a:spcAft>
+              <a:buNone/>
+            </a:pPr>
+            <a:r>
+              <a:rPr b="0" i="0" lang="en-US" sz="3000" u="none" cap="none" strike="noStrike">
+                <a:solidFill>
+                  <a:srgbClr val="000000"/>
+                </a:solidFill>
+                <a:latin typeface="Poppins"/>
+                <a:ea typeface="Poppins"/>
+                <a:cs typeface="Poppins"/>
+                <a:sym typeface="Poppins"/>
+              </a:rPr>
+              <a:t>Grants first, then one angel round. Profit in Year 5.</a:t>
+            </a:r>
+            <a:endParaRPr/>
+          </a:p>
+        </p:txBody>
+      </p:sp>
+    </p:spTree>
+  </p:cSld>
+  <p:clrMapOvr>
+    <a:masterClrMapping/>
+  </p:clrMapOvr>
+</p:sld>
+</file>
+
+<file path=ppt/slides/slide2.xml><?xml version="1.0" encoding="utf-8"?>
+<p:sld xmlns:a="http://schemas.openxmlformats.org/drawingml/2006/main" xmlns:r="http://schemas.openxmlformats.org/officeDocument/2006/relationships" xmlns:mc="http://schemas.openxmlformats.org/markup-compatibility/2006" xmlns:mv="urn:schemas-microsoft-com:mac:vml" xmlns:p="http://schemas.openxmlformats.org/presentationml/2006/main" xmlns:c="http://schemas.openxmlformats.org/drawingml/2006/chart" xmlns:dgm="http://schemas.openxmlformats.org/drawingml/2006/diagram" xmlns:o="urn:schemas-microsoft-com:office:office" xmlns:v="urn:schemas-microsoft-com:vml" xmlns:pvml="urn:schemas-microsoft-com:office:powerpoint" xmlns:com="http://schemas.openxmlformats.org/drawingml/2006/compatibility" xmlns:p14="http://schemas.microsoft.com/office/powerpoint/2010/main" xmlns:p15="http://schemas.microsoft.com/office/powerpoint/2012/main" xmlns:ahyp="http://schemas.microsoft.com/office/drawing/2018/hyperlinkcolor">
+  <p:cSld>
+    <p:bg>
+      <p:bgPr>
+        <a:solidFill>
+          <a:srgbClr val="AAA676"/>
+        </a:solidFill>
+        <a:effectLst/>
+      </p:bgPr>
+    </p:bg>
+    <p:spTree>
+      <p:nvGrpSpPr>
+        <p:cNvPr id="112" name="Shape 112"/>
+        <p:cNvGrpSpPr/>
+        <p:nvPr/>
+      </p:nvGrpSpPr>
+      <p:grpSpPr>
+        <a:xfrm>
+          <a:off x="0" y="0"/>
+          <a:ext cx="0" cy="0"/>
+          <a:chOff x="0" y="0"/>
+          <a:chExt cx="0" cy="0"/>
+        </a:xfrm>
+      </p:grpSpPr>
+      <p:sp>
+        <p:nvSpPr>
+          <p:cNvPr id="113" name="Google Shape;113;p2"/>
+          <p:cNvSpPr txBox="1"/>
+          <p:nvPr/>
+        </p:nvSpPr>
+        <p:spPr>
+          <a:xfrm>
+            <a:off x="822960" y="685800"/>
+            <a:ext cx="10972800" cy="411480"/>
+          </a:xfrm>
+          <a:prstGeom prst="rect">
+            <a:avLst/>
+          </a:prstGeom>
+          <a:noFill/>
+          <a:ln>
+            <a:noFill/>
+          </a:ln>
+        </p:spPr>
+        <p:txBody>
+          <a:bodyPr anchorCtr="0" anchor="t" bIns="0" lIns="0" spcFirstLastPara="1" rIns="0" wrap="square" tIns="0">
+            <a:spAutoFit/>
+          </a:bodyPr>
+          <a:lstStyle/>
+          <a:p>
+            <a:pPr indent="0" lvl="0" marL="0" marR="0" rtl="0" algn="l">
+              <a:lnSpc>
+                <a:spcPct val="110000"/>
+              </a:lnSpc>
+              <a:spcBef>
+                <a:spcPts val="0"/>
+              </a:spcBef>
+              <a:spcAft>
+                <a:spcPts val="0"/>
+              </a:spcAft>
+              <a:buNone/>
+            </a:pPr>
+            <a:r>
+              <a:rPr b="0" i="0" lang="en-US" sz="1800" u="none" cap="none" strike="noStrike">
+                <a:solidFill>
+                  <a:srgbClr val="2E2D12"/>
                 </a:solidFill>
                 <a:latin typeface="Poppins"/>
                 <a:ea typeface="Poppins"/>
@@ -15806,7 +16947,7 @@
             <a:r>
               <a:rPr b="0" i="0" lang="en-US" sz="1400" u="none" cap="none" strike="noStrike">
                 <a:solidFill>
-                  <a:srgbClr val="595959"/>
+                  <a:srgbClr val="1F1F1F"/>
                 </a:solidFill>
                 <a:latin typeface="Poppins"/>
                 <a:ea typeface="Poppins"/>
@@ -15871,7 +17012,7 @@
             <a:r>
               <a:rPr b="0" i="0" lang="en-US" sz="4400" u="none" cap="none" strike="noStrike">
                 <a:solidFill>
-                  <a:srgbClr val="595959"/>
+                  <a:srgbClr val="2E2D12"/>
                 </a:solidFill>
                 <a:latin typeface="Poppins"/>
                 <a:ea typeface="Poppins"/>
@@ -15924,7 +17065,7 @@
             <a:r>
               <a:rPr b="0" i="0" lang="en-US" sz="1400" u="none" cap="none" strike="noStrike">
                 <a:solidFill>
-                  <a:srgbClr val="595959"/>
+                  <a:srgbClr val="2E2D12"/>
                 </a:solidFill>
                 <a:latin typeface="Roboto Mono"/>
                 <a:ea typeface="Roboto Mono"/>
@@ -15952,7 +17093,7 @@
             <a:avLst/>
           </a:prstGeom>
           <a:solidFill>
-            <a:srgbClr val="6F6B34"/>
+            <a:srgbClr val="2E2D12"/>
           </a:solidFill>
           <a:ln>
             <a:noFill/>
@@ -16035,7 +17176,7 @@
             <a:r>
               <a:rPr b="0" i="0" lang="en-US" sz="6600" u="none" cap="none" strike="noStrike">
                 <a:solidFill>
-                  <a:srgbClr val="6F6B34"/>
+                  <a:srgbClr val="2E2D12"/>
                 </a:solidFill>
                 <a:latin typeface="Poppins"/>
                 <a:ea typeface="Poppins"/>
@@ -16141,7 +17282,7 @@
             <a:r>
               <a:rPr b="0" i="0" lang="en-US" sz="2400" u="none" cap="none" strike="noStrike">
                 <a:solidFill>
-                  <a:srgbClr val="434343"/>
+                  <a:srgbClr val="1F1F1F"/>
                 </a:solidFill>
                 <a:latin typeface="Poppins"/>
                 <a:ea typeface="Poppins"/>
@@ -16194,7 +17335,7 @@
             <a:r>
               <a:rPr b="0" i="0" lang="en-US" sz="6600" u="none" cap="none" strike="noStrike">
                 <a:solidFill>
-                  <a:srgbClr val="6F6B34"/>
+                  <a:srgbClr val="2E2D12"/>
                 </a:solidFill>
                 <a:latin typeface="Poppins"/>
                 <a:ea typeface="Poppins"/>
@@ -16300,7 +17441,7 @@
             <a:r>
               <a:rPr b="0" i="0" lang="en-US" sz="2400" u="none" cap="none" strike="noStrike">
                 <a:solidFill>
-                  <a:srgbClr val="434343"/>
+                  <a:srgbClr val="1F1F1F"/>
                 </a:solidFill>
                 <a:latin typeface="Poppins"/>
                 <a:ea typeface="Poppins"/>
@@ -16353,7 +17494,7 @@
             <a:r>
               <a:rPr b="0" i="0" lang="en-US" sz="6600" u="none" cap="none" strike="noStrike">
                 <a:solidFill>
-                  <a:srgbClr val="6F6B34"/>
+                  <a:srgbClr val="2E2D12"/>
                 </a:solidFill>
                 <a:latin typeface="Poppins"/>
                 <a:ea typeface="Poppins"/>
@@ -16459,7 +17600,7 @@
             <a:r>
               <a:rPr b="0" i="0" lang="en-US" sz="2400" u="none" cap="none" strike="noStrike">
                 <a:solidFill>
-                  <a:srgbClr val="434343"/>
+                  <a:srgbClr val="1F1F1F"/>
                 </a:solidFill>
                 <a:latin typeface="Poppins"/>
                 <a:ea typeface="Poppins"/>
@@ -16724,7 +17865,7 @@
             <a:r>
               <a:rPr b="0" i="0" lang="en-US" sz="2400" u="none" cap="none" strike="noStrike">
                 <a:solidFill>
-                  <a:srgbClr val="434343"/>
+                  <a:srgbClr val="1F1F1F"/>
                 </a:solidFill>
                 <a:latin typeface="Poppins"/>
                 <a:ea typeface="Poppins"/>
@@ -16809,7 +17950,7 @@
                 <a:cs typeface="Poppins"/>
                 <a:sym typeface="Poppins"/>
               </a:rPr>
-              <a:t>What's in the app</a:t>
+              <a:t>What we’re building</a:t>
             </a:r>
             <a:endParaRPr/>
           </a:p>
@@ -16877,7 +18018,7 @@
         <p:spPr>
           <a:xfrm>
             <a:off x="822960" y="1208965"/>
-            <a:ext cx="15087600" cy="677400"/>
+            <a:ext cx="15087600" cy="1463040"/>
           </a:xfrm>
           <a:prstGeom prst="rect">
             <a:avLst/>
@@ -16915,7 +18056,19 @@
                 <a:cs typeface="Poppins"/>
                 <a:sym typeface="Poppins"/>
               </a:rPr>
-              <a:t>Everything about where to eat, in one app.</a:t>
+              <a:t xml:space="preserve">One page for every restaurant, </a:t>
+            </a:r>
+            <a:r>
+              <a:rPr b="0" i="0" lang="en-US" sz="4400" u="none" cap="none" strike="noStrike">
+                <a:solidFill>
+                  <a:srgbClr val="595959"/>
+                </a:solidFill>
+                <a:latin typeface="Poppins"/>
+                <a:ea typeface="Poppins"/>
+                <a:cs typeface="Poppins"/>
+                <a:sym typeface="Poppins"/>
+              </a:rPr>
+              <a:t>and a score that only counts people who ate there.</a:t>
             </a:r>
             <a:endParaRPr/>
           </a:p>
@@ -18416,7 +19569,7 @@
                 <a:cs typeface="Poppins"/>
                 <a:sym typeface="Poppins"/>
               </a:rPr>
-              <a:t>How big it is</a:t>
+              <a:t>Why it matters</a:t>
             </a:r>
             <a:endParaRPr/>
           </a:p>
@@ -19518,7 +20671,7 @@
                 <a:cs typeface="Poppins"/>
                 <a:sym typeface="Poppins"/>
               </a:rPr>
-              <a:t>How we get users</a:t>
+              <a:t>How we win users</a:t>
             </a:r>
             <a:endParaRPr/>
           </a:p>
@@ -20635,7 +21788,7 @@
                 <a:cs typeface="Poppins"/>
                 <a:sym typeface="Poppins"/>
               </a:rPr>
-              <a:t>Why restaurants pay</a:t>
+              <a:t>How we make money</a:t>
             </a:r>
             <a:endParaRPr/>
           </a:p>
@@ -22914,7 +24067,7 @@
                 <a:cs typeface="Poppins"/>
                 <a:sym typeface="Poppins"/>
               </a:rPr>
-              <a:t>9</a:t>
+              <a:t>10</a:t>
             </a:r>
             <a:endParaRPr/>
           </a:p>
@@ -22929,7 +24082,7 @@
         <p:spPr>
           <a:xfrm>
             <a:off x="822960" y="1234440"/>
-            <a:ext cx="15087600" cy="2011680"/>
+            <a:ext cx="15087600" cy="1463040"/>
           </a:xfrm>
           <a:prstGeom prst="rect">
             <a:avLst/>
@@ -22967,7 +24120,7 @@
                 <a:cs typeface="Poppins"/>
                 <a:sym typeface="Poppins"/>
               </a:rPr>
-              <a:t>We spend about $11K a quarter for two years. </a:t>
+              <a:t xml:space="preserve">We spend about $11K a quarter for two years. </a:t>
             </a:r>
             <a:r>
               <a:rPr b="0" i="0" lang="en-US" sz="4400" u="none" cap="none" strike="noStrike">
@@ -22979,7 +24132,7 @@
                 <a:cs typeface="Poppins"/>
                 <a:sym typeface="Poppins"/>
               </a:rPr>
-              <a:t>Year 5 is our first profit.</a:t>
+              <a:t>Our lowest point is $192K, in Year 4.</a:t>
             </a:r>
             <a:endParaRPr/>
           </a:p>

</xml_diff>

<commit_message>
Apply back-row review fixes; 11-slide deck with summary close
Co-Authored-By: Claude Opus 5.5 <noreply@anthropic.com>
Claude-Session: https://claude.ai/code/session_017KdnwN2qyuF8wMBvTngErS
</commit_message>
<xml_diff>
--- a/ENTR_4501_Gate_2_deck_readable.pptx
+++ b/ENTR_4501_Gate_2_deck_readable.pptx
@@ -16,10 +16,9 @@
     <p:sldId id="261" r:id="rId12"/>
     <p:sldId id="262" r:id="rId13"/>
     <p:sldId id="263" r:id="rId14"/>
-    <p:sldId id="267" r:id="rId27"/>
     <p:sldId id="264" r:id="rId15"/>
     <p:sldId id="265" r:id="rId16"/>
-    <p:sldId id="268" r:id="rId28"/>
+    <p:sldId id="267" r:id="rId27"/>
     <p:sldId id="266" r:id="rId17"/>
   </p:sldIdLst>
   <p:sldSz cy="10287000" cx="18288000"/>
@@ -811,7 +810,7 @@
             </a:pPr>
             <a:r>
               <a:rPr lang="en-US"/>
-              <a:t>We’re building a free app that tells you where to eat in Boston. We’re starting at Northeastern.</a:t>
+              <a:t>We’re building a free app that tells you where to eat in Boston, starting at Northeastern.</a:t>
             </a:r>
           </a:p>
           <a:p>
@@ -856,7 +855,7 @@
             </a:pPr>
             <a:r>
               <a:rPr lang="en-US"/>
-              <a:t>We don’t have a name yet. Here’s why we think it’s worth building.</a:t>
+              <a:t>It doesn’t have a name yet. So why build it? Because of what we heard.</a:t>
             </a:r>
           </a:p>
         </p:txBody>
@@ -1006,7 +1005,7 @@
             </a:pPr>
             <a:r>
               <a:rPr lang="en-US"/>
-              <a:t>Last piece: how we pay for it.</a:t>
+              <a:t>So how do we pay for it? We start with grants, the way Beli did. Northeastern’s IDEA Gap Fund and pitch competitions around Boston, about $74,000, cover Years 1 and 2. If we fall short, we cover the gap ourselves.</a:t>
             </a:r>
           </a:p>
           <a:p>
@@ -1021,7 +1020,7 @@
             </a:pPr>
             <a:r>
               <a:rPr lang="en-US"/>
-              <a:t>We start with grants, the way Beli did. Northeastern’s IDEA Gap Fund and pitch competitions around Boston, about $74,000, cover Years 1 and 2. If we fall short, we cover the gap ourselves.</a:t>
+              <a:t>At the end of Year 2, once restaurants have paid us for four quarters, we raise one angel round of about $166,000. We’ll show them about 31,000 Boston users and visits proven by receipts. We’d find angels through IDEA, competition judges and our own networks.</a:t>
             </a:r>
           </a:p>
           <a:p>
@@ -1036,7 +1035,7 @@
             </a:pPr>
             <a:r>
               <a:rPr lang="en-US"/>
-              <a:t>At the end of Year 2 we raise one angel round, about $166,000. What we’ll show them is about 31,000 Boston users, a year of restaurants paying for diners we sent, and visits proven by receipts. We’d look for angels through IDEA, competition judges and our own networks.</a:t>
+              <a:t>That’s $240,000 in all. At $356,000 of Year 5 revenue we’re too small for venture funds, so the angels’ way out is a sale to a bigger platform or a card company, the way Resy sold to American Express.</a:t>
             </a:r>
           </a:p>
           <a:p>
@@ -1051,22 +1050,7 @@
             </a:pPr>
             <a:r>
               <a:rPr lang="en-US"/>
-              <a:t>Together that’s the $240,000. At $356,000 of revenue in Year 5 we’re too small for venture funds, so the angels’ way out is a sale to a bigger platform or a card company, the way Resy sold to American Express.</a:t>
-            </a:r>
-          </a:p>
-          <a:p>
-            <a:pPr indent="0" lvl="0" marL="0" rtl="0" algn="l">
-              <a:spcBef>
-                <a:spcPts val="0"/>
-              </a:spcBef>
-              <a:spcAft>
-                <a:spcPts val="600"/>
-              </a:spcAft>
-              <a:buNone/>
-            </a:pPr>
-            <a:r>
-              <a:rPr lang="en-US"/>
-              <a:t>That’s the plan. Let me sum it up.</a:t>
+              <a:t>That’s the plan.</a:t>
             </a:r>
           </a:p>
         </p:txBody>
@@ -1411,7 +1395,7 @@
             </a:pPr>
             <a:r>
               <a:rPr lang="en-US"/>
-              <a:t>So what does that add up to?</a:t>
+              <a:t>Let me pull it together.</a:t>
             </a:r>
           </a:p>
           <a:p>
@@ -1426,7 +1410,7 @@
             </a:pPr>
             <a:r>
               <a:rPr lang="en-US"/>
-              <a:t>Restaurants start paying us in Year 2, and Year 5 is our first profitable year.</a:t>
+              <a:t>Boston students don’t trust the ratings they see, and checking five apps doesn’t fix that.</a:t>
             </a:r>
           </a:p>
           <a:p>
@@ -1441,144 +1425,24 @@
             </a:pPr>
             <a:r>
               <a:rPr lang="en-US"/>
-              <a:t>Here’s how the numbers get there.</a:t>
-            </a:r>
-          </a:p>
-        </p:txBody>
-      </p:sp>
-      <p:sp>
-        <p:nvSpPr>
-          <p:cNvPr id="111" name="Google Shape;111;p2:notes"/>
-          <p:cNvSpPr txBox="1"/>
-          <p:nvPr>
-            <p:ph idx="12" type="sldNum"/>
-          </p:nvPr>
-        </p:nvSpPr>
-        <p:spPr>
-          <a:xfrm>
-            <a:off x="0" y="0"/>
-            <a:ext cx="3000000" cy="3000000"/>
-          </a:xfrm>
-          <a:prstGeom prst="rect">
-            <a:avLst/>
-          </a:prstGeom>
-          <a:noFill/>
-          <a:ln>
-            <a:noFill/>
-          </a:ln>
-        </p:spPr>
-        <p:txBody>
-          <a:bodyPr anchorCtr="0" anchor="ctr" bIns="91425" lIns="91425" spcFirstLastPara="1" rIns="91425" wrap="square" tIns="91425">
-            <a:noAutofit/>
-          </a:bodyPr>
-          <a:lstStyle/>
+              <a:t>So we’re building one free app, and our score only counts people who proved they ate there.</a:t>
+            </a:r>
+          </a:p>
           <a:p>
             <a:pPr indent="0" lvl="0" marL="0" rtl="0" algn="l">
               <a:spcBef>
                 <a:spcPts val="0"/>
               </a:spcBef>
               <a:spcAft>
-                <a:spcPts val="0"/>
-              </a:spcAft>
-              <a:buNone/>
-            </a:pPr>
-            <a:r>
-              <a:t/>
-            </a:r>
-            <a:endParaRPr/>
-          </a:p>
-        </p:txBody>
-      </p:sp>
-    </p:spTree>
-  </p:cSld>
-  <p:clrMapOvr>
-    <a:masterClrMapping/>
-  </p:clrMapOvr>
-</p:notes>
-</file>
-
-<file path=ppt/notesSlides/notesSlide13.xml><?xml version="1.0" encoding="utf-8"?>
-<p:notes xmlns:a="http://schemas.openxmlformats.org/drawingml/2006/main" xmlns:r="http://schemas.openxmlformats.org/officeDocument/2006/relationships" xmlns:mc="http://schemas.openxmlformats.org/markup-compatibility/2006" xmlns:mv="urn:schemas-microsoft-com:mac:vml" xmlns:p="http://schemas.openxmlformats.org/presentationml/2006/main" xmlns:c="http://schemas.openxmlformats.org/drawingml/2006/chart" xmlns:dgm="http://schemas.openxmlformats.org/drawingml/2006/diagram" xmlns:o="urn:schemas-microsoft-com:office:office" xmlns:v="urn:schemas-microsoft-com:vml" xmlns:pvml="urn:schemas-microsoft-com:office:powerpoint" xmlns:com="http://schemas.openxmlformats.org/drawingml/2006/compatibility" xmlns:p14="http://schemas.microsoft.com/office/powerpoint/2010/main" xmlns:p15="http://schemas.microsoft.com/office/powerpoint/2012/main" xmlns:ahyp="http://schemas.microsoft.com/office/drawing/2018/hyperlinkcolor" showMasterPhAnim="0" showMasterSp="0">
-  <p:cSld>
-    <p:spTree>
-      <p:nvGrpSpPr>
-        <p:cNvPr id="108" name="Shape 108"/>
-        <p:cNvGrpSpPr/>
-        <p:nvPr/>
-      </p:nvGrpSpPr>
-      <p:grpSpPr>
-        <a:xfrm>
-          <a:off x="0" y="0"/>
-          <a:ext cx="0" cy="0"/>
-          <a:chOff x="0" y="0"/>
-          <a:chExt cx="0" cy="0"/>
-        </a:xfrm>
-      </p:grpSpPr>
-      <p:sp>
-        <p:nvSpPr>
-          <p:cNvPr id="109" name="Google Shape;109;p2:notes"/>
-          <p:cNvSpPr/>
-          <p:nvPr>
-            <p:ph idx="2" type="sldImg"/>
-          </p:nvPr>
-        </p:nvSpPr>
-        <p:spPr>
-          <a:xfrm>
-            <a:off x="0" y="0"/>
-            <a:ext cx="3000000" cy="3000000"/>
-          </a:xfrm>
-          <a:custGeom>
-            <a:rect b="b" l="l" r="r" t="t"/>
-            <a:pathLst>
-              <a:path extrusionOk="0" h="120000" w="120000">
-                <a:moveTo>
-                  <a:pt x="0" y="0"/>
-                </a:moveTo>
-                <a:lnTo>
-                  <a:pt x="120000" y="0"/>
-                </a:lnTo>
-                <a:lnTo>
-                  <a:pt x="120000" y="120000"/>
-                </a:lnTo>
-                <a:lnTo>
-                  <a:pt x="0" y="120000"/>
-                </a:lnTo>
-                <a:close/>
-              </a:path>
-            </a:pathLst>
-          </a:custGeom>
-          <a:noFill/>
-          <a:ln>
-            <a:noFill/>
-          </a:ln>
-        </p:spPr>
-      </p:sp>
-      <p:sp>
-        <p:nvSpPr>
-          <p:cNvPr id="110" name="Google Shape;110;p2:notes"/>
-          <p:cNvSpPr txBox="1"/>
-          <p:nvPr>
-            <p:ph idx="1" type="body"/>
-          </p:nvPr>
-        </p:nvSpPr>
-        <p:spPr>
-          <a:xfrm>
-            <a:off x="0" y="0"/>
-            <a:ext cx="3000000" cy="3000000"/>
-          </a:xfrm>
-          <a:prstGeom prst="rect">
-            <a:avLst/>
-          </a:prstGeom>
-          <a:noFill/>
-          <a:ln>
-            <a:noFill/>
-          </a:ln>
-        </p:spPr>
-        <p:txBody>
-          <a:bodyPr anchorCtr="0" anchor="t" bIns="45700" lIns="91425" spcFirstLastPara="1" rIns="91425" wrap="square" tIns="45700">
-            <a:noAutofit/>
-          </a:bodyPr>
-          <a:lstStyle/>
+                <a:spcPts val="600"/>
+              </a:spcAft>
+              <a:buNone/>
+            </a:pPr>
+            <a:r>
+              <a:rPr lang="en-US"/>
+              <a:t>Restaurants pay for the diners we send, so users never have to. We start on grants, raise one angel round, and reach a profit in Year 5.</a:t>
+            </a:r>
+          </a:p>
           <a:p>
             <a:pPr indent="0" lvl="0" marL="0" rtl="0" algn="l">
               <a:spcBef>
@@ -1591,67 +1455,7 @@
             </a:pPr>
             <a:r>
               <a:rPr lang="en-US"/>
-              <a:t>To sum up.</a:t>
-            </a:r>
-          </a:p>
-          <a:p>
-            <a:pPr indent="0" lvl="0" marL="0" rtl="0" algn="l">
-              <a:spcBef>
-                <a:spcPts val="0"/>
-              </a:spcBef>
-              <a:spcAft>
-                <a:spcPts val="600"/>
-              </a:spcAft>
-              <a:buNone/>
-            </a:pPr>
-            <a:r>
-              <a:rPr lang="en-US"/>
-              <a:t>Boston students don’t trust the ratings they see, and checking five apps doesn’t fix it.</a:t>
-            </a:r>
-          </a:p>
-          <a:p>
-            <a:pPr indent="0" lvl="0" marL="0" rtl="0" algn="l">
-              <a:spcBef>
-                <a:spcPts val="0"/>
-              </a:spcBef>
-              <a:spcAft>
-                <a:spcPts val="600"/>
-              </a:spcAft>
-              <a:buNone/>
-            </a:pPr>
-            <a:r>
-              <a:rPr lang="en-US"/>
-              <a:t>Trust: we’re building one free app that only counts people who proved they ate there.</a:t>
-            </a:r>
-          </a:p>
-          <a:p>
-            <a:pPr indent="0" lvl="0" marL="0" rtl="0" algn="l">
-              <a:spcBef>
-                <a:spcPts val="0"/>
-              </a:spcBef>
-              <a:spcAft>
-                <a:spcPts val="600"/>
-              </a:spcAft>
-              <a:buNone/>
-            </a:pPr>
-            <a:r>
-              <a:rPr lang="en-US"/>
-              <a:t>Money: restaurants pay for the diners we send, so users never pay.</a:t>
-            </a:r>
-          </a:p>
-          <a:p>
-            <a:pPr indent="0" lvl="0" marL="0" rtl="0" algn="l">
-              <a:spcBef>
-                <a:spcPts val="0"/>
-              </a:spcBef>
-              <a:spcAft>
-                <a:spcPts val="600"/>
-              </a:spcAft>
-              <a:buNone/>
-            </a:pPr>
-            <a:r>
-              <a:rPr lang="en-US"/>
-              <a:t>Path: we start on grants, raise one angel round, and reach a profit in Year 5.</a:t>
+              <a:t>What we need to learn next is whether restaurants will pay. So we’re making five owner calls with a free 30-day pilot, and testing receipt scanning with about ten users.</a:t>
             </a:r>
           </a:p>
           <a:p>
@@ -1816,7 +1620,7 @@
             </a:pPr>
             <a:r>
               <a:rPr lang="en-US"/>
-              <a:t>We talked to 35 students and young professionals this fall. Almost all of them described the same routine.</a:t>
+              <a:t>We talked to 35 students and young professionals this fall, and almost all of them described the same routine.</a:t>
             </a:r>
           </a:p>
           <a:p>
@@ -1846,7 +1650,7 @@
             </a:pPr>
             <a:r>
               <a:rPr lang="en-US"/>
-              <a:t>Two things came up again and again. Nobody has one place to save where they want to go. And they want one app they can trust.</a:t>
+              <a:t>Two things kept coming up. Nobody has one place to save where they want to go. And they want one app they can trust.</a:t>
             </a:r>
           </a:p>
           <a:p>
@@ -1861,7 +1665,7 @@
             </a:pPr>
             <a:r>
               <a:rPr lang="en-US"/>
-              <a:t>There’s plenty of information out there. Knowing which of it to trust is the hard part.</a:t>
+              <a:t>The info is all out there. People just don’t trust it.</a:t>
             </a:r>
           </a:p>
         </p:txBody>
@@ -2011,7 +1815,7 @@
             </a:pPr>
             <a:r>
               <a:rPr lang="en-US"/>
-              <a:t>The app does three things: find, compare and keep.</a:t>
+              <a:t>So we put everything about a place on one page.</a:t>
             </a:r>
           </a:p>
           <a:p>
@@ -2026,7 +1830,7 @@
             </a:pPr>
             <a:r>
               <a:rPr lang="en-US"/>
-              <a:t>Find: what’s open near you, filtered by diet, price and distance, plus new places people are talking about.</a:t>
+              <a:t>First, it helps you find somewhere: what’s open near you, filtered by diet, price and distance, plus new places people are talking about.</a:t>
             </a:r>
           </a:p>
           <a:p>
@@ -2041,7 +1845,7 @@
             </a:pPr>
             <a:r>
               <a:rPr lang="en-US"/>
-              <a:t>Compare: every rating and post for a place on one page, next to our own score. Our score only counts diners who scanned a receipt, and nobody can pay to rank higher.</a:t>
+              <a:t>Then you compare. Every rating and post sits next to our own score, which only counts diners who scanned a receipt. Nobody can pay to rank higher.</a:t>
             </a:r>
           </a:p>
           <a:p>
@@ -2056,7 +1860,7 @@
             </a:pPr>
             <a:r>
               <a:rPr lang="en-US"/>
-              <a:t>Keep: your history, your lists, and booking a table.</a:t>
+              <a:t>And you keep track of it all: your history, your lists, and booking a table.</a:t>
             </a:r>
           </a:p>
           <a:p>
@@ -2071,7 +1875,37 @@
             </a:pPr>
             <a:r>
               <a:rPr lang="en-US"/>
-              <a:t>All of it is free. You asked whether people would pay for a dietary filter. We think they shouldn’t. A halal or nut-free search is what sends a restaurant the diner it pays for, so it stays free.</a:t>
+              <a:t>The core app is free. Earlier feedback asked if we’d charge for dietary filters. We won’t. A halal or nut-free search is exactly what sends a restaurant the diner it pays for.</a:t>
+            </a:r>
+          </a:p>
+          <a:p>
+            <a:pPr indent="0" lvl="0" marL="0" rtl="0" algn="l">
+              <a:spcBef>
+                <a:spcPts val="0"/>
+              </a:spcBef>
+              <a:spcAft>
+                <a:spcPts val="600"/>
+              </a:spcAft>
+              <a:buNone/>
+            </a:pPr>
+            <a:r>
+              <a:rPr lang="en-US"/>
+              <a:t>If another app won’t let us show its ratings, we link out to it instead.</a:t>
+            </a:r>
+          </a:p>
+          <a:p>
+            <a:pPr indent="0" lvl="0" marL="0" rtl="0" algn="l">
+              <a:spcBef>
+                <a:spcPts val="0"/>
+              </a:spcBef>
+              <a:spcAft>
+                <a:spcPts val="600"/>
+              </a:spcAft>
+              <a:buNone/>
+            </a:pPr>
+            <a:r>
+              <a:rPr lang="en-US"/>
+              <a:t>And why not just use Beli? Beli ranks where you’ve been. We tell you where to go now, with scores people proved.</a:t>
             </a:r>
           </a:p>
         </p:txBody>
@@ -2284,21 +2118,6 @@
               <a:t>Four, check every rating. Our verified score sits next to Google, Yelp, Beli, Reddit and TikTok, and creators’ paid posts are flagged.</a:t>
             </a:r>
           </a:p>
-          <a:p>
-            <a:pPr indent="0" lvl="0" marL="0" rtl="0" algn="l">
-              <a:spcBef>
-                <a:spcPts val="0"/>
-              </a:spcBef>
-              <a:spcAft>
-                <a:spcPts val="600"/>
-              </a:spcAft>
-              <a:buNone/>
-            </a:pPr>
-            <a:r>
-              <a:rPr lang="en-US"/>
-              <a:t>Next we put this in front of students on campus.</a:t>
-            </a:r>
-          </a:p>
         </p:txBody>
       </p:sp>
       <p:sp>
@@ -2446,7 +2265,7 @@
             </a:pPr>
             <a:r>
               <a:rPr lang="en-US"/>
-              <a:t>Start with the smallest number. Boston has 162,000 college students, and we want 12,000 of them in Year 1.</a:t>
+              <a:t>We start small. Boston has 162,000 college students, and we want 12,000 of them in Year 1.</a:t>
             </a:r>
           </a:p>
           <a:p>
@@ -2461,7 +2280,7 @@
             </a:pPr>
             <a:r>
               <a:rPr lang="en-US"/>
-              <a:t>Zoom out and there are about 19 million college students in the US. That’s who we can reach, one campus at a time. The bigger pool is 77.8 million people between 18 and 34.</a:t>
+              <a:t>There are about 19 million college students in the US, and we can reach them one campus at a time.</a:t>
             </a:r>
           </a:p>
           <a:p>
@@ -2491,22 +2310,7 @@
             </a:pPr>
             <a:r>
               <a:rPr lang="en-US"/>
-              <a:t>On the other side, Boston has 3,350 licensed places to eat. Those are the businesses that will pay us.</a:t>
-            </a:r>
-          </a:p>
-          <a:p>
-            <a:pPr indent="0" lvl="0" marL="0" rtl="0" algn="l">
-              <a:spcBef>
-                <a:spcPts val="0"/>
-              </a:spcBef>
-              <a:spcAft>
-                <a:spcPts val="600"/>
-              </a:spcAft>
-              <a:buNone/>
-            </a:pPr>
-            <a:r>
-              <a:rPr lang="en-US"/>
-              <a:t>People ask why not Beli. Beli ranks where you’ve been. We tell you where to go right now, with scores people proved.</a:t>
+              <a:t>And on the side that pays, Boston has 3,350 licensed places to eat.</a:t>
             </a:r>
           </a:p>
         </p:txBody>
@@ -2656,7 +2460,7 @@
             </a:pPr>
             <a:r>
               <a:rPr lang="en-US"/>
-              <a:t>How do we get our first users? One friend at a time.</a:t>
+              <a:t>So how do we get our first users? One friend at a time.</a:t>
             </a:r>
           </a:p>
           <a:p>
@@ -2671,7 +2475,7 @@
             </a:pPr>
             <a:r>
               <a:rPr lang="en-US"/>
-              <a:t>The first ten are people we interviewed, plus our friends. They test the prototype this semester, and what we tell them is: help us build it.</a:t>
+              <a:t>The first ten are people we interviewed, plus our friends. They test the prototype this semester, and we ask them to help us build it.</a:t>
             </a:r>
           </a:p>
           <a:p>
@@ -2686,7 +2490,7 @@
             </a:pPr>
             <a:r>
               <a:rPr lang="en-US"/>
-              <a:t>The first hundred are Northeastern students they invite, plus clubs and group chats. Now the pitch is every rating for a place, in one app.</a:t>
+              <a:t>The first hundred are Northeastern students they invite, plus clubs and group chats. What we tell them is every rating for a place, in one app.</a:t>
             </a:r>
           </a:p>
           <a:p>
@@ -2731,7 +2535,7 @@
             </a:pPr>
             <a:r>
               <a:rPr lang="en-US"/>
-              <a:t>Users never pay. Restaurants do, and that’s next.</a:t>
+              <a:t>Users never pay. Restaurants do.</a:t>
             </a:r>
           </a:p>
         </p:txBody>
@@ -2881,7 +2685,7 @@
             </a:pPr>
             <a:r>
               <a:rPr lang="en-US"/>
-              <a:t>Here’s how we make money. Restaurants pay for the diners we send them, not for ads.</a:t>
+              <a:t>Restaurants pay us for the diners we send, not for ads.</a:t>
             </a:r>
           </a:p>
           <a:p>
@@ -2896,7 +2700,7 @@
             </a:pPr>
             <a:r>
               <a:rPr lang="en-US"/>
-              <a:t>Today a restaurant pays for ads and boosted posts before it knows if anyone will walk in. We flip that. It pays about 90 cents, and only after a receipt shows the diner came. OpenTable charges $1 to $1.50 a diner.</a:t>
+              <a:t>Today a restaurant pays for ads and boosted posts before it knows if anyone will walk in. We’d rather get paid only when it works. A restaurant pays about 90 cents, and only after a receipt shows the diner came. OpenTable charges $1 to $1.50 a diner.</a:t>
             </a:r>
           </a:p>
           <a:p>
@@ -2911,7 +2715,7 @@
             </a:pPr>
             <a:r>
               <a:rPr lang="en-US"/>
-              <a:t>Booking sites pay per table. And from Year 3, chains pay $6,000 a year per neighborhood to see what people there eat. All of that adds up to $288,000 in Year 5.</a:t>
+              <a:t>Booking sites pay per table. And from Year 3, chains pay $6,000 a year per area to see what people there eat. That’s $288,000 in Year 5.</a:t>
             </a:r>
           </a:p>
           <a:p>
@@ -2926,7 +2730,7 @@
             </a:pPr>
             <a:r>
               <a:rPr lang="en-US"/>
-              <a:t>On the user side the app is free. About 3 in 1,000 pay $5 a month for extras, and that’s another $67,000.</a:t>
+              <a:t>On the user side the app is free. About 3 in 1,000 pay $5 a month for extras, which adds $67,000.</a:t>
             </a:r>
           </a:p>
           <a:p>
@@ -2941,7 +2745,7 @@
             </a:pPr>
             <a:r>
               <a:rPr lang="en-US"/>
-              <a:t>So $356,000 in Year 5. Nothing anyone pays changes a score or a ranking.</a:t>
+              <a:t>Nothing anyone pays changes a score or a ranking.</a:t>
             </a:r>
           </a:p>
           <a:p>
@@ -2956,7 +2760,7 @@
             </a:pPr>
             <a:r>
               <a:rPr lang="en-US"/>
-              <a:t>We haven’t talked to restaurant owners yet. Five owner calls are next, each with a free 30-day pilot and a report on the diners we sent.</a:t>
+              <a:t>We haven’t tested this with owners yet. Five owner calls are next, each with a free 30-day pilot and a report on the diners we sent.</a:t>
             </a:r>
           </a:p>
         </p:txBody>
@@ -3136,7 +2940,7 @@
             </a:pPr>
             <a:r>
               <a:rPr lang="en-US"/>
-              <a:t>So we made three choices. No salaries, and co-op students before hires. Costs low enough that we only need about $240,000, starting with grants. And Beli as our yardstick: a quarter of its size, almost no ads, and restaurants paying from Year 2.</a:t>
+              <a:t>So we made three choices. No founder salaries, and co-op students before full-time hires. Costs low enough that we only need about $240,000, starting with grants. And Beli as our yardstick: a quarter of its size, almost no ads, and restaurants paying from Year 2.</a:t>
             </a:r>
           </a:p>
           <a:p>
@@ -3151,7 +2955,7 @@
             </a:pPr>
             <a:r>
               <a:rPr lang="en-US"/>
-              <a:t>The trade-off is a smaller team, and it only works if restaurants sign up. Here’s what that means for us.</a:t>
+              <a:t>The trade-off is a smaller team, and it only works if restaurants sign up.</a:t>
             </a:r>
           </a:p>
         </p:txBody>
@@ -3301,7 +3105,7 @@
             </a:pPr>
             <a:r>
               <a:rPr lang="en-US"/>
-              <a:t>Here’s the detail. Look at the three highlighted numbers.</a:t>
+              <a:t>This is what lean looks like in numbers. Watch the three highlighted cells.</a:t>
             </a:r>
           </a:p>
           <a:p>
@@ -3316,7 +3120,7 @@
             </a:pPr>
             <a:r>
               <a:rPr lang="en-US"/>
-              <a:t>Years 1 and 2 are flat on purpose, about $11,000 a quarter. That’s a contract developer at $7,500, $1,500 for marketing, $1,500 for legal and insurance, and a little hosting. Nobody else gets paid until restaurants do.</a:t>
+              <a:t>Years 1 and 2 are flat on purpose, about $10,500 a quarter. That’s a contract developer at $7,500, $1,500 for marketing, $1,500 for legal and insurance, and a little hosting. Nobody else gets paid until the angel round funds Year 3.</a:t>
             </a:r>
           </a:p>
           <a:p>
@@ -3331,7 +3135,7 @@
             </a:pPr>
             <a:r>
               <a:rPr lang="en-US"/>
-              <a:t>The first highlight is Year 2, when the first revenue comes in. From Year 3, co-op students join as our users grow.</a:t>
+              <a:t>The first highlight is our first revenue, in Year 2. From Year 3, co-op students join as our users grow.</a:t>
             </a:r>
           </a:p>
           <a:p>
@@ -3346,7 +3150,7 @@
             </a:pPr>
             <a:r>
               <a:rPr lang="en-US"/>
-              <a:t>The second is the low point, about $192,000 down in Year 4. That’s why we’re raising $240,000: the low point plus a 25% cushion.</a:t>
+              <a:t>The second is the low point, about $192,000 down in Year 4. We’re raising $240,000, which is that low plus a 25% cushion.</a:t>
             </a:r>
           </a:p>
           <a:p>
@@ -14421,7 +14225,7 @@
                 <a:cs typeface="Poppins"/>
                 <a:sym typeface="Poppins"/>
               </a:rPr>
-              <a:t>11</a:t>
+              <a:t>10</a:t>
             </a:r>
             <a:endParaRPr/>
           </a:p>
@@ -16109,210 +15913,6 @@
     <p:bg>
       <p:bgPr>
         <a:solidFill>
-          <a:srgbClr val="000000"/>
-        </a:solidFill>
-        <a:effectLst/>
-      </p:bgPr>
-    </p:bg>
-    <p:spTree>
-      <p:nvGrpSpPr>
-        <p:cNvPr id="112" name="Shape 112"/>
-        <p:cNvGrpSpPr/>
-        <p:nvPr/>
-      </p:nvGrpSpPr>
-      <p:grpSpPr>
-        <a:xfrm>
-          <a:off x="0" y="0"/>
-          <a:ext cx="0" cy="0"/>
-          <a:chOff x="0" y="0"/>
-          <a:chExt cx="0" cy="0"/>
-        </a:xfrm>
-      </p:grpSpPr>
-      <p:sp>
-        <p:nvSpPr>
-          <p:cNvPr id="113" name="Google Shape;113;p2"/>
-          <p:cNvSpPr txBox="1"/>
-          <p:nvPr/>
-        </p:nvSpPr>
-        <p:spPr>
-          <a:xfrm>
-            <a:off x="822960" y="3017520"/>
-            <a:ext cx="10972800" cy="411480"/>
-          </a:xfrm>
-          <a:prstGeom prst="rect">
-            <a:avLst/>
-          </a:prstGeom>
-          <a:noFill/>
-          <a:ln>
-            <a:noFill/>
-          </a:ln>
-        </p:spPr>
-        <p:txBody>
-          <a:bodyPr anchorCtr="0" anchor="t" bIns="0" lIns="0" spcFirstLastPara="1" rIns="0" wrap="square" tIns="0">
-            <a:spAutoFit/>
-          </a:bodyPr>
-          <a:lstStyle/>
-          <a:p>
-            <a:pPr indent="0" lvl="0" marL="0" marR="0" rtl="0" algn="l">
-              <a:lnSpc>
-                <a:spcPct val="110000"/>
-              </a:lnSpc>
-              <a:spcBef>
-                <a:spcPts val="0"/>
-              </a:spcBef>
-              <a:spcAft>
-                <a:spcPts val="0"/>
-              </a:spcAft>
-              <a:buNone/>
-            </a:pPr>
-            <a:r>
-              <a:rPr b="0" i="0" lang="en-US" sz="2400" u="none" cap="none" strike="noStrike">
-                <a:solidFill>
-                  <a:srgbClr val="AAA676"/>
-                </a:solidFill>
-                <a:latin typeface="Poppins"/>
-                <a:ea typeface="Poppins"/>
-                <a:cs typeface="Poppins"/>
-                <a:sym typeface="Poppins"/>
-              </a:rPr>
-              <a:t>What it means</a:t>
-            </a:r>
-            <a:endParaRPr/>
-          </a:p>
-        </p:txBody>
-      </p:sp>
-      <p:sp>
-        <p:nvSpPr>
-          <p:cNvPr id="114" name="Google Shape;114;p2"/>
-          <p:cNvSpPr txBox="1"/>
-          <p:nvPr/>
-        </p:nvSpPr>
-        <p:spPr>
-          <a:xfrm>
-            <a:off x="16093440" y="685800"/>
-            <a:ext cx="1371600" cy="365760"/>
-          </a:xfrm>
-          <a:prstGeom prst="rect">
-            <a:avLst/>
-          </a:prstGeom>
-          <a:noFill/>
-          <a:ln>
-            <a:noFill/>
-          </a:ln>
-        </p:spPr>
-        <p:txBody>
-          <a:bodyPr anchorCtr="0" anchor="t" bIns="0" lIns="0" spcFirstLastPara="1" rIns="0" wrap="square" tIns="0">
-            <a:spAutoFit/>
-          </a:bodyPr>
-          <a:lstStyle/>
-          <a:p>
-            <a:pPr indent="0" lvl="0" marL="0" marR="0" rtl="0" algn="r">
-              <a:lnSpc>
-                <a:spcPct val="110000"/>
-              </a:lnSpc>
-              <a:spcBef>
-                <a:spcPts val="0"/>
-              </a:spcBef>
-              <a:spcAft>
-                <a:spcPts val="0"/>
-              </a:spcAft>
-              <a:buNone/>
-            </a:pPr>
-            <a:r>
-              <a:rPr b="0" i="0" lang="en-US" sz="1400" u="none" cap="none" strike="noStrike">
-                <a:solidFill>
-                  <a:srgbClr val="8C8C8C"/>
-                </a:solidFill>
-                <a:latin typeface="Poppins"/>
-                <a:ea typeface="Poppins"/>
-                <a:cs typeface="Poppins"/>
-                <a:sym typeface="Poppins"/>
-              </a:rPr>
-              <a:t>9</a:t>
-            </a:r>
-            <a:endParaRPr/>
-          </a:p>
-        </p:txBody>
-      </p:sp>
-      <p:sp>
-        <p:nvSpPr>
-          <p:cNvPr id="115" name="Google Shape;115;p2"/>
-          <p:cNvSpPr txBox="1"/>
-          <p:nvPr/>
-        </p:nvSpPr>
-        <p:spPr>
-          <a:xfrm>
-            <a:off x="822960" y="3611880"/>
-            <a:ext cx="14173200" cy="2377440"/>
-          </a:xfrm>
-          <a:prstGeom prst="rect">
-            <a:avLst/>
-          </a:prstGeom>
-          <a:noFill/>
-          <a:ln>
-            <a:noFill/>
-          </a:ln>
-        </p:spPr>
-        <p:txBody>
-          <a:bodyPr anchorCtr="0" anchor="t" bIns="0" lIns="0" spcFirstLastPara="1" rIns="0" wrap="square" tIns="0">
-            <a:spAutoFit/>
-          </a:bodyPr>
-          <a:lstStyle/>
-          <a:p>
-            <a:pPr indent="0" lvl="0" marL="0" marR="0" rtl="0" algn="l">
-              <a:lnSpc>
-                <a:spcPct val="108000"/>
-              </a:lnSpc>
-              <a:spcBef>
-                <a:spcPts val="0"/>
-              </a:spcBef>
-              <a:spcAft>
-                <a:spcPts val="0"/>
-              </a:spcAft>
-              <a:buNone/>
-            </a:pPr>
-            <a:r>
-              <a:rPr b="0" i="0" lang="en-US" sz="6000" u="none" cap="none" strike="noStrike">
-                <a:solidFill>
-                  <a:srgbClr val="FFFFFF"/>
-                </a:solidFill>
-                <a:latin typeface="Poppins"/>
-                <a:ea typeface="Poppins"/>
-                <a:cs typeface="Poppins"/>
-                <a:sym typeface="Poppins"/>
-              </a:rPr>
-              <a:t xml:space="preserve">Restaurants start paying us in Year 2, </a:t>
-            </a:r>
-            <a:r>
-              <a:rPr b="0" i="0" lang="en-US" sz="6000" u="none" cap="none" strike="noStrike">
-                <a:solidFill>
-                  <a:srgbClr val="AAA676"/>
-                </a:solidFill>
-                <a:latin typeface="Poppins"/>
-                <a:ea typeface="Poppins"/>
-                <a:cs typeface="Poppins"/>
-                <a:sym typeface="Poppins"/>
-              </a:rPr>
-              <a:t>and Year 5 is our first profit.</a:t>
-            </a:r>
-            <a:endParaRPr/>
-          </a:p>
-        </p:txBody>
-      </p:sp>
-    </p:spTree>
-  </p:cSld>
-  <p:clrMapOvr>
-    <a:masterClrMapping/>
-  </p:clrMapOvr>
-</p:sld>
-</file>
-
-<file path=ppt/slides/slide13.xml><?xml version="1.0" encoding="utf-8"?>
-<p:sld xmlns:a="http://schemas.openxmlformats.org/drawingml/2006/main" xmlns:r="http://schemas.openxmlformats.org/officeDocument/2006/relationships" xmlns:mc="http://schemas.openxmlformats.org/markup-compatibility/2006" xmlns:mv="urn:schemas-microsoft-com:mac:vml" xmlns:p="http://schemas.openxmlformats.org/presentationml/2006/main" xmlns:c="http://schemas.openxmlformats.org/drawingml/2006/chart" xmlns:dgm="http://schemas.openxmlformats.org/drawingml/2006/diagram" xmlns:o="urn:schemas-microsoft-com:office:office" xmlns:v="urn:schemas-microsoft-com:vml" xmlns:pvml="urn:schemas-microsoft-com:office:powerpoint" xmlns:com="http://schemas.openxmlformats.org/drawingml/2006/compatibility" xmlns:p14="http://schemas.microsoft.com/office/powerpoint/2010/main" xmlns:p15="http://schemas.microsoft.com/office/powerpoint/2012/main" xmlns:ahyp="http://schemas.microsoft.com/office/drawing/2018/hyperlinkcolor">
-  <p:cSld>
-    <p:bg>
-      <p:bgPr>
-        <a:solidFill>
           <a:srgbClr val="AAA676"/>
         </a:solidFill>
         <a:effectLst/>
@@ -16412,13 +16012,13 @@
           <a:p>
             <a:pPr indent="0" lvl="0" marL="0" marR="0" rtl="0" algn="r">
               <a:lnSpc>
-                <a:spcPct val="110000"/>
+                <a:spcPct val="1F1F1F"/>
               </a:lnSpc>
               <a:spcBef>
-                <a:spcPts val="0"/>
-              </a:spcBef>
-              <a:spcAft>
-                <a:spcPts val="0"/>
+                <a:spcPts val="1F1F1F"/>
+              </a:spcBef>
+              <a:spcAft>
+                <a:spcPts val="1F1F1F"/>
               </a:spcAft>
               <a:buNone/>
             </a:pPr>
@@ -16432,7 +16032,7 @@
                 <a:cs typeface="Poppins"/>
                 <a:sym typeface="Poppins"/>
               </a:rPr>
-              <a:t>12</a:t>
+              <a:t>11</a:t>
             </a:r>
             <a:endParaRPr/>
           </a:p>
@@ -16511,7 +16111,7 @@
         </p:nvSpPr>
         <p:spPr>
           <a:xfrm>
-            <a:off x="822960" y="4206240"/>
+            <a:off x="822960" y="3931920"/>
             <a:ext cx="5120640" cy="411480"/>
           </a:xfrm>
           <a:prstGeom prst="rect">
@@ -16564,7 +16164,7 @@
         </p:nvSpPr>
         <p:spPr>
           <a:xfrm>
-            <a:off x="822960" y="4800600"/>
+            <a:off x="822960" y="4526280"/>
             <a:ext cx="4937760" cy="1828800"/>
           </a:xfrm>
           <a:prstGeom prst="rect">
@@ -16617,7 +16217,7 @@
         </p:nvSpPr>
         <p:spPr>
           <a:xfrm>
-            <a:off x="6492240" y="4206240"/>
+            <a:off x="6492240" y="3931920"/>
             <a:ext cx="5120640" cy="411480"/>
           </a:xfrm>
           <a:prstGeom prst="rect">
@@ -16670,7 +16270,7 @@
         </p:nvSpPr>
         <p:spPr>
           <a:xfrm>
-            <a:off x="6492240" y="4800600"/>
+            <a:off x="6492240" y="4526280"/>
             <a:ext cx="4937760" cy="1828800"/>
           </a:xfrm>
           <a:prstGeom prst="rect">
@@ -16723,7 +16323,7 @@
         </p:nvSpPr>
         <p:spPr>
           <a:xfrm>
-            <a:off x="12161520" y="4206240"/>
+            <a:off x="12161520" y="3931920"/>
             <a:ext cx="5120640" cy="411480"/>
           </a:xfrm>
           <a:prstGeom prst="rect">
@@ -16776,7 +16376,7 @@
         </p:nvSpPr>
         <p:spPr>
           <a:xfrm>
-            <a:off x="12161520" y="4800600"/>
+            <a:off x="12161520" y="4526280"/>
             <a:ext cx="4937760" cy="1828800"/>
           </a:xfrm>
           <a:prstGeom prst="rect">
@@ -16816,6 +16416,112 @@
                 <a:sym typeface="Poppins"/>
               </a:rPr>
               <a:t>Grants first, then one angel round. Profit in Year 5.</a:t>
+            </a:r>
+            <a:endParaRPr/>
+          </a:p>
+        </p:txBody>
+      </p:sp>
+      <p:sp>
+        <p:nvSpPr>
+          <p:cNvPr id="906" name="Google Shape;906;p2"/>
+          <p:cNvSpPr txBox="1"/>
+          <p:nvPr/>
+        </p:nvSpPr>
+        <p:spPr>
+          <a:xfrm>
+            <a:off x="822960" y="7223760"/>
+            <a:ext cx="5120640" cy="411480"/>
+          </a:xfrm>
+          <a:prstGeom prst="rect">
+            <a:avLst/>
+          </a:prstGeom>
+          <a:noFill/>
+          <a:ln>
+            <a:noFill/>
+          </a:ln>
+        </p:spPr>
+        <p:txBody>
+          <a:bodyPr anchorCtr="0" anchor="t" bIns="0" lIns="0" spcFirstLastPara="1" rIns="0" wrap="square" tIns="0">
+            <a:spAutoFit/>
+          </a:bodyPr>
+          <a:lstStyle/>
+          <a:p>
+            <a:pPr indent="0" lvl="0" marL="0" marR="0" rtl="0" algn="l">
+              <a:lnSpc>
+                <a:spcPct val="110000"/>
+              </a:lnSpc>
+              <a:spcBef>
+                <a:spcPts val="0"/>
+              </a:spcBef>
+              <a:spcAft>
+                <a:spcPts val="0"/>
+              </a:spcAft>
+              <a:buNone/>
+            </a:pPr>
+            <a:r>
+              <a:rPr b="1" i="0" lang="en-US" sz="2400" u="none" cap="none" strike="noStrike">
+                <a:solidFill>
+                  <a:srgbClr val="2E2D12"/>
+                </a:solidFill>
+                <a:latin typeface="Poppins"/>
+                <a:ea typeface="Poppins"/>
+                <a:cs typeface="Poppins"/>
+                <a:sym typeface="Poppins"/>
+              </a:rPr>
+              <a:t>Next</a:t>
+            </a:r>
+            <a:endParaRPr/>
+          </a:p>
+        </p:txBody>
+      </p:sp>
+      <p:sp>
+        <p:nvSpPr>
+          <p:cNvPr id="907" name="Google Shape;907;p2"/>
+          <p:cNvSpPr txBox="1"/>
+          <p:nvPr/>
+        </p:nvSpPr>
+        <p:spPr>
+          <a:xfrm>
+            <a:off x="822960" y="7818120"/>
+            <a:ext cx="16002000" cy="914400"/>
+          </a:xfrm>
+          <a:prstGeom prst="rect">
+            <a:avLst/>
+          </a:prstGeom>
+          <a:noFill/>
+          <a:ln>
+            <a:noFill/>
+          </a:ln>
+        </p:spPr>
+        <p:txBody>
+          <a:bodyPr anchorCtr="0" anchor="t" bIns="0" lIns="0" spcFirstLastPara="1" rIns="0" wrap="square" tIns="0">
+            <a:spAutoFit/>
+          </a:bodyPr>
+          <a:lstStyle/>
+          <a:p>
+            <a:pPr indent="0" lvl="0" marL="0" marR="0" rtl="0" algn="l">
+              <a:lnSpc>
+                <a:spcPct val="110000"/>
+              </a:lnSpc>
+              <a:spcBef>
+                <a:spcPts val="0"/>
+              </a:spcBef>
+              <a:spcAft>
+                <a:spcPts val="0"/>
+              </a:spcAft>
+              <a:buNone/>
+            </a:pPr>
+            <a:r>
+              <a:rPr b="0" i="0" lang="en-US" sz="3000" u="none" cap="none" strike="noStrike">
+                <a:solidFill>
+                  <a:srgbClr val="000000"/>
+                </a:solidFill>
+                <a:latin typeface="Poppins"/>
+                <a:ea typeface="Poppins"/>
+                <a:cs typeface="Poppins"/>
+                <a:sym typeface="Poppins"/>
+              </a:rPr>
+              <a:t>Five owner calls with a free 30-day pilot, and a receipt-scan test with about 10 users.</a:t>
             </a:r>
             <a:endParaRPr/>
           </a:p>
@@ -17144,8 +16850,8 @@
         </p:nvSpPr>
         <p:spPr>
           <a:xfrm>
-            <a:off x="822960" y="3749039"/>
-            <a:ext cx="3840480" cy="1188720"/>
+            <a:off x="822960" y="4023360"/>
+            <a:ext cx="3840480" cy="822960"/>
           </a:xfrm>
           <a:prstGeom prst="rect">
             <a:avLst/>
@@ -17174,7 +16880,7 @@
               <a:buNone/>
             </a:pPr>
             <a:r>
-              <a:rPr b="0" i="0" lang="en-US" sz="6600" u="none" cap="none" strike="noStrike">
+              <a:rPr b="0" i="0" lang="en-US" sz="4000" u="none" cap="none" strike="noStrike">
                 <a:solidFill>
                   <a:srgbClr val="2E2D12"/>
                 </a:solidFill>
@@ -17227,7 +16933,7 @@
               <a:buNone/>
             </a:pPr>
             <a:r>
-              <a:rPr b="0" i="0" lang="en-US" sz="2400" u="none" cap="none" strike="noStrike">
+              <a:rPr b="1" i="0" lang="en-US" sz="2800" u="none" cap="none" strike="noStrike">
                 <a:solidFill>
                   <a:srgbClr val="000000"/>
                 </a:solidFill>
@@ -17238,7 +16944,7 @@
               </a:rPr>
               <a:t>Google Maps</a:t>
             </a:r>
-            <a:endParaRPr sz="2400"/>
+            <a:endParaRPr sz="2800"/>
           </a:p>
         </p:txBody>
       </p:sp>
@@ -17250,7 +16956,7 @@
         </p:nvSpPr>
         <p:spPr>
           <a:xfrm>
-            <a:off x="822960" y="5989320"/>
+            <a:off x="822960" y="6035040"/>
             <a:ext cx="3931800" cy="369300"/>
           </a:xfrm>
           <a:prstGeom prst="rect">
@@ -17303,8 +17009,8 @@
         </p:nvSpPr>
         <p:spPr>
           <a:xfrm>
-            <a:off x="5074920" y="3749039"/>
-            <a:ext cx="3840480" cy="1188720"/>
+            <a:off x="5074920" y="4023360"/>
+            <a:ext cx="3840480" cy="822960"/>
           </a:xfrm>
           <a:prstGeom prst="rect">
             <a:avLst/>
@@ -17333,7 +17039,7 @@
               <a:buNone/>
             </a:pPr>
             <a:r>
-              <a:rPr b="0" i="0" lang="en-US" sz="6600" u="none" cap="none" strike="noStrike">
+              <a:rPr b="0" i="0" lang="en-US" sz="4000" u="none" cap="none" strike="noStrike">
                 <a:solidFill>
                   <a:srgbClr val="2E2D12"/>
                 </a:solidFill>
@@ -17386,7 +17092,7 @@
               <a:buNone/>
             </a:pPr>
             <a:r>
-              <a:rPr b="0" i="0" lang="en-US" sz="2400" u="none" cap="none" strike="noStrike">
+              <a:rPr b="1" i="0" lang="en-US" sz="2800" u="none" cap="none" strike="noStrike">
                 <a:solidFill>
                   <a:srgbClr val="000000"/>
                 </a:solidFill>
@@ -17397,7 +17103,7 @@
               </a:rPr>
               <a:t>Instagram or TikTok</a:t>
             </a:r>
-            <a:endParaRPr sz="2400"/>
+            <a:endParaRPr sz="2800"/>
           </a:p>
         </p:txBody>
       </p:sp>
@@ -17409,7 +17115,7 @@
         </p:nvSpPr>
         <p:spPr>
           <a:xfrm>
-            <a:off x="5074920" y="5989320"/>
+            <a:off x="5074920" y="6035040"/>
             <a:ext cx="3931800" cy="369300"/>
           </a:xfrm>
           <a:prstGeom prst="rect">
@@ -17462,8 +17168,8 @@
         </p:nvSpPr>
         <p:spPr>
           <a:xfrm>
-            <a:off x="9326880" y="3749039"/>
-            <a:ext cx="3840480" cy="1188720"/>
+            <a:off x="9326880" y="4023360"/>
+            <a:ext cx="3840480" cy="822960"/>
           </a:xfrm>
           <a:prstGeom prst="rect">
             <a:avLst/>
@@ -17492,7 +17198,7 @@
               <a:buNone/>
             </a:pPr>
             <a:r>
-              <a:rPr b="0" i="0" lang="en-US" sz="6600" u="none" cap="none" strike="noStrike">
+              <a:rPr b="0" i="0" lang="en-US" sz="4000" u="none" cap="none" strike="noStrike">
                 <a:solidFill>
                   <a:srgbClr val="2E2D12"/>
                 </a:solidFill>
@@ -17545,7 +17251,7 @@
               <a:buNone/>
             </a:pPr>
             <a:r>
-              <a:rPr b="0" i="0" lang="en-US" sz="2400" u="none" cap="none" strike="noStrike">
+              <a:rPr b="1" i="0" lang="en-US" sz="2800" u="none" cap="none" strike="noStrike">
                 <a:solidFill>
                   <a:srgbClr val="000000"/>
                 </a:solidFill>
@@ -17556,7 +17262,7 @@
               </a:rPr>
               <a:t>A friend</a:t>
             </a:r>
-            <a:endParaRPr sz="2400"/>
+            <a:endParaRPr sz="2800"/>
           </a:p>
         </p:txBody>
       </p:sp>
@@ -17568,7 +17274,7 @@
         </p:nvSpPr>
         <p:spPr>
           <a:xfrm>
-            <a:off x="9326880" y="5989320"/>
+            <a:off x="9326880" y="6035040"/>
             <a:ext cx="3931800" cy="369300"/>
           </a:xfrm>
           <a:prstGeom prst="rect">
@@ -17621,8 +17327,8 @@
         </p:nvSpPr>
         <p:spPr>
           <a:xfrm>
-            <a:off x="13578840" y="3749039"/>
-            <a:ext cx="3840480" cy="1188720"/>
+            <a:off x="13578840" y="4023360"/>
+            <a:ext cx="3840480" cy="822960"/>
           </a:xfrm>
           <a:prstGeom prst="rect">
             <a:avLst/>
@@ -17651,7 +17357,7 @@
               <a:buNone/>
             </a:pPr>
             <a:r>
-              <a:rPr b="0" i="0" lang="en-US" sz="6600" u="none" cap="none" strike="noStrike">
+              <a:rPr b="0" i="0" lang="en-US" sz="4000" u="none" cap="none" strike="noStrike">
                 <a:solidFill>
                   <a:srgbClr val="000000"/>
                 </a:solidFill>
@@ -17704,7 +17410,7 @@
               <a:buNone/>
             </a:pPr>
             <a:r>
-              <a:rPr b="0" i="0" lang="en-US" sz="2400" u="none" cap="none" strike="noStrike">
+              <a:rPr b="1" i="0" lang="en-US" sz="2800" u="none" cap="none" strike="noStrike">
                 <a:solidFill>
                   <a:srgbClr val="000000"/>
                 </a:solidFill>
@@ -17715,7 +17421,7 @@
               </a:rPr>
               <a:t>Then they go</a:t>
             </a:r>
-            <a:endParaRPr sz="2400"/>
+            <a:endParaRPr sz="2800"/>
           </a:p>
         </p:txBody>
       </p:sp>
@@ -17727,7 +17433,7 @@
         </p:nvSpPr>
         <p:spPr>
           <a:xfrm>
-            <a:off x="13578840" y="5989320"/>
+            <a:off x="13578840" y="6035040"/>
             <a:ext cx="3931800" cy="369300"/>
           </a:xfrm>
           <a:prstGeom prst="rect">
@@ -17810,7 +17516,7 @@
               <a:buNone/>
             </a:pPr>
             <a:r>
-              <a:rPr b="0" i="0" lang="en-US" sz="2400" u="none" cap="none" strike="noStrike">
+              <a:rPr b="1" i="0" lang="en-US" sz="2800" u="none" cap="none" strike="noStrike">
                 <a:solidFill>
                   <a:srgbClr val="000000"/>
                 </a:solidFill>
@@ -17821,7 +17527,7 @@
               </a:rPr>
               <a:t>Nobody had one place to save where they want to go.</a:t>
             </a:r>
-            <a:endParaRPr sz="2400"/>
+            <a:endParaRPr sz="2800"/>
           </a:p>
         </p:txBody>
       </p:sp>
@@ -17833,7 +17539,7 @@
         </p:nvSpPr>
         <p:spPr>
           <a:xfrm>
-            <a:off x="822960" y="8275320"/>
+            <a:off x="822960" y="8229600"/>
             <a:ext cx="16642200" cy="369300"/>
           </a:xfrm>
           <a:prstGeom prst="rect">
@@ -17863,7 +17569,7 @@
               <a:buNone/>
             </a:pPr>
             <a:r>
-              <a:rPr b="0" i="0" lang="en-US" sz="2400" u="none" cap="none" strike="noStrike">
+              <a:rPr b="1" i="0" lang="en-US" sz="2800" u="none" cap="none" strike="noStrike">
                 <a:solidFill>
                   <a:srgbClr val="1F1F1F"/>
                 </a:solidFill>
@@ -17874,7 +17580,7 @@
               </a:rPr>
               <a:t>They want one app they can trust.</a:t>
             </a:r>
-            <a:endParaRPr sz="2400"/>
+            <a:endParaRPr sz="2800"/>
           </a:p>
         </p:txBody>
       </p:sp>
@@ -18783,13 +18489,78 @@
       </p:sp>
       <p:sp>
         <p:nvSpPr>
+          <p:cNvPr id="960" name="Google Shape;960;p3"/>
+          <p:cNvSpPr txBox="1"/>
+          <p:nvPr/>
+        </p:nvSpPr>
+        <p:spPr>
+          <a:xfrm>
+            <a:off x="822960" y="7360920"/>
+            <a:ext cx="16642080" cy="822960"/>
+          </a:xfrm>
+          <a:prstGeom prst="rect">
+            <a:avLst/>
+          </a:prstGeom>
+          <a:noFill/>
+          <a:ln>
+            <a:noFill/>
+          </a:ln>
+        </p:spPr>
+        <p:txBody>
+          <a:bodyPr anchorCtr="0" anchor="t" bIns="0" lIns="0" spcFirstLastPara="1" rIns="0" wrap="square" tIns="0">
+            <a:spAutoFit/>
+          </a:bodyPr>
+          <a:lstStyle/>
+          <a:p>
+            <a:pPr indent="0" lvl="0" marL="0" marR="0" rtl="0" algn="l">
+              <a:lnSpc>
+                <a:spcPct val="110000"/>
+              </a:lnSpc>
+              <a:spcBef>
+                <a:spcPts val="0"/>
+              </a:spcBef>
+              <a:spcAft>
+                <a:spcPts val="0"/>
+              </a:spcAft>
+              <a:buNone/>
+            </a:pPr>
+            <a:r>
+              <a:rPr b="1" i="0" lang="en-US" sz="2400" u="none" cap="none" strike="noStrike">
+                <a:solidFill>
+                  <a:srgbClr val="6F6B34"/>
+                </a:solidFill>
+                <a:latin typeface="Poppins"/>
+                <a:ea typeface="Poppins"/>
+                <a:cs typeface="Poppins"/>
+                <a:sym typeface="Poppins"/>
+              </a:rPr>
+              <a:t xml:space="preserve">Why not Beli? </a:t>
+            </a:r>
+            <a:r>
+              <a:rPr b="0" i="0" lang="en-US" sz="2400" u="none" cap="none" strike="noStrike">
+                <a:solidFill>
+                  <a:srgbClr val="434343"/>
+                </a:solidFill>
+                <a:latin typeface="Poppins"/>
+                <a:ea typeface="Poppins"/>
+                <a:cs typeface="Poppins"/>
+                <a:sym typeface="Poppins"/>
+              </a:rPr>
+              <a:t>Beli ranks where you’ve been. We tell you where to go now, with scores people proved.</a:t>
+            </a:r>
+            <a:endParaRPr/>
+          </a:p>
+        </p:txBody>
+      </p:sp>
+      <p:sp>
+        <p:nvSpPr>
           <p:cNvPr id="150" name="Google Shape;150;p3"/>
           <p:cNvSpPr txBox="1"/>
           <p:nvPr/>
         </p:nvSpPr>
         <p:spPr>
           <a:xfrm>
-            <a:off x="822960" y="8458200"/>
+            <a:off x="822960" y="8412480"/>
             <a:ext cx="16642080" cy="548640"/>
           </a:xfrm>
           <a:prstGeom prst="rect">
@@ -18861,6 +18632,124 @@
       </p:grpSpPr>
       <p:sp>
         <p:nvSpPr>
+          <p:cNvPr id="950" name="Google Shape;950;p5"/>
+          <p:cNvSpPr txBox="1"/>
+          <p:nvPr/>
+        </p:nvSpPr>
+        <p:spPr>
+          <a:xfrm>
+            <a:off x="822960" y="685800"/>
+            <a:ext cx="10972800" cy="411480"/>
+          </a:xfrm>
+          <a:prstGeom prst="rect">
+            <a:avLst/>
+          </a:prstGeom>
+          <a:noFill/>
+          <a:ln>
+            <a:noFill/>
+          </a:ln>
+        </p:spPr>
+        <p:txBody>
+          <a:bodyPr anchorCtr="0" anchor="t" bIns="0" lIns="0" spcFirstLastPara="1" rIns="0" wrap="square" tIns="0">
+            <a:spAutoFit/>
+          </a:bodyPr>
+          <a:lstStyle/>
+          <a:p>
+            <a:pPr indent="0" lvl="0" marL="0" marR="0" rtl="0" algn="l">
+              <a:lnSpc>
+                <a:spcPct val="110000"/>
+              </a:lnSpc>
+              <a:spcBef>
+                <a:spcPts val="0"/>
+              </a:spcBef>
+              <a:spcAft>
+                <a:spcPts val="0"/>
+              </a:spcAft>
+              <a:buNone/>
+            </a:pPr>
+            <a:r>
+              <a:rPr b="0" i="0" lang="en-US" sz="1800" u="none" cap="none" strike="noStrike">
+                <a:solidFill>
+                  <a:srgbClr val="6F6B34"/>
+                </a:solidFill>
+                <a:latin typeface="Poppins"/>
+                <a:ea typeface="Poppins"/>
+                <a:cs typeface="Poppins"/>
+                <a:sym typeface="Poppins"/>
+              </a:rPr>
+              <a:t>What it looks like</a:t>
+            </a:r>
+            <a:endParaRPr/>
+          </a:p>
+        </p:txBody>
+      </p:sp>
+      <p:sp>
+        <p:nvSpPr>
+          <p:cNvPr id="951" name="Google Shape;951;p5"/>
+          <p:cNvSpPr txBox="1"/>
+          <p:nvPr/>
+        </p:nvSpPr>
+        <p:spPr>
+          <a:xfrm>
+            <a:off x="822960" y="1234440"/>
+            <a:ext cx="15087600" cy="731520"/>
+          </a:xfrm>
+          <a:prstGeom prst="rect">
+            <a:avLst/>
+          </a:prstGeom>
+          <a:noFill/>
+          <a:ln>
+            <a:noFill/>
+          </a:ln>
+        </p:spPr>
+        <p:txBody>
+          <a:bodyPr anchorCtr="0" anchor="t" bIns="0" lIns="0" spcFirstLastPara="1" rIns="0" wrap="square" tIns="0">
+            <a:spAutoFit/>
+          </a:bodyPr>
+          <a:lstStyle/>
+          <a:p>
+            <a:pPr indent="0" lvl="0" marL="0" marR="0" rtl="0" algn="l">
+              <a:lnSpc>
+                <a:spcPct val="108000"/>
+              </a:lnSpc>
+              <a:spcBef>
+                <a:spcPts val="0"/>
+              </a:spcBef>
+              <a:spcAft>
+                <a:spcPts val="0"/>
+              </a:spcAft>
+              <a:buNone/>
+            </a:pPr>
+            <a:r>
+              <a:rPr b="0" i="0" lang="en-US" sz="4400" u="none" cap="none" strike="noStrike">
+                <a:solidFill>
+                  <a:srgbClr val="000000"/>
+                </a:solidFill>
+                <a:latin typeface="Poppins"/>
+                <a:ea typeface="Poppins"/>
+                <a:cs typeface="Poppins"/>
+                <a:sym typeface="Poppins"/>
+              </a:rPr>
+              <a:t xml:space="preserve">Open it, and it picks one place for you, </a:t>
+            </a:r>
+            <a:r>
+              <a:rPr b="0" i="0" lang="en-US" sz="4400" u="none" cap="none" strike="noStrike">
+                <a:solidFill>
+                  <a:srgbClr val="595959"/>
+                </a:solidFill>
+                <a:latin typeface="Poppins"/>
+                <a:ea typeface="Poppins"/>
+                <a:cs typeface="Poppins"/>
+                <a:sym typeface="Poppins"/>
+              </a:rPr>
+              <a:t>and shows why.</a:t>
+            </a:r>
+            <a:endParaRPr/>
+          </a:p>
+        </p:txBody>
+      </p:sp>
+      <p:sp>
+        <p:nvSpPr>
           <p:cNvPr id="156" name="Google Shape;156;p4"/>
           <p:cNvSpPr txBox="1"/>
           <p:nvPr/>
@@ -18980,8 +18869,8 @@
         </p:blipFill>
         <p:spPr>
           <a:xfrm>
-            <a:off x="822950" y="685800"/>
-            <a:ext cx="3617965" cy="7463324"/>
+            <a:off x="1224550" y="2331720"/>
+            <a:ext cx="2814764" cy="5806440"/>
           </a:xfrm>
           <a:prstGeom prst="rect">
             <a:avLst/>
@@ -19030,7 +18919,7 @@
               <a:buNone/>
             </a:pPr>
             <a:r>
-              <a:rPr b="1" i="0" lang="en-US" sz="2000" u="none" cap="none" strike="noStrike">
+              <a:rPr b="1" i="0" lang="en-US" sz="2200" u="none" cap="none" strike="noStrike">
                 <a:solidFill>
                   <a:srgbClr val="6F6B34"/>
                 </a:solidFill>
@@ -19113,8 +19002,8 @@
         </p:blipFill>
         <p:spPr>
           <a:xfrm>
-            <a:off x="5074925" y="685785"/>
-            <a:ext cx="3617975" cy="7463313"/>
+            <a:off x="5476524" y="2331720"/>
+            <a:ext cx="2814776" cy="5806440"/>
           </a:xfrm>
           <a:prstGeom prst="rect">
             <a:avLst/>
@@ -19163,7 +19052,7 @@
               <a:buNone/>
             </a:pPr>
             <a:r>
-              <a:rPr b="1" i="0" lang="en-US" sz="2000" u="none" cap="none" strike="noStrike">
+              <a:rPr b="1" i="0" lang="en-US" sz="2200" u="none" cap="none" strike="noStrike">
                 <a:solidFill>
                   <a:srgbClr val="6F6B34"/>
                 </a:solidFill>
@@ -19246,8 +19135,8 @@
         </p:blipFill>
         <p:spPr>
           <a:xfrm>
-            <a:off x="9326875" y="685785"/>
-            <a:ext cx="3617975" cy="7463313"/>
+            <a:off x="9728474" y="2331720"/>
+            <a:ext cx="2814776" cy="5806440"/>
           </a:xfrm>
           <a:prstGeom prst="rect">
             <a:avLst/>
@@ -19296,7 +19185,7 @@
               <a:buNone/>
             </a:pPr>
             <a:r>
-              <a:rPr b="1" i="0" lang="en-US" sz="2000" u="none" cap="none" strike="noStrike">
+              <a:rPr b="1" i="0" lang="en-US" sz="2200" u="none" cap="none" strike="noStrike">
                 <a:solidFill>
                   <a:srgbClr val="6F6B34"/>
                 </a:solidFill>
@@ -19379,8 +19268,8 @@
         </p:blipFill>
         <p:spPr>
           <a:xfrm>
-            <a:off x="13578850" y="685785"/>
-            <a:ext cx="3617975" cy="7463313"/>
+            <a:off x="13980449" y="2331720"/>
+            <a:ext cx="2814776" cy="5806440"/>
           </a:xfrm>
           <a:prstGeom prst="rect">
             <a:avLst/>
@@ -19429,7 +19318,7 @@
               <a:buNone/>
             </a:pPr>
             <a:r>
-              <a:rPr b="1" i="0" lang="en-US" sz="2000" u="none" cap="none" strike="noStrike">
+              <a:rPr b="1" i="0" lang="en-US" sz="2200" u="none" cap="none" strike="noStrike">
                 <a:solidFill>
                   <a:srgbClr val="6F6B34"/>
                 </a:solidFill>
@@ -20289,7 +20178,7 @@
         </p:nvSpPr>
         <p:spPr>
           <a:xfrm>
-            <a:off x="822960" y="7040880"/>
+            <a:off x="822960" y="7196328"/>
             <a:ext cx="2743200" cy="369300"/>
           </a:xfrm>
           <a:prstGeom prst="rect">
@@ -20342,7 +20231,7 @@
         </p:nvSpPr>
         <p:spPr>
           <a:xfrm>
-            <a:off x="3657600" y="7022592"/>
+            <a:off x="3657600" y="7178040"/>
             <a:ext cx="13807500" cy="775800"/>
           </a:xfrm>
           <a:prstGeom prst="rect">
@@ -20395,7 +20284,7 @@
         </p:nvSpPr>
         <p:spPr>
           <a:xfrm>
-            <a:off x="822935" y="8046720"/>
+            <a:off x="822935" y="8229600"/>
             <a:ext cx="2743200" cy="369300"/>
           </a:xfrm>
           <a:prstGeom prst="rect">
@@ -20448,7 +20337,7 @@
         </p:nvSpPr>
         <p:spPr>
           <a:xfrm>
-            <a:off x="3657575" y="8028432"/>
+            <a:off x="3657575" y="8211312"/>
             <a:ext cx="13807500" cy="369300"/>
           </a:xfrm>
           <a:prstGeom prst="rect">
@@ -20488,112 +20377,6 @@
                 <a:sym typeface="Poppins"/>
               </a:rPr>
               <a:t>Boston first. Other cities from Year 3.</a:t>
-            </a:r>
-            <a:endParaRPr sz="2400"/>
-          </a:p>
-        </p:txBody>
-      </p:sp>
-      <p:sp>
-        <p:nvSpPr>
-          <p:cNvPr id="193" name="Google Shape;193;p5"/>
-          <p:cNvSpPr txBox="1"/>
-          <p:nvPr/>
-        </p:nvSpPr>
-        <p:spPr>
-          <a:xfrm>
-            <a:off x="822935" y="8686800"/>
-            <a:ext cx="2743200" cy="369300"/>
-          </a:xfrm>
-          <a:prstGeom prst="rect">
-            <a:avLst/>
-          </a:prstGeom>
-          <a:noFill/>
-          <a:ln>
-            <a:noFill/>
-          </a:ln>
-        </p:spPr>
-        <p:txBody>
-          <a:bodyPr anchorCtr="0" anchor="t" bIns="0" lIns="0" spcFirstLastPara="1" rIns="0" wrap="square" tIns="0">
-            <a:spAutoFit/>
-          </a:bodyPr>
-          <a:lstStyle/>
-          <a:p>
-            <a:pPr indent="0" lvl="0" marL="0" marR="0" rtl="0" algn="l">
-              <a:lnSpc>
-                <a:spcPct val="110000"/>
-              </a:lnSpc>
-              <a:spcBef>
-                <a:spcPts val="0"/>
-              </a:spcBef>
-              <a:spcAft>
-                <a:spcPts val="0"/>
-              </a:spcAft>
-              <a:buNone/>
-            </a:pPr>
-            <a:r>
-              <a:rPr b="1" i="0" lang="en-US" sz="2400" u="none" cap="none" strike="noStrike">
-                <a:solidFill>
-                  <a:srgbClr val="6F6B34"/>
-                </a:solidFill>
-                <a:latin typeface="Poppins"/>
-                <a:ea typeface="Poppins"/>
-                <a:cs typeface="Poppins"/>
-                <a:sym typeface="Poppins"/>
-              </a:rPr>
-              <a:t>Why not Beli</a:t>
-            </a:r>
-            <a:endParaRPr sz="2400"/>
-          </a:p>
-        </p:txBody>
-      </p:sp>
-      <p:sp>
-        <p:nvSpPr>
-          <p:cNvPr id="194" name="Google Shape;194;p5"/>
-          <p:cNvSpPr txBox="1"/>
-          <p:nvPr/>
-        </p:nvSpPr>
-        <p:spPr>
-          <a:xfrm>
-            <a:off x="3657575" y="8668512"/>
-            <a:ext cx="13807500" cy="369300"/>
-          </a:xfrm>
-          <a:prstGeom prst="rect">
-            <a:avLst/>
-          </a:prstGeom>
-          <a:noFill/>
-          <a:ln>
-            <a:noFill/>
-          </a:ln>
-        </p:spPr>
-        <p:txBody>
-          <a:bodyPr anchorCtr="0" anchor="t" bIns="0" lIns="0" spcFirstLastPara="1" rIns="0" wrap="square" tIns="0">
-            <a:spAutoFit/>
-          </a:bodyPr>
-          <a:lstStyle/>
-          <a:p>
-            <a:pPr indent="0" lvl="0" marL="0" marR="0" rtl="0" algn="l">
-              <a:lnSpc>
-                <a:spcPct val="110000"/>
-              </a:lnSpc>
-              <a:spcBef>
-                <a:spcPts val="0"/>
-              </a:spcBef>
-              <a:spcAft>
-                <a:spcPts val="0"/>
-              </a:spcAft>
-              <a:buNone/>
-            </a:pPr>
-            <a:r>
-              <a:rPr b="0" i="0" lang="en-US" sz="2400" u="none" cap="none" strike="noStrike">
-                <a:solidFill>
-                  <a:srgbClr val="434343"/>
-                </a:solidFill>
-                <a:latin typeface="Poppins"/>
-                <a:ea typeface="Poppins"/>
-                <a:cs typeface="Poppins"/>
-                <a:sym typeface="Poppins"/>
-              </a:rPr>
-              <a:t>Beli ranks where you've been. We tell you where to go now, with scores people proved.</a:t>
             </a:r>
             <a:endParaRPr sz="2400"/>
           </a:p>
@@ -22270,7 +22053,7 @@
                 <a:cs typeface="Poppins"/>
                 <a:sym typeface="Poppins"/>
               </a:rPr>
-              <a:t>Pay for ads up front and can't tell what worked. Chains guess what a neighborhood eats before signing a lease.</a:t>
+              <a:t>Pay for ads up front and can’t tell what worked.</a:t>
             </a:r>
             <a:endParaRPr sz="2200"/>
           </a:p>
@@ -22323,16 +22106,7 @@
                 <a:cs typeface="Poppins"/>
                 <a:sym typeface="Poppins"/>
               </a:rPr>
-              <a:t>About $0.90 per new diner we send, once a receipt proves it. Booking sites pay per table. Chains: $6,000 a year per neighborhood</a:t>
-            </a:r>
-            <a:r>
-              <a:rPr lang="en-US" sz="2200">
-                <a:latin typeface="Poppins"/>
-                <a:ea typeface="Poppins"/>
-                <a:cs typeface="Poppins"/>
-                <a:sym typeface="Poppins"/>
-              </a:rPr>
-              <a:t>.</a:t>
+              <a:t>About $0.90 per new diner, once a receipt proves the visit. Booking sites pay per table. Chains pay $6,000 a year per area.</a:t>
             </a:r>
             <a:endParaRPr sz="2200"/>
           </a:p>
@@ -22549,7 +22323,7 @@
                 <a:cs typeface="Poppins"/>
                 <a:sym typeface="Poppins"/>
               </a:rPr>
-              <a:t>The app is free. About 3 in 1,000 pay for extras. What the $5 buys is our first Year 1 test.</a:t>
+              <a:t>The app is free. About 3 in 1,000 pay for extras.</a:t>
             </a:r>
             <a:endParaRPr sz="2200"/>
           </a:p>
@@ -22810,6 +22584,18 @@
               <a:buNone/>
             </a:pPr>
             <a:r>
+              <a:rPr b="1" i="0" lang="en-US" sz="2400" u="none" cap="none" strike="noStrike">
+                <a:solidFill>
+                  <a:srgbClr val="000000"/>
+                </a:solidFill>
+                <a:latin typeface="Poppins"/>
+                <a:ea typeface="Poppins"/>
+                <a:cs typeface="Poppins"/>
+                <a:sym typeface="Poppins"/>
+              </a:rPr>
+              <a:t xml:space="preserve">Not yet tested with owners. </a:t>
+            </a:r>
+            <a:r>
               <a:rPr b="0" i="0" lang="en-US" sz="2400" u="none" cap="none" strike="noStrike">
                 <a:solidFill>
                   <a:srgbClr val="434343"/>
@@ -22819,7 +22605,7 @@
                 <a:cs typeface="Poppins"/>
                 <a:sym typeface="Poppins"/>
               </a:rPr>
-              <a:t>Next: five owner calls, each offered a free 30-day pilot and a report of the diners we sent.</a:t>
+              <a:t>Next: five owner calls, each with a free 30-day pilot and a diner report.</a:t>
             </a:r>
             <a:endParaRPr sz="2400"/>
           </a:p>
@@ -23391,7 +23177,7 @@
                 <a:cs typeface="Poppins"/>
                 <a:sym typeface="Poppins"/>
               </a:rPr>
-              <a:t>No salaries. Co-op students before hires.</a:t>
+              <a:t>No founder salaries. Co-op students before full-time hires.</a:t>
             </a:r>
             <a:endParaRPr sz="2400"/>
           </a:p>
@@ -24067,7 +23853,7 @@
                 <a:cs typeface="Poppins"/>
                 <a:sym typeface="Poppins"/>
               </a:rPr>
-              <a:t>10</a:t>
+              <a:t>9</a:t>
             </a:r>
             <a:endParaRPr/>
           </a:p>
@@ -24132,7 +23918,7 @@
                 <a:cs typeface="Poppins"/>
                 <a:sym typeface="Poppins"/>
               </a:rPr>
-              <a:t>Our lowest point is $192K, in Year 4.</a:t>
+              <a:t>Year 5 is our first profit.</a:t>
             </a:r>
             <a:endParaRPr/>
           </a:p>
@@ -25273,7 +25059,7 @@
                   </a:txBody>
                   <a:tcPr marT="27425" marB="27425" marR="73150" marL="73150" anchor="ctr">
                     <a:solidFill>
-                      <a:srgbClr val="EFE6C4"/>
+                      <a:srgbClr val="AAA676"/>
                     </a:solidFill>
                   </a:tcPr>
                 </a:tc>
@@ -26327,7 +26113,7 @@
                   </a:txBody>
                   <a:tcPr marT="27425" marB="27425" marR="73150" marL="73150" anchor="ctr">
                     <a:solidFill>
-                      <a:srgbClr val="EFE6C4"/>
+                      <a:srgbClr val="AAA676"/>
                     </a:solidFill>
                   </a:tcPr>
                 </a:tc>
@@ -26714,7 +26500,7 @@
                   </a:txBody>
                   <a:tcPr marT="27425" marB="27425" marR="73150" marL="73150" anchor="ctr">
                     <a:solidFill>
-                      <a:srgbClr val="EFE6C4"/>
+                      <a:srgbClr val="AAA676"/>
                     </a:solidFill>
                   </a:tcPr>
                 </a:tc>

</xml_diff>

<commit_message>
Make slides 2 and 8 the olive key moments; summary back to white
Co-Authored-By: Claude Opus 5.5 <noreply@anthropic.com>
Claude-Session: https://claude.ai/code/session_017KdnwN2qyuF8wMBvTngErS
</commit_message>
<xml_diff>
--- a/ENTR_4501_Gate_2_deck_readable.pptx
+++ b/ENTR_4501_Gate_2_deck_readable.pptx
@@ -15910,14 +15910,6 @@
 <file path=ppt/slides/slide12.xml><?xml version="1.0" encoding="utf-8"?>
 <p:sld xmlns:a="http://schemas.openxmlformats.org/drawingml/2006/main" xmlns:r="http://schemas.openxmlformats.org/officeDocument/2006/relationships" xmlns:mc="http://schemas.openxmlformats.org/markup-compatibility/2006" xmlns:mv="urn:schemas-microsoft-com:mac:vml" xmlns:p="http://schemas.openxmlformats.org/presentationml/2006/main" xmlns:c="http://schemas.openxmlformats.org/drawingml/2006/chart" xmlns:dgm="http://schemas.openxmlformats.org/drawingml/2006/diagram" xmlns:o="urn:schemas-microsoft-com:office:office" xmlns:v="urn:schemas-microsoft-com:vml" xmlns:pvml="urn:schemas-microsoft-com:office:powerpoint" xmlns:com="http://schemas.openxmlformats.org/drawingml/2006/compatibility" xmlns:p14="http://schemas.microsoft.com/office/powerpoint/2010/main" xmlns:p15="http://schemas.microsoft.com/office/powerpoint/2012/main" xmlns:ahyp="http://schemas.microsoft.com/office/drawing/2018/hyperlinkcolor">
   <p:cSld>
-    <p:bg>
-      <p:bgPr>
-        <a:solidFill>
-          <a:srgbClr val="AAA676"/>
-        </a:solidFill>
-        <a:effectLst/>
-      </p:bgPr>
-    </p:bg>
     <p:spTree>
       <p:nvGrpSpPr>
         <p:cNvPr id="112" name="Shape 112"/>
@@ -15972,7 +15964,7 @@
             <a:r>
               <a:rPr b="0" i="0" lang="en-US" sz="1800" u="none" cap="none" strike="noStrike">
                 <a:solidFill>
-                  <a:srgbClr val="2E2D12"/>
+                  <a:srgbClr val="6F6B34"/>
                 </a:solidFill>
                 <a:latin typeface="Poppins"/>
                 <a:ea typeface="Poppins"/>
@@ -16012,20 +16004,20 @@
           <a:p>
             <a:pPr indent="0" lvl="0" marL="0" marR="0" rtl="0" algn="r">
               <a:lnSpc>
-                <a:spcPct val="1F1F1F"/>
+                <a:spcPct val="110000"/>
               </a:lnSpc>
               <a:spcBef>
-                <a:spcPts val="1F1F1F"/>
-              </a:spcBef>
-              <a:spcAft>
-                <a:spcPts val="1F1F1F"/>
+                <a:spcPts val="0"/>
+              </a:spcBef>
+              <a:spcAft>
+                <a:spcPts val="0"/>
               </a:spcAft>
               <a:buNone/>
             </a:pPr>
             <a:r>
               <a:rPr b="0" i="0" lang="en-US" sz="1400" u="none" cap="none" strike="noStrike">
                 <a:solidFill>
-                  <a:srgbClr val="1F1F1F"/>
+                  <a:srgbClr val="595959"/>
                 </a:solidFill>
                 <a:latin typeface="Poppins"/>
                 <a:ea typeface="Poppins"/>
@@ -16090,7 +16082,7 @@
             <a:r>
               <a:rPr b="0" i="0" lang="en-US" sz="4400" u="none" cap="none" strike="noStrike">
                 <a:solidFill>
-                  <a:srgbClr val="2E2D12"/>
+                  <a:srgbClr val="595959"/>
                 </a:solidFill>
                 <a:latin typeface="Poppins"/>
                 <a:ea typeface="Poppins"/>
@@ -16143,7 +16135,7 @@
             <a:r>
               <a:rPr b="1" i="0" lang="en-US" sz="2400" u="none" cap="none" strike="noStrike">
                 <a:solidFill>
-                  <a:srgbClr val="2E2D12"/>
+                  <a:srgbClr val="6F6B34"/>
                 </a:solidFill>
                 <a:latin typeface="Poppins"/>
                 <a:ea typeface="Poppins"/>
@@ -16249,7 +16241,7 @@
             <a:r>
               <a:rPr b="1" i="0" lang="en-US" sz="2400" u="none" cap="none" strike="noStrike">
                 <a:solidFill>
-                  <a:srgbClr val="2E2D12"/>
+                  <a:srgbClr val="6F6B34"/>
                 </a:solidFill>
                 <a:latin typeface="Poppins"/>
                 <a:ea typeface="Poppins"/>
@@ -16355,7 +16347,7 @@
             <a:r>
               <a:rPr b="1" i="0" lang="en-US" sz="2400" u="none" cap="none" strike="noStrike">
                 <a:solidFill>
-                  <a:srgbClr val="2E2D12"/>
+                  <a:srgbClr val="6F6B34"/>
                 </a:solidFill>
                 <a:latin typeface="Poppins"/>
                 <a:ea typeface="Poppins"/>
@@ -16461,7 +16453,7 @@
             <a:r>
               <a:rPr b="1" i="0" lang="en-US" sz="2400" u="none" cap="none" strike="noStrike">
                 <a:solidFill>
-                  <a:srgbClr val="2E2D12"/>
+                  <a:srgbClr val="6F6B34"/>
                 </a:solidFill>
                 <a:latin typeface="Poppins"/>
                 <a:ea typeface="Poppins"/>
@@ -22622,6 +22614,14 @@
 <file path=ppt/slides/slide8.xml><?xml version="1.0" encoding="utf-8"?>
 <p:sld xmlns:a="http://schemas.openxmlformats.org/drawingml/2006/main" xmlns:r="http://schemas.openxmlformats.org/officeDocument/2006/relationships" xmlns:mc="http://schemas.openxmlformats.org/markup-compatibility/2006" xmlns:mv="urn:schemas-microsoft-com:mac:vml" xmlns:p="http://schemas.openxmlformats.org/presentationml/2006/main" xmlns:c="http://schemas.openxmlformats.org/drawingml/2006/chart" xmlns:dgm="http://schemas.openxmlformats.org/drawingml/2006/diagram" xmlns:o="urn:schemas-microsoft-com:office:office" xmlns:v="urn:schemas-microsoft-com:vml" xmlns:pvml="urn:schemas-microsoft-com:office:powerpoint" xmlns:com="http://schemas.openxmlformats.org/drawingml/2006/compatibility" xmlns:p14="http://schemas.microsoft.com/office/powerpoint/2010/main" xmlns:p15="http://schemas.microsoft.com/office/powerpoint/2012/main" xmlns:ahyp="http://schemas.microsoft.com/office/drawing/2018/hyperlinkcolor">
   <p:cSld>
+    <p:bg>
+      <p:bgPr>
+        <a:solidFill>
+          <a:srgbClr val="AAA676"/>
+        </a:solidFill>
+        <a:effectLst/>
+      </p:bgPr>
+    </p:bg>
     <p:spTree>
       <p:nvGrpSpPr>
         <p:cNvPr id="249" name="Shape 249"/>
@@ -22676,7 +22676,7 @@
             <a:r>
               <a:rPr b="0" i="0" lang="en-US" sz="1800" u="none" cap="none" strike="noStrike">
                 <a:solidFill>
-                  <a:srgbClr val="6F6B34"/>
+                  <a:srgbClr val="2E2D12"/>
                 </a:solidFill>
                 <a:latin typeface="Poppins"/>
                 <a:ea typeface="Poppins"/>
@@ -22729,7 +22729,7 @@
             <a:r>
               <a:rPr b="0" i="0" lang="en-US" sz="1400" u="none" cap="none" strike="noStrike">
                 <a:solidFill>
-                  <a:srgbClr val="595959"/>
+                  <a:srgbClr val="2E2D12"/>
                 </a:solidFill>
                 <a:latin typeface="Poppins"/>
                 <a:ea typeface="Poppins"/>
@@ -22794,7 +22794,7 @@
             <a:r>
               <a:rPr b="0" i="0" lang="en-US" sz="4400" u="none" cap="none" strike="noStrike">
                 <a:solidFill>
-                  <a:srgbClr val="595959"/>
+                  <a:srgbClr val="2E2D12"/>
                 </a:solidFill>
                 <a:latin typeface="Poppins"/>
                 <a:ea typeface="Poppins"/>
@@ -22847,7 +22847,7 @@
             <a:r>
               <a:rPr b="0" i="0" lang="en-US" sz="1400" u="none" cap="none" strike="noStrike">
                 <a:solidFill>
-                  <a:srgbClr val="595959"/>
+                  <a:srgbClr val="2E2D12"/>
                 </a:solidFill>
                 <a:latin typeface="Roboto Mono"/>
                 <a:ea typeface="Roboto Mono"/>
@@ -22900,7 +22900,7 @@
             <a:r>
               <a:rPr b="1" i="0" lang="en-US" sz="2400" u="none" cap="none" strike="noStrike">
                 <a:solidFill>
-                  <a:srgbClr val="6F6B34"/>
+                  <a:srgbClr val="2E2D12"/>
                 </a:solidFill>
                 <a:latin typeface="Poppins"/>
                 <a:ea typeface="Poppins"/>
@@ -22953,7 +22953,7 @@
             <a:r>
               <a:rPr b="1" i="0" lang="en-US" sz="2400" u="none" cap="none" strike="noStrike">
                 <a:solidFill>
-                  <a:srgbClr val="6F6B34"/>
+                  <a:srgbClr val="2E2D12"/>
                 </a:solidFill>
                 <a:latin typeface="Poppins"/>
                 <a:ea typeface="Poppins"/>
@@ -22981,7 +22981,7 @@
             <a:avLst/>
           </a:prstGeom>
           <a:solidFill>
-            <a:srgbClr val="D9D9D9"/>
+            <a:srgbClr val="6F6B34"/>
           </a:solidFill>
           <a:ln>
             <a:noFill/>
@@ -23117,7 +23117,7 @@
             <a:r>
               <a:rPr b="0" i="0" lang="en-US" sz="2400" u="none" cap="none" strike="noStrike">
                 <a:solidFill>
-                  <a:srgbClr val="434343"/>
+                  <a:srgbClr val="1F1F1F"/>
                 </a:solidFill>
                 <a:latin typeface="Poppins"/>
                 <a:ea typeface="Poppins"/>
@@ -23198,7 +23198,7 @@
             <a:avLst/>
           </a:prstGeom>
           <a:solidFill>
-            <a:srgbClr val="D9D9D9"/>
+            <a:srgbClr val="6F6B34"/>
           </a:solidFill>
           <a:ln>
             <a:noFill/>
@@ -23334,7 +23334,7 @@
             <a:r>
               <a:rPr b="0" i="0" lang="en-US" sz="2400" u="none" cap="none" strike="noStrike">
                 <a:solidFill>
-                  <a:srgbClr val="434343"/>
+                  <a:srgbClr val="1F1F1F"/>
                 </a:solidFill>
                 <a:latin typeface="Poppins"/>
                 <a:ea typeface="Poppins"/>
@@ -23415,7 +23415,7 @@
             <a:avLst/>
           </a:prstGeom>
           <a:solidFill>
-            <a:srgbClr val="D9D9D9"/>
+            <a:srgbClr val="6F6B34"/>
           </a:solidFill>
           <a:ln>
             <a:noFill/>
@@ -23551,7 +23551,7 @@
             <a:r>
               <a:rPr b="0" i="0" lang="en-US" sz="2400" u="none" cap="none" strike="noStrike">
                 <a:solidFill>
-                  <a:srgbClr val="434343"/>
+                  <a:srgbClr val="1F1F1F"/>
                 </a:solidFill>
                 <a:latin typeface="Poppins"/>
                 <a:ea typeface="Poppins"/>
@@ -23632,7 +23632,7 @@
             <a:avLst/>
           </a:prstGeom>
           <a:solidFill>
-            <a:srgbClr val="D9D9D9"/>
+            <a:srgbClr val="6F6B34"/>
           </a:solidFill>
           <a:ln>
             <a:noFill/>
@@ -23715,7 +23715,7 @@
             <a:r>
               <a:rPr b="0" i="0" lang="en-US" sz="2400" u="none" cap="none" strike="noStrike">
                 <a:solidFill>
-                  <a:srgbClr val="434343"/>
+                  <a:srgbClr val="1F1F1F"/>
                 </a:solidFill>
                 <a:latin typeface="Poppins"/>
                 <a:ea typeface="Poppins"/>

</xml_diff>

<commit_message>
Ground deck claims in research and model; keep users-never-pay lead
Co-Authored-By: Claude Opus 5.5 <noreply@anthropic.com>
Claude-Session: https://claude.ai/code/session_017KdnwN2qyuF8wMBvTngErS
</commit_message>
<xml_diff>
--- a/ENTR_4501_Gate_2_deck_readable.pptx
+++ b/ENTR_4501_Gate_2_deck_readable.pptx
@@ -810,7 +810,7 @@
             </a:pPr>
             <a:r>
               <a:rPr lang="en-US"/>
-              <a:t>We’re building a free app that tells you where to eat in Boston, starting at Northeastern.</a:t>
+              <a:t>We’re working on a free app that helps you decide where to eat in Boston. We’d start at Northeastern.</a:t>
             </a:r>
           </a:p>
           <a:p>
@@ -825,7 +825,7 @@
             </a:pPr>
             <a:r>
               <a:rPr lang="en-US"/>
-              <a:t>It’s for students and young professionals who want a great meal but can’t trust the ratings. Right now you check Google Maps, then Yelp, then Instagram, then TikTok, then Beli, and you still end up guessing.</a:t>
+              <a:t>Right now, picking a place usually means checking Google Maps, then Instagram or TikTok, then asking a friend. Our idea is to put the reviews, posts, hours and booking for a place on one page.</a:t>
             </a:r>
           </a:p>
           <a:p>
@@ -840,7 +840,7 @@
             </a:pPr>
             <a:r>
               <a:rPr lang="en-US"/>
-              <a:t>Our app puts the reviews, the posts, the hours and booking for a place on one page. And our score only counts people who proved they ate there.</a:t>
+              <a:t>The one thing we’d add is our own score, and it only counts people who scanned a receipt from that place.</a:t>
             </a:r>
           </a:p>
           <a:p>
@@ -855,7 +855,7 @@
             </a:pPr>
             <a:r>
               <a:rPr lang="en-US"/>
-              <a:t>It doesn’t have a name yet. So why build it? Because of what we heard.</a:t>
+              <a:t>It doesn’t have a name yet, and we haven’t built it. What you’ll see is the concept and the research behind it.</a:t>
             </a:r>
           </a:p>
         </p:txBody>
@@ -1005,7 +1005,7 @@
             </a:pPr>
             <a:r>
               <a:rPr lang="en-US"/>
-              <a:t>So how do we pay for it? We start with grants, the way Beli did. Northeastern’s IDEA Gap Fund and pitch competitions around Boston, about $74,000, cover Years 1 and 2. If we fall short, we cover the gap ourselves.</a:t>
+              <a:t>For funding, we’d start with grants, the way Beli did. Northeastern’s IDEA Gap Fund and Boston pitch competitions, about $74,000, would cover Years 1 and 2, and we’d cover any gap ourselves.</a:t>
             </a:r>
           </a:p>
           <a:p>
@@ -1020,7 +1020,7 @@
             </a:pPr>
             <a:r>
               <a:rPr lang="en-US"/>
-              <a:t>At the end of Year 2, once restaurants have paid us for four quarters, we raise one angel round of about $166,000. We’ll show them about 31,000 Boston users and visits proven by receipts. We’d find angels through IDEA, competition judges and our own networks.</a:t>
+              <a:t>At the end of Year 2, after four quarters of restaurants paying, we’d raise one angel round of about $166,000. By then we’d want to show around 31,000 Boston users and receipt-proven visits.</a:t>
             </a:r>
           </a:p>
           <a:p>
@@ -1035,22 +1035,7 @@
             </a:pPr>
             <a:r>
               <a:rPr lang="en-US"/>
-              <a:t>That’s $240,000 in all. At $356,000 of Year 5 revenue we’re too small for venture funds, so the angels’ way out is a sale to a bigger platform or a card company, the way Resy sold to American Express.</a:t>
-            </a:r>
-          </a:p>
-          <a:p>
-            <a:pPr indent="0" lvl="0" marL="0" rtl="0" algn="l">
-              <a:spcBef>
-                <a:spcPts val="0"/>
-              </a:spcBef>
-              <a:spcAft>
-                <a:spcPts val="600"/>
-              </a:spcAft>
-              <a:buNone/>
-            </a:pPr>
-            <a:r>
-              <a:rPr lang="en-US"/>
-              <a:t>That’s the plan.</a:t>
+              <a:t>At $356,000 of revenue in Year 5, this is too small for venture funds. The realistic exit for an angel is a sale to a bigger platform or a card company, the way Resy sold to American Express.</a:t>
             </a:r>
           </a:p>
         </p:txBody>
@@ -1395,7 +1380,7 @@
             </a:pPr>
             <a:r>
               <a:rPr lang="en-US"/>
-              <a:t>Let me pull it together.</a:t>
+              <a:t>To wrap up.</a:t>
             </a:r>
           </a:p>
           <a:p>
@@ -1410,7 +1395,7 @@
             </a:pPr>
             <a:r>
               <a:rPr lang="en-US"/>
-              <a:t>Boston students don’t trust the ratings they see, and checking five apps doesn’t fix that.</a:t>
+              <a:t>Picking where to eat takes several apps today, and we think it can take one. Our score only counts people who proved they ate there. Restaurants would pay for the diners we send, and users never have to pay. We’d start on grants, and our model reaches a profit in Year 5.</a:t>
             </a:r>
           </a:p>
           <a:p>
@@ -1425,37 +1410,7 @@
             </a:pPr>
             <a:r>
               <a:rPr lang="en-US"/>
-              <a:t>So we’re building one free app, and our score only counts people who proved they ate there.</a:t>
-            </a:r>
-          </a:p>
-          <a:p>
-            <a:pPr indent="0" lvl="0" marL="0" rtl="0" algn="l">
-              <a:spcBef>
-                <a:spcPts val="0"/>
-              </a:spcBef>
-              <a:spcAft>
-                <a:spcPts val="600"/>
-              </a:spcAft>
-              <a:buNone/>
-            </a:pPr>
-            <a:r>
-              <a:rPr lang="en-US"/>
-              <a:t>Restaurants pay for the diners we send, so users never have to. We start on grants, raise one angel round, and reach a profit in Year 5.</a:t>
-            </a:r>
-          </a:p>
-          <a:p>
-            <a:pPr indent="0" lvl="0" marL="0" rtl="0" algn="l">
-              <a:spcBef>
-                <a:spcPts val="0"/>
-              </a:spcBef>
-              <a:spcAft>
-                <a:spcPts val="600"/>
-              </a:spcAft>
-              <a:buNone/>
-            </a:pPr>
-            <a:r>
-              <a:rPr lang="en-US"/>
-              <a:t>What we need to learn next is whether restaurants will pay. So we’re making five owner calls with a free 30-day pilot, and testing receipt scanning with about ten users.</a:t>
+              <a:t>The two things we still need to prove are whether restaurants will pay and whether people will scan receipts. So next we’re calling five owners with a free 30-day pilot, and testing receipt scanning with about ten users.</a:t>
             </a:r>
           </a:p>
           <a:p>
@@ -1620,7 +1575,7 @@
             </a:pPr>
             <a:r>
               <a:rPr lang="en-US"/>
-              <a:t>We talked to 35 students and young professionals this fall, and almost all of them described the same routine.</a:t>
+              <a:t>We interviewed 35 students and young professionals in September and October.</a:t>
             </a:r>
           </a:p>
           <a:p>
@@ -1635,7 +1590,7 @@
             </a:pPr>
             <a:r>
               <a:rPr lang="en-US"/>
-              <a:t>They open Google Maps to see what’s nearby. Then Instagram or TikTok to see the food. Then they ask a friend if it’s good. Then they go, and it’s still a miss.</a:t>
+              <a:t>Most of them described a similar routine. Google Maps to see what’s nearby. Instagram or TikTok to see the food. A friend to check it’s good. And sometimes it still doesn’t work out.</a:t>
             </a:r>
           </a:p>
           <a:p>
@@ -1650,7 +1605,7 @@
             </a:pPr>
             <a:r>
               <a:rPr lang="en-US"/>
-              <a:t>Two things kept coming up. Nobody has one place to save where they want to go. And they want one app they can trust.</a:t>
+              <a:t>What we heard most was that people don’t have one place to save where they want to go, and they’d like one app they can rely on.</a:t>
             </a:r>
           </a:p>
           <a:p>
@@ -1665,7 +1620,7 @@
             </a:pPr>
             <a:r>
               <a:rPr lang="en-US"/>
-              <a:t>The info is all out there. People just don’t trust it.</a:t>
+              <a:t>So the information is out there. It’s just spread across a lot of places.</a:t>
             </a:r>
           </a:p>
         </p:txBody>
@@ -1815,7 +1770,7 @@
             </a:pPr>
             <a:r>
               <a:rPr lang="en-US"/>
-              <a:t>So we put everything about a place on one page.</a:t>
+              <a:t>So the idea is one page per restaurant.</a:t>
             </a:r>
           </a:p>
           <a:p>
@@ -1830,7 +1785,7 @@
             </a:pPr>
             <a:r>
               <a:rPr lang="en-US"/>
-              <a:t>First, it helps you find somewhere: what’s open near you, filtered by diet, price and distance, plus new places people are talking about.</a:t>
+              <a:t>You can find a place: what’s open near you, filtered by diet, price and distance.</a:t>
             </a:r>
           </a:p>
           <a:p>
@@ -1845,7 +1800,7 @@
             </a:pPr>
             <a:r>
               <a:rPr lang="en-US"/>
-              <a:t>Then you compare. Every rating and post sits next to our own score, which only counts diners who scanned a receipt. Nobody can pay to rank higher.</a:t>
+              <a:t>You can compare: ratings and posts from other apps, where they let us show them, next to our own score. Our score only counts diners who scanned a receipt, and restaurants can’t pay to rank higher. If an app won’t share its ratings, we link out to it.</a:t>
             </a:r>
           </a:p>
           <a:p>
@@ -1860,7 +1815,7 @@
             </a:pPr>
             <a:r>
               <a:rPr lang="en-US"/>
-              <a:t>And you keep track of it all: your history, your lists, and booking a table.</a:t>
+              <a:t>And you can keep track: your history, your lists, and booking a table.</a:t>
             </a:r>
           </a:p>
           <a:p>
@@ -1875,7 +1830,7 @@
             </a:pPr>
             <a:r>
               <a:rPr lang="en-US"/>
-              <a:t>The core app is free. Earlier feedback asked if we’d charge for dietary filters. We won’t. A halal or nut-free search is exactly what sends a restaurant the diner it pays for.</a:t>
+              <a:t>The core app is free, including dietary filters. A halal or nut-free search is what sends a restaurant a diner, so we don’t want to charge for it.</a:t>
             </a:r>
           </a:p>
           <a:p>
@@ -1890,22 +1845,7 @@
             </a:pPr>
             <a:r>
               <a:rPr lang="en-US"/>
-              <a:t>If another app won’t let us show its ratings, we link out to it instead.</a:t>
-            </a:r>
-          </a:p>
-          <a:p>
-            <a:pPr indent="0" lvl="0" marL="0" rtl="0" algn="l">
-              <a:spcBef>
-                <a:spcPts val="0"/>
-              </a:spcBef>
-              <a:spcAft>
-                <a:spcPts val="600"/>
-              </a:spcAft>
-              <a:buNone/>
-            </a:pPr>
-            <a:r>
-              <a:rPr lang="en-US"/>
-              <a:t>And why not just use Beli? Beli ranks where you’ve been. We tell you where to go now, with scores people proved.</a:t>
+              <a:t>People ask about Beli a lot. Beli is great for ranking places you’ve been. We’re focused on deciding where to go next.</a:t>
             </a:r>
           </a:p>
         </p:txBody>
@@ -2055,7 +1995,7 @@
             </a:pPr>
             <a:r>
               <a:rPr lang="en-US"/>
-              <a:t>These are four screens from our concept. Every score and person on them is made up.</a:t>
+              <a:t>These are concept screens. Every score and person on them is made up.</a:t>
             </a:r>
           </a:p>
           <a:p>
@@ -2070,7 +2010,7 @@
             </a:pPr>
             <a:r>
               <a:rPr lang="en-US"/>
-              <a:t>One, start nearby. You open the app and see what’s open around you.</a:t>
+              <a:t>The first shows what’s open around you. The second suggests one place that fits your budget and diet, and shows which friends have been. The third gives three picks, each with a reason. The fourth puts our receipt-based score next to the ratings from other apps, and flags creators’ paid posts.</a:t>
             </a:r>
           </a:p>
           <a:p>
@@ -2085,37 +2025,7 @@
             </a:pPr>
             <a:r>
               <a:rPr lang="en-US"/>
-              <a:t>Two, let it pick. You get one best bet that’s open, close, in your budget and fits your diet, and you see which friends have been.</a:t>
-            </a:r>
-          </a:p>
-          <a:p>
-            <a:pPr indent="0" lvl="0" marL="0" rtl="0" algn="l">
-              <a:spcBef>
-                <a:spcPts val="0"/>
-              </a:spcBef>
-              <a:spcAft>
-                <a:spcPts val="600"/>
-              </a:spcAft>
-              <a:buNone/>
-            </a:pPr>
-            <a:r>
-              <a:rPr lang="en-US"/>
-              <a:t>Three, see why. Three picks for the occasion, each with a reason.</a:t>
-            </a:r>
-          </a:p>
-          <a:p>
-            <a:pPr indent="0" lvl="0" marL="0" rtl="0" algn="l">
-              <a:spcBef>
-                <a:spcPts val="0"/>
-              </a:spcBef>
-              <a:spcAft>
-                <a:spcPts val="600"/>
-              </a:spcAft>
-              <a:buNone/>
-            </a:pPr>
-            <a:r>
-              <a:rPr lang="en-US"/>
-              <a:t>Four, check every rating. Our verified score sits next to Google, Yelp, Beli, Reddit and TikTok, and creators’ paid posts are flagged.</a:t>
+              <a:t>We want to test these with students on campus before we build anything.</a:t>
             </a:r>
           </a:p>
         </p:txBody>
@@ -2265,7 +2175,7 @@
             </a:pPr>
             <a:r>
               <a:rPr lang="en-US"/>
-              <a:t>We start small. Boston has 162,000 college students, and we want 12,000 of them in Year 1.</a:t>
+              <a:t>Boston has about 162,000 college students. Our Year 1 goal is 12,000 of them.</a:t>
             </a:r>
           </a:p>
           <a:p>
@@ -2280,7 +2190,7 @@
             </a:pPr>
             <a:r>
               <a:rPr lang="en-US"/>
-              <a:t>There are about 19 million college students in the US, and we can reach them one campus at a time.</a:t>
+              <a:t>Across the US there are about 19 million college students. Our Year 5 target is 540,000 users, which is 2.8% of them, inside the 2 to 5% range from class.</a:t>
             </a:r>
           </a:p>
           <a:p>
@@ -2295,22 +2205,7 @@
             </a:pPr>
             <a:r>
               <a:rPr lang="en-US"/>
-              <a:t>By Year 5 we want 540,000 active users. That’s 2.8% of US college students, inside the 2 to 5% range we talked about in class.</a:t>
-            </a:r>
-          </a:p>
-          <a:p>
-            <a:pPr indent="0" lvl="0" marL="0" rtl="0" algn="l">
-              <a:spcBef>
-                <a:spcPts val="0"/>
-              </a:spcBef>
-              <a:spcAft>
-                <a:spcPts val="600"/>
-              </a:spcAft>
-              <a:buNone/>
-            </a:pPr>
-            <a:r>
-              <a:rPr lang="en-US"/>
-              <a:t>And on the side that pays, Boston has 3,350 licensed places to eat.</a:t>
+              <a:t>On the restaurant side, Boston has 3,350 licensed places to eat.</a:t>
             </a:r>
           </a:p>
         </p:txBody>
@@ -2460,7 +2355,7 @@
             </a:pPr>
             <a:r>
               <a:rPr lang="en-US"/>
-              <a:t>So how do we get our first users? One friend at a time.</a:t>
+              <a:t>We’d grow the way Beli did, mostly through friends. About 80% of Beli’s users came that way.</a:t>
             </a:r>
           </a:p>
           <a:p>
@@ -2475,7 +2370,7 @@
             </a:pPr>
             <a:r>
               <a:rPr lang="en-US"/>
-              <a:t>The first ten are people we interviewed, plus our friends. They test the prototype this semester, and we ask them to help us build it.</a:t>
+              <a:t>The first ten users would be people we interviewed and our friends, testing the prototype. The next hundred would be Northeastern students they invite, plus clubs and group chats. The first thousand would come from other Boston campuses, through student ambassadors and food posts.</a:t>
             </a:r>
           </a:p>
           <a:p>
@@ -2490,52 +2385,7 @@
             </a:pPr>
             <a:r>
               <a:rPr lang="en-US"/>
-              <a:t>The first hundred are Northeastern students they invite, plus clubs and group chats. What we tell them is every rating for a place, in one app.</a:t>
-            </a:r>
-          </a:p>
-          <a:p>
-            <a:pPr indent="0" lvl="0" marL="0" rtl="0" algn="l">
-              <a:spcBef>
-                <a:spcPts val="0"/>
-              </a:spcBef>
-              <a:spcAft>
-                <a:spcPts val="600"/>
-              </a:spcAft>
-              <a:buNone/>
-            </a:pPr>
-            <a:r>
-              <a:rPr lang="en-US"/>
-              <a:t>The first thousand come from other Boston campuses, through student ambassadors and food posts. One app instead of five tabs.</a:t>
-            </a:r>
-          </a:p>
-          <a:p>
-            <a:pPr indent="0" lvl="0" marL="0" rtl="0" algn="l">
-              <a:spcBef>
-                <a:spcPts val="0"/>
-              </a:spcBef>
-              <a:spcAft>
-                <a:spcPts val="600"/>
-              </a:spcAft>
-              <a:buNone/>
-            </a:pPr>
-            <a:r>
-              <a:rPr lang="en-US"/>
-              <a:t>It’s the same loop every time. A friend tells you, you download, you save a place, you invite someone. About 80% of Beli’s users arrived that way, and it’s how we get to 12,000 by the end of Year 1.</a:t>
-            </a:r>
-          </a:p>
-          <a:p>
-            <a:pPr indent="0" lvl="0" marL="0" rtl="0" algn="l">
-              <a:spcBef>
-                <a:spcPts val="0"/>
-              </a:spcBef>
-              <a:spcAft>
-                <a:spcPts val="600"/>
-              </a:spcAft>
-              <a:buNone/>
-            </a:pPr>
-            <a:r>
-              <a:rPr lang="en-US"/>
-              <a:t>Users never pay. Restaurants do.</a:t>
+              <a:t>If that works, our model gets to 12,000 users by the end of Year 1. Users never have to pay. Restaurants would.</a:t>
             </a:r>
           </a:p>
         </p:txBody>
@@ -2685,7 +2535,7 @@
             </a:pPr>
             <a:r>
               <a:rPr lang="en-US"/>
-              <a:t>Restaurants pay us for the diners we send, not for ads.</a:t>
+              <a:t>This is how we’d make money. We’d charge restaurants for the diners we send, instead of for ads.</a:t>
             </a:r>
           </a:p>
           <a:p>
@@ -2700,7 +2550,7 @@
             </a:pPr>
             <a:r>
               <a:rPr lang="en-US"/>
-              <a:t>Today a restaurant pays for ads and boosted posts before it knows if anyone will walk in. We’d rather get paid only when it works. A restaurant pays about 90 cents, and only after a receipt shows the diner came. OpenTable charges $1 to $1.50 a diner.</a:t>
+              <a:t>A restaurant would pay about 90 cents, and only after a receipt shows the diner came. For comparison, OpenTable charges $1 to $1.50 a diner. Booking sites would pay per table, and from Year 3 chains would pay $6,000 a year per area for insights.</a:t>
             </a:r>
           </a:p>
           <a:p>
@@ -2715,7 +2565,7 @@
             </a:pPr>
             <a:r>
               <a:rPr lang="en-US"/>
-              <a:t>Booking sites pay per table. And from Year 3, chains pay $6,000 a year per area to see what people there eat. That’s $288,000 in Year 5.</a:t>
+              <a:t>Users never have to pay. We’re also thinking about an optional $5 a month membership for extras, and we’d expect about 3 in 1,000 to sign up.</a:t>
             </a:r>
           </a:p>
           <a:p>
@@ -2730,7 +2580,7 @@
             </a:pPr>
             <a:r>
               <a:rPr lang="en-US"/>
-              <a:t>On the user side the app is free. About 3 in 1,000 pay $5 a month for extras, which adds $67,000.</a:t>
+              <a:t>In our model that’s $356,000 in Year 5. Nothing anyone pays would change a score or a ranking.</a:t>
             </a:r>
           </a:p>
           <a:p>
@@ -2745,22 +2595,7 @@
             </a:pPr>
             <a:r>
               <a:rPr lang="en-US"/>
-              <a:t>Nothing anyone pays changes a score or a ranking.</a:t>
-            </a:r>
-          </a:p>
-          <a:p>
-            <a:pPr indent="0" lvl="0" marL="0" rtl="0" algn="l">
-              <a:spcBef>
-                <a:spcPts val="0"/>
-              </a:spcBef>
-              <a:spcAft>
-                <a:spcPts val="600"/>
-              </a:spcAft>
-              <a:buNone/>
-            </a:pPr>
-            <a:r>
-              <a:rPr lang="en-US"/>
-              <a:t>We haven’t tested this with owners yet. Five owner calls are next, each with a free 30-day pilot and a report on the diners we sent.</a:t>
+              <a:t>To be clear, we haven’t tested any of this with restaurant owners yet. That’s our next step: five owner calls, each with a free 30-day pilot and a report on the diners we sent.</a:t>
             </a:r>
           </a:p>
         </p:txBody>
@@ -2910,7 +2745,7 @@
             </a:pPr>
             <a:r>
               <a:rPr lang="en-US"/>
-              <a:t>Before we built our numbers, we looked at the apps closest to us. None of them made money early.</a:t>
+              <a:t>Before building our numbers, we looked at the apps closest to us.</a:t>
             </a:r>
           </a:p>
           <a:p>
@@ -2925,7 +2760,7 @@
             </a:pPr>
             <a:r>
               <a:rPr lang="en-US"/>
-              <a:t>OpenTable took nine years to turn a profit and lost $57 million getting there. Resy ran on $45 million of investor money and then sold. Beli has 1.1 million monthly users, mostly through friends, with five people and almost no revenue.</a:t>
+              <a:t>OpenTable took nine years to turn a profit and lost $57 million on the way. Resy ran on $45 million of investor money and was sold. Beli has 1.1 million monthly users, a team of five, and almost no revenue.</a:t>
             </a:r>
           </a:p>
           <a:p>
@@ -2940,7 +2775,7 @@
             </a:pPr>
             <a:r>
               <a:rPr lang="en-US"/>
-              <a:t>So we made three choices. No founder salaries, and co-op students before full-time hires. Costs low enough that we only need about $240,000, starting with grants. And Beli as our yardstick: a quarter of its size, almost no ads, and restaurants paying from Year 2.</a:t>
+              <a:t>That made us plan for slow money. No founder salaries, co-op students before full-time hires, and costs low enough that we’d need about $240,000 in total. We’re also planning for growth at about a quarter of Beli’s size.</a:t>
             </a:r>
           </a:p>
           <a:p>
@@ -2955,7 +2790,7 @@
             </a:pPr>
             <a:r>
               <a:rPr lang="en-US"/>
-              <a:t>The trade-off is a smaller team, and it only works if restaurants sign up.</a:t>
+              <a:t>The trade-off is a small team, and it only works if restaurants sign up.</a:t>
             </a:r>
           </a:p>
         </p:txBody>
@@ -3105,7 +2940,7 @@
             </a:pPr>
             <a:r>
               <a:rPr lang="en-US"/>
-              <a:t>This is what lean looks like in numbers. Watch the three highlighted cells.</a:t>
+              <a:t>Here’s the model. The three highlighted cells are the ones to look at.</a:t>
             </a:r>
           </a:p>
           <a:p>
@@ -3120,7 +2955,7 @@
             </a:pPr>
             <a:r>
               <a:rPr lang="en-US"/>
-              <a:t>Years 1 and 2 are flat on purpose, about $10,500 a quarter. That’s a contract developer at $7,500, $1,500 for marketing, $1,500 for legal and insurance, and a little hosting. Nobody else gets paid until the angel round funds Year 3.</a:t>
+              <a:t>Years 1 and 2 cost about $10,500 a quarter: a contract developer at $7,500, $1,500 for marketing, $1,500 for legal and insurance, and hosting. No one else is paid until the angel round funds Year 3.</a:t>
             </a:r>
           </a:p>
           <a:p>
@@ -3135,37 +2970,7 @@
             </a:pPr>
             <a:r>
               <a:rPr lang="en-US"/>
-              <a:t>The first highlight is our first revenue, in Year 2. From Year 3, co-op students join as our users grow.</a:t>
-            </a:r>
-          </a:p>
-          <a:p>
-            <a:pPr indent="0" lvl="0" marL="0" rtl="0" algn="l">
-              <a:spcBef>
-                <a:spcPts val="0"/>
-              </a:spcBef>
-              <a:spcAft>
-                <a:spcPts val="600"/>
-              </a:spcAft>
-              <a:buNone/>
-            </a:pPr>
-            <a:r>
-              <a:rPr lang="en-US"/>
-              <a:t>The second is the low point, about $192,000 down in Year 4. We’re raising $240,000, which is that low plus a 25% cushion.</a:t>
-            </a:r>
-          </a:p>
-          <a:p>
-            <a:pPr indent="0" lvl="0" marL="0" rtl="0" algn="l">
-              <a:spcBef>
-                <a:spcPts val="0"/>
-              </a:spcBef>
-              <a:spcAft>
-                <a:spcPts val="600"/>
-              </a:spcAft>
-              <a:buNone/>
-            </a:pPr>
-            <a:r>
-              <a:rPr lang="en-US"/>
-              <a:t>The third is Year 5, our first profitable year, at about $72,000.</a:t>
+              <a:t>First revenue shows up in Year 2. The lowest point is about $192,000 down in Year 4, and we’d raise $240,000 to cover that with a 25% cushion. Year 5 is the first profitable year in the model, at about $72,000.</a:t>
             </a:r>
           </a:p>
         </p:txBody>
@@ -12987,7 +12792,7 @@
                 <a:cs typeface="Poppins"/>
                 <a:sym typeface="Poppins"/>
               </a:rPr>
-              <a:t xml:space="preserve">One free app for deciding where to eat, </a:t>
+              <a:t xml:space="preserve">A free app for deciding where to eat in Boston, </a:t>
             </a:r>
             <a:r>
               <a:rPr b="0" i="0" lang="en-US" sz="4400" u="none" cap="none" strike="noStrike">
@@ -12999,7 +12804,7 @@
                 <a:cs typeface="Poppins"/>
                 <a:sym typeface="Poppins"/>
               </a:rPr>
-              <a:t>with ratings you can trust.</a:t>
+              <a:t>with a score based on real visits.</a:t>
             </a:r>
             <a:endParaRPr/>
           </a:p>
@@ -13380,7 +13185,7 @@
                 <a:cs typeface="Poppins"/>
                 <a:sym typeface="Poppins"/>
               </a:rPr>
-              <a:t>want great places to eat but can't trust the ratings</a:t>
+              <a:t>want a good place to eat without checking five apps first</a:t>
             </a:r>
             <a:endParaRPr/>
           </a:p>
@@ -14278,7 +14083,7 @@
                 <a:cs typeface="Poppins"/>
                 <a:sym typeface="Poppins"/>
               </a:rPr>
-              <a:t>We'd start on grants, as Beli did. </a:t>
+              <a:t xml:space="preserve">We’d start on grants, as Beli did. </a:t>
             </a:r>
             <a:r>
               <a:rPr b="0" i="0" lang="en-US" sz="4400" u="none" cap="none" strike="noStrike">
@@ -14290,7 +14095,7 @@
                 <a:cs typeface="Poppins"/>
                 <a:sym typeface="Poppins"/>
               </a:rPr>
-              <a:t>One angel round of about $166K takes us to profit.</a:t>
+              <a:t>In our model, one angel round of about $166K gets us to profit.</a:t>
             </a:r>
             <a:endParaRPr/>
           </a:p>
@@ -16077,7 +15882,7 @@
                 <a:cs typeface="Poppins"/>
                 <a:sym typeface="Poppins"/>
               </a:rPr>
-              <a:t xml:space="preserve">Boston students can’t trust the ratings. </a:t>
+              <a:t xml:space="preserve">Picking where to eat takes several apps today. </a:t>
             </a:r>
             <a:r>
               <a:rPr b="0" i="0" lang="en-US" sz="4400" u="none" cap="none" strike="noStrike">
@@ -16089,7 +15894,7 @@
                 <a:cs typeface="Poppins"/>
                 <a:sym typeface="Poppins"/>
               </a:rPr>
-              <a:t>We’re building the one app they can.</a:t>
+              <a:t>We think it can take one.</a:t>
             </a:r>
             <a:endParaRPr/>
           </a:p>
@@ -16301,7 +16106,7 @@
                 <a:cs typeface="Poppins"/>
                 <a:sym typeface="Poppins"/>
               </a:rPr>
-              <a:t>Restaurants pay for the diners we send. Users never pay.</a:t>
+              <a:t>Restaurants would pay for the diners we send. Users never have to pay.</a:t>
             </a:r>
             <a:endParaRPr/>
           </a:p>
@@ -16407,7 +16212,7 @@
                 <a:cs typeface="Poppins"/>
                 <a:sym typeface="Poppins"/>
               </a:rPr>
-              <a:t>Grants first, then one angel round. Profit in Year 5.</a:t>
+              <a:t>Grants first, then one angel round. Our model shows profit in Year 5.</a:t>
             </a:r>
             <a:endParaRPr/>
           </a:p>
@@ -16460,7 +16265,7 @@
                 <a:cs typeface="Poppins"/>
                 <a:sym typeface="Poppins"/>
               </a:rPr>
-              <a:t>Next</a:t>
+              <a:t>What we still need to prove</a:t>
             </a:r>
             <a:endParaRPr/>
           </a:p>
@@ -16475,7 +16280,7 @@
         <p:spPr>
           <a:xfrm>
             <a:off x="822960" y="7818120"/>
-            <a:ext cx="16002000" cy="914400"/>
+            <a:ext cx="16002000" cy="1280160"/>
           </a:xfrm>
           <a:prstGeom prst="rect">
             <a:avLst/>
@@ -16513,7 +16318,7 @@
                 <a:cs typeface="Poppins"/>
                 <a:sym typeface="Poppins"/>
               </a:rPr>
-              <a:t>Five owner calls with a free 30-day pilot, and a receipt-scan test with about 10 users.</a:t>
+              <a:t>Whether restaurants will pay, and whether people will scan receipts. Next: five owner calls with a free 30-day pilot, and a receipt-scan test with about 10 users.</a:t>
             </a:r>
             <a:endParaRPr/>
           </a:p>
@@ -16705,7 +16510,7 @@
                 <a:cs typeface="Poppins"/>
                 <a:sym typeface="Poppins"/>
               </a:rPr>
-              <a:t>Finding one good place to eat takes multiple apps, </a:t>
+              <a:t xml:space="preserve">Most people we talked to check three apps to pick one place to eat, </a:t>
             </a:r>
             <a:r>
               <a:rPr b="0" i="0" lang="en-US" sz="4400" u="none" cap="none" strike="noStrike">
@@ -16717,7 +16522,7 @@
                 <a:cs typeface="Poppins"/>
                 <a:sym typeface="Poppins"/>
               </a:rPr>
-              <a:t>and people still get it wrong.</a:t>
+              <a:t>and it still misses.</a:t>
             </a:r>
             <a:endParaRPr/>
           </a:p>
@@ -17517,7 +17322,7 @@
                 <a:cs typeface="Poppins"/>
                 <a:sym typeface="Poppins"/>
               </a:rPr>
-              <a:t>Nobody had one place to save where they want to go.</a:t>
+              <a:t>Most had no single place to save where they want to go.</a:t>
             </a:r>
             <a:endParaRPr sz="2800"/>
           </a:p>
@@ -17570,7 +17375,7 @@
                 <a:cs typeface="Poppins"/>
                 <a:sym typeface="Poppins"/>
               </a:rPr>
-              <a:t>They want one app they can trust.</a:t>
+              <a:t>Many said they’d like one app they can rely on.</a:t>
             </a:r>
             <a:endParaRPr sz="2800"/>
           </a:p>
@@ -17754,7 +17559,7 @@
                 <a:cs typeface="Poppins"/>
                 <a:sym typeface="Poppins"/>
               </a:rPr>
-              <a:t xml:space="preserve">One page for every restaurant, </a:t>
+              <a:t xml:space="preserve">One page per restaurant, </a:t>
             </a:r>
             <a:r>
               <a:rPr b="0" i="0" lang="en-US" sz="4400" u="none" cap="none" strike="noStrike">
@@ -17766,7 +17571,7 @@
                 <a:cs typeface="Poppins"/>
                 <a:sym typeface="Poppins"/>
               </a:rPr>
-              <a:t>and a score that only counts people who ate there.</a:t>
+              <a:t>and a score that only counts diners with a receipt.</a:t>
             </a:r>
             <a:endParaRPr/>
           </a:p>
@@ -18201,7 +18006,7 @@
                 <a:cs typeface="Poppins"/>
                 <a:sym typeface="Poppins"/>
               </a:rPr>
-              <a:t>Every rating and post on one page</a:t>
+              <a:t>Other apps’ ratings and posts, where they let us show them</a:t>
             </a:r>
             <a:endParaRPr sz="2400"/>
           </a:p>
@@ -18538,7 +18343,7 @@
                 <a:cs typeface="Poppins"/>
                 <a:sym typeface="Poppins"/>
               </a:rPr>
-              <a:t>Beli ranks where you’ve been. We tell you where to go now, with scores people proved.</a:t>
+              <a:t>Beli is for ranking places you’ve been. We help you decide where to go next, with a score based on receipts.</a:t>
             </a:r>
             <a:endParaRPr/>
           </a:p>
@@ -18722,7 +18527,7 @@
                 <a:cs typeface="Poppins"/>
                 <a:sym typeface="Poppins"/>
               </a:rPr>
-              <a:t xml:space="preserve">Open it, and it picks one place for you, </a:t>
+              <a:t xml:space="preserve">In our concept, it picks one place </a:t>
             </a:r>
             <a:r>
               <a:rPr b="0" i="0" lang="en-US" sz="4400" u="none" cap="none" strike="noStrike">
@@ -19450,7 +19255,7 @@
                 <a:cs typeface="Poppins"/>
                 <a:sym typeface="Poppins"/>
               </a:rPr>
-              <a:t>Why it matters</a:t>
+              <a:t>How big it is</a:t>
             </a:r>
             <a:endParaRPr/>
           </a:p>
@@ -20446,7 +20251,7 @@
                 <a:cs typeface="Poppins"/>
                 <a:sym typeface="Poppins"/>
               </a:rPr>
-              <a:t>How we win users</a:t>
+              <a:t>How we’d get users</a:t>
             </a:r>
             <a:endParaRPr/>
           </a:p>
@@ -20552,7 +20357,7 @@
                 <a:cs typeface="Poppins"/>
                 <a:sym typeface="Poppins"/>
               </a:rPr>
-              <a:t>Our first 1,000 users come from Boston campuses, starting with ours, </a:t>
+              <a:t xml:space="preserve">We plan to find our first 1,000 users on Boston campuses, </a:t>
             </a:r>
             <a:r>
               <a:rPr b="0" i="0" lang="en-US" sz="4400" u="none" cap="none" strike="noStrike">
@@ -20564,7 +20369,7 @@
                 <a:cs typeface="Poppins"/>
                 <a:sym typeface="Poppins"/>
               </a:rPr>
-              <a:t>one friend inviting the next.</a:t>
+              <a:t>starting with ours, one friend at a time.</a:t>
             </a:r>
             <a:endParaRPr/>
           </a:p>
@@ -21485,7 +21290,7 @@
                 <a:cs typeface="Poppins"/>
                 <a:sym typeface="Poppins"/>
               </a:rPr>
-              <a:t>Friends inviting friends gets us to 12K by the end of Year 1; about 80% of Beli's users arrived that way. Users never have to pay.</a:t>
+              <a:t>If friends invite friends, our model reaches 12K users by the end of Year 1; about 80% of Beli’s users arrived that way. Users never have to pay.</a:t>
             </a:r>
             <a:endParaRPr sz="2400"/>
           </a:p>
@@ -21563,7 +21368,7 @@
                 <a:cs typeface="Poppins"/>
                 <a:sym typeface="Poppins"/>
               </a:rPr>
-              <a:t>How we make money</a:t>
+              <a:t>How we’d make money</a:t>
             </a:r>
             <a:endParaRPr/>
           </a:p>
@@ -21669,7 +21474,7 @@
                 <a:cs typeface="Poppins"/>
                 <a:sym typeface="Poppins"/>
               </a:rPr>
-              <a:t>Restaurants pay for the diners we send, not for ads.</a:t>
+              <a:t>We’d charge restaurants per diner sent, not for ads.</a:t>
             </a:r>
             <a:endParaRPr/>
           </a:p>
@@ -22532,7 +22337,7 @@
                 <a:cs typeface="Poppins"/>
                 <a:sym typeface="Poppins"/>
               </a:rPr>
-              <a:t>Two sides pay, $356K in Year 5. Paying never changes a score or a ranking.</a:t>
+              <a:t>In our model, two sides pay: $356K in Year 5. Paying never changes a score or a ranking.</a:t>
             </a:r>
             <a:endParaRPr sz="2400"/>
           </a:p>
@@ -22789,7 +22594,7 @@
                 <a:cs typeface="Poppins"/>
                 <a:sym typeface="Poppins"/>
               </a:rPr>
-              <a:t>None of the apps before us made money early, </a:t>
+              <a:t xml:space="preserve">The apps closest to us took years to make money, </a:t>
             </a:r>
             <a:r>
               <a:rPr b="0" i="0" lang="en-US" sz="4400" u="none" cap="none" strike="noStrike">
@@ -22801,7 +22606,7 @@
                 <a:cs typeface="Poppins"/>
                 <a:sym typeface="Poppins"/>
               </a:rPr>
-              <a:t>so we kept ours lean.</a:t>
+              <a:t>so we kept our costs low.</a:t>
             </a:r>
             <a:endParaRPr/>
           </a:p>
@@ -23906,7 +23711,7 @@
                 <a:cs typeface="Poppins"/>
                 <a:sym typeface="Poppins"/>
               </a:rPr>
-              <a:t xml:space="preserve">We spend about $11K a quarter for two years. </a:t>
+              <a:t xml:space="preserve">We plan to spend about $11K a quarter for two years. </a:t>
             </a:r>
             <a:r>
               <a:rPr b="0" i="0" lang="en-US" sz="4400" u="none" cap="none" strike="noStrike">
@@ -23918,7 +23723,7 @@
                 <a:cs typeface="Poppins"/>
                 <a:sym typeface="Poppins"/>
               </a:rPr>
-              <a:t>Year 5 is our first profit.</a:t>
+              <a:t>Our model shows a first profit in Year 5.</a:t>
             </a:r>
             <a:endParaRPr/>
           </a:p>

</xml_diff>

<commit_message>
Slide 2: match interview findings
Co-Authored-By: Claude Opus 5.5 <noreply@anthropic.com>
Claude-Session: https://claude.ai/code/session_017KdnwN2qyuF8wMBvTngErS
</commit_message>
<xml_diff>
--- a/ENTR_4501_Gate_2_deck_readable.pptx
+++ b/ENTR_4501_Gate_2_deck_readable.pptx
@@ -1590,7 +1590,7 @@
             </a:pPr>
             <a:r>
               <a:rPr lang="en-US"/>
-              <a:t>Most of them described a similar routine. Google Maps to see what’s nearby. Instagram or TikTok to see the food. A friend to check it’s good. And sometimes it still doesn’t work out.</a:t>
+              <a:t>Most of them check three apps to pick one place. Google Maps to see what’s nearby, Instagram or TikTok to see the food, and a friend to check it’s good. Many said it still misses after all that.</a:t>
             </a:r>
           </a:p>
           <a:p>
@@ -1605,7 +1605,7 @@
             </a:pPr>
             <a:r>
               <a:rPr lang="en-US"/>
-              <a:t>What we heard most was that people don’t have one place to save where they want to go, and they’d like one app they can rely on.</a:t>
+              <a:t>Most people were okay with what they use now. But they told us they’d try something better.</a:t>
             </a:r>
           </a:p>
           <a:p>
@@ -1620,7 +1620,7 @@
             </a:pPr>
             <a:r>
               <a:rPr lang="en-US"/>
-              <a:t>So the information is out there. It’s just spread across a lot of places.</a:t>
+              <a:t>So it’s an annoying routine more than a crisis, and we think it can be easier.</a:t>
             </a:r>
           </a:p>
         </p:txBody>
@@ -16522,7 +16522,7 @@
                 <a:cs typeface="Poppins"/>
                 <a:sym typeface="Poppins"/>
               </a:rPr>
-              <a:t>and it still misses.</a:t>
+              <a:t>and for many, it still misses.</a:t>
             </a:r>
             <a:endParaRPr/>
           </a:p>
@@ -17322,7 +17322,7 @@
                 <a:cs typeface="Poppins"/>
                 <a:sym typeface="Poppins"/>
               </a:rPr>
-              <a:t>Most had no single place to save where they want to go.</a:t>
+              <a:t>Many said it still misses after checking all three.</a:t>
             </a:r>
             <a:endParaRPr sz="2800"/>
           </a:p>
@@ -17375,7 +17375,7 @@
                 <a:cs typeface="Poppins"/>
                 <a:sym typeface="Poppins"/>
               </a:rPr>
-              <a:t>Many said they’d like one app they can rely on.</a:t>
+              <a:t>Most are okay with what they use now, but would try something better.</a:t>
             </a:r>
             <a:endParaRPr sz="2800"/>
           </a:p>

</xml_diff>

<commit_message>
Apply review fixes: three apps, grounded claims, concise notes
Co-Authored-By: Claude Opus 5.5 <noreply@anthropic.com>
Claude-Session: https://claude.ai/code/session_017KdnwN2qyuF8wMBvTngErS
</commit_message>
<xml_diff>
--- a/ENTR_4501_Gate_2_deck_readable.pptx
+++ b/ENTR_4501_Gate_2_deck_readable.pptx
@@ -810,7 +810,7 @@
             </a:pPr>
             <a:r>
               <a:rPr lang="en-US"/>
-              <a:t>We’re working on a free app that helps you decide where to eat in Boston. We’d start at Northeastern.</a:t>
+              <a:t>We’re working on a free app that helps you decide where to eat in Boston, starting at Northeastern.</a:t>
             </a:r>
           </a:p>
           <a:p>
@@ -825,7 +825,7 @@
             </a:pPr>
             <a:r>
               <a:rPr lang="en-US"/>
-              <a:t>Right now, picking a place usually means checking Google Maps, then Instagram or TikTok, then asking a friend. Our idea is to put the reviews, posts, hours and booking for a place on one page.</a:t>
+              <a:t>Today most people check Google Maps, then Instagram or TikTok, then ask a friend. We’d put the reviews, posts, hours and booking for a place on one page, plus our own score that only counts people who scanned a receipt.</a:t>
             </a:r>
           </a:p>
           <a:p>
@@ -840,22 +840,7 @@
             </a:pPr>
             <a:r>
               <a:rPr lang="en-US"/>
-              <a:t>The one thing we’d add is our own score, and it only counts people who scanned a receipt from that place.</a:t>
-            </a:r>
-          </a:p>
-          <a:p>
-            <a:pPr indent="0" lvl="0" marL="0" rtl="0" algn="l">
-              <a:spcBef>
-                <a:spcPts val="0"/>
-              </a:spcBef>
-              <a:spcAft>
-                <a:spcPts val="600"/>
-              </a:spcAft>
-              <a:buNone/>
-            </a:pPr>
-            <a:r>
-              <a:rPr lang="en-US"/>
-              <a:t>It doesn’t have a name yet, and we haven’t built it. What you’ll see is the concept and the research behind it.</a:t>
+              <a:t>It doesn’t have a name yet, and we haven’t built it. This is the concept and the research behind it.</a:t>
             </a:r>
           </a:p>
         </p:txBody>
@@ -1005,7 +990,7 @@
             </a:pPr>
             <a:r>
               <a:rPr lang="en-US"/>
-              <a:t>For funding, we’d start with grants, the way Beli did. Northeastern’s IDEA Gap Fund and Boston pitch competitions, about $74,000, would cover Years 1 and 2, and we’d cover any gap ourselves.</a:t>
+              <a:t>We’d start with grants, the way Beli did. Northeastern’s IDEA Gap Fund and Boston pitch competitions, about $74,000, cover Years 1 and 2. If we come up short, we cover the gap ourselves.</a:t>
             </a:r>
           </a:p>
           <a:p>
@@ -1020,7 +1005,7 @@
             </a:pPr>
             <a:r>
               <a:rPr lang="en-US"/>
-              <a:t>At the end of Year 2, after four quarters of restaurants paying, we’d raise one angel round of about $166,000. By then we’d want to show around 31,000 Boston users and receipt-proven visits.</a:t>
+              <a:t>At the end of Year 2, after four quarters of restaurants paying, we’d raise one angel round of about $166,000. By then we want around 31,000 Boston users and receipt-proven visits to show.</a:t>
             </a:r>
           </a:p>
           <a:p>
@@ -1035,7 +1020,7 @@
             </a:pPr>
             <a:r>
               <a:rPr lang="en-US"/>
-              <a:t>At $356,000 of revenue in Year 5, this is too small for venture funds. The realistic exit for an angel is a sale to a bigger platform or a card company, the way Resy sold to American Express.</a:t>
+              <a:t>At $356,000 in Year 5 revenue we’re too small for venture funds. An angel’s exit would be a sale to a bigger platform or a card company, like Resy’s sale to American Express.</a:t>
             </a:r>
           </a:p>
         </p:txBody>
@@ -1185,7 +1170,7 @@
             </a:pPr>
             <a:r>
               <a:rPr lang="en-US"/>
-              <a:t>This one is for questions. It shows where each price comes from.</a:t>
+              <a:t>If it comes up, this is where each price comes from.</a:t>
             </a:r>
           </a:p>
           <a:p>
@@ -1200,7 +1185,7 @@
             </a:pPr>
             <a:r>
               <a:rPr lang="en-US"/>
-              <a:t>Businesses pay $288,000 in Year 5: $156,000 for diners we send, $54,000 for tables booked and $78,000 for area insights for chains. About 90 cents a diner sits under OpenTable’s $1 to $1.50. Bookings are a quarter of Tabelog’s rate, and chains pay a quarter of what Placer.ai charges.</a:t>
+              <a:t>Businesses pay $288,000 in Year 5: $156,000 for diners we send, $54,000 for bookings and $78,000 for area insights for chains. The 90 cents is under OpenTable’s $1 to $1.50, bookings are a quarter of Tabelog’s rate, and chains pay a quarter of Placer.ai’s price.</a:t>
             </a:r>
           </a:p>
           <a:p>
@@ -1215,22 +1200,7 @@
             </a:pPr>
             <a:r>
               <a:rPr lang="en-US"/>
-              <a:t>Users pay $67,000 for the optional $5 a month membership. About 0.3% sign up, the same share as Tabelog’s users.</a:t>
-            </a:r>
-          </a:p>
-          <a:p>
-            <a:pPr indent="0" lvl="0" marL="0" rtl="0" algn="l">
-              <a:spcBef>
-                <a:spcPts val="0"/>
-              </a:spcBef>
-              <a:spcAft>
-                <a:spcPts val="600"/>
-              </a:spcAft>
-              <a:buNone/>
-            </a:pPr>
-            <a:r>
-              <a:rPr lang="en-US"/>
-              <a:t>Every price starts from a real company’s number. How many we sell is our guess.</a:t>
+              <a:t>The membership brings in $67,000, from about 0.3% of our average Year 5 users. That’s the same share as Tabelog.</a:t>
             </a:r>
           </a:p>
         </p:txBody>
@@ -1380,7 +1350,7 @@
             </a:pPr>
             <a:r>
               <a:rPr lang="en-US"/>
-              <a:t>To wrap up.</a:t>
+              <a:t>Right now, picking a place to eat takes three apps. We think it could take one.</a:t>
             </a:r>
           </a:p>
           <a:p>
@@ -1395,7 +1365,7 @@
             </a:pPr>
             <a:r>
               <a:rPr lang="en-US"/>
-              <a:t>Picking where to eat takes several apps today, and we think it can take one. Our score only counts people who proved they ate there. Restaurants would pay for the diners we send, and users never have to pay. We’d start on grants, and our model reaches a profit in Year 5.</a:t>
+              <a:t>Our score only counts people who proved they ate there. Restaurants would pay for the diners we send, and users never have to pay. We’d start on grants, and Year 5 is our first profitable year.</a:t>
             </a:r>
           </a:p>
           <a:p>
@@ -1410,7 +1380,7 @@
             </a:pPr>
             <a:r>
               <a:rPr lang="en-US"/>
-              <a:t>The two things we still need to prove are whether restaurants will pay and whether people will scan receipts. So next we’re calling five owners with a free 30-day pilot, and testing receipt scanning with about ten users.</a:t>
+              <a:t>What we still need to prove is whether restaurants will pay and whether people will scan receipts. So next, we’re calling five owners with a free pilot and testing receipt scanning with about ten users.</a:t>
             </a:r>
           </a:p>
           <a:p>
@@ -1425,7 +1395,7 @@
             </a:pPr>
             <a:r>
               <a:rPr lang="en-US"/>
-              <a:t>Thank you. We’re happy to take questions.</a:t>
+              <a:t>Thanks. We’re happy to take questions.</a:t>
             </a:r>
           </a:p>
         </p:txBody>
@@ -1785,7 +1755,7 @@
             </a:pPr>
             <a:r>
               <a:rPr lang="en-US"/>
-              <a:t>You can find a place: what’s open near you, filtered by diet, price and distance.</a:t>
+              <a:t>You can find what’s open near you, filtered by diet, price and distance. You can compare other apps’ ratings, where they let us show them, next to our score, which only counts diners with a receipt. If an app won’t share, we link out. And you can keep your lists and history, and book a table.</a:t>
             </a:r>
           </a:p>
           <a:p>
@@ -1800,7 +1770,7 @@
             </a:pPr>
             <a:r>
               <a:rPr lang="en-US"/>
-              <a:t>You can compare: ratings and posts from other apps, where they let us show them, next to our own score. Our score only counts diners who scanned a receipt, and restaurants can’t pay to rank higher. If an app won’t share its ratings, we link out to it.</a:t>
+              <a:t>Dietary filters stay free. A halal or nut-free search is what sends a restaurant a diner, so it shouldn’t cost anything.</a:t>
             </a:r>
           </a:p>
           <a:p>
@@ -1815,37 +1785,7 @@
             </a:pPr>
             <a:r>
               <a:rPr lang="en-US"/>
-              <a:t>And you can keep track: your history, your lists, and booking a table.</a:t>
-            </a:r>
-          </a:p>
-          <a:p>
-            <a:pPr indent="0" lvl="0" marL="0" rtl="0" algn="l">
-              <a:spcBef>
-                <a:spcPts val="0"/>
-              </a:spcBef>
-              <a:spcAft>
-                <a:spcPts val="600"/>
-              </a:spcAft>
-              <a:buNone/>
-            </a:pPr>
-            <a:r>
-              <a:rPr lang="en-US"/>
-              <a:t>The core app is free, including dietary filters. A halal or nut-free search is what sends a restaurant a diner, so we don’t want to charge for it.</a:t>
-            </a:r>
-          </a:p>
-          <a:p>
-            <a:pPr indent="0" lvl="0" marL="0" rtl="0" algn="l">
-              <a:spcBef>
-                <a:spcPts val="0"/>
-              </a:spcBef>
-              <a:spcAft>
-                <a:spcPts val="600"/>
-              </a:spcAft>
-              <a:buNone/>
-            </a:pPr>
-            <a:r>
-              <a:rPr lang="en-US"/>
-              <a:t>People ask about Beli a lot. Beli is great for ranking places you’ve been. We’re focused on deciding where to go next.</a:t>
+              <a:t>People ask about Beli a lot. Beli is for ranking places you’ve been. We’re about deciding where to go next.</a:t>
             </a:r>
           </a:p>
         </p:txBody>
@@ -1995,7 +1935,7 @@
             </a:pPr>
             <a:r>
               <a:rPr lang="en-US"/>
-              <a:t>These are concept screens. Every score and person on them is made up.</a:t>
+              <a:t>These are concept screens, and every score and person on them is made up.</a:t>
             </a:r>
           </a:p>
           <a:p>
@@ -2010,7 +1950,7 @@
             </a:pPr>
             <a:r>
               <a:rPr lang="en-US"/>
-              <a:t>The first shows what’s open around you. The second suggests one place that fits your budget and diet, and shows which friends have been. The third gives three picks, each with a reason. The fourth puts our receipt-based score next to the ratings from other apps, and flags creators’ paid posts.</a:t>
+              <a:t>You see what’s open nearby. The app suggests one place that fits your budget and diet, then gives three picks with a reason for each. The last screen puts our receipt score next to other apps’ ratings and flags paid posts.</a:t>
             </a:r>
           </a:p>
           <a:p>
@@ -2025,7 +1965,7 @@
             </a:pPr>
             <a:r>
               <a:rPr lang="en-US"/>
-              <a:t>We want to test these with students on campus before we build anything.</a:t>
+              <a:t>We want to test these with students before we build anything.</a:t>
             </a:r>
           </a:p>
         </p:txBody>
@@ -2175,7 +2115,7 @@
             </a:pPr>
             <a:r>
               <a:rPr lang="en-US"/>
-              <a:t>Boston has about 162,000 college students. Our Year 1 goal is 12,000 of them.</a:t>
+              <a:t>Boston has about 162,000 college students. We’re aiming for 12,000 of them in Year 1.</a:t>
             </a:r>
           </a:p>
           <a:p>
@@ -2190,7 +2130,7 @@
             </a:pPr>
             <a:r>
               <a:rPr lang="en-US"/>
-              <a:t>Across the US there are about 19 million college students. Our Year 5 target is 540,000 users, which is 2.8% of them, inside the 2 to 5% range from class.</a:t>
+              <a:t>Across the US there are about 19 million college students. Our Year 5 target is 540,000 users, about 2.8% of them, which is inside the 2 to 5% range from class.</a:t>
             </a:r>
           </a:p>
           <a:p>
@@ -2205,7 +2145,7 @@
             </a:pPr>
             <a:r>
               <a:rPr lang="en-US"/>
-              <a:t>On the restaurant side, Boston has 3,350 licensed places to eat.</a:t>
+              <a:t>And Boston has 3,350 licensed places to eat.</a:t>
             </a:r>
           </a:p>
         </p:txBody>
@@ -2355,7 +2295,7 @@
             </a:pPr>
             <a:r>
               <a:rPr lang="en-US"/>
-              <a:t>We’d grow the way Beli did, mostly through friends. About 80% of Beli’s users came that way.</a:t>
+              <a:t>We’d grow mostly through friends, the way Beli did. About 80% of Beli’s users came that way.</a:t>
             </a:r>
           </a:p>
           <a:p>
@@ -2370,7 +2310,7 @@
             </a:pPr>
             <a:r>
               <a:rPr lang="en-US"/>
-              <a:t>The first ten users would be people we interviewed and our friends, testing the prototype. The next hundred would be Northeastern students they invite, plus clubs and group chats. The first thousand would come from other Boston campuses, through student ambassadors and food posts.</a:t>
+              <a:t>The first ten users are people we interviewed and our friends. The next hundred are Northeastern students they invite, plus clubs and group chats. The first thousand come from other Boston campuses, through student ambassadors and food posts.</a:t>
             </a:r>
           </a:p>
           <a:p>
@@ -2385,7 +2325,7 @@
             </a:pPr>
             <a:r>
               <a:rPr lang="en-US"/>
-              <a:t>If that works, our model gets to 12,000 users by the end of Year 1. Users never have to pay. Restaurants would.</a:t>
+              <a:t>If that works, we get to 12,000 users by the end of Year 1. Users never have to pay.</a:t>
             </a:r>
           </a:p>
         </p:txBody>
@@ -2535,7 +2475,7 @@
             </a:pPr>
             <a:r>
               <a:rPr lang="en-US"/>
-              <a:t>This is how we’d make money. We’d charge restaurants for the diners we send, instead of for ads.</a:t>
+              <a:t>Users never pay. We’d charge restaurants for the diners we send, not for ads.</a:t>
             </a:r>
           </a:p>
           <a:p>
@@ -2550,7 +2490,7 @@
             </a:pPr>
             <a:r>
               <a:rPr lang="en-US"/>
-              <a:t>A restaurant would pay about 90 cents, and only after a receipt shows the diner came. For comparison, OpenTable charges $1 to $1.50 a diner. Booking sites would pay per table, and from Year 3 chains would pay $6,000 a year per area for insights.</a:t>
+              <a:t>A restaurant pays about 90 cents for a new diner whose visit started in our app, once a receipt confirms it. OpenTable charges $1 to $1.50. Booking sites pay per table, and from Year 3 chains pay $6,000 a year per area.</a:t>
             </a:r>
           </a:p>
           <a:p>
@@ -2565,7 +2505,7 @@
             </a:pPr>
             <a:r>
               <a:rPr lang="en-US"/>
-              <a:t>Users never have to pay. We’re also thinking about an optional $5 a month membership for extras, and we’d expect about 3 in 1,000 to sign up.</a:t>
+              <a:t>We’re also thinking about an optional $5 a month membership for extras. We expect about 3 in 1,000 users to sign up.</a:t>
             </a:r>
           </a:p>
           <a:p>
@@ -2580,7 +2520,7 @@
             </a:pPr>
             <a:r>
               <a:rPr lang="en-US"/>
-              <a:t>In our model that’s $356,000 in Year 5. Nothing anyone pays would change a score or a ranking.</a:t>
+              <a:t>That’s $356,000 in Year 5, and nobody can pay to change a score.</a:t>
             </a:r>
           </a:p>
           <a:p>
@@ -2595,7 +2535,7 @@
             </a:pPr>
             <a:r>
               <a:rPr lang="en-US"/>
-              <a:t>To be clear, we haven’t tested any of this with restaurant owners yet. That’s our next step: five owner calls, each with a free 30-day pilot and a report on the diners we sent.</a:t>
+              <a:t>We haven’t tested this with restaurant owners yet. Next we’re calling five owners and offering a free 30-day pilot.</a:t>
             </a:r>
           </a:p>
         </p:txBody>
@@ -2745,7 +2685,7 @@
             </a:pPr>
             <a:r>
               <a:rPr lang="en-US"/>
-              <a:t>Before building our numbers, we looked at the apps closest to us.</a:t>
+              <a:t>Before we built our numbers, we looked at the apps closest to us.</a:t>
             </a:r>
           </a:p>
           <a:p>
@@ -2760,7 +2700,7 @@
             </a:pPr>
             <a:r>
               <a:rPr lang="en-US"/>
-              <a:t>OpenTable took nine years to turn a profit and lost $57 million on the way. Resy ran on $45 million of investor money and was sold. Beli has 1.1 million monthly users, a team of five, and almost no revenue.</a:t>
+              <a:t>OpenTable took nine years to make a profit and lost $57 million getting there. Resy ran on $45 million of investor money and then sold. Beli has 1.1 million monthly users, five people, and almost no revenue.</a:t>
             </a:r>
           </a:p>
           <a:p>
@@ -2775,7 +2715,7 @@
             </a:pPr>
             <a:r>
               <a:rPr lang="en-US"/>
-              <a:t>That made us plan for slow money. No founder salaries, co-op students before full-time hires, and costs low enough that we’d need about $240,000 in total. We’re also planning for growth at about a quarter of Beli’s size.</a:t>
+              <a:t>So we planned for slow money: no founder salaries, co-op students before full-time hires, and about $240,000 in total. We’re planning for a quarter of Beli’s size.</a:t>
             </a:r>
           </a:p>
           <a:p>
@@ -2940,7 +2880,7 @@
             </a:pPr>
             <a:r>
               <a:rPr lang="en-US"/>
-              <a:t>Here’s the model. The three highlighted cells are the ones to look at.</a:t>
+              <a:t>Look at the three highlighted cells.</a:t>
             </a:r>
           </a:p>
           <a:p>
@@ -2955,7 +2895,7 @@
             </a:pPr>
             <a:r>
               <a:rPr lang="en-US"/>
-              <a:t>Years 1 and 2 cost about $10,500 a quarter: a contract developer at $7,500, $1,500 for marketing, $1,500 for legal and insurance, and hosting. No one else is paid until the angel round funds Year 3.</a:t>
+              <a:t>Years 1 and 2 cost about $10,500 a quarter: a contract developer at $7,500, $1,500 for marketing, $1,500 for legal and insurance, and hosting. No one else gets paid until the angel round funds Year 3.</a:t>
             </a:r>
           </a:p>
           <a:p>
@@ -2970,7 +2910,7 @@
             </a:pPr>
             <a:r>
               <a:rPr lang="en-US"/>
-              <a:t>First revenue shows up in Year 2. The lowest point is about $192,000 down in Year 4, and we’d raise $240,000 to cover that with a 25% cushion. Year 5 is the first profitable year in the model, at about $72,000.</a:t>
+              <a:t>First revenue comes in Year 2. Our low point is about $192,000 down in Year 4, so we’d raise $240,000, that low plus a 25% cushion. Year 5 is our first profitable year, at about $72,000.</a:t>
             </a:r>
           </a:p>
         </p:txBody>
@@ -13185,7 +13125,7 @@
                 <a:cs typeface="Poppins"/>
                 <a:sym typeface="Poppins"/>
               </a:rPr>
-              <a:t>want a good place to eat without checking five apps first</a:t>
+              <a:t>want a good place to eat without checking three apps first</a:t>
             </a:r>
             <a:endParaRPr/>
           </a:p>
@@ -13677,7 +13617,7 @@
                 <a:cs typeface="Poppins"/>
                 <a:sym typeface="Poppins"/>
               </a:rPr>
-              <a:t>checking Google Maps, Yelp, Instagram, TikTok and Beli one by one</a:t>
+              <a:t>checking Google Maps, Instagram or TikTok, and a friend one by one</a:t>
             </a:r>
             <a:endParaRPr/>
           </a:p>
@@ -14095,7 +14035,7 @@
                 <a:cs typeface="Poppins"/>
                 <a:sym typeface="Poppins"/>
               </a:rPr>
-              <a:t>In our model, one angel round of about $166K gets us to profit.</a:t>
+              <a:t>One angel round of about $166K gets us to a first profitable year.</a:t>
             </a:r>
             <a:endParaRPr/>
           </a:p>
@@ -15882,7 +15822,7 @@
                 <a:cs typeface="Poppins"/>
                 <a:sym typeface="Poppins"/>
               </a:rPr>
-              <a:t xml:space="preserve">Picking where to eat takes several apps today. </a:t>
+              <a:t xml:space="preserve">Right now, picking a place to eat takes three apps. </a:t>
             </a:r>
             <a:r>
               <a:rPr b="0" i="0" lang="en-US" sz="4400" u="none" cap="none" strike="noStrike">
@@ -15894,7 +15834,7 @@
                 <a:cs typeface="Poppins"/>
                 <a:sym typeface="Poppins"/>
               </a:rPr>
-              <a:t>We think it can take one.</a:t>
+              <a:t>We think it could take one.</a:t>
             </a:r>
             <a:endParaRPr/>
           </a:p>
@@ -16404,7 +16344,7 @@
                 <a:cs typeface="Poppins"/>
                 <a:sym typeface="Poppins"/>
               </a:rPr>
-              <a:t>What we heard</a:t>
+              <a:t>The challenge</a:t>
             </a:r>
             <a:endParaRPr/>
           </a:p>
@@ -17453,7 +17393,7 @@
                 <a:cs typeface="Poppins"/>
                 <a:sym typeface="Poppins"/>
               </a:rPr>
-              <a:t>What we’re building</a:t>
+              <a:t>The opportunity</a:t>
             </a:r>
             <a:endParaRPr/>
           </a:p>
@@ -18645,7 +18585,7 @@
                 <a:cs typeface="Roboto Mono"/>
                 <a:sym typeface="Roboto Mono"/>
               </a:rPr>
-              <a:t>Concept screens. Every score and person is made up. Photos: Unsplash; Daderot, Wikimedia Commons (CC0).</a:t>
+              <a:t>Concept screens. Every score and person is made up. Other apps’ ratings shown only where we’re allowed. Photos: Unsplash; Daderot, Wikimedia Commons (CC0).</a:t>
             </a:r>
             <a:endParaRPr/>
           </a:p>
@@ -19797,7 +19737,7 @@
                 <a:cs typeface="Poppins"/>
                 <a:sym typeface="Poppins"/>
               </a:rPr>
-              <a:t>Restaurants we can sign</a:t>
+              <a:t>Restaurants in Boston</a:t>
             </a:r>
             <a:endParaRPr/>
           </a:p>
@@ -21179,7 +21119,7 @@
                 <a:cs typeface="Poppins"/>
                 <a:sym typeface="Poppins"/>
               </a:rPr>
-              <a:t>One app instead of five tabs.</a:t>
+              <a:t>One app instead of three.</a:t>
             </a:r>
             <a:endParaRPr sz="2400"/>
           </a:p>
@@ -21903,7 +21843,7 @@
                 <a:cs typeface="Poppins"/>
                 <a:sym typeface="Poppins"/>
               </a:rPr>
-              <a:t>About $0.90 per new diner, once a receipt proves the visit. Booking sites pay per table. Chains pay $6,000 a year per area.</a:t>
+              <a:t>About $0.90 per new diner whose visit started in our app, confirmed by receipt. Booking sites pay per table. Chains pay $6,000 a year per area.</a:t>
             </a:r>
             <a:endParaRPr sz="2200"/>
           </a:p>

</xml_diff>

<commit_message>
Apply story and voice review fixes
Co-Authored-By: Claude Opus 5.5 <noreply@anthropic.com>
Claude-Session: https://claude.ai/code/session_017KdnwN2qyuF8wMBvTngErS
</commit_message>
<xml_diff>
--- a/ENTR_4501_Gate_2_deck_readable.pptx
+++ b/ENTR_4501_Gate_2_deck_readable.pptx
@@ -1170,7 +1170,7 @@
             </a:pPr>
             <a:r>
               <a:rPr lang="en-US"/>
-              <a:t>If it comes up, this is where each price comes from.</a:t>
+              <a:t>If someone asks where our prices come from, this is it.</a:t>
             </a:r>
           </a:p>
           <a:p>
@@ -1395,7 +1395,7 @@
             </a:pPr>
             <a:r>
               <a:rPr lang="en-US"/>
-              <a:t>Thanks. We’re happy to take questions.</a:t>
+              <a:t>That’s our idea and our research so far. What would you like to ask?</a:t>
             </a:r>
           </a:p>
         </p:txBody>
@@ -1590,7 +1590,7 @@
             </a:pPr>
             <a:r>
               <a:rPr lang="en-US"/>
-              <a:t>So it’s an annoying routine more than a crisis, and we think it can be easier.</a:t>
+              <a:t>It’s not a crisis. It’s just annoying. We think it can be easier.</a:t>
             </a:r>
           </a:p>
         </p:txBody>
@@ -1740,7 +1740,7 @@
             </a:pPr>
             <a:r>
               <a:rPr lang="en-US"/>
-              <a:t>So the idea is one page per restaurant.</a:t>
+              <a:t>Here’s the idea: one page for each restaurant.</a:t>
             </a:r>
           </a:p>
           <a:p>
@@ -2115,7 +2115,7 @@
             </a:pPr>
             <a:r>
               <a:rPr lang="en-US"/>
-              <a:t>Boston has about 162,000 college students. We’re aiming for 12,000 of them in Year 1.</a:t>
+              <a:t>If students like it, here’s how far it can go. Boston has about 162,000 college students, and we’re aiming for 12,000 of them in Year 1.</a:t>
             </a:r>
           </a:p>
           <a:p>
@@ -2130,7 +2130,7 @@
             </a:pPr>
             <a:r>
               <a:rPr lang="en-US"/>
-              <a:t>Across the US there are about 19 million college students. Our Year 5 target is 540,000 users, about 2.8% of them, which is inside the 2 to 5% range from class.</a:t>
+              <a:t>Across the US there are about 19 million college students. By Year 5 we’re aiming for 540,000 users. That’s about 2.8% of them, inside the 2 to 5% range we covered in class.</a:t>
             </a:r>
           </a:p>
           <a:p>
@@ -2325,7 +2325,7 @@
             </a:pPr>
             <a:r>
               <a:rPr lang="en-US"/>
-              <a:t>If that works, we get to 12,000 users by the end of Year 1. Users never have to pay.</a:t>
+              <a:t>If that works, we get to 12,000 users by the end of Year 1.</a:t>
             </a:r>
           </a:p>
         </p:txBody>
@@ -2475,7 +2475,7 @@
             </a:pPr>
             <a:r>
               <a:rPr lang="en-US"/>
-              <a:t>Users never pay. We’d charge restaurants for the diners we send, not for ads.</a:t>
+              <a:t>Users never have to pay. We’d charge restaurants for the diners we send, not for ads.</a:t>
             </a:r>
           </a:p>
           <a:p>
@@ -2880,7 +2880,7 @@
             </a:pPr>
             <a:r>
               <a:rPr lang="en-US"/>
-              <a:t>Look at the three highlighted cells.</a:t>
+              <a:t>Three numbers matter here, and they’re highlighted.</a:t>
             </a:r>
           </a:p>
           <a:p>
@@ -2895,7 +2895,7 @@
             </a:pPr>
             <a:r>
               <a:rPr lang="en-US"/>
-              <a:t>Years 1 and 2 cost about $10,500 a quarter: a contract developer at $7,500, $1,500 for marketing, $1,500 for legal and insurance, and hosting. No one else gets paid until the angel round funds Year 3.</a:t>
+              <a:t>Years 1 and 2 cost about $11,000 a quarter: a contract developer at $7,500, $1,500 for marketing, $1,500 for legal and insurance, and hosting. No one else gets paid until the angel round funds Year 3.</a:t>
             </a:r>
           </a:p>
           <a:p>
@@ -19301,7 +19301,7 @@
                 <a:cs typeface="Poppins"/>
                 <a:sym typeface="Poppins"/>
               </a:rPr>
-              <a:t>We start with Boston's 162,000 students. </a:t>
+              <a:t xml:space="preserve">We start with Boston’s 162,000 students </a:t>
             </a:r>
             <a:r>
               <a:rPr b="0" i="0" lang="en-US" sz="4400" u="none" cap="none" strike="noStrike">
@@ -19313,7 +19313,7 @@
                 <a:cs typeface="Poppins"/>
                 <a:sym typeface="Poppins"/>
               </a:rPr>
-              <a:t>About 19 million US students could use it.</a:t>
+              <a:t>and aim for 540,000 US users by Year 5.</a:t>
             </a:r>
             <a:endParaRPr/>
           </a:p>
@@ -21230,7 +21230,7 @@
                 <a:cs typeface="Poppins"/>
                 <a:sym typeface="Poppins"/>
               </a:rPr>
-              <a:t>If friends invite friends, our model reaches 12K users by the end of Year 1; about 80% of Beli’s users arrived that way. Users never have to pay.</a:t>
+              <a:t>If friends invite friends, our model reaches 12K users by the end of Year 1; about 80% of Beli’s users arrived that way.</a:t>
             </a:r>
             <a:endParaRPr sz="2400"/>
           </a:p>

</xml_diff>

<commit_message>
Deck: tighten slides 2, 3, 7, 8 per Ashley and AI-writing reviews
Co-Authored-By: Claude Opus 5.5 <noreply@anthropic.com>
Claude-Session: https://claude.ai/code/session_017KdnwN2qyuF8wMBvTngErS
</commit_message>
<xml_diff>
--- a/ENTR_4501_Gate_2_deck_readable.pptx
+++ b/ENTR_4501_Gate_2_deck_readable.pptx
@@ -1590,7 +1590,7 @@
             </a:pPr>
             <a:r>
               <a:rPr lang="en-US"/>
-              <a:t>It’s not a crisis. It’s just annoying. We think it can be easier.</a:t>
+              <a:t>It’s not a huge problem, it’s just annoying, and we think it can be easier.</a:t>
             </a:r>
           </a:p>
         </p:txBody>
@@ -2880,7 +2880,7 @@
             </a:pPr>
             <a:r>
               <a:rPr lang="en-US"/>
-              <a:t>Three numbers matter here, and they’re highlighted.</a:t>
+              <a:t>We highlighted the three numbers to look at.</a:t>
             </a:r>
           </a:p>
           <a:p>
@@ -16588,7 +16588,7 @@
         <p:spPr>
           <a:xfrm>
             <a:off x="822960" y="4023360"/>
-            <a:ext cx="3840480" cy="822960"/>
+            <a:ext cx="5120640" cy="822960"/>
           </a:xfrm>
           <a:prstGeom prst="rect">
             <a:avLst/>
@@ -16641,7 +16641,7 @@
         <p:spPr>
           <a:xfrm>
             <a:off x="822960" y="5349240"/>
-            <a:ext cx="3931800" cy="369300"/>
+            <a:ext cx="5120640" cy="369300"/>
           </a:xfrm>
           <a:prstGeom prst="rect">
             <a:avLst/>
@@ -16694,7 +16694,7 @@
         <p:spPr>
           <a:xfrm>
             <a:off x="822960" y="6035040"/>
-            <a:ext cx="3931800" cy="369300"/>
+            <a:ext cx="5120640" cy="369300"/>
           </a:xfrm>
           <a:prstGeom prst="rect">
             <a:avLst/>
@@ -16746,8 +16746,8 @@
         </p:nvSpPr>
         <p:spPr>
           <a:xfrm>
-            <a:off x="5074920" y="4023360"/>
-            <a:ext cx="3840480" cy="822960"/>
+            <a:off x="6492240" y="4023360"/>
+            <a:ext cx="5120640" cy="822960"/>
           </a:xfrm>
           <a:prstGeom prst="rect">
             <a:avLst/>
@@ -16799,8 +16799,8 @@
         </p:nvSpPr>
         <p:spPr>
           <a:xfrm>
-            <a:off x="5074920" y="5349240"/>
-            <a:ext cx="3931800" cy="369300"/>
+            <a:off x="6492240" y="5349240"/>
+            <a:ext cx="5120640" cy="369300"/>
           </a:xfrm>
           <a:prstGeom prst="rect">
             <a:avLst/>
@@ -16852,8 +16852,8 @@
         </p:nvSpPr>
         <p:spPr>
           <a:xfrm>
-            <a:off x="5074920" y="6035040"/>
-            <a:ext cx="3931800" cy="369300"/>
+            <a:off x="6492240" y="6035040"/>
+            <a:ext cx="5120640" cy="369300"/>
           </a:xfrm>
           <a:prstGeom prst="rect">
             <a:avLst/>
@@ -16905,8 +16905,8 @@
         </p:nvSpPr>
         <p:spPr>
           <a:xfrm>
-            <a:off x="9326880" y="4023360"/>
-            <a:ext cx="3840480" cy="822960"/>
+            <a:off x="12161520" y="4023360"/>
+            <a:ext cx="5120640" cy="822960"/>
           </a:xfrm>
           <a:prstGeom prst="rect">
             <a:avLst/>
@@ -16958,8 +16958,8 @@
         </p:nvSpPr>
         <p:spPr>
           <a:xfrm>
-            <a:off x="9326880" y="5349240"/>
-            <a:ext cx="3931800" cy="369300"/>
+            <a:off x="12161520" y="5349240"/>
+            <a:ext cx="5120640" cy="369300"/>
           </a:xfrm>
           <a:prstGeom prst="rect">
             <a:avLst/>
@@ -17011,8 +17011,8 @@
         </p:nvSpPr>
         <p:spPr>
           <a:xfrm>
-            <a:off x="9326880" y="6035040"/>
-            <a:ext cx="3931800" cy="369300"/>
+            <a:off x="12161520" y="6035040"/>
+            <a:ext cx="5120640" cy="369300"/>
           </a:xfrm>
           <a:prstGeom prst="rect">
             <a:avLst/>
@@ -17058,225 +17058,13 @@
       </p:sp>
       <p:sp>
         <p:nvSpPr>
-          <p:cNvPr id="127" name="Google Shape;127;p2"/>
-          <p:cNvSpPr txBox="1"/>
-          <p:nvPr/>
-        </p:nvSpPr>
-        <p:spPr>
-          <a:xfrm>
-            <a:off x="13578840" y="4023360"/>
-            <a:ext cx="3840480" cy="822960"/>
-          </a:xfrm>
-          <a:prstGeom prst="rect">
-            <a:avLst/>
-          </a:prstGeom>
-          <a:noFill/>
-          <a:ln>
-            <a:noFill/>
-          </a:ln>
-        </p:spPr>
-        <p:txBody>
-          <a:bodyPr anchorCtr="0" anchor="t" bIns="0" lIns="0" spcFirstLastPara="1" rIns="0" wrap="square" tIns="0">
-            <a:spAutoFit/>
-          </a:bodyPr>
-          <a:lstStyle/>
-          <a:p>
-            <a:pPr indent="0" lvl="0" marL="0" marR="0" rtl="0" algn="l">
-              <a:lnSpc>
-                <a:spcPct val="110000"/>
-              </a:lnSpc>
-              <a:spcBef>
-                <a:spcPts val="0"/>
-              </a:spcBef>
-              <a:spcAft>
-                <a:spcPts val="0"/>
-              </a:spcAft>
-              <a:buNone/>
-            </a:pPr>
-            <a:r>
-              <a:rPr b="0" i="0" lang="en-US" sz="4000" u="none" cap="none" strike="noStrike">
-                <a:solidFill>
-                  <a:srgbClr val="000000"/>
-                </a:solidFill>
-                <a:latin typeface="Poppins"/>
-                <a:ea typeface="Poppins"/>
-                <a:cs typeface="Poppins"/>
-                <a:sym typeface="Poppins"/>
-              </a:rPr>
-              <a:t>4</a:t>
-            </a:r>
-            <a:endParaRPr/>
-          </a:p>
-        </p:txBody>
-      </p:sp>
-      <p:sp>
-        <p:nvSpPr>
-          <p:cNvPr id="128" name="Google Shape;128;p2"/>
-          <p:cNvSpPr txBox="1"/>
-          <p:nvPr/>
-        </p:nvSpPr>
-        <p:spPr>
-          <a:xfrm>
-            <a:off x="13578840" y="5349240"/>
-            <a:ext cx="3931800" cy="369300"/>
-          </a:xfrm>
-          <a:prstGeom prst="rect">
-            <a:avLst/>
-          </a:prstGeom>
-          <a:noFill/>
-          <a:ln>
-            <a:noFill/>
-          </a:ln>
-        </p:spPr>
-        <p:txBody>
-          <a:bodyPr anchorCtr="0" anchor="t" bIns="0" lIns="0" spcFirstLastPara="1" rIns="0" wrap="square" tIns="0">
-            <a:spAutoFit/>
-          </a:bodyPr>
-          <a:lstStyle/>
-          <a:p>
-            <a:pPr indent="0" lvl="0" marL="0" marR="0" rtl="0" algn="l">
-              <a:lnSpc>
-                <a:spcPct val="110000"/>
-              </a:lnSpc>
-              <a:spcBef>
-                <a:spcPts val="0"/>
-              </a:spcBef>
-              <a:spcAft>
-                <a:spcPts val="0"/>
-              </a:spcAft>
-              <a:buNone/>
-            </a:pPr>
-            <a:r>
-              <a:rPr b="1" i="0" lang="en-US" sz="2800" u="none" cap="none" strike="noStrike">
-                <a:solidFill>
-                  <a:srgbClr val="000000"/>
-                </a:solidFill>
-                <a:latin typeface="Poppins"/>
-                <a:ea typeface="Poppins"/>
-                <a:cs typeface="Poppins"/>
-                <a:sym typeface="Poppins"/>
-              </a:rPr>
-              <a:t>Then they go</a:t>
-            </a:r>
-            <a:endParaRPr sz="2800"/>
-          </a:p>
-        </p:txBody>
-      </p:sp>
-      <p:sp>
-        <p:nvSpPr>
-          <p:cNvPr id="129" name="Google Shape;129;p2"/>
-          <p:cNvSpPr txBox="1"/>
-          <p:nvPr/>
-        </p:nvSpPr>
-        <p:spPr>
-          <a:xfrm>
-            <a:off x="13578840" y="6035040"/>
-            <a:ext cx="3931800" cy="369300"/>
-          </a:xfrm>
-          <a:prstGeom prst="rect">
-            <a:avLst/>
-          </a:prstGeom>
-          <a:noFill/>
-          <a:ln>
-            <a:noFill/>
-          </a:ln>
-        </p:spPr>
-        <p:txBody>
-          <a:bodyPr anchorCtr="0" anchor="t" bIns="0" lIns="0" spcFirstLastPara="1" rIns="0" wrap="square" tIns="0">
-            <a:spAutoFit/>
-          </a:bodyPr>
-          <a:lstStyle/>
-          <a:p>
-            <a:pPr indent="0" lvl="0" marL="0" marR="0" rtl="0" algn="l">
-              <a:lnSpc>
-                <a:spcPct val="110000"/>
-              </a:lnSpc>
-              <a:spcBef>
-                <a:spcPts val="0"/>
-              </a:spcBef>
-              <a:spcAft>
-                <a:spcPts val="0"/>
-              </a:spcAft>
-              <a:buNone/>
-            </a:pPr>
-            <a:r>
-              <a:rPr b="0" i="0" lang="en-US" sz="2400" u="none" cap="none" strike="noStrike">
-                <a:solidFill>
-                  <a:srgbClr val="000000"/>
-                </a:solidFill>
-                <a:latin typeface="Poppins"/>
-                <a:ea typeface="Poppins"/>
-                <a:cs typeface="Poppins"/>
-                <a:sym typeface="Poppins"/>
-              </a:rPr>
-              <a:t>and it's still a miss</a:t>
-            </a:r>
-            <a:endParaRPr sz="2400"/>
-          </a:p>
-        </p:txBody>
-      </p:sp>
-      <p:sp>
-        <p:nvSpPr>
-          <p:cNvPr id="130" name="Google Shape;130;p2"/>
-          <p:cNvSpPr txBox="1"/>
-          <p:nvPr/>
-        </p:nvSpPr>
-        <p:spPr>
-          <a:xfrm>
-            <a:off x="822960" y="7589520"/>
-            <a:ext cx="16642200" cy="369300"/>
-          </a:xfrm>
-          <a:prstGeom prst="rect">
-            <a:avLst/>
-          </a:prstGeom>
-          <a:noFill/>
-          <a:ln>
-            <a:noFill/>
-          </a:ln>
-        </p:spPr>
-        <p:txBody>
-          <a:bodyPr anchorCtr="0" anchor="t" bIns="0" lIns="0" spcFirstLastPara="1" rIns="0" wrap="square" tIns="0">
-            <a:spAutoFit/>
-          </a:bodyPr>
-          <a:lstStyle/>
-          <a:p>
-            <a:pPr indent="0" lvl="0" marL="0" marR="0" rtl="0" algn="l">
-              <a:lnSpc>
-                <a:spcPct val="110000"/>
-              </a:lnSpc>
-              <a:spcBef>
-                <a:spcPts val="0"/>
-              </a:spcBef>
-              <a:spcAft>
-                <a:spcPts val="0"/>
-              </a:spcAft>
-              <a:buNone/>
-            </a:pPr>
-            <a:r>
-              <a:rPr b="1" i="0" lang="en-US" sz="2800" u="none" cap="none" strike="noStrike">
-                <a:solidFill>
-                  <a:srgbClr val="000000"/>
-                </a:solidFill>
-                <a:latin typeface="Poppins"/>
-                <a:ea typeface="Poppins"/>
-                <a:cs typeface="Poppins"/>
-                <a:sym typeface="Poppins"/>
-              </a:rPr>
-              <a:t>Many said it still misses after checking all three.</a:t>
-            </a:r>
-            <a:endParaRPr sz="2800"/>
-          </a:p>
-        </p:txBody>
-      </p:sp>
-      <p:sp>
-        <p:nvSpPr>
           <p:cNvPr id="131" name="Google Shape;131;p2"/>
           <p:cNvSpPr txBox="1"/>
           <p:nvPr/>
         </p:nvSpPr>
         <p:spPr>
           <a:xfrm>
-            <a:off x="822960" y="8229600"/>
+            <a:off x="822960" y="7589520"/>
             <a:ext cx="16642200" cy="369300"/>
           </a:xfrm>
           <a:prstGeom prst="rect">
@@ -17946,7 +17734,7 @@
                 <a:cs typeface="Poppins"/>
                 <a:sym typeface="Poppins"/>
               </a:rPr>
-              <a:t>Other apps’ ratings and posts, where they let us show them</a:t>
+              <a:t>Other apps’ ratings, where allowed</a:t>
             </a:r>
             <a:endParaRPr sz="2400"/>
           </a:p>
@@ -18284,59 +18072,6 @@
                 <a:sym typeface="Poppins"/>
               </a:rPr>
               <a:t>Beli is for ranking places you’ve been. We help you decide where to go next, with a score based on receipts.</a:t>
-            </a:r>
-            <a:endParaRPr/>
-          </a:p>
-        </p:txBody>
-      </p:sp>
-      <p:sp>
-        <p:nvSpPr>
-          <p:cNvPr id="150" name="Google Shape;150;p3"/>
-          <p:cNvSpPr txBox="1"/>
-          <p:nvPr/>
-        </p:nvSpPr>
-        <p:spPr>
-          <a:xfrm>
-            <a:off x="822960" y="8412480"/>
-            <a:ext cx="16642080" cy="548640"/>
-          </a:xfrm>
-          <a:prstGeom prst="rect">
-            <a:avLst/>
-          </a:prstGeom>
-          <a:noFill/>
-          <a:ln>
-            <a:noFill/>
-          </a:ln>
-        </p:spPr>
-        <p:txBody>
-          <a:bodyPr anchorCtr="0" anchor="t" bIns="0" lIns="0" spcFirstLastPara="1" rIns="0" wrap="square" tIns="0">
-            <a:spAutoFit/>
-          </a:bodyPr>
-          <a:lstStyle/>
-          <a:p>
-            <a:pPr indent="0" lvl="0" marL="0" marR="0" rtl="0" algn="l">
-              <a:lnSpc>
-                <a:spcPct val="110000"/>
-              </a:lnSpc>
-              <a:spcBef>
-                <a:spcPts val="0"/>
-              </a:spcBef>
-              <a:spcAft>
-                <a:spcPts val="0"/>
-              </a:spcAft>
-              <a:buNone/>
-            </a:pPr>
-            <a:r>
-              <a:rPr b="0" i="0" lang="en-US" sz="2400" u="none" cap="none" strike="noStrike">
-                <a:solidFill>
-                  <a:srgbClr val="434343"/>
-                </a:solidFill>
-                <a:latin typeface="Poppins"/>
-                <a:ea typeface="Poppins"/>
-                <a:cs typeface="Poppins"/>
-                <a:sym typeface="Poppins"/>
-              </a:rPr>
-              <a:t>Dietary filters stay free: a halal or nut-free search is what sends a restaurant the diner it pays for. Nobody pays for placement.</a:t>
             </a:r>
             <a:endParaRPr/>
           </a:p>
@@ -21843,7 +21578,7 @@
                 <a:cs typeface="Poppins"/>
                 <a:sym typeface="Poppins"/>
               </a:rPr>
-              <a:t>About $0.90 per new diner whose visit started in our app, confirmed by receipt. Booking sites pay per table. Chains pay $6,000 a year per area.</a:t>
+              <a:t>About $0.90 per new diner whose visit started in our app, confirmed by receipt.</a:t>
             </a:r>
             <a:endParaRPr sz="2200"/>
           </a:p>
@@ -22060,7 +21795,7 @@
                 <a:cs typeface="Poppins"/>
                 <a:sym typeface="Poppins"/>
               </a:rPr>
-              <a:t>The app is free. About 3 in 1,000 pay for extras.</a:t>
+              <a:t>Want extras on top of a free app.</a:t>
             </a:r>
             <a:endParaRPr sz="2200"/>
           </a:p>
@@ -22428,7 +22163,7 @@
                 <a:cs typeface="Poppins"/>
                 <a:sym typeface="Poppins"/>
               </a:rPr>
-              <a:t>What we learned</a:t>
+              <a:t>What we learned from rivals</a:t>
             </a:r>
             <a:endParaRPr/>
           </a:p>
@@ -23356,7 +23091,7 @@
                 <a:cs typeface="Poppins"/>
                 <a:sym typeface="Poppins"/>
               </a:rPr>
-              <a:t>A quarter of its size, almost no ads, restaurants paying from Year 2.</a:t>
+              <a:t>We plan for a quarter of Beli’s size, almost no ads, and restaurants paying from Year 2.</a:t>
             </a:r>
             <a:endParaRPr sz="2400"/>
           </a:p>

</xml_diff>

<commit_message>
Merge teammate deck edits; add revised Deliverable 2 and Financial Summary drafts
Co-Authored-By: Claude Opus 5.5 <noreply@anthropic.com>
Claude-Session: https://claude.ai/code/session_017KdnwN2qyuF8wMBvTngErS
</commit_message>
<xml_diff>
--- a/ENTR_4501_Gate_2_deck_readable.pptx
+++ b/ENTR_4501_Gate_2_deck_readable.pptx
@@ -18149,7 +18149,7 @@
                 <a:cs typeface="Poppins"/>
                 <a:sym typeface="Poppins"/>
               </a:rPr>
-              <a:t>What it looks like</a:t>
+              <a:t>A first look</a:t>
             </a:r>
             <a:endParaRPr/>
           </a:p>
@@ -18214,7 +18214,7 @@
                 <a:cs typeface="Poppins"/>
                 <a:sym typeface="Poppins"/>
               </a:rPr>
-              <a:t>and shows why.</a:t>
+              <a:t>and shows you why.</a:t>
             </a:r>
             <a:endParaRPr/>
           </a:p>
@@ -21578,7 +21578,7 @@
                 <a:cs typeface="Poppins"/>
                 <a:sym typeface="Poppins"/>
               </a:rPr>
-              <a:t>About $0.90 per new diner whose visit started in our app, confirmed by receipt.</a:t>
+              <a:t>About $0.90 per new diner whose visit started in our app, confirmed by receipt. Booking sites pay per table. Chains pay $6,000 a year per area from Year 3, counted from the month each signs.</a:t>
             </a:r>
             <a:endParaRPr sz="2200"/>
           </a:p>

</xml_diff>

<commit_message>
Remove embedded subset fonts that garble in some viewers; final review fixes
Co-Authored-By: Claude Opus 5.5 <noreply@anthropic.com>
Claude-Session: https://claude.ai/code/session_017KdnwN2qyuF8wMBvTngErS
</commit_message>
<xml_diff>
--- a/ENTR_4501_Gate_2_deck_readable.pptx
+++ b/ENTR_4501_Gate_2_deck_readable.pptx
@@ -23,22 +23,6 @@
   </p:sldIdLst>
   <p:sldSz cy="10287000" cx="18288000"/>
   <p:notesSz cx="6858000" cy="9144000"/>
-  <p:embeddedFontLst>
-    <p:embeddedFont>
-      <p:font typeface="Poppins"/>
-      <p:regular r:id="rId18"/>
-      <p:bold r:id="rId19"/>
-      <p:italic r:id="rId20"/>
-      <p:boldItalic r:id="rId21"/>
-    </p:embeddedFont>
-    <p:embeddedFont>
-      <p:font typeface="Roboto Mono"/>
-      <p:regular r:id="rId22"/>
-      <p:bold r:id="rId23"/>
-      <p:italic r:id="rId24"/>
-      <p:boldItalic r:id="rId25"/>
-    </p:embeddedFont>
-  </p:embeddedFontLst>
   <p:defaultTextStyle>
     <a:defPPr lvl="0" marR="0" rtl="0" algn="l">
       <a:lnSpc>
@@ -21202,7 +21186,7 @@
                 <a:cs typeface="Roboto Mono"/>
                 <a:sym typeface="Roboto Mono"/>
               </a:rPr>
-              <a:t>OpenTable pricing via Eat App, 2026. TechCrunch, Aug 2024 (Placer.ai). Together these come to $356K of revenue in Year 5.</a:t>
+              <a:t>OpenTable pricing via Eat App, 2026. TechCrunch, Aug 2024 (Placer.ai).</a:t>
             </a:r>
             <a:endParaRPr/>
           </a:p>
@@ -21375,7 +21359,7 @@
         </p:nvSpPr>
         <p:spPr>
           <a:xfrm>
-            <a:off x="822960" y="4041648"/>
+            <a:off x="822960" y="4160520"/>
             <a:ext cx="16642080" cy="10972"/>
           </a:xfrm>
           <a:prstGeom prst="rect">
@@ -23091,7 +23075,7 @@
                 <a:cs typeface="Poppins"/>
                 <a:sym typeface="Poppins"/>
               </a:rPr>
-              <a:t>We plan for a quarter of Beli’s size, almost no ads, and restaurants paying from Year 2.</a:t>
+              <a:t>A quarter of Beli’s size, almost no ad spending, restaurants paying from Year 2.</a:t>
             </a:r>
             <a:endParaRPr sz="2400"/>
           </a:p>
@@ -24954,7 +24938,7 @@
                           <a:cs typeface="Poppins"/>
                           <a:sym typeface="Poppins"/>
                         </a:rPr>
-                        <a:t>10.9</a:t>
+                        <a:t>10.8</a:t>
                       </a:r>
                       <a:endParaRPr/>
                     </a:p>
@@ -26553,7 +26537,7 @@
                 <a:cs typeface="Poppins"/>
                 <a:sym typeface="Poppins"/>
               </a:rPr>
-              <a:t>Hire co-op for yr 3</a:t>
+              <a:t>Hire co-op</a:t>
             </a:r>
             <a:endParaRPr sz="1600"/>
           </a:p>

</xml_diff>

<commit_message>
Switch deck fonts to Arial so text renders in every viewer
Co-Authored-By: Claude Opus 5.5 <noreply@anthropic.com>
Claude-Session: https://claude.ai/code/session_017KdnwN2qyuF8wMBvTngErS
</commit_message>
<xml_diff>
--- a/ENTR_4501_Gate_2_deck_readable.pptx
+++ b/ENTR_4501_Gate_2_deck_readable.pptx
@@ -12605,10 +12605,10 @@
                 <a:solidFill>
                   <a:srgbClr val="6F6B34"/>
                 </a:solidFill>
-                <a:latin typeface="Poppins"/>
-                <a:ea typeface="Poppins"/>
-                <a:cs typeface="Poppins"/>
-                <a:sym typeface="Poppins"/>
+                <a:latin typeface="Arial"/>
+                <a:ea typeface="Arial"/>
+                <a:cs typeface="Arial"/>
+                <a:sym typeface="Arial"/>
               </a:rPr>
               <a:t>Our idea</a:t>
             </a:r>
@@ -12658,10 +12658,10 @@
                 <a:solidFill>
                   <a:srgbClr val="595959"/>
                 </a:solidFill>
-                <a:latin typeface="Poppins"/>
-                <a:ea typeface="Poppins"/>
-                <a:cs typeface="Poppins"/>
-                <a:sym typeface="Poppins"/>
+                <a:latin typeface="Arial"/>
+                <a:ea typeface="Arial"/>
+                <a:cs typeface="Arial"/>
+                <a:sym typeface="Arial"/>
               </a:rPr>
               <a:t>1</a:t>
             </a:r>
@@ -12711,10 +12711,10 @@
                 <a:solidFill>
                   <a:srgbClr val="000000"/>
                 </a:solidFill>
-                <a:latin typeface="Poppins"/>
-                <a:ea typeface="Poppins"/>
-                <a:cs typeface="Poppins"/>
-                <a:sym typeface="Poppins"/>
+                <a:latin typeface="Arial"/>
+                <a:ea typeface="Arial"/>
+                <a:cs typeface="Arial"/>
+                <a:sym typeface="Arial"/>
               </a:rPr>
               <a:t xml:space="preserve">A free app for deciding where to eat in Boston, </a:t>
             </a:r>
@@ -12723,10 +12723,10 @@
                 <a:solidFill>
                   <a:srgbClr val="595959"/>
                 </a:solidFill>
-                <a:latin typeface="Poppins"/>
-                <a:ea typeface="Poppins"/>
-                <a:cs typeface="Poppins"/>
-                <a:sym typeface="Poppins"/>
+                <a:latin typeface="Arial"/>
+                <a:ea typeface="Arial"/>
+                <a:cs typeface="Arial"/>
+                <a:sym typeface="Arial"/>
               </a:rPr>
               <a:t>with a score based on real visits.</a:t>
             </a:r>
@@ -12776,10 +12776,10 @@
                 <a:solidFill>
                   <a:srgbClr val="595959"/>
                 </a:solidFill>
-                <a:latin typeface="Roboto Mono"/>
-                <a:ea typeface="Roboto Mono"/>
-                <a:cs typeface="Roboto Mono"/>
-                <a:sym typeface="Roboto Mono"/>
+                <a:latin typeface="Arial"/>
+                <a:ea typeface="Arial"/>
+                <a:cs typeface="Arial"/>
+                <a:sym typeface="Arial"/>
               </a:rPr>
               <a:t>Our value proposition. The app doesn't have a name yet.</a:t>
             </a:r>
@@ -12887,10 +12887,10 @@
                 <a:solidFill>
                   <a:srgbClr val="6F6B34"/>
                 </a:solidFill>
-                <a:latin typeface="Poppins"/>
-                <a:ea typeface="Poppins"/>
-                <a:cs typeface="Poppins"/>
-                <a:sym typeface="Poppins"/>
+                <a:latin typeface="Arial"/>
+                <a:ea typeface="Arial"/>
+                <a:cs typeface="Arial"/>
+                <a:sym typeface="Arial"/>
               </a:rPr>
               <a:t>For</a:t>
             </a:r>
@@ -12940,10 +12940,10 @@
                 <a:solidFill>
                   <a:srgbClr val="434343"/>
                 </a:solidFill>
-                <a:latin typeface="Poppins"/>
-                <a:ea typeface="Poppins"/>
-                <a:cs typeface="Poppins"/>
-                <a:sym typeface="Poppins"/>
+                <a:latin typeface="Arial"/>
+                <a:ea typeface="Arial"/>
+                <a:cs typeface="Arial"/>
+                <a:sym typeface="Arial"/>
               </a:rPr>
               <a:t>students and young professionals in Boston, starting at Northeastern</a:t>
             </a:r>
@@ -13051,10 +13051,10 @@
                 <a:solidFill>
                   <a:srgbClr val="6F6B34"/>
                 </a:solidFill>
-                <a:latin typeface="Poppins"/>
-                <a:ea typeface="Poppins"/>
-                <a:cs typeface="Poppins"/>
-                <a:sym typeface="Poppins"/>
+                <a:latin typeface="Arial"/>
+                <a:ea typeface="Arial"/>
+                <a:cs typeface="Arial"/>
+                <a:sym typeface="Arial"/>
               </a:rPr>
               <a:t>Who</a:t>
             </a:r>
@@ -13104,10 +13104,10 @@
                 <a:solidFill>
                   <a:srgbClr val="434343"/>
                 </a:solidFill>
-                <a:latin typeface="Poppins"/>
-                <a:ea typeface="Poppins"/>
-                <a:cs typeface="Poppins"/>
-                <a:sym typeface="Poppins"/>
+                <a:latin typeface="Arial"/>
+                <a:ea typeface="Arial"/>
+                <a:cs typeface="Arial"/>
+                <a:sym typeface="Arial"/>
               </a:rPr>
               <a:t>want a good place to eat without checking three apps first</a:t>
             </a:r>
@@ -13215,10 +13215,10 @@
                 <a:solidFill>
                   <a:srgbClr val="6F6B34"/>
                 </a:solidFill>
-                <a:latin typeface="Poppins"/>
-                <a:ea typeface="Poppins"/>
-                <a:cs typeface="Poppins"/>
-                <a:sym typeface="Poppins"/>
+                <a:latin typeface="Arial"/>
+                <a:ea typeface="Arial"/>
+                <a:cs typeface="Arial"/>
+                <a:sym typeface="Arial"/>
               </a:rPr>
               <a:t>Our app is</a:t>
             </a:r>
@@ -13268,10 +13268,10 @@
                 <a:solidFill>
                   <a:srgbClr val="434343"/>
                 </a:solidFill>
-                <a:latin typeface="Poppins"/>
-                <a:ea typeface="Poppins"/>
-                <a:cs typeface="Poppins"/>
-                <a:sym typeface="Poppins"/>
+                <a:latin typeface="Arial"/>
+                <a:ea typeface="Arial"/>
+                <a:cs typeface="Arial"/>
+                <a:sym typeface="Arial"/>
               </a:rPr>
               <a:t>a free restaurant guide</a:t>
             </a:r>
@@ -13379,10 +13379,10 @@
                 <a:solidFill>
                   <a:srgbClr val="6F6B34"/>
                 </a:solidFill>
-                <a:latin typeface="Poppins"/>
-                <a:ea typeface="Poppins"/>
-                <a:cs typeface="Poppins"/>
-                <a:sym typeface="Poppins"/>
+                <a:latin typeface="Arial"/>
+                <a:ea typeface="Arial"/>
+                <a:cs typeface="Arial"/>
+                <a:sym typeface="Arial"/>
               </a:rPr>
               <a:t>That</a:t>
             </a:r>
@@ -13432,10 +13432,10 @@
                 <a:solidFill>
                   <a:srgbClr val="434343"/>
                 </a:solidFill>
-                <a:latin typeface="Poppins"/>
-                <a:ea typeface="Poppins"/>
-                <a:cs typeface="Poppins"/>
-                <a:sym typeface="Poppins"/>
+                <a:latin typeface="Arial"/>
+                <a:ea typeface="Arial"/>
+                <a:cs typeface="Arial"/>
+                <a:sym typeface="Arial"/>
               </a:rPr>
               <a:t>puts reviews, posts, hours and booking for each place on one page</a:t>
             </a:r>
@@ -13543,10 +13543,10 @@
                 <a:solidFill>
                   <a:srgbClr val="6F6B34"/>
                 </a:solidFill>
-                <a:latin typeface="Poppins"/>
-                <a:ea typeface="Poppins"/>
-                <a:cs typeface="Poppins"/>
-                <a:sym typeface="Poppins"/>
+                <a:latin typeface="Arial"/>
+                <a:ea typeface="Arial"/>
+                <a:cs typeface="Arial"/>
+                <a:sym typeface="Arial"/>
               </a:rPr>
               <a:t>Unlike</a:t>
             </a:r>
@@ -13596,10 +13596,10 @@
                 <a:solidFill>
                   <a:srgbClr val="434343"/>
                 </a:solidFill>
-                <a:latin typeface="Poppins"/>
-                <a:ea typeface="Poppins"/>
-                <a:cs typeface="Poppins"/>
-                <a:sym typeface="Poppins"/>
+                <a:latin typeface="Arial"/>
+                <a:ea typeface="Arial"/>
+                <a:cs typeface="Arial"/>
+                <a:sym typeface="Arial"/>
               </a:rPr>
               <a:t>checking Google Maps, Instagram or TikTok, and a friend one by one</a:t>
             </a:r>
@@ -13707,10 +13707,10 @@
                 <a:solidFill>
                   <a:srgbClr val="6F6B34"/>
                 </a:solidFill>
-                <a:latin typeface="Poppins"/>
-                <a:ea typeface="Poppins"/>
-                <a:cs typeface="Poppins"/>
-                <a:sym typeface="Poppins"/>
+                <a:latin typeface="Arial"/>
+                <a:ea typeface="Arial"/>
+                <a:cs typeface="Arial"/>
+                <a:sym typeface="Arial"/>
               </a:rPr>
               <a:t>Ours</a:t>
             </a:r>
@@ -13760,10 +13760,10 @@
                 <a:solidFill>
                   <a:srgbClr val="000000"/>
                 </a:solidFill>
-                <a:latin typeface="Poppins"/>
-                <a:ea typeface="Poppins"/>
-                <a:cs typeface="Poppins"/>
-                <a:sym typeface="Poppins"/>
+                <a:latin typeface="Arial"/>
+                <a:ea typeface="Arial"/>
+                <a:cs typeface="Arial"/>
+                <a:sym typeface="Arial"/>
               </a:rPr>
               <a:t>only counts reviews from people who proved they ate there</a:t>
             </a:r>
@@ -13896,10 +13896,10 @@
                 <a:solidFill>
                   <a:srgbClr val="6F6B34"/>
                 </a:solidFill>
-                <a:latin typeface="Poppins"/>
-                <a:ea typeface="Poppins"/>
-                <a:cs typeface="Poppins"/>
-                <a:sym typeface="Poppins"/>
+                <a:latin typeface="Arial"/>
+                <a:ea typeface="Arial"/>
+                <a:cs typeface="Arial"/>
+                <a:sym typeface="Arial"/>
               </a:rPr>
               <a:t>How we’d fund it</a:t>
             </a:r>
@@ -13949,10 +13949,10 @@
                 <a:solidFill>
                   <a:srgbClr val="595959"/>
                 </a:solidFill>
-                <a:latin typeface="Poppins"/>
-                <a:ea typeface="Poppins"/>
-                <a:cs typeface="Poppins"/>
-                <a:sym typeface="Poppins"/>
+                <a:latin typeface="Arial"/>
+                <a:ea typeface="Arial"/>
+                <a:cs typeface="Arial"/>
+                <a:sym typeface="Arial"/>
               </a:rPr>
               <a:t>10</a:t>
             </a:r>
@@ -14002,10 +14002,10 @@
                 <a:solidFill>
                   <a:srgbClr val="000000"/>
                 </a:solidFill>
-                <a:latin typeface="Poppins"/>
-                <a:ea typeface="Poppins"/>
-                <a:cs typeface="Poppins"/>
-                <a:sym typeface="Poppins"/>
+                <a:latin typeface="Arial"/>
+                <a:ea typeface="Arial"/>
+                <a:cs typeface="Arial"/>
+                <a:sym typeface="Arial"/>
               </a:rPr>
               <a:t xml:space="preserve">We’d start on grants, as Beli did. </a:t>
             </a:r>
@@ -14014,10 +14014,10 @@
                 <a:solidFill>
                   <a:srgbClr val="595959"/>
                 </a:solidFill>
-                <a:latin typeface="Poppins"/>
-                <a:ea typeface="Poppins"/>
-                <a:cs typeface="Poppins"/>
-                <a:sym typeface="Poppins"/>
+                <a:latin typeface="Arial"/>
+                <a:ea typeface="Arial"/>
+                <a:cs typeface="Arial"/>
+                <a:sym typeface="Arial"/>
               </a:rPr>
               <a:t>One angel round of about $166K gets us to a first profitable year.</a:t>
             </a:r>
@@ -14067,10 +14067,10 @@
                 <a:solidFill>
                   <a:srgbClr val="595959"/>
                 </a:solidFill>
-                <a:latin typeface="Roboto Mono"/>
-                <a:ea typeface="Roboto Mono"/>
-                <a:cs typeface="Roboto Mono"/>
-                <a:sym typeface="Roboto Mono"/>
+                <a:latin typeface="Arial"/>
+                <a:ea typeface="Arial"/>
+                <a:cs typeface="Arial"/>
+                <a:sym typeface="Arial"/>
               </a:rPr>
               <a:t>Beli: Wikipedia (Harvard grants); CB Insights ($5.3M, Nov 2023); Boston Globe, Nov 2025 (users). IDEA Gap Fund: Northeastern Global News. Amounts are from our Gate 2 model.</a:t>
             </a:r>
@@ -14120,10 +14120,10 @@
                 <a:solidFill>
                   <a:srgbClr val="6F6B34"/>
                 </a:solidFill>
-                <a:latin typeface="Poppins"/>
-                <a:ea typeface="Poppins"/>
-                <a:cs typeface="Poppins"/>
-                <a:sym typeface="Poppins"/>
+                <a:latin typeface="Arial"/>
+                <a:ea typeface="Arial"/>
+                <a:cs typeface="Arial"/>
+                <a:sym typeface="Arial"/>
               </a:rPr>
               <a:t>When</a:t>
             </a:r>
@@ -14173,10 +14173,10 @@
                 <a:solidFill>
                   <a:srgbClr val="6F6B34"/>
                 </a:solidFill>
-                <a:latin typeface="Poppins"/>
-                <a:ea typeface="Poppins"/>
-                <a:cs typeface="Poppins"/>
-                <a:sym typeface="Poppins"/>
+                <a:latin typeface="Arial"/>
+                <a:ea typeface="Arial"/>
+                <a:cs typeface="Arial"/>
+                <a:sym typeface="Arial"/>
               </a:rPr>
               <a:t>What we'd show to get it</a:t>
             </a:r>
@@ -14284,10 +14284,10 @@
                 <a:solidFill>
                   <a:srgbClr val="000000"/>
                 </a:solidFill>
-                <a:latin typeface="Poppins"/>
-                <a:ea typeface="Poppins"/>
-                <a:cs typeface="Poppins"/>
-                <a:sym typeface="Poppins"/>
+                <a:latin typeface="Arial"/>
+                <a:ea typeface="Arial"/>
+                <a:cs typeface="Arial"/>
+                <a:sym typeface="Arial"/>
               </a:rPr>
               <a:t>Grants and competitions, about $74K</a:t>
             </a:r>
@@ -14337,10 +14337,10 @@
                 <a:solidFill>
                   <a:srgbClr val="434343"/>
                 </a:solidFill>
-                <a:latin typeface="Poppins"/>
-                <a:ea typeface="Poppins"/>
-                <a:cs typeface="Poppins"/>
-                <a:sym typeface="Poppins"/>
+                <a:latin typeface="Arial"/>
+                <a:ea typeface="Arial"/>
+                <a:cs typeface="Arial"/>
+                <a:sym typeface="Arial"/>
               </a:rPr>
               <a:t>Years 1 and 2</a:t>
             </a:r>
@@ -14390,10 +14390,10 @@
                 <a:solidFill>
                   <a:srgbClr val="434343"/>
                 </a:solidFill>
-                <a:latin typeface="Poppins"/>
-                <a:ea typeface="Poppins"/>
-                <a:cs typeface="Poppins"/>
-                <a:sym typeface="Poppins"/>
+                <a:latin typeface="Arial"/>
+                <a:ea typeface="Arial"/>
+                <a:cs typeface="Arial"/>
+                <a:sym typeface="Arial"/>
               </a:rPr>
               <a:t>IDEA Gap Fund and Boston pitch competitions. If we fall short, or the round slips, we cover the gap ourselves.</a:t>
             </a:r>
@@ -14501,10 +14501,10 @@
                 <a:solidFill>
                   <a:srgbClr val="000000"/>
                 </a:solidFill>
-                <a:latin typeface="Poppins"/>
-                <a:ea typeface="Poppins"/>
-                <a:cs typeface="Poppins"/>
-                <a:sym typeface="Poppins"/>
+                <a:latin typeface="Arial"/>
+                <a:ea typeface="Arial"/>
+                <a:cs typeface="Arial"/>
+                <a:sym typeface="Arial"/>
               </a:rPr>
               <a:t>One angel round, about $166K</a:t>
             </a:r>
@@ -14554,10 +14554,10 @@
                 <a:solidFill>
                   <a:srgbClr val="434343"/>
                 </a:solidFill>
-                <a:latin typeface="Poppins"/>
-                <a:ea typeface="Poppins"/>
-                <a:cs typeface="Poppins"/>
-                <a:sym typeface="Poppins"/>
+                <a:latin typeface="Arial"/>
+                <a:ea typeface="Arial"/>
+                <a:cs typeface="Arial"/>
+                <a:sym typeface="Arial"/>
               </a:rPr>
               <a:t>End of Year 2</a:t>
             </a:r>
@@ -14607,10 +14607,10 @@
                 <a:solidFill>
                   <a:srgbClr val="434343"/>
                 </a:solidFill>
-                <a:latin typeface="Poppins"/>
-                <a:ea typeface="Poppins"/>
-                <a:cs typeface="Poppins"/>
-                <a:sym typeface="Poppins"/>
+                <a:latin typeface="Arial"/>
+                <a:ea typeface="Arial"/>
+                <a:cs typeface="Arial"/>
+                <a:sym typeface="Arial"/>
               </a:rPr>
               <a:t>31K Boston users, restaurants paying for four quarters, and receipt-proven visits.</a:t>
             </a:r>
@@ -14718,10 +14718,10 @@
                 <a:solidFill>
                   <a:srgbClr val="434343"/>
                 </a:solidFill>
-                <a:latin typeface="Poppins"/>
-                <a:ea typeface="Poppins"/>
-                <a:cs typeface="Poppins"/>
-                <a:sym typeface="Poppins"/>
+                <a:latin typeface="Arial"/>
+                <a:ea typeface="Arial"/>
+                <a:cs typeface="Arial"/>
+                <a:sym typeface="Arial"/>
               </a:rPr>
               <a:t>$74K in grants plus $166K from angels: $240K in all. At $356K of Year 5 revenue we're too small for venture funds, so the angels' way out is a sale to a bigger platform or a card company, as Resy sold to American Express.</a:t>
             </a:r>
@@ -14796,10 +14796,10 @@
                 <a:solidFill>
                   <a:srgbClr val="6F6B34"/>
                 </a:solidFill>
-                <a:latin typeface="Poppins"/>
-                <a:ea typeface="Poppins"/>
-                <a:cs typeface="Poppins"/>
-                <a:sym typeface="Poppins"/>
+                <a:latin typeface="Arial"/>
+                <a:ea typeface="Arial"/>
+                <a:cs typeface="Arial"/>
+                <a:sym typeface="Arial"/>
               </a:rPr>
               <a:t>Appendix</a:t>
             </a:r>
@@ -14901,10 +14901,10 @@
                 <a:solidFill>
                   <a:srgbClr val="000000"/>
                 </a:solidFill>
-                <a:latin typeface="Poppins"/>
-                <a:ea typeface="Poppins"/>
-                <a:cs typeface="Poppins"/>
-                <a:sym typeface="Poppins"/>
+                <a:latin typeface="Arial"/>
+                <a:ea typeface="Arial"/>
+                <a:cs typeface="Arial"/>
+                <a:sym typeface="Arial"/>
               </a:rPr>
               <a:t>Two sides pay, and every price starts from a real company’s number. </a:t>
             </a:r>
@@ -14913,10 +14913,10 @@
                 <a:solidFill>
                   <a:srgbClr val="595959"/>
                 </a:solidFill>
-                <a:latin typeface="Poppins"/>
-                <a:ea typeface="Poppins"/>
-                <a:cs typeface="Poppins"/>
-                <a:sym typeface="Poppins"/>
+                <a:latin typeface="Arial"/>
+                <a:ea typeface="Arial"/>
+                <a:cs typeface="Arial"/>
+                <a:sym typeface="Arial"/>
               </a:rPr>
               <a:t>How many we sell is our guess.</a:t>
             </a:r>
@@ -14966,10 +14966,10 @@
                 <a:solidFill>
                   <a:srgbClr val="595959"/>
                 </a:solidFill>
-                <a:latin typeface="Roboto Mono"/>
-                <a:ea typeface="Roboto Mono"/>
-                <a:cs typeface="Roboto Mono"/>
-                <a:sym typeface="Roboto Mono"/>
+                <a:latin typeface="Arial"/>
+                <a:ea typeface="Arial"/>
+                <a:cs typeface="Arial"/>
+                <a:sym typeface="Arial"/>
               </a:rPr>
               <a:t>OpenTable pricing via Eat App, 2026. TechCrunch, Aug 2024 (Placer.ai). Kakaku.com results, Nov 2025 (Tabelog).</a:t>
             </a:r>
@@ -15019,10 +15019,10 @@
                 <a:solidFill>
                   <a:srgbClr val="6F6B34"/>
                 </a:solidFill>
-                <a:latin typeface="Poppins"/>
-                <a:ea typeface="Poppins"/>
-                <a:cs typeface="Poppins"/>
-                <a:sym typeface="Poppins"/>
+                <a:latin typeface="Arial"/>
+                <a:ea typeface="Arial"/>
+                <a:cs typeface="Arial"/>
+                <a:sym typeface="Arial"/>
               </a:rPr>
               <a:t>Stream</a:t>
             </a:r>
@@ -15072,10 +15072,10 @@
                 <a:solidFill>
                   <a:srgbClr val="6F6B34"/>
                 </a:solidFill>
-                <a:latin typeface="Poppins"/>
-                <a:ea typeface="Poppins"/>
-                <a:cs typeface="Poppins"/>
-                <a:sym typeface="Poppins"/>
+                <a:latin typeface="Arial"/>
+                <a:ea typeface="Arial"/>
+                <a:cs typeface="Arial"/>
+                <a:sym typeface="Arial"/>
               </a:rPr>
               <a:t>Year 5</a:t>
             </a:r>
@@ -15125,10 +15125,10 @@
                 <a:solidFill>
                   <a:srgbClr val="6F6B34"/>
                 </a:solidFill>
-                <a:latin typeface="Poppins"/>
-                <a:ea typeface="Poppins"/>
-                <a:cs typeface="Poppins"/>
-                <a:sym typeface="Poppins"/>
+                <a:latin typeface="Arial"/>
+                <a:ea typeface="Arial"/>
+                <a:cs typeface="Arial"/>
+                <a:sym typeface="Arial"/>
               </a:rPr>
               <a:t>What they pay for and why</a:t>
             </a:r>
@@ -15236,10 +15236,10 @@
                 <a:solidFill>
                   <a:srgbClr val="000000"/>
                 </a:solidFill>
-                <a:latin typeface="Poppins"/>
-                <a:ea typeface="Poppins"/>
-                <a:cs typeface="Poppins"/>
-                <a:sym typeface="Poppins"/>
+                <a:latin typeface="Arial"/>
+                <a:ea typeface="Arial"/>
+                <a:cs typeface="Arial"/>
+                <a:sym typeface="Arial"/>
               </a:rPr>
               <a:t>Businesses</a:t>
             </a:r>
@@ -15289,10 +15289,10 @@
                 <a:solidFill>
                   <a:srgbClr val="000000"/>
                 </a:solidFill>
-                <a:latin typeface="Poppins"/>
-                <a:ea typeface="Poppins"/>
-                <a:cs typeface="Poppins"/>
-                <a:sym typeface="Poppins"/>
+                <a:latin typeface="Arial"/>
+                <a:ea typeface="Arial"/>
+                <a:cs typeface="Arial"/>
+                <a:sym typeface="Arial"/>
               </a:rPr>
               <a:t>$288K</a:t>
             </a:r>
@@ -15342,10 +15342,10 @@
                 <a:solidFill>
                   <a:srgbClr val="434343"/>
                 </a:solidFill>
-                <a:latin typeface="Poppins"/>
-                <a:ea typeface="Poppins"/>
-                <a:cs typeface="Poppins"/>
-                <a:sym typeface="Poppins"/>
+                <a:latin typeface="Arial"/>
+                <a:ea typeface="Arial"/>
+                <a:cs typeface="Arial"/>
+                <a:sym typeface="Arial"/>
               </a:rPr>
               <a:t>Diners we send ($156K), tables booked ($54K) and area insights for chains ($78K). They pay for customers, not for ads. About $0.90 a diner sits under OpenTable’s $1.00 to $1.50, bookings are a quarter of Tabelog’s rate, and chains pay a quarter of Placer.ai’s.</a:t>
             </a:r>
@@ -15453,10 +15453,10 @@
                 <a:solidFill>
                   <a:srgbClr val="000000"/>
                 </a:solidFill>
-                <a:latin typeface="Poppins"/>
-                <a:ea typeface="Poppins"/>
-                <a:cs typeface="Poppins"/>
-                <a:sym typeface="Poppins"/>
+                <a:latin typeface="Arial"/>
+                <a:ea typeface="Arial"/>
+                <a:cs typeface="Arial"/>
+                <a:sym typeface="Arial"/>
               </a:rPr>
               <a:t>Users</a:t>
             </a:r>
@@ -15506,10 +15506,10 @@
                 <a:solidFill>
                   <a:srgbClr val="000000"/>
                 </a:solidFill>
-                <a:latin typeface="Poppins"/>
-                <a:ea typeface="Poppins"/>
-                <a:cs typeface="Poppins"/>
-                <a:sym typeface="Poppins"/>
+                <a:latin typeface="Arial"/>
+                <a:ea typeface="Arial"/>
+                <a:cs typeface="Arial"/>
+                <a:sym typeface="Arial"/>
               </a:rPr>
               <a:t>$67K</a:t>
             </a:r>
@@ -15559,10 +15559,10 @@
                 <a:solidFill>
                   <a:srgbClr val="434343"/>
                 </a:solidFill>
-                <a:latin typeface="Poppins"/>
-                <a:ea typeface="Poppins"/>
-                <a:cs typeface="Poppins"/>
-                <a:sym typeface="Poppins"/>
+                <a:latin typeface="Arial"/>
+                <a:ea typeface="Arial"/>
+                <a:cs typeface="Arial"/>
+                <a:sym typeface="Arial"/>
               </a:rPr>
               <a:t>The optional $5 a month membership: extras on top of a free app, such as taste match with friends. About 0.3% pay, the same share as Tabelog’s users.</a:t>
             </a:r>
@@ -15695,10 +15695,10 @@
                 <a:solidFill>
                   <a:srgbClr val="6F6B34"/>
                 </a:solidFill>
-                <a:latin typeface="Poppins"/>
-                <a:ea typeface="Poppins"/>
-                <a:cs typeface="Poppins"/>
-                <a:sym typeface="Poppins"/>
+                <a:latin typeface="Arial"/>
+                <a:ea typeface="Arial"/>
+                <a:cs typeface="Arial"/>
+                <a:sym typeface="Arial"/>
               </a:rPr>
               <a:t>In summary</a:t>
             </a:r>
@@ -15748,10 +15748,10 @@
                 <a:solidFill>
                   <a:srgbClr val="595959"/>
                 </a:solidFill>
-                <a:latin typeface="Poppins"/>
-                <a:ea typeface="Poppins"/>
-                <a:cs typeface="Poppins"/>
-                <a:sym typeface="Poppins"/>
+                <a:latin typeface="Arial"/>
+                <a:ea typeface="Arial"/>
+                <a:cs typeface="Arial"/>
+                <a:sym typeface="Arial"/>
               </a:rPr>
               <a:t>11</a:t>
             </a:r>
@@ -15801,10 +15801,10 @@
                 <a:solidFill>
                   <a:srgbClr val="000000"/>
                 </a:solidFill>
-                <a:latin typeface="Poppins"/>
-                <a:ea typeface="Poppins"/>
-                <a:cs typeface="Poppins"/>
-                <a:sym typeface="Poppins"/>
+                <a:latin typeface="Arial"/>
+                <a:ea typeface="Arial"/>
+                <a:cs typeface="Arial"/>
+                <a:sym typeface="Arial"/>
               </a:rPr>
               <a:t xml:space="preserve">Right now, picking a place to eat takes three apps. </a:t>
             </a:r>
@@ -15813,10 +15813,10 @@
                 <a:solidFill>
                   <a:srgbClr val="595959"/>
                 </a:solidFill>
-                <a:latin typeface="Poppins"/>
-                <a:ea typeface="Poppins"/>
-                <a:cs typeface="Poppins"/>
-                <a:sym typeface="Poppins"/>
+                <a:latin typeface="Arial"/>
+                <a:ea typeface="Arial"/>
+                <a:cs typeface="Arial"/>
+                <a:sym typeface="Arial"/>
               </a:rPr>
               <a:t>We think it could take one.</a:t>
             </a:r>
@@ -15866,10 +15866,10 @@
                 <a:solidFill>
                   <a:srgbClr val="6F6B34"/>
                 </a:solidFill>
-                <a:latin typeface="Poppins"/>
-                <a:ea typeface="Poppins"/>
-                <a:cs typeface="Poppins"/>
-                <a:sym typeface="Poppins"/>
+                <a:latin typeface="Arial"/>
+                <a:ea typeface="Arial"/>
+                <a:cs typeface="Arial"/>
+                <a:sym typeface="Arial"/>
               </a:rPr>
               <a:t>Trust</a:t>
             </a:r>
@@ -15919,10 +15919,10 @@
                 <a:solidFill>
                   <a:srgbClr val="000000"/>
                 </a:solidFill>
-                <a:latin typeface="Poppins"/>
-                <a:ea typeface="Poppins"/>
-                <a:cs typeface="Poppins"/>
-                <a:sym typeface="Poppins"/>
+                <a:latin typeface="Arial"/>
+                <a:ea typeface="Arial"/>
+                <a:cs typeface="Arial"/>
+                <a:sym typeface="Arial"/>
               </a:rPr>
               <a:t>Only diners who proved they ate there count toward our score.</a:t>
             </a:r>
@@ -15972,10 +15972,10 @@
                 <a:solidFill>
                   <a:srgbClr val="6F6B34"/>
                 </a:solidFill>
-                <a:latin typeface="Poppins"/>
-                <a:ea typeface="Poppins"/>
-                <a:cs typeface="Poppins"/>
-                <a:sym typeface="Poppins"/>
+                <a:latin typeface="Arial"/>
+                <a:ea typeface="Arial"/>
+                <a:cs typeface="Arial"/>
+                <a:sym typeface="Arial"/>
               </a:rPr>
               <a:t>Money</a:t>
             </a:r>
@@ -16025,10 +16025,10 @@
                 <a:solidFill>
                   <a:srgbClr val="000000"/>
                 </a:solidFill>
-                <a:latin typeface="Poppins"/>
-                <a:ea typeface="Poppins"/>
-                <a:cs typeface="Poppins"/>
-                <a:sym typeface="Poppins"/>
+                <a:latin typeface="Arial"/>
+                <a:ea typeface="Arial"/>
+                <a:cs typeface="Arial"/>
+                <a:sym typeface="Arial"/>
               </a:rPr>
               <a:t>Restaurants would pay for the diners we send. Users never have to pay.</a:t>
             </a:r>
@@ -16078,10 +16078,10 @@
                 <a:solidFill>
                   <a:srgbClr val="6F6B34"/>
                 </a:solidFill>
-                <a:latin typeface="Poppins"/>
-                <a:ea typeface="Poppins"/>
-                <a:cs typeface="Poppins"/>
-                <a:sym typeface="Poppins"/>
+                <a:latin typeface="Arial"/>
+                <a:ea typeface="Arial"/>
+                <a:cs typeface="Arial"/>
+                <a:sym typeface="Arial"/>
               </a:rPr>
               <a:t>Path</a:t>
             </a:r>
@@ -16131,10 +16131,10 @@
                 <a:solidFill>
                   <a:srgbClr val="000000"/>
                 </a:solidFill>
-                <a:latin typeface="Poppins"/>
-                <a:ea typeface="Poppins"/>
-                <a:cs typeface="Poppins"/>
-                <a:sym typeface="Poppins"/>
+                <a:latin typeface="Arial"/>
+                <a:ea typeface="Arial"/>
+                <a:cs typeface="Arial"/>
+                <a:sym typeface="Arial"/>
               </a:rPr>
               <a:t>Grants first, then one angel round. Our model shows profit in Year 5.</a:t>
             </a:r>
@@ -16184,10 +16184,10 @@
                 <a:solidFill>
                   <a:srgbClr val="6F6B34"/>
                 </a:solidFill>
-                <a:latin typeface="Poppins"/>
-                <a:ea typeface="Poppins"/>
-                <a:cs typeface="Poppins"/>
-                <a:sym typeface="Poppins"/>
+                <a:latin typeface="Arial"/>
+                <a:ea typeface="Arial"/>
+                <a:cs typeface="Arial"/>
+                <a:sym typeface="Arial"/>
               </a:rPr>
               <a:t>What we still need to prove</a:t>
             </a:r>
@@ -16237,10 +16237,10 @@
                 <a:solidFill>
                   <a:srgbClr val="000000"/>
                 </a:solidFill>
-                <a:latin typeface="Poppins"/>
-                <a:ea typeface="Poppins"/>
-                <a:cs typeface="Poppins"/>
-                <a:sym typeface="Poppins"/>
+                <a:latin typeface="Arial"/>
+                <a:ea typeface="Arial"/>
+                <a:cs typeface="Arial"/>
+                <a:sym typeface="Arial"/>
               </a:rPr>
               <a:t>Whether restaurants will pay, and whether people will scan receipts. Next: five owner calls with a free 30-day pilot, and a receipt-scan test with about 10 users.</a:t>
             </a:r>
@@ -16323,10 +16323,10 @@
                 <a:solidFill>
                   <a:srgbClr val="2E2D12"/>
                 </a:solidFill>
-                <a:latin typeface="Poppins"/>
-                <a:ea typeface="Poppins"/>
-                <a:cs typeface="Poppins"/>
-                <a:sym typeface="Poppins"/>
+                <a:latin typeface="Arial"/>
+                <a:ea typeface="Arial"/>
+                <a:cs typeface="Arial"/>
+                <a:sym typeface="Arial"/>
               </a:rPr>
               <a:t>The challenge</a:t>
             </a:r>
@@ -16376,10 +16376,10 @@
                 <a:solidFill>
                   <a:srgbClr val="1F1F1F"/>
                 </a:solidFill>
-                <a:latin typeface="Poppins"/>
-                <a:ea typeface="Poppins"/>
-                <a:cs typeface="Poppins"/>
-                <a:sym typeface="Poppins"/>
+                <a:latin typeface="Arial"/>
+                <a:ea typeface="Arial"/>
+                <a:cs typeface="Arial"/>
+                <a:sym typeface="Arial"/>
               </a:rPr>
               <a:t>2</a:t>
             </a:r>
@@ -16429,10 +16429,10 @@
                 <a:solidFill>
                   <a:srgbClr val="000000"/>
                 </a:solidFill>
-                <a:latin typeface="Poppins"/>
-                <a:ea typeface="Poppins"/>
-                <a:cs typeface="Poppins"/>
-                <a:sym typeface="Poppins"/>
+                <a:latin typeface="Arial"/>
+                <a:ea typeface="Arial"/>
+                <a:cs typeface="Arial"/>
+                <a:sym typeface="Arial"/>
               </a:rPr>
               <a:t xml:space="preserve">Most people we talked to check three apps to pick one place to eat, </a:t>
             </a:r>
@@ -16441,10 +16441,10 @@
                 <a:solidFill>
                   <a:srgbClr val="2E2D12"/>
                 </a:solidFill>
-                <a:latin typeface="Poppins"/>
-                <a:ea typeface="Poppins"/>
-                <a:cs typeface="Poppins"/>
-                <a:sym typeface="Poppins"/>
+                <a:latin typeface="Arial"/>
+                <a:ea typeface="Arial"/>
+                <a:cs typeface="Arial"/>
+                <a:sym typeface="Arial"/>
               </a:rPr>
               <a:t>and for many, it still misses.</a:t>
             </a:r>
@@ -16494,10 +16494,10 @@
                 <a:solidFill>
                   <a:srgbClr val="2E2D12"/>
                 </a:solidFill>
-                <a:latin typeface="Roboto Mono"/>
-                <a:ea typeface="Roboto Mono"/>
-                <a:cs typeface="Roboto Mono"/>
-                <a:sym typeface="Roboto Mono"/>
+                <a:latin typeface="Arial"/>
+                <a:ea typeface="Arial"/>
+                <a:cs typeface="Arial"/>
+                <a:sym typeface="Arial"/>
               </a:rPr>
               <a:t>From 35 interviews with students and young professionals, Sep to Oct 2026.</a:t>
             </a:r>
@@ -16605,10 +16605,10 @@
                 <a:solidFill>
                   <a:srgbClr val="2E2D12"/>
                 </a:solidFill>
-                <a:latin typeface="Poppins"/>
-                <a:ea typeface="Poppins"/>
-                <a:cs typeface="Poppins"/>
-                <a:sym typeface="Poppins"/>
+                <a:latin typeface="Arial"/>
+                <a:ea typeface="Arial"/>
+                <a:cs typeface="Arial"/>
+                <a:sym typeface="Arial"/>
               </a:rPr>
               <a:t>1</a:t>
             </a:r>
@@ -16658,10 +16658,10 @@
                 <a:solidFill>
                   <a:srgbClr val="000000"/>
                 </a:solidFill>
-                <a:latin typeface="Poppins"/>
-                <a:ea typeface="Poppins"/>
-                <a:cs typeface="Poppins"/>
-                <a:sym typeface="Poppins"/>
+                <a:latin typeface="Arial"/>
+                <a:ea typeface="Arial"/>
+                <a:cs typeface="Arial"/>
+                <a:sym typeface="Arial"/>
               </a:rPr>
               <a:t>Google Maps</a:t>
             </a:r>
@@ -16711,10 +16711,10 @@
                 <a:solidFill>
                   <a:srgbClr val="1F1F1F"/>
                 </a:solidFill>
-                <a:latin typeface="Poppins"/>
-                <a:ea typeface="Poppins"/>
-                <a:cs typeface="Poppins"/>
-                <a:sym typeface="Poppins"/>
+                <a:latin typeface="Arial"/>
+                <a:ea typeface="Arial"/>
+                <a:cs typeface="Arial"/>
+                <a:sym typeface="Arial"/>
               </a:rPr>
               <a:t>to see what's nearby</a:t>
             </a:r>
@@ -16764,10 +16764,10 @@
                 <a:solidFill>
                   <a:srgbClr val="2E2D12"/>
                 </a:solidFill>
-                <a:latin typeface="Poppins"/>
-                <a:ea typeface="Poppins"/>
-                <a:cs typeface="Poppins"/>
-                <a:sym typeface="Poppins"/>
+                <a:latin typeface="Arial"/>
+                <a:ea typeface="Arial"/>
+                <a:cs typeface="Arial"/>
+                <a:sym typeface="Arial"/>
               </a:rPr>
               <a:t>2</a:t>
             </a:r>
@@ -16817,10 +16817,10 @@
                 <a:solidFill>
                   <a:srgbClr val="000000"/>
                 </a:solidFill>
-                <a:latin typeface="Poppins"/>
-                <a:ea typeface="Poppins"/>
-                <a:cs typeface="Poppins"/>
-                <a:sym typeface="Poppins"/>
+                <a:latin typeface="Arial"/>
+                <a:ea typeface="Arial"/>
+                <a:cs typeface="Arial"/>
+                <a:sym typeface="Arial"/>
               </a:rPr>
               <a:t>Instagram or TikTok</a:t>
             </a:r>
@@ -16870,10 +16870,10 @@
                 <a:solidFill>
                   <a:srgbClr val="1F1F1F"/>
                 </a:solidFill>
-                <a:latin typeface="Poppins"/>
-                <a:ea typeface="Poppins"/>
-                <a:cs typeface="Poppins"/>
-                <a:sym typeface="Poppins"/>
+                <a:latin typeface="Arial"/>
+                <a:ea typeface="Arial"/>
+                <a:cs typeface="Arial"/>
+                <a:sym typeface="Arial"/>
               </a:rPr>
               <a:t>to see the food</a:t>
             </a:r>
@@ -16923,10 +16923,10 @@
                 <a:solidFill>
                   <a:srgbClr val="2E2D12"/>
                 </a:solidFill>
-                <a:latin typeface="Poppins"/>
-                <a:ea typeface="Poppins"/>
-                <a:cs typeface="Poppins"/>
-                <a:sym typeface="Poppins"/>
+                <a:latin typeface="Arial"/>
+                <a:ea typeface="Arial"/>
+                <a:cs typeface="Arial"/>
+                <a:sym typeface="Arial"/>
               </a:rPr>
               <a:t>3</a:t>
             </a:r>
@@ -16976,10 +16976,10 @@
                 <a:solidFill>
                   <a:srgbClr val="000000"/>
                 </a:solidFill>
-                <a:latin typeface="Poppins"/>
-                <a:ea typeface="Poppins"/>
-                <a:cs typeface="Poppins"/>
-                <a:sym typeface="Poppins"/>
+                <a:latin typeface="Arial"/>
+                <a:ea typeface="Arial"/>
+                <a:cs typeface="Arial"/>
+                <a:sym typeface="Arial"/>
               </a:rPr>
               <a:t>A friend</a:t>
             </a:r>
@@ -17029,10 +17029,10 @@
                 <a:solidFill>
                   <a:srgbClr val="1F1F1F"/>
                 </a:solidFill>
-                <a:latin typeface="Poppins"/>
-                <a:ea typeface="Poppins"/>
-                <a:cs typeface="Poppins"/>
-                <a:sym typeface="Poppins"/>
+                <a:latin typeface="Arial"/>
+                <a:ea typeface="Arial"/>
+                <a:cs typeface="Arial"/>
+                <a:sym typeface="Arial"/>
               </a:rPr>
               <a:t>to check it's good</a:t>
             </a:r>
@@ -17082,10 +17082,10 @@
                 <a:solidFill>
                   <a:srgbClr val="1F1F1F"/>
                 </a:solidFill>
-                <a:latin typeface="Poppins"/>
-                <a:ea typeface="Poppins"/>
-                <a:cs typeface="Poppins"/>
-                <a:sym typeface="Poppins"/>
+                <a:latin typeface="Arial"/>
+                <a:ea typeface="Arial"/>
+                <a:cs typeface="Arial"/>
+                <a:sym typeface="Arial"/>
               </a:rPr>
               <a:t>Most are okay with what they use now, but would try something better.</a:t>
             </a:r>
@@ -17160,10 +17160,10 @@
                 <a:solidFill>
                   <a:srgbClr val="6F6B34"/>
                 </a:solidFill>
-                <a:latin typeface="Poppins"/>
-                <a:ea typeface="Poppins"/>
-                <a:cs typeface="Poppins"/>
-                <a:sym typeface="Poppins"/>
+                <a:latin typeface="Arial"/>
+                <a:ea typeface="Arial"/>
+                <a:cs typeface="Arial"/>
+                <a:sym typeface="Arial"/>
               </a:rPr>
               <a:t>The opportunity</a:t>
             </a:r>
@@ -17213,10 +17213,10 @@
                 <a:solidFill>
                   <a:srgbClr val="595959"/>
                 </a:solidFill>
-                <a:latin typeface="Poppins"/>
-                <a:ea typeface="Poppins"/>
-                <a:cs typeface="Poppins"/>
-                <a:sym typeface="Poppins"/>
+                <a:latin typeface="Arial"/>
+                <a:ea typeface="Arial"/>
+                <a:cs typeface="Arial"/>
+                <a:sym typeface="Arial"/>
               </a:rPr>
               <a:t>3</a:t>
             </a:r>
@@ -17266,10 +17266,10 @@
                 <a:solidFill>
                   <a:srgbClr val="000000"/>
                 </a:solidFill>
-                <a:latin typeface="Poppins"/>
-                <a:ea typeface="Poppins"/>
-                <a:cs typeface="Poppins"/>
-                <a:sym typeface="Poppins"/>
+                <a:latin typeface="Arial"/>
+                <a:ea typeface="Arial"/>
+                <a:cs typeface="Arial"/>
+                <a:sym typeface="Arial"/>
               </a:rPr>
               <a:t xml:space="preserve">One page per restaurant, </a:t>
             </a:r>
@@ -17278,10 +17278,10 @@
                 <a:solidFill>
                   <a:srgbClr val="595959"/>
                 </a:solidFill>
-                <a:latin typeface="Poppins"/>
-                <a:ea typeface="Poppins"/>
-                <a:cs typeface="Poppins"/>
-                <a:sym typeface="Poppins"/>
+                <a:latin typeface="Arial"/>
+                <a:ea typeface="Arial"/>
+                <a:cs typeface="Arial"/>
+                <a:sym typeface="Arial"/>
               </a:rPr>
               <a:t>and a score that only counts diners with a receipt.</a:t>
             </a:r>
@@ -17331,10 +17331,10 @@
                 <a:solidFill>
                   <a:srgbClr val="595959"/>
                 </a:solidFill>
-                <a:latin typeface="Roboto Mono"/>
-                <a:ea typeface="Roboto Mono"/>
-                <a:cs typeface="Roboto Mono"/>
-                <a:sym typeface="Roboto Mono"/>
+                <a:latin typeface="Arial"/>
+                <a:ea typeface="Arial"/>
+                <a:cs typeface="Arial"/>
+                <a:sym typeface="Arial"/>
               </a:rPr>
               <a:t>The core app is free. If another app won't share its ratings, we link out to it.</a:t>
             </a:r>
@@ -17384,10 +17384,10 @@
                 <a:solidFill>
                   <a:srgbClr val="6F6B34"/>
                 </a:solidFill>
-                <a:latin typeface="Poppins"/>
-                <a:ea typeface="Poppins"/>
-                <a:cs typeface="Poppins"/>
-                <a:sym typeface="Poppins"/>
+                <a:latin typeface="Arial"/>
+                <a:ea typeface="Arial"/>
+                <a:cs typeface="Arial"/>
+                <a:sym typeface="Arial"/>
               </a:rPr>
               <a:t>Find</a:t>
             </a:r>
@@ -17495,10 +17495,10 @@
                 <a:solidFill>
                   <a:srgbClr val="434343"/>
                 </a:solidFill>
-                <a:latin typeface="Poppins"/>
-                <a:ea typeface="Poppins"/>
-                <a:cs typeface="Poppins"/>
-                <a:sym typeface="Poppins"/>
+                <a:latin typeface="Arial"/>
+                <a:ea typeface="Arial"/>
+                <a:cs typeface="Arial"/>
+                <a:sym typeface="Arial"/>
               </a:rPr>
               <a:t>What's open near you</a:t>
             </a:r>
@@ -17522,10 +17522,10 @@
                 <a:solidFill>
                   <a:srgbClr val="434343"/>
                 </a:solidFill>
-                <a:latin typeface="Poppins"/>
-                <a:ea typeface="Poppins"/>
-                <a:cs typeface="Poppins"/>
-                <a:sym typeface="Poppins"/>
+                <a:latin typeface="Arial"/>
+                <a:ea typeface="Arial"/>
+                <a:cs typeface="Arial"/>
+                <a:sym typeface="Arial"/>
               </a:rPr>
               <a:t>Filter by diet, price and distance</a:t>
             </a:r>
@@ -17549,10 +17549,10 @@
                 <a:solidFill>
                   <a:srgbClr val="434343"/>
                 </a:solidFill>
-                <a:latin typeface="Poppins"/>
-                <a:ea typeface="Poppins"/>
-                <a:cs typeface="Poppins"/>
-                <a:sym typeface="Poppins"/>
+                <a:latin typeface="Arial"/>
+                <a:ea typeface="Arial"/>
+                <a:cs typeface="Arial"/>
+                <a:sym typeface="Arial"/>
               </a:rPr>
               <a:t>New places people are talking about</a:t>
             </a:r>
@@ -17602,10 +17602,10 @@
                 <a:solidFill>
                   <a:srgbClr val="6F6B34"/>
                 </a:solidFill>
-                <a:latin typeface="Poppins"/>
-                <a:ea typeface="Poppins"/>
-                <a:cs typeface="Poppins"/>
-                <a:sym typeface="Poppins"/>
+                <a:latin typeface="Arial"/>
+                <a:ea typeface="Arial"/>
+                <a:cs typeface="Arial"/>
+                <a:sym typeface="Arial"/>
               </a:rPr>
               <a:t>Compare</a:t>
             </a:r>
@@ -17713,10 +17713,10 @@
                 <a:solidFill>
                   <a:srgbClr val="434343"/>
                 </a:solidFill>
-                <a:latin typeface="Poppins"/>
-                <a:ea typeface="Poppins"/>
-                <a:cs typeface="Poppins"/>
-                <a:sym typeface="Poppins"/>
+                <a:latin typeface="Arial"/>
+                <a:ea typeface="Arial"/>
+                <a:cs typeface="Arial"/>
+                <a:sym typeface="Arial"/>
               </a:rPr>
               <a:t>Other apps’ ratings, where allowed</a:t>
             </a:r>
@@ -17740,10 +17740,10 @@
                 <a:solidFill>
                   <a:srgbClr val="434343"/>
                 </a:solidFill>
-                <a:latin typeface="Poppins"/>
-                <a:ea typeface="Poppins"/>
-                <a:cs typeface="Poppins"/>
-                <a:sym typeface="Poppins"/>
+                <a:latin typeface="Arial"/>
+                <a:ea typeface="Arial"/>
+                <a:cs typeface="Arial"/>
+                <a:sym typeface="Arial"/>
               </a:rPr>
               <a:t>Our score only counts diners who scanned a receipt</a:t>
             </a:r>
@@ -17767,10 +17767,10 @@
                 <a:solidFill>
                   <a:srgbClr val="434343"/>
                 </a:solidFill>
-                <a:latin typeface="Poppins"/>
-                <a:ea typeface="Poppins"/>
-                <a:cs typeface="Poppins"/>
-                <a:sym typeface="Poppins"/>
+                <a:latin typeface="Arial"/>
+                <a:ea typeface="Arial"/>
+                <a:cs typeface="Arial"/>
+                <a:sym typeface="Arial"/>
               </a:rPr>
               <a:t>Nobody pays to rank higher</a:t>
             </a:r>
@@ -17820,10 +17820,10 @@
                 <a:solidFill>
                   <a:srgbClr val="6F6B34"/>
                 </a:solidFill>
-                <a:latin typeface="Poppins"/>
-                <a:ea typeface="Poppins"/>
-                <a:cs typeface="Poppins"/>
-                <a:sym typeface="Poppins"/>
+                <a:latin typeface="Arial"/>
+                <a:ea typeface="Arial"/>
+                <a:cs typeface="Arial"/>
+                <a:sym typeface="Arial"/>
               </a:rPr>
               <a:t>Keep</a:t>
             </a:r>
@@ -17931,10 +17931,10 @@
                 <a:solidFill>
                   <a:srgbClr val="434343"/>
                 </a:solidFill>
-                <a:latin typeface="Poppins"/>
-                <a:ea typeface="Poppins"/>
-                <a:cs typeface="Poppins"/>
-                <a:sym typeface="Poppins"/>
+                <a:latin typeface="Arial"/>
+                <a:ea typeface="Arial"/>
+                <a:cs typeface="Arial"/>
+                <a:sym typeface="Arial"/>
               </a:rPr>
               <a:t>Your history and lists</a:t>
             </a:r>
@@ -17958,10 +17958,10 @@
                 <a:solidFill>
                   <a:srgbClr val="434343"/>
                 </a:solidFill>
-                <a:latin typeface="Poppins"/>
-                <a:ea typeface="Poppins"/>
-                <a:cs typeface="Poppins"/>
-                <a:sym typeface="Poppins"/>
+                <a:latin typeface="Arial"/>
+                <a:ea typeface="Arial"/>
+                <a:cs typeface="Arial"/>
+                <a:sym typeface="Arial"/>
               </a:rPr>
               <a:t>Scan a receipt, get a verified badge</a:t>
             </a:r>
@@ -17985,10 +17985,10 @@
                 <a:solidFill>
                   <a:srgbClr val="434343"/>
                 </a:solidFill>
-                <a:latin typeface="Poppins"/>
-                <a:ea typeface="Poppins"/>
-                <a:cs typeface="Poppins"/>
-                <a:sym typeface="Poppins"/>
+                <a:latin typeface="Arial"/>
+                <a:ea typeface="Arial"/>
+                <a:cs typeface="Arial"/>
+                <a:sym typeface="Arial"/>
               </a:rPr>
               <a:t>Book a table</a:t>
             </a:r>
@@ -18038,10 +18038,10 @@
                 <a:solidFill>
                   <a:srgbClr val="6F6B34"/>
                 </a:solidFill>
-                <a:latin typeface="Poppins"/>
-                <a:ea typeface="Poppins"/>
-                <a:cs typeface="Poppins"/>
-                <a:sym typeface="Poppins"/>
+                <a:latin typeface="Arial"/>
+                <a:ea typeface="Arial"/>
+                <a:cs typeface="Arial"/>
+                <a:sym typeface="Arial"/>
               </a:rPr>
               <a:t xml:space="preserve">Why not Beli? </a:t>
             </a:r>
@@ -18050,10 +18050,10 @@
                 <a:solidFill>
                   <a:srgbClr val="434343"/>
                 </a:solidFill>
-                <a:latin typeface="Poppins"/>
-                <a:ea typeface="Poppins"/>
-                <a:cs typeface="Poppins"/>
-                <a:sym typeface="Poppins"/>
+                <a:latin typeface="Arial"/>
+                <a:ea typeface="Arial"/>
+                <a:cs typeface="Arial"/>
+                <a:sym typeface="Arial"/>
               </a:rPr>
               <a:t>Beli is for ranking places you’ve been. We help you decide where to go next, with a score based on receipts.</a:t>
             </a:r>
@@ -18128,10 +18128,10 @@
                 <a:solidFill>
                   <a:srgbClr val="6F6B34"/>
                 </a:solidFill>
-                <a:latin typeface="Poppins"/>
-                <a:ea typeface="Poppins"/>
-                <a:cs typeface="Poppins"/>
-                <a:sym typeface="Poppins"/>
+                <a:latin typeface="Arial"/>
+                <a:ea typeface="Arial"/>
+                <a:cs typeface="Arial"/>
+                <a:sym typeface="Arial"/>
               </a:rPr>
               <a:t>A first look</a:t>
             </a:r>
@@ -18181,10 +18181,10 @@
                 <a:solidFill>
                   <a:srgbClr val="000000"/>
                 </a:solidFill>
-                <a:latin typeface="Poppins"/>
-                <a:ea typeface="Poppins"/>
-                <a:cs typeface="Poppins"/>
-                <a:sym typeface="Poppins"/>
+                <a:latin typeface="Arial"/>
+                <a:ea typeface="Arial"/>
+                <a:cs typeface="Arial"/>
+                <a:sym typeface="Arial"/>
               </a:rPr>
               <a:t xml:space="preserve">In our concept, it picks one place </a:t>
             </a:r>
@@ -18193,10 +18193,10 @@
                 <a:solidFill>
                   <a:srgbClr val="595959"/>
                 </a:solidFill>
-                <a:latin typeface="Poppins"/>
-                <a:ea typeface="Poppins"/>
-                <a:cs typeface="Poppins"/>
-                <a:sym typeface="Poppins"/>
+                <a:latin typeface="Arial"/>
+                <a:ea typeface="Arial"/>
+                <a:cs typeface="Arial"/>
+                <a:sym typeface="Arial"/>
               </a:rPr>
               <a:t>and shows you why.</a:t>
             </a:r>
@@ -18246,10 +18246,10 @@
                 <a:solidFill>
                   <a:srgbClr val="595959"/>
                 </a:solidFill>
-                <a:latin typeface="Poppins"/>
-                <a:ea typeface="Poppins"/>
-                <a:cs typeface="Poppins"/>
-                <a:sym typeface="Poppins"/>
+                <a:latin typeface="Arial"/>
+                <a:ea typeface="Arial"/>
+                <a:cs typeface="Arial"/>
+                <a:sym typeface="Arial"/>
               </a:rPr>
               <a:t>4</a:t>
             </a:r>
@@ -18299,10 +18299,10 @@
                 <a:solidFill>
                   <a:srgbClr val="595959"/>
                 </a:solidFill>
-                <a:latin typeface="Roboto Mono"/>
-                <a:ea typeface="Roboto Mono"/>
-                <a:cs typeface="Roboto Mono"/>
-                <a:sym typeface="Roboto Mono"/>
+                <a:latin typeface="Arial"/>
+                <a:ea typeface="Arial"/>
+                <a:cs typeface="Arial"/>
+                <a:sym typeface="Arial"/>
               </a:rPr>
               <a:t>Concept screens. Every score and person is made up. Other apps’ ratings shown only where we’re allowed. Photos: Unsplash; Daderot, Wikimedia Commons (CC0).</a:t>
             </a:r>
@@ -18379,10 +18379,10 @@
                 <a:solidFill>
                   <a:srgbClr val="6F6B34"/>
                 </a:solidFill>
-                <a:latin typeface="Poppins"/>
-                <a:ea typeface="Poppins"/>
-                <a:cs typeface="Poppins"/>
-                <a:sym typeface="Poppins"/>
+                <a:latin typeface="Arial"/>
+                <a:ea typeface="Arial"/>
+                <a:cs typeface="Arial"/>
+                <a:sym typeface="Arial"/>
               </a:rPr>
               <a:t>1  Start nearby</a:t>
             </a:r>
@@ -18432,10 +18432,10 @@
                 <a:solidFill>
                   <a:srgbClr val="434343"/>
                 </a:solidFill>
-                <a:latin typeface="Poppins"/>
-                <a:ea typeface="Poppins"/>
-                <a:cs typeface="Poppins"/>
-                <a:sym typeface="Poppins"/>
+                <a:latin typeface="Arial"/>
+                <a:ea typeface="Arial"/>
+                <a:cs typeface="Arial"/>
+                <a:sym typeface="Arial"/>
               </a:rPr>
               <a:t>What's open around you.</a:t>
             </a:r>
@@ -18512,10 +18512,10 @@
                 <a:solidFill>
                   <a:srgbClr val="6F6B34"/>
                 </a:solidFill>
-                <a:latin typeface="Poppins"/>
-                <a:ea typeface="Poppins"/>
-                <a:cs typeface="Poppins"/>
-                <a:sym typeface="Poppins"/>
+                <a:latin typeface="Arial"/>
+                <a:ea typeface="Arial"/>
+                <a:cs typeface="Arial"/>
+                <a:sym typeface="Arial"/>
               </a:rPr>
               <a:t>2  Let it pick</a:t>
             </a:r>
@@ -18565,10 +18565,10 @@
                 <a:solidFill>
                   <a:srgbClr val="434343"/>
                 </a:solidFill>
-                <a:latin typeface="Poppins"/>
-                <a:ea typeface="Poppins"/>
-                <a:cs typeface="Poppins"/>
-                <a:sym typeface="Poppins"/>
+                <a:latin typeface="Arial"/>
+                <a:ea typeface="Arial"/>
+                <a:cs typeface="Arial"/>
+                <a:sym typeface="Arial"/>
               </a:rPr>
               <a:t>One best bet for your budget and diet.</a:t>
             </a:r>
@@ -18645,10 +18645,10 @@
                 <a:solidFill>
                   <a:srgbClr val="6F6B34"/>
                 </a:solidFill>
-                <a:latin typeface="Poppins"/>
-                <a:ea typeface="Poppins"/>
-                <a:cs typeface="Poppins"/>
-                <a:sym typeface="Poppins"/>
+                <a:latin typeface="Arial"/>
+                <a:ea typeface="Arial"/>
+                <a:cs typeface="Arial"/>
+                <a:sym typeface="Arial"/>
               </a:rPr>
               <a:t>3  See why</a:t>
             </a:r>
@@ -18698,10 +18698,10 @@
                 <a:solidFill>
                   <a:srgbClr val="434343"/>
                 </a:solidFill>
-                <a:latin typeface="Poppins"/>
-                <a:ea typeface="Poppins"/>
-                <a:cs typeface="Poppins"/>
-                <a:sym typeface="Poppins"/>
+                <a:latin typeface="Arial"/>
+                <a:ea typeface="Arial"/>
+                <a:cs typeface="Arial"/>
+                <a:sym typeface="Arial"/>
               </a:rPr>
               <a:t>Three picks, each with a reason.</a:t>
             </a:r>
@@ -18778,10 +18778,10 @@
                 <a:solidFill>
                   <a:srgbClr val="6F6B34"/>
                 </a:solidFill>
-                <a:latin typeface="Poppins"/>
-                <a:ea typeface="Poppins"/>
-                <a:cs typeface="Poppins"/>
-                <a:sym typeface="Poppins"/>
+                <a:latin typeface="Arial"/>
+                <a:ea typeface="Arial"/>
+                <a:cs typeface="Arial"/>
+                <a:sym typeface="Arial"/>
               </a:rPr>
               <a:t>4  Check every rating</a:t>
             </a:r>
@@ -18831,10 +18831,10 @@
                 <a:solidFill>
                   <a:srgbClr val="434343"/>
                 </a:solidFill>
-                <a:latin typeface="Poppins"/>
-                <a:ea typeface="Poppins"/>
-                <a:cs typeface="Poppins"/>
-                <a:sym typeface="Poppins"/>
+                <a:latin typeface="Arial"/>
+                <a:ea typeface="Arial"/>
+                <a:cs typeface="Arial"/>
+                <a:sym typeface="Arial"/>
               </a:rPr>
               <a:t>Our verified score next to everyone else's, with creators' paid posts flagged.</a:t>
             </a:r>
@@ -18909,10 +18909,10 @@
                 <a:solidFill>
                   <a:srgbClr val="6F6B34"/>
                 </a:solidFill>
-                <a:latin typeface="Poppins"/>
-                <a:ea typeface="Poppins"/>
-                <a:cs typeface="Poppins"/>
-                <a:sym typeface="Poppins"/>
+                <a:latin typeface="Arial"/>
+                <a:ea typeface="Arial"/>
+                <a:cs typeface="Arial"/>
+                <a:sym typeface="Arial"/>
               </a:rPr>
               <a:t>How big it is</a:t>
             </a:r>
@@ -18962,10 +18962,10 @@
                 <a:solidFill>
                   <a:srgbClr val="595959"/>
                 </a:solidFill>
-                <a:latin typeface="Poppins"/>
-                <a:ea typeface="Poppins"/>
-                <a:cs typeface="Poppins"/>
-                <a:sym typeface="Poppins"/>
+                <a:latin typeface="Arial"/>
+                <a:ea typeface="Arial"/>
+                <a:cs typeface="Arial"/>
+                <a:sym typeface="Arial"/>
               </a:rPr>
               <a:t>5</a:t>
             </a:r>
@@ -19015,10 +19015,10 @@
                 <a:solidFill>
                   <a:srgbClr val="000000"/>
                 </a:solidFill>
-                <a:latin typeface="Poppins"/>
-                <a:ea typeface="Poppins"/>
-                <a:cs typeface="Poppins"/>
-                <a:sym typeface="Poppins"/>
+                <a:latin typeface="Arial"/>
+                <a:ea typeface="Arial"/>
+                <a:cs typeface="Arial"/>
+                <a:sym typeface="Arial"/>
               </a:rPr>
               <a:t xml:space="preserve">We start with Boston’s 162,000 students </a:t>
             </a:r>
@@ -19027,10 +19027,10 @@
                 <a:solidFill>
                   <a:srgbClr val="595959"/>
                 </a:solidFill>
-                <a:latin typeface="Poppins"/>
-                <a:ea typeface="Poppins"/>
-                <a:cs typeface="Poppins"/>
-                <a:sym typeface="Poppins"/>
+                <a:latin typeface="Arial"/>
+                <a:ea typeface="Arial"/>
+                <a:cs typeface="Arial"/>
+                <a:sym typeface="Arial"/>
               </a:rPr>
               <a:t>and aim for 540,000 US users by Year 5.</a:t>
             </a:r>
@@ -19080,10 +19080,10 @@
                 <a:solidFill>
                   <a:srgbClr val="595959"/>
                 </a:solidFill>
-                <a:latin typeface="Roboto Mono"/>
-                <a:ea typeface="Roboto Mono"/>
-                <a:cs typeface="Roboto Mono"/>
-                <a:sym typeface="Roboto Mono"/>
+                <a:latin typeface="Arial"/>
+                <a:ea typeface="Arial"/>
+                <a:cs typeface="Arial"/>
+                <a:sym typeface="Arial"/>
               </a:rPr>
               <a:t>US Census Bureau, 2024 estimates. NCES Digest of Education Statistics 2024, fall 2023 enrollment. City of Boston Student Housing Report 2025 and license data, Oct 2026.</a:t>
             </a:r>
@@ -19133,10 +19133,10 @@
                 <a:solidFill>
                   <a:srgbClr val="6F6B34"/>
                 </a:solidFill>
-                <a:latin typeface="Poppins"/>
-                <a:ea typeface="Poppins"/>
-                <a:cs typeface="Poppins"/>
-                <a:sym typeface="Poppins"/>
+                <a:latin typeface="Arial"/>
+                <a:ea typeface="Arial"/>
+                <a:cs typeface="Arial"/>
+                <a:sym typeface="Arial"/>
               </a:rPr>
               <a:t>Where we start</a:t>
             </a:r>
@@ -19186,10 +19186,10 @@
                 <a:solidFill>
                   <a:srgbClr val="000000"/>
                 </a:solidFill>
-                <a:latin typeface="Poppins"/>
-                <a:ea typeface="Poppins"/>
-                <a:cs typeface="Poppins"/>
-                <a:sym typeface="Poppins"/>
+                <a:latin typeface="Arial"/>
+                <a:ea typeface="Arial"/>
+                <a:cs typeface="Arial"/>
+                <a:sym typeface="Arial"/>
               </a:rPr>
               <a:t>162K</a:t>
             </a:r>
@@ -19239,10 +19239,10 @@
                 <a:solidFill>
                   <a:srgbClr val="434343"/>
                 </a:solidFill>
-                <a:latin typeface="Poppins"/>
-                <a:ea typeface="Poppins"/>
-                <a:cs typeface="Poppins"/>
-                <a:sym typeface="Poppins"/>
+                <a:latin typeface="Arial"/>
+                <a:ea typeface="Arial"/>
+                <a:cs typeface="Arial"/>
+                <a:sym typeface="Arial"/>
               </a:rPr>
               <a:t>Boston college students. Year 1 is 12K of them.</a:t>
             </a:r>
@@ -19292,10 +19292,10 @@
                 <a:solidFill>
                   <a:srgbClr val="6F6B34"/>
                 </a:solidFill>
-                <a:latin typeface="Poppins"/>
-                <a:ea typeface="Poppins"/>
-                <a:cs typeface="Poppins"/>
-                <a:sym typeface="Poppins"/>
+                <a:latin typeface="Arial"/>
+                <a:ea typeface="Arial"/>
+                <a:cs typeface="Arial"/>
+                <a:sym typeface="Arial"/>
               </a:rPr>
               <a:t>Our users by Year 5</a:t>
             </a:r>
@@ -19345,10 +19345,10 @@
                 <a:solidFill>
                   <a:srgbClr val="000000"/>
                 </a:solidFill>
-                <a:latin typeface="Poppins"/>
-                <a:ea typeface="Poppins"/>
-                <a:cs typeface="Poppins"/>
-                <a:sym typeface="Poppins"/>
+                <a:latin typeface="Arial"/>
+                <a:ea typeface="Arial"/>
+                <a:cs typeface="Arial"/>
+                <a:sym typeface="Arial"/>
               </a:rPr>
               <a:t>540K</a:t>
             </a:r>
@@ -19398,10 +19398,10 @@
                 <a:solidFill>
                   <a:srgbClr val="434343"/>
                 </a:solidFill>
-                <a:latin typeface="Poppins"/>
-                <a:ea typeface="Poppins"/>
-                <a:cs typeface="Poppins"/>
-                <a:sym typeface="Poppins"/>
+                <a:latin typeface="Arial"/>
+                <a:ea typeface="Arial"/>
+                <a:cs typeface="Arial"/>
+                <a:sym typeface="Arial"/>
               </a:rPr>
               <a:t>2.8% of US college students</a:t>
             </a:r>
@@ -19451,10 +19451,10 @@
                 <a:solidFill>
                   <a:srgbClr val="6F6B34"/>
                 </a:solidFill>
-                <a:latin typeface="Poppins"/>
-                <a:ea typeface="Poppins"/>
-                <a:cs typeface="Poppins"/>
-                <a:sym typeface="Poppins"/>
+                <a:latin typeface="Arial"/>
+                <a:ea typeface="Arial"/>
+                <a:cs typeface="Arial"/>
+                <a:sym typeface="Arial"/>
               </a:rPr>
               <a:t>Restaurants in Boston</a:t>
             </a:r>
@@ -19504,10 +19504,10 @@
                 <a:solidFill>
                   <a:srgbClr val="000000"/>
                 </a:solidFill>
-                <a:latin typeface="Poppins"/>
-                <a:ea typeface="Poppins"/>
-                <a:cs typeface="Poppins"/>
-                <a:sym typeface="Poppins"/>
+                <a:latin typeface="Arial"/>
+                <a:ea typeface="Arial"/>
+                <a:cs typeface="Arial"/>
+                <a:sym typeface="Arial"/>
               </a:rPr>
               <a:t>3,350</a:t>
             </a:r>
@@ -19557,10 +19557,10 @@
                 <a:solidFill>
                   <a:srgbClr val="434343"/>
                 </a:solidFill>
-                <a:latin typeface="Poppins"/>
-                <a:ea typeface="Poppins"/>
-                <a:cs typeface="Poppins"/>
-                <a:sym typeface="Poppins"/>
+                <a:latin typeface="Arial"/>
+                <a:ea typeface="Arial"/>
+                <a:cs typeface="Arial"/>
+                <a:sym typeface="Arial"/>
               </a:rPr>
               <a:t>Licensed places to eat in Boston</a:t>
             </a:r>
@@ -19668,10 +19668,10 @@
                 <a:solidFill>
                   <a:srgbClr val="6F6B34"/>
                 </a:solidFill>
-                <a:latin typeface="Poppins"/>
-                <a:ea typeface="Poppins"/>
-                <a:cs typeface="Poppins"/>
-                <a:sym typeface="Poppins"/>
+                <a:latin typeface="Arial"/>
+                <a:ea typeface="Arial"/>
+                <a:cs typeface="Arial"/>
+                <a:sym typeface="Arial"/>
               </a:rPr>
               <a:t>The market</a:t>
             </a:r>
@@ -19721,10 +19721,10 @@
                 <a:solidFill>
                   <a:srgbClr val="434343"/>
                 </a:solidFill>
-                <a:latin typeface="Poppins"/>
-                <a:ea typeface="Poppins"/>
-                <a:cs typeface="Poppins"/>
-                <a:sym typeface="Poppins"/>
+                <a:latin typeface="Arial"/>
+                <a:ea typeface="Arial"/>
+                <a:cs typeface="Arial"/>
+                <a:sym typeface="Arial"/>
               </a:rPr>
               <a:t>77.8M people aged 18 to 34 (TAM), 19M US college students we can reach (SAM), 540K we plan to win (SOM).</a:t>
             </a:r>
@@ -19774,10 +19774,10 @@
                 <a:solidFill>
                   <a:srgbClr val="6F6B34"/>
                 </a:solidFill>
-                <a:latin typeface="Poppins"/>
-                <a:ea typeface="Poppins"/>
-                <a:cs typeface="Poppins"/>
-                <a:sym typeface="Poppins"/>
+                <a:latin typeface="Arial"/>
+                <a:ea typeface="Arial"/>
+                <a:cs typeface="Arial"/>
+                <a:sym typeface="Arial"/>
               </a:rPr>
               <a:t>Growth</a:t>
             </a:r>
@@ -19827,10 +19827,10 @@
                 <a:solidFill>
                   <a:srgbClr val="434343"/>
                 </a:solidFill>
-                <a:latin typeface="Poppins"/>
-                <a:ea typeface="Poppins"/>
-                <a:cs typeface="Poppins"/>
-                <a:sym typeface="Poppins"/>
+                <a:latin typeface="Arial"/>
+                <a:ea typeface="Arial"/>
+                <a:cs typeface="Arial"/>
+                <a:sym typeface="Arial"/>
               </a:rPr>
               <a:t>Boston first. Other cities from Year 3.</a:t>
             </a:r>
@@ -19905,10 +19905,10 @@
                 <a:solidFill>
                   <a:srgbClr val="6F6B34"/>
                 </a:solidFill>
-                <a:latin typeface="Poppins"/>
-                <a:ea typeface="Poppins"/>
-                <a:cs typeface="Poppins"/>
-                <a:sym typeface="Poppins"/>
+                <a:latin typeface="Arial"/>
+                <a:ea typeface="Arial"/>
+                <a:cs typeface="Arial"/>
+                <a:sym typeface="Arial"/>
               </a:rPr>
               <a:t>How we’d get users</a:t>
             </a:r>
@@ -19958,10 +19958,10 @@
                 <a:solidFill>
                   <a:srgbClr val="595959"/>
                 </a:solidFill>
-                <a:latin typeface="Poppins"/>
-                <a:ea typeface="Poppins"/>
-                <a:cs typeface="Poppins"/>
-                <a:sym typeface="Poppins"/>
+                <a:latin typeface="Arial"/>
+                <a:ea typeface="Arial"/>
+                <a:cs typeface="Arial"/>
+                <a:sym typeface="Arial"/>
               </a:rPr>
               <a:t>6</a:t>
             </a:r>
@@ -20011,10 +20011,10 @@
                 <a:solidFill>
                   <a:srgbClr val="000000"/>
                 </a:solidFill>
-                <a:latin typeface="Poppins"/>
-                <a:ea typeface="Poppins"/>
-                <a:cs typeface="Poppins"/>
-                <a:sym typeface="Poppins"/>
+                <a:latin typeface="Arial"/>
+                <a:ea typeface="Arial"/>
+                <a:cs typeface="Arial"/>
+                <a:sym typeface="Arial"/>
               </a:rPr>
               <a:t xml:space="preserve">We plan to find our first 1,000 users on Boston campuses, </a:t>
             </a:r>
@@ -20023,10 +20023,10 @@
                 <a:solidFill>
                   <a:srgbClr val="595959"/>
                 </a:solidFill>
-                <a:latin typeface="Poppins"/>
-                <a:ea typeface="Poppins"/>
-                <a:cs typeface="Poppins"/>
-                <a:sym typeface="Poppins"/>
+                <a:latin typeface="Arial"/>
+                <a:ea typeface="Arial"/>
+                <a:cs typeface="Arial"/>
+                <a:sym typeface="Arial"/>
               </a:rPr>
               <a:t>starting with ours, one friend at a time.</a:t>
             </a:r>
@@ -20076,10 +20076,10 @@
                 <a:solidFill>
                   <a:srgbClr val="595959"/>
                 </a:solidFill>
-                <a:latin typeface="Roboto Mono"/>
-                <a:ea typeface="Roboto Mono"/>
-                <a:cs typeface="Roboto Mono"/>
-                <a:sym typeface="Roboto Mono"/>
+                <a:latin typeface="Arial"/>
+                <a:ea typeface="Arial"/>
+                <a:cs typeface="Arial"/>
+                <a:sym typeface="Arial"/>
               </a:rPr>
               <a:t>Beli referrals: Wall Street Journal, May 2025. User targets are from our Gate 2 model.</a:t>
             </a:r>
@@ -20129,10 +20129,10 @@
                 <a:solidFill>
                   <a:srgbClr val="6F6B34"/>
                 </a:solidFill>
-                <a:latin typeface="Poppins"/>
-                <a:ea typeface="Poppins"/>
-                <a:cs typeface="Poppins"/>
-                <a:sym typeface="Poppins"/>
+                <a:latin typeface="Arial"/>
+                <a:ea typeface="Arial"/>
+                <a:cs typeface="Arial"/>
+                <a:sym typeface="Arial"/>
               </a:rPr>
               <a:t>Who they are and where we find them</a:t>
             </a:r>
@@ -20182,10 +20182,10 @@
                 <a:solidFill>
                   <a:srgbClr val="6F6B34"/>
                 </a:solidFill>
-                <a:latin typeface="Poppins"/>
-                <a:ea typeface="Poppins"/>
-                <a:cs typeface="Poppins"/>
-                <a:sym typeface="Poppins"/>
+                <a:latin typeface="Arial"/>
+                <a:ea typeface="Arial"/>
+                <a:cs typeface="Arial"/>
+                <a:sym typeface="Arial"/>
               </a:rPr>
               <a:t>What we tell them</a:t>
             </a:r>
@@ -20293,10 +20293,10 @@
                 <a:solidFill>
                   <a:srgbClr val="000000"/>
                 </a:solidFill>
-                <a:latin typeface="Poppins"/>
-                <a:ea typeface="Poppins"/>
-                <a:cs typeface="Poppins"/>
-                <a:sym typeface="Poppins"/>
+                <a:latin typeface="Arial"/>
+                <a:ea typeface="Arial"/>
+                <a:cs typeface="Arial"/>
+                <a:sym typeface="Arial"/>
               </a:rPr>
               <a:t>First 10</a:t>
             </a:r>
@@ -20346,10 +20346,10 @@
                 <a:solidFill>
                   <a:srgbClr val="434343"/>
                 </a:solidFill>
-                <a:latin typeface="Poppins"/>
-                <a:ea typeface="Poppins"/>
-                <a:cs typeface="Poppins"/>
-                <a:sym typeface="Poppins"/>
+                <a:latin typeface="Arial"/>
+                <a:ea typeface="Arial"/>
+                <a:cs typeface="Arial"/>
+                <a:sym typeface="Arial"/>
               </a:rPr>
               <a:t>People we interviewed and our friends test the prototype.</a:t>
             </a:r>
@@ -20399,10 +20399,10 @@
                 <a:solidFill>
                   <a:srgbClr val="000000"/>
                 </a:solidFill>
-                <a:latin typeface="Poppins"/>
-                <a:ea typeface="Poppins"/>
-                <a:cs typeface="Poppins"/>
-                <a:sym typeface="Poppins"/>
+                <a:latin typeface="Arial"/>
+                <a:ea typeface="Arial"/>
+                <a:cs typeface="Arial"/>
+                <a:sym typeface="Arial"/>
               </a:rPr>
               <a:t>Help us build it.</a:t>
             </a:r>
@@ -20510,10 +20510,10 @@
                 <a:solidFill>
                   <a:srgbClr val="000000"/>
                 </a:solidFill>
-                <a:latin typeface="Poppins"/>
-                <a:ea typeface="Poppins"/>
-                <a:cs typeface="Poppins"/>
-                <a:sym typeface="Poppins"/>
+                <a:latin typeface="Arial"/>
+                <a:ea typeface="Arial"/>
+                <a:cs typeface="Arial"/>
+                <a:sym typeface="Arial"/>
               </a:rPr>
               <a:t>First 100</a:t>
             </a:r>
@@ -20563,10 +20563,10 @@
                 <a:solidFill>
                   <a:srgbClr val="434343"/>
                 </a:solidFill>
-                <a:latin typeface="Poppins"/>
-                <a:ea typeface="Poppins"/>
-                <a:cs typeface="Poppins"/>
-                <a:sym typeface="Poppins"/>
+                <a:latin typeface="Arial"/>
+                <a:ea typeface="Arial"/>
+                <a:cs typeface="Arial"/>
+                <a:sym typeface="Arial"/>
               </a:rPr>
               <a:t>Northeastern students they invite, plus clubs and group chats.</a:t>
             </a:r>
@@ -20616,10 +20616,10 @@
                 <a:solidFill>
                   <a:srgbClr val="000000"/>
                 </a:solidFill>
-                <a:latin typeface="Poppins"/>
-                <a:ea typeface="Poppins"/>
-                <a:cs typeface="Poppins"/>
-                <a:sym typeface="Poppins"/>
+                <a:latin typeface="Arial"/>
+                <a:ea typeface="Arial"/>
+                <a:cs typeface="Arial"/>
+                <a:sym typeface="Arial"/>
               </a:rPr>
               <a:t>Every rating for a place, in one app.</a:t>
             </a:r>
@@ -20727,10 +20727,10 @@
                 <a:solidFill>
                   <a:srgbClr val="000000"/>
                 </a:solidFill>
-                <a:latin typeface="Poppins"/>
-                <a:ea typeface="Poppins"/>
-                <a:cs typeface="Poppins"/>
-                <a:sym typeface="Poppins"/>
+                <a:latin typeface="Arial"/>
+                <a:ea typeface="Arial"/>
+                <a:cs typeface="Arial"/>
+                <a:sym typeface="Arial"/>
               </a:rPr>
               <a:t>First 1,000</a:t>
             </a:r>
@@ -20780,10 +20780,10 @@
                 <a:solidFill>
                   <a:srgbClr val="434343"/>
                 </a:solidFill>
-                <a:latin typeface="Poppins"/>
-                <a:ea typeface="Poppins"/>
-                <a:cs typeface="Poppins"/>
-                <a:sym typeface="Poppins"/>
+                <a:latin typeface="Arial"/>
+                <a:ea typeface="Arial"/>
+                <a:cs typeface="Arial"/>
+                <a:sym typeface="Arial"/>
               </a:rPr>
               <a:t>Other Boston campuses, through student ambassadors and food posts.</a:t>
             </a:r>
@@ -20833,10 +20833,10 @@
                 <a:solidFill>
                   <a:srgbClr val="000000"/>
                 </a:solidFill>
-                <a:latin typeface="Poppins"/>
-                <a:ea typeface="Poppins"/>
-                <a:cs typeface="Poppins"/>
-                <a:sym typeface="Poppins"/>
+                <a:latin typeface="Arial"/>
+                <a:ea typeface="Arial"/>
+                <a:cs typeface="Arial"/>
+                <a:sym typeface="Arial"/>
               </a:rPr>
               <a:t>One app instead of three.</a:t>
             </a:r>
@@ -20944,10 +20944,10 @@
                 <a:solidFill>
                   <a:srgbClr val="434343"/>
                 </a:solidFill>
-                <a:latin typeface="Poppins"/>
-                <a:ea typeface="Poppins"/>
-                <a:cs typeface="Poppins"/>
-                <a:sym typeface="Poppins"/>
+                <a:latin typeface="Arial"/>
+                <a:ea typeface="Arial"/>
+                <a:cs typeface="Arial"/>
+                <a:sym typeface="Arial"/>
               </a:rPr>
               <a:t>If friends invite friends, our model reaches 12K users by the end of Year 1; about 80% of Beli’s users arrived that way.</a:t>
             </a:r>
@@ -21022,10 +21022,10 @@
                 <a:solidFill>
                   <a:srgbClr val="6F6B34"/>
                 </a:solidFill>
-                <a:latin typeface="Poppins"/>
-                <a:ea typeface="Poppins"/>
-                <a:cs typeface="Poppins"/>
-                <a:sym typeface="Poppins"/>
+                <a:latin typeface="Arial"/>
+                <a:ea typeface="Arial"/>
+                <a:cs typeface="Arial"/>
+                <a:sym typeface="Arial"/>
               </a:rPr>
               <a:t>How we’d make money</a:t>
             </a:r>
@@ -21075,10 +21075,10 @@
                 <a:solidFill>
                   <a:srgbClr val="595959"/>
                 </a:solidFill>
-                <a:latin typeface="Poppins"/>
-                <a:ea typeface="Poppins"/>
-                <a:cs typeface="Poppins"/>
-                <a:sym typeface="Poppins"/>
+                <a:latin typeface="Arial"/>
+                <a:ea typeface="Arial"/>
+                <a:cs typeface="Arial"/>
+                <a:sym typeface="Arial"/>
               </a:rPr>
               <a:t>7</a:t>
             </a:r>
@@ -21128,10 +21128,10 @@
                 <a:solidFill>
                   <a:srgbClr val="000000"/>
                 </a:solidFill>
-                <a:latin typeface="Poppins"/>
-                <a:ea typeface="Poppins"/>
-                <a:cs typeface="Poppins"/>
-                <a:sym typeface="Poppins"/>
+                <a:latin typeface="Arial"/>
+                <a:ea typeface="Arial"/>
+                <a:cs typeface="Arial"/>
+                <a:sym typeface="Arial"/>
               </a:rPr>
               <a:t>We’d charge restaurants per diner sent, not for ads.</a:t>
             </a:r>
@@ -21181,10 +21181,10 @@
                 <a:solidFill>
                   <a:srgbClr val="595959"/>
                 </a:solidFill>
-                <a:latin typeface="Roboto Mono"/>
-                <a:ea typeface="Roboto Mono"/>
-                <a:cs typeface="Roboto Mono"/>
-                <a:sym typeface="Roboto Mono"/>
+                <a:latin typeface="Arial"/>
+                <a:ea typeface="Arial"/>
+                <a:cs typeface="Arial"/>
+                <a:sym typeface="Arial"/>
               </a:rPr>
               <a:t>OpenTable pricing via Eat App, 2026. TechCrunch, Aug 2024 (Placer.ai).</a:t>
             </a:r>
@@ -21234,10 +21234,10 @@
                 <a:solidFill>
                   <a:srgbClr val="6F6B34"/>
                 </a:solidFill>
-                <a:latin typeface="Poppins"/>
-                <a:ea typeface="Poppins"/>
-                <a:cs typeface="Poppins"/>
-                <a:sym typeface="Poppins"/>
+                <a:latin typeface="Arial"/>
+                <a:ea typeface="Arial"/>
+                <a:cs typeface="Arial"/>
+                <a:sym typeface="Arial"/>
               </a:rPr>
               <a:t>Their problem</a:t>
             </a:r>
@@ -21287,10 +21287,10 @@
                 <a:solidFill>
                   <a:srgbClr val="6F6B34"/>
                 </a:solidFill>
-                <a:latin typeface="Poppins"/>
-                <a:ea typeface="Poppins"/>
-                <a:cs typeface="Poppins"/>
-                <a:sym typeface="Poppins"/>
+                <a:latin typeface="Arial"/>
+                <a:ea typeface="Arial"/>
+                <a:cs typeface="Arial"/>
+                <a:sym typeface="Arial"/>
               </a:rPr>
               <a:t>What we charge</a:t>
             </a:r>
@@ -21340,10 +21340,10 @@
                 <a:solidFill>
                   <a:srgbClr val="6F6B34"/>
                 </a:solidFill>
-                <a:latin typeface="Poppins"/>
-                <a:ea typeface="Poppins"/>
-                <a:cs typeface="Poppins"/>
-                <a:sym typeface="Poppins"/>
+                <a:latin typeface="Arial"/>
+                <a:ea typeface="Arial"/>
+                <a:cs typeface="Arial"/>
+                <a:sym typeface="Arial"/>
               </a:rPr>
               <a:t>Year 5</a:t>
             </a:r>
@@ -21451,10 +21451,10 @@
                 <a:solidFill>
                   <a:srgbClr val="000000"/>
                 </a:solidFill>
-                <a:latin typeface="Poppins"/>
-                <a:ea typeface="Poppins"/>
-                <a:cs typeface="Poppins"/>
-                <a:sym typeface="Poppins"/>
+                <a:latin typeface="Arial"/>
+                <a:ea typeface="Arial"/>
+                <a:cs typeface="Arial"/>
+                <a:sym typeface="Arial"/>
               </a:rPr>
               <a:t>Restaurants, booking sites, chains</a:t>
             </a:r>
@@ -21504,10 +21504,10 @@
                 <a:solidFill>
                   <a:srgbClr val="434343"/>
                 </a:solidFill>
-                <a:latin typeface="Poppins"/>
-                <a:ea typeface="Poppins"/>
-                <a:cs typeface="Poppins"/>
-                <a:sym typeface="Poppins"/>
+                <a:latin typeface="Arial"/>
+                <a:ea typeface="Arial"/>
+                <a:cs typeface="Arial"/>
+                <a:sym typeface="Arial"/>
               </a:rPr>
               <a:t>Pay for ads up front and can’t tell what worked.</a:t>
             </a:r>
@@ -21557,10 +21557,10 @@
                 <a:solidFill>
                   <a:srgbClr val="000000"/>
                 </a:solidFill>
-                <a:latin typeface="Poppins"/>
-                <a:ea typeface="Poppins"/>
-                <a:cs typeface="Poppins"/>
-                <a:sym typeface="Poppins"/>
+                <a:latin typeface="Arial"/>
+                <a:ea typeface="Arial"/>
+                <a:cs typeface="Arial"/>
+                <a:sym typeface="Arial"/>
               </a:rPr>
               <a:t>About $0.90 per new diner whose visit started in our app, confirmed by receipt. Booking sites pay per table. Chains pay $6,000 a year per area from Year 3, counted from the month each signs.</a:t>
             </a:r>
@@ -21610,10 +21610,10 @@
                 <a:solidFill>
                   <a:srgbClr val="000000"/>
                 </a:solidFill>
-                <a:latin typeface="Poppins"/>
-                <a:ea typeface="Poppins"/>
-                <a:cs typeface="Poppins"/>
-                <a:sym typeface="Poppins"/>
+                <a:latin typeface="Arial"/>
+                <a:ea typeface="Arial"/>
+                <a:cs typeface="Arial"/>
+                <a:sym typeface="Arial"/>
               </a:rPr>
               <a:t>$288K</a:t>
             </a:r>
@@ -21721,10 +21721,10 @@
                 <a:solidFill>
                   <a:srgbClr val="000000"/>
                 </a:solidFill>
-                <a:latin typeface="Poppins"/>
-                <a:ea typeface="Poppins"/>
-                <a:cs typeface="Poppins"/>
-                <a:sym typeface="Poppins"/>
+                <a:latin typeface="Arial"/>
+                <a:ea typeface="Arial"/>
+                <a:cs typeface="Arial"/>
+                <a:sym typeface="Arial"/>
               </a:rPr>
               <a:t>Users</a:t>
             </a:r>
@@ -21774,10 +21774,10 @@
                 <a:solidFill>
                   <a:srgbClr val="434343"/>
                 </a:solidFill>
-                <a:latin typeface="Poppins"/>
-                <a:ea typeface="Poppins"/>
-                <a:cs typeface="Poppins"/>
-                <a:sym typeface="Poppins"/>
+                <a:latin typeface="Arial"/>
+                <a:ea typeface="Arial"/>
+                <a:cs typeface="Arial"/>
+                <a:sym typeface="Arial"/>
               </a:rPr>
               <a:t>Want extras on top of a free app.</a:t>
             </a:r>
@@ -21827,10 +21827,10 @@
                 <a:solidFill>
                   <a:srgbClr val="000000"/>
                 </a:solidFill>
-                <a:latin typeface="Poppins"/>
-                <a:ea typeface="Poppins"/>
-                <a:cs typeface="Poppins"/>
-                <a:sym typeface="Poppins"/>
+                <a:latin typeface="Arial"/>
+                <a:ea typeface="Arial"/>
+                <a:cs typeface="Arial"/>
+                <a:sym typeface="Arial"/>
               </a:rPr>
               <a:t>An optional $5 a month membership.</a:t>
             </a:r>
@@ -21880,10 +21880,10 @@
                 <a:solidFill>
                   <a:srgbClr val="000000"/>
                 </a:solidFill>
-                <a:latin typeface="Poppins"/>
-                <a:ea typeface="Poppins"/>
-                <a:cs typeface="Poppins"/>
-                <a:sym typeface="Poppins"/>
+                <a:latin typeface="Arial"/>
+                <a:ea typeface="Arial"/>
+                <a:cs typeface="Arial"/>
+                <a:sym typeface="Arial"/>
               </a:rPr>
               <a:t>$67K</a:t>
             </a:r>
@@ -21991,10 +21991,10 @@
                 <a:solidFill>
                   <a:srgbClr val="000000"/>
                 </a:solidFill>
-                <a:latin typeface="Poppins"/>
-                <a:ea typeface="Poppins"/>
-                <a:cs typeface="Poppins"/>
-                <a:sym typeface="Poppins"/>
+                <a:latin typeface="Arial"/>
+                <a:ea typeface="Arial"/>
+                <a:cs typeface="Arial"/>
+                <a:sym typeface="Arial"/>
               </a:rPr>
               <a:t>In our model, two sides pay: $356K in Year 5. Paying never changes a score or a ranking.</a:t>
             </a:r>
@@ -22044,10 +22044,10 @@
                 <a:solidFill>
                   <a:srgbClr val="000000"/>
                 </a:solidFill>
-                <a:latin typeface="Poppins"/>
-                <a:ea typeface="Poppins"/>
-                <a:cs typeface="Poppins"/>
-                <a:sym typeface="Poppins"/>
+                <a:latin typeface="Arial"/>
+                <a:ea typeface="Arial"/>
+                <a:cs typeface="Arial"/>
+                <a:sym typeface="Arial"/>
               </a:rPr>
               <a:t xml:space="preserve">Not yet tested with owners. </a:t>
             </a:r>
@@ -22056,10 +22056,10 @@
                 <a:solidFill>
                   <a:srgbClr val="434343"/>
                 </a:solidFill>
-                <a:latin typeface="Poppins"/>
-                <a:ea typeface="Poppins"/>
-                <a:cs typeface="Poppins"/>
-                <a:sym typeface="Poppins"/>
+                <a:latin typeface="Arial"/>
+                <a:ea typeface="Arial"/>
+                <a:cs typeface="Arial"/>
+                <a:sym typeface="Arial"/>
               </a:rPr>
               <a:t>Next: five owner calls, each with a free 30-day pilot and a diner report.</a:t>
             </a:r>
@@ -22142,10 +22142,10 @@
                 <a:solidFill>
                   <a:srgbClr val="2E2D12"/>
                 </a:solidFill>
-                <a:latin typeface="Poppins"/>
-                <a:ea typeface="Poppins"/>
-                <a:cs typeface="Poppins"/>
-                <a:sym typeface="Poppins"/>
+                <a:latin typeface="Arial"/>
+                <a:ea typeface="Arial"/>
+                <a:cs typeface="Arial"/>
+                <a:sym typeface="Arial"/>
               </a:rPr>
               <a:t>What we learned from rivals</a:t>
             </a:r>
@@ -22195,10 +22195,10 @@
                 <a:solidFill>
                   <a:srgbClr val="2E2D12"/>
                 </a:solidFill>
-                <a:latin typeface="Poppins"/>
-                <a:ea typeface="Poppins"/>
-                <a:cs typeface="Poppins"/>
-                <a:sym typeface="Poppins"/>
+                <a:latin typeface="Arial"/>
+                <a:ea typeface="Arial"/>
+                <a:cs typeface="Arial"/>
+                <a:sym typeface="Arial"/>
               </a:rPr>
               <a:t>8</a:t>
             </a:r>
@@ -22248,10 +22248,10 @@
                 <a:solidFill>
                   <a:srgbClr val="000000"/>
                 </a:solidFill>
-                <a:latin typeface="Poppins"/>
-                <a:ea typeface="Poppins"/>
-                <a:cs typeface="Poppins"/>
-                <a:sym typeface="Poppins"/>
+                <a:latin typeface="Arial"/>
+                <a:ea typeface="Arial"/>
+                <a:cs typeface="Arial"/>
+                <a:sym typeface="Arial"/>
               </a:rPr>
               <a:t xml:space="preserve">The apps closest to us took years to make money, </a:t>
             </a:r>
@@ -22260,10 +22260,10 @@
                 <a:solidFill>
                   <a:srgbClr val="2E2D12"/>
                 </a:solidFill>
-                <a:latin typeface="Poppins"/>
-                <a:ea typeface="Poppins"/>
-                <a:cs typeface="Poppins"/>
-                <a:sym typeface="Poppins"/>
+                <a:latin typeface="Arial"/>
+                <a:ea typeface="Arial"/>
+                <a:cs typeface="Arial"/>
+                <a:sym typeface="Arial"/>
               </a:rPr>
               <a:t>so we kept our costs low.</a:t>
             </a:r>
@@ -22313,10 +22313,10 @@
                 <a:solidFill>
                   <a:srgbClr val="2E2D12"/>
                 </a:solidFill>
-                <a:latin typeface="Roboto Mono"/>
-                <a:ea typeface="Roboto Mono"/>
-                <a:cs typeface="Roboto Mono"/>
-                <a:sym typeface="Roboto Mono"/>
+                <a:latin typeface="Arial"/>
+                <a:ea typeface="Arial"/>
+                <a:cs typeface="Arial"/>
+                <a:sym typeface="Arial"/>
               </a:rPr>
               <a:t>OpenTable Form S-1, 2009. TechCrunch, May 2019 (Resy). Sensor Tower in the Boston Globe, Nov 2025, and Wall Street Journal, May 2025 (Beli). Resy never reported a profit.</a:t>
             </a:r>
@@ -22366,10 +22366,10 @@
                 <a:solidFill>
                   <a:srgbClr val="2E2D12"/>
                 </a:solidFill>
-                <a:latin typeface="Poppins"/>
-                <a:ea typeface="Poppins"/>
-                <a:cs typeface="Poppins"/>
-                <a:sym typeface="Poppins"/>
+                <a:latin typeface="Arial"/>
+                <a:ea typeface="Arial"/>
+                <a:cs typeface="Arial"/>
+                <a:sym typeface="Arial"/>
               </a:rPr>
               <a:t>What happened to them</a:t>
             </a:r>
@@ -22419,10 +22419,10 @@
                 <a:solidFill>
                   <a:srgbClr val="2E2D12"/>
                 </a:solidFill>
-                <a:latin typeface="Poppins"/>
-                <a:ea typeface="Poppins"/>
-                <a:cs typeface="Poppins"/>
-                <a:sym typeface="Poppins"/>
+                <a:latin typeface="Arial"/>
+                <a:ea typeface="Arial"/>
+                <a:cs typeface="Arial"/>
+                <a:sym typeface="Arial"/>
               </a:rPr>
               <a:t>What we did about it</a:t>
             </a:r>
@@ -22530,10 +22530,10 @@
                 <a:solidFill>
                   <a:srgbClr val="000000"/>
                 </a:solidFill>
-                <a:latin typeface="Poppins"/>
-                <a:ea typeface="Poppins"/>
-                <a:cs typeface="Poppins"/>
-                <a:sym typeface="Poppins"/>
+                <a:latin typeface="Arial"/>
+                <a:ea typeface="Arial"/>
+                <a:cs typeface="Arial"/>
+                <a:sym typeface="Arial"/>
               </a:rPr>
               <a:t>OpenTable</a:t>
             </a:r>
@@ -22583,10 +22583,10 @@
                 <a:solidFill>
                   <a:srgbClr val="1F1F1F"/>
                 </a:solidFill>
-                <a:latin typeface="Poppins"/>
-                <a:ea typeface="Poppins"/>
-                <a:cs typeface="Poppins"/>
-                <a:sym typeface="Poppins"/>
+                <a:latin typeface="Arial"/>
+                <a:ea typeface="Arial"/>
+                <a:cs typeface="Arial"/>
+                <a:sym typeface="Arial"/>
               </a:rPr>
               <a:t>Nine years to a profit, $57M lost getting there.</a:t>
             </a:r>
@@ -22636,10 +22636,10 @@
                 <a:solidFill>
                   <a:srgbClr val="000000"/>
                 </a:solidFill>
-                <a:latin typeface="Poppins"/>
-                <a:ea typeface="Poppins"/>
-                <a:cs typeface="Poppins"/>
-                <a:sym typeface="Poppins"/>
+                <a:latin typeface="Arial"/>
+                <a:ea typeface="Arial"/>
+                <a:cs typeface="Arial"/>
+                <a:sym typeface="Arial"/>
               </a:rPr>
               <a:t>No founder salaries. Co-op students before full-time hires.</a:t>
             </a:r>
@@ -22747,10 +22747,10 @@
                 <a:solidFill>
                   <a:srgbClr val="000000"/>
                 </a:solidFill>
-                <a:latin typeface="Poppins"/>
-                <a:ea typeface="Poppins"/>
-                <a:cs typeface="Poppins"/>
-                <a:sym typeface="Poppins"/>
+                <a:latin typeface="Arial"/>
+                <a:ea typeface="Arial"/>
+                <a:cs typeface="Arial"/>
+                <a:sym typeface="Arial"/>
               </a:rPr>
               <a:t>Resy</a:t>
             </a:r>
@@ -22800,10 +22800,10 @@
                 <a:solidFill>
                   <a:srgbClr val="1F1F1F"/>
                 </a:solidFill>
-                <a:latin typeface="Poppins"/>
-                <a:ea typeface="Poppins"/>
-                <a:cs typeface="Poppins"/>
-                <a:sym typeface="Poppins"/>
+                <a:latin typeface="Arial"/>
+                <a:ea typeface="Arial"/>
+                <a:cs typeface="Arial"/>
+                <a:sym typeface="Arial"/>
               </a:rPr>
               <a:t>Ran on $45M of investor money, then sold.</a:t>
             </a:r>
@@ -22853,10 +22853,10 @@
                 <a:solidFill>
                   <a:srgbClr val="000000"/>
                 </a:solidFill>
-                <a:latin typeface="Poppins"/>
-                <a:ea typeface="Poppins"/>
-                <a:cs typeface="Poppins"/>
-                <a:sym typeface="Poppins"/>
+                <a:latin typeface="Arial"/>
+                <a:ea typeface="Arial"/>
+                <a:cs typeface="Arial"/>
+                <a:sym typeface="Arial"/>
               </a:rPr>
               <a:t>Costs low enough to need $240K, starting with grants.</a:t>
             </a:r>
@@ -22964,10 +22964,10 @@
                 <a:solidFill>
                   <a:srgbClr val="000000"/>
                 </a:solidFill>
-                <a:latin typeface="Poppins"/>
-                <a:ea typeface="Poppins"/>
-                <a:cs typeface="Poppins"/>
-                <a:sym typeface="Poppins"/>
+                <a:latin typeface="Arial"/>
+                <a:ea typeface="Arial"/>
+                <a:cs typeface="Arial"/>
+                <a:sym typeface="Arial"/>
               </a:rPr>
               <a:t>Beli</a:t>
             </a:r>
@@ -23017,10 +23017,10 @@
                 <a:solidFill>
                   <a:srgbClr val="1F1F1F"/>
                 </a:solidFill>
-                <a:latin typeface="Poppins"/>
-                <a:ea typeface="Poppins"/>
-                <a:cs typeface="Poppins"/>
-                <a:sym typeface="Poppins"/>
+                <a:latin typeface="Arial"/>
+                <a:ea typeface="Arial"/>
+                <a:cs typeface="Arial"/>
+                <a:sym typeface="Arial"/>
               </a:rPr>
               <a:t>1.1M monthly users, mostly through friends, five people, almost no revenue.</a:t>
             </a:r>
@@ -23070,10 +23070,10 @@
                 <a:solidFill>
                   <a:srgbClr val="000000"/>
                 </a:solidFill>
-                <a:latin typeface="Poppins"/>
-                <a:ea typeface="Poppins"/>
-                <a:cs typeface="Poppins"/>
-                <a:sym typeface="Poppins"/>
+                <a:latin typeface="Arial"/>
+                <a:ea typeface="Arial"/>
+                <a:cs typeface="Arial"/>
+                <a:sym typeface="Arial"/>
               </a:rPr>
               <a:t>A quarter of Beli’s size, almost no ad spending, restaurants paying from Year 2.</a:t>
             </a:r>
@@ -23181,10 +23181,10 @@
                 <a:solidFill>
                   <a:srgbClr val="1F1F1F"/>
                 </a:solidFill>
-                <a:latin typeface="Poppins"/>
-                <a:ea typeface="Poppins"/>
-                <a:cs typeface="Poppins"/>
-                <a:sym typeface="Poppins"/>
+                <a:latin typeface="Arial"/>
+                <a:ea typeface="Arial"/>
+                <a:cs typeface="Arial"/>
+                <a:sym typeface="Arial"/>
               </a:rPr>
               <a:t>The trade-off: a smaller team, and it only works if restaurants sign up.</a:t>
             </a:r>
@@ -23259,10 +23259,10 @@
                 <a:solidFill>
                   <a:srgbClr val="6F6B34"/>
                 </a:solidFill>
-                <a:latin typeface="Poppins"/>
-                <a:ea typeface="Poppins"/>
-                <a:cs typeface="Poppins"/>
-                <a:sym typeface="Poppins"/>
+                <a:latin typeface="Arial"/>
+                <a:ea typeface="Arial"/>
+                <a:cs typeface="Arial"/>
+                <a:sym typeface="Arial"/>
               </a:rPr>
               <a:t>The numbers</a:t>
             </a:r>
@@ -23312,10 +23312,10 @@
                 <a:solidFill>
                   <a:srgbClr val="595959"/>
                 </a:solidFill>
-                <a:latin typeface="Poppins"/>
-                <a:ea typeface="Poppins"/>
-                <a:cs typeface="Poppins"/>
-                <a:sym typeface="Poppins"/>
+                <a:latin typeface="Arial"/>
+                <a:ea typeface="Arial"/>
+                <a:cs typeface="Arial"/>
+                <a:sym typeface="Arial"/>
               </a:rPr>
               <a:t>9</a:t>
             </a:r>
@@ -23365,10 +23365,10 @@
                 <a:solidFill>
                   <a:srgbClr val="000000"/>
                 </a:solidFill>
-                <a:latin typeface="Poppins"/>
-                <a:ea typeface="Poppins"/>
-                <a:cs typeface="Poppins"/>
-                <a:sym typeface="Poppins"/>
+                <a:latin typeface="Arial"/>
+                <a:ea typeface="Arial"/>
+                <a:cs typeface="Arial"/>
+                <a:sym typeface="Arial"/>
               </a:rPr>
               <a:t xml:space="preserve">We plan to spend about $11K a quarter for two years. </a:t>
             </a:r>
@@ -23377,10 +23377,10 @@
                 <a:solidFill>
                   <a:srgbClr val="595959"/>
                 </a:solidFill>
-                <a:latin typeface="Poppins"/>
-                <a:ea typeface="Poppins"/>
-                <a:cs typeface="Poppins"/>
-                <a:sym typeface="Poppins"/>
+                <a:latin typeface="Arial"/>
+                <a:ea typeface="Arial"/>
+                <a:cs typeface="Arial"/>
+                <a:sym typeface="Arial"/>
               </a:rPr>
               <a:t>Our model shows a first profit in Year 5.</a:t>
             </a:r>
@@ -23430,10 +23430,10 @@
                 <a:solidFill>
                   <a:srgbClr val="595959"/>
                 </a:solidFill>
-                <a:latin typeface="Roboto Mono"/>
-                <a:ea typeface="Roboto Mono"/>
-                <a:cs typeface="Roboto Mono"/>
-                <a:sym typeface="Roboto Mono"/>
+                <a:latin typeface="Arial"/>
+                <a:ea typeface="Arial"/>
+                <a:cs typeface="Arial"/>
+                <a:sym typeface="Arial"/>
               </a:rPr>
               <a:t>$K. Years 1 and 2 by quarter, years 3 to 5 by year. From our Gate 2 model; assumptions and sources are in the workbook.</a:t>
             </a:r>
@@ -23492,10 +23492,10 @@
                           <a:solidFill>
                             <a:srgbClr val="6F6B34"/>
                           </a:solidFill>
-                          <a:latin typeface="Poppins"/>
-                          <a:ea typeface="Poppins"/>
-                          <a:cs typeface="Poppins"/>
-                          <a:sym typeface="Poppins"/>
+                          <a:latin typeface="Arial"/>
+                          <a:ea typeface="Arial"/>
+                          <a:cs typeface="Arial"/>
+                          <a:sym typeface="Arial"/>
                         </a:rPr>
                         <a:t>$K</a:t>
                       </a:r>
@@ -23527,10 +23527,10 @@
                           <a:solidFill>
                             <a:srgbClr val="6F6B34"/>
                           </a:solidFill>
-                          <a:latin typeface="Poppins"/>
-                          <a:ea typeface="Poppins"/>
-                          <a:cs typeface="Poppins"/>
-                          <a:sym typeface="Poppins"/>
+                          <a:latin typeface="Arial"/>
+                          <a:ea typeface="Arial"/>
+                          <a:cs typeface="Arial"/>
+                          <a:sym typeface="Arial"/>
                         </a:rPr>
                         <a:t>Q1</a:t>
                       </a:r>
@@ -23562,10 +23562,10 @@
                           <a:solidFill>
                             <a:srgbClr val="6F6B34"/>
                           </a:solidFill>
-                          <a:latin typeface="Poppins"/>
-                          <a:ea typeface="Poppins"/>
-                          <a:cs typeface="Poppins"/>
-                          <a:sym typeface="Poppins"/>
+                          <a:latin typeface="Arial"/>
+                          <a:ea typeface="Arial"/>
+                          <a:cs typeface="Arial"/>
+                          <a:sym typeface="Arial"/>
                         </a:rPr>
                         <a:t>Q2</a:t>
                       </a:r>
@@ -23597,10 +23597,10 @@
                           <a:solidFill>
                             <a:srgbClr val="6F6B34"/>
                           </a:solidFill>
-                          <a:latin typeface="Poppins"/>
-                          <a:ea typeface="Poppins"/>
-                          <a:cs typeface="Poppins"/>
-                          <a:sym typeface="Poppins"/>
+                          <a:latin typeface="Arial"/>
+                          <a:ea typeface="Arial"/>
+                          <a:cs typeface="Arial"/>
+                          <a:sym typeface="Arial"/>
                         </a:rPr>
                         <a:t>Q3</a:t>
                       </a:r>
@@ -23632,10 +23632,10 @@
                           <a:solidFill>
                             <a:srgbClr val="6F6B34"/>
                           </a:solidFill>
-                          <a:latin typeface="Poppins"/>
-                          <a:ea typeface="Poppins"/>
-                          <a:cs typeface="Poppins"/>
-                          <a:sym typeface="Poppins"/>
+                          <a:latin typeface="Arial"/>
+                          <a:ea typeface="Arial"/>
+                          <a:cs typeface="Arial"/>
+                          <a:sym typeface="Arial"/>
                         </a:rPr>
                         <a:t>Q4</a:t>
                       </a:r>
@@ -23667,10 +23667,10 @@
                           <a:solidFill>
                             <a:srgbClr val="6F6B34"/>
                           </a:solidFill>
-                          <a:latin typeface="Poppins"/>
-                          <a:ea typeface="Poppins"/>
-                          <a:cs typeface="Poppins"/>
-                          <a:sym typeface="Poppins"/>
+                          <a:latin typeface="Arial"/>
+                          <a:ea typeface="Arial"/>
+                          <a:cs typeface="Arial"/>
+                          <a:sym typeface="Arial"/>
                         </a:rPr>
                         <a:t>Q5</a:t>
                       </a:r>
@@ -23702,10 +23702,10 @@
                           <a:solidFill>
                             <a:srgbClr val="6F6B34"/>
                           </a:solidFill>
-                          <a:latin typeface="Poppins"/>
-                          <a:ea typeface="Poppins"/>
-                          <a:cs typeface="Poppins"/>
-                          <a:sym typeface="Poppins"/>
+                          <a:latin typeface="Arial"/>
+                          <a:ea typeface="Arial"/>
+                          <a:cs typeface="Arial"/>
+                          <a:sym typeface="Arial"/>
                         </a:rPr>
                         <a:t>Q6</a:t>
                       </a:r>
@@ -23737,10 +23737,10 @@
                           <a:solidFill>
                             <a:srgbClr val="6F6B34"/>
                           </a:solidFill>
-                          <a:latin typeface="Poppins"/>
-                          <a:ea typeface="Poppins"/>
-                          <a:cs typeface="Poppins"/>
-                          <a:sym typeface="Poppins"/>
+                          <a:latin typeface="Arial"/>
+                          <a:ea typeface="Arial"/>
+                          <a:cs typeface="Arial"/>
+                          <a:sym typeface="Arial"/>
                         </a:rPr>
                         <a:t>Q7</a:t>
                       </a:r>
@@ -23772,10 +23772,10 @@
                           <a:solidFill>
                             <a:srgbClr val="6F6B34"/>
                           </a:solidFill>
-                          <a:latin typeface="Poppins"/>
-                          <a:ea typeface="Poppins"/>
-                          <a:cs typeface="Poppins"/>
-                          <a:sym typeface="Poppins"/>
+                          <a:latin typeface="Arial"/>
+                          <a:ea typeface="Arial"/>
+                          <a:cs typeface="Arial"/>
+                          <a:sym typeface="Arial"/>
                         </a:rPr>
                         <a:t>Q8</a:t>
                       </a:r>
@@ -23807,10 +23807,10 @@
                           <a:solidFill>
                             <a:srgbClr val="6F6B34"/>
                           </a:solidFill>
-                          <a:latin typeface="Poppins"/>
-                          <a:ea typeface="Poppins"/>
-                          <a:cs typeface="Poppins"/>
-                          <a:sym typeface="Poppins"/>
+                          <a:latin typeface="Arial"/>
+                          <a:ea typeface="Arial"/>
+                          <a:cs typeface="Arial"/>
+                          <a:sym typeface="Arial"/>
                         </a:rPr>
                         <a:t>Yr 3</a:t>
                       </a:r>
@@ -23842,10 +23842,10 @@
                           <a:solidFill>
                             <a:srgbClr val="6F6B34"/>
                           </a:solidFill>
-                          <a:latin typeface="Poppins"/>
-                          <a:ea typeface="Poppins"/>
-                          <a:cs typeface="Poppins"/>
-                          <a:sym typeface="Poppins"/>
+                          <a:latin typeface="Arial"/>
+                          <a:ea typeface="Arial"/>
+                          <a:cs typeface="Arial"/>
+                          <a:sym typeface="Arial"/>
                         </a:rPr>
                         <a:t>Yr 4</a:t>
                       </a:r>
@@ -23877,10 +23877,10 @@
                           <a:solidFill>
                             <a:srgbClr val="6F6B34"/>
                           </a:solidFill>
-                          <a:latin typeface="Poppins"/>
-                          <a:ea typeface="Poppins"/>
-                          <a:cs typeface="Poppins"/>
-                          <a:sym typeface="Poppins"/>
+                          <a:latin typeface="Arial"/>
+                          <a:ea typeface="Arial"/>
+                          <a:cs typeface="Arial"/>
+                          <a:sym typeface="Arial"/>
                         </a:rPr>
                         <a:t>Yr 5</a:t>
                       </a:r>
@@ -23914,10 +23914,10 @@
                           <a:solidFill>
                             <a:srgbClr val="434343"/>
                           </a:solidFill>
-                          <a:latin typeface="Poppins"/>
-                          <a:ea typeface="Poppins"/>
-                          <a:cs typeface="Poppins"/>
-                          <a:sym typeface="Poppins"/>
+                          <a:latin typeface="Arial"/>
+                          <a:ea typeface="Arial"/>
+                          <a:cs typeface="Arial"/>
+                          <a:sym typeface="Arial"/>
                         </a:rPr>
                         <a:t>Active users (K)</a:t>
                       </a:r>
@@ -23949,10 +23949,10 @@
                           <a:solidFill>
                             <a:srgbClr val="707070"/>
                           </a:solidFill>
-                          <a:latin typeface="Poppins"/>
-                          <a:ea typeface="Poppins"/>
-                          <a:cs typeface="Poppins"/>
-                          <a:sym typeface="Poppins"/>
+                          <a:latin typeface="Arial"/>
+                          <a:ea typeface="Arial"/>
+                          <a:cs typeface="Arial"/>
+                          <a:sym typeface="Arial"/>
                         </a:rPr>
                         <a:t>0</a:t>
                       </a:r>
@@ -23984,10 +23984,10 @@
                           <a:solidFill>
                             <a:srgbClr val="707070"/>
                           </a:solidFill>
-                          <a:latin typeface="Poppins"/>
-                          <a:ea typeface="Poppins"/>
-                          <a:cs typeface="Poppins"/>
-                          <a:sym typeface="Poppins"/>
+                          <a:latin typeface="Arial"/>
+                          <a:ea typeface="Arial"/>
+                          <a:cs typeface="Arial"/>
+                          <a:sym typeface="Arial"/>
                         </a:rPr>
                         <a:t>1.8</a:t>
                       </a:r>
@@ -24019,10 +24019,10 @@
                           <a:solidFill>
                             <a:srgbClr val="707070"/>
                           </a:solidFill>
-                          <a:latin typeface="Poppins"/>
-                          <a:ea typeface="Poppins"/>
-                          <a:cs typeface="Poppins"/>
-                          <a:sym typeface="Poppins"/>
+                          <a:latin typeface="Arial"/>
+                          <a:ea typeface="Arial"/>
+                          <a:cs typeface="Arial"/>
+                          <a:sym typeface="Arial"/>
                         </a:rPr>
                         <a:t>5.4</a:t>
                       </a:r>
@@ -24054,10 +24054,10 @@
                           <a:solidFill>
                             <a:srgbClr val="707070"/>
                           </a:solidFill>
-                          <a:latin typeface="Poppins"/>
-                          <a:ea typeface="Poppins"/>
-                          <a:cs typeface="Poppins"/>
-                          <a:sym typeface="Poppins"/>
+                          <a:latin typeface="Arial"/>
+                          <a:ea typeface="Arial"/>
+                          <a:cs typeface="Arial"/>
+                          <a:sym typeface="Arial"/>
                         </a:rPr>
                         <a:t>12.0</a:t>
                       </a:r>
@@ -24089,10 +24089,10 @@
                           <a:solidFill>
                             <a:srgbClr val="707070"/>
                           </a:solidFill>
-                          <a:latin typeface="Poppins"/>
-                          <a:ea typeface="Poppins"/>
-                          <a:cs typeface="Poppins"/>
-                          <a:sym typeface="Poppins"/>
+                          <a:latin typeface="Arial"/>
+                          <a:ea typeface="Arial"/>
+                          <a:cs typeface="Arial"/>
+                          <a:sym typeface="Arial"/>
                         </a:rPr>
                         <a:t>15.2</a:t>
                       </a:r>
@@ -24124,10 +24124,10 @@
                           <a:solidFill>
                             <a:srgbClr val="707070"/>
                           </a:solidFill>
-                          <a:latin typeface="Poppins"/>
-                          <a:ea typeface="Poppins"/>
-                          <a:cs typeface="Poppins"/>
-                          <a:sym typeface="Poppins"/>
+                          <a:latin typeface="Arial"/>
+                          <a:ea typeface="Arial"/>
+                          <a:cs typeface="Arial"/>
+                          <a:sym typeface="Arial"/>
                         </a:rPr>
                         <a:t>19.3</a:t>
                       </a:r>
@@ -24159,10 +24159,10 @@
                           <a:solidFill>
                             <a:srgbClr val="707070"/>
                           </a:solidFill>
-                          <a:latin typeface="Poppins"/>
-                          <a:ea typeface="Poppins"/>
-                          <a:cs typeface="Poppins"/>
-                          <a:sym typeface="Poppins"/>
+                          <a:latin typeface="Arial"/>
+                          <a:ea typeface="Arial"/>
+                          <a:cs typeface="Arial"/>
+                          <a:sym typeface="Arial"/>
                         </a:rPr>
                         <a:t>24.5</a:t>
                       </a:r>
@@ -24194,10 +24194,10 @@
                           <a:solidFill>
                             <a:srgbClr val="707070"/>
                           </a:solidFill>
-                          <a:latin typeface="Poppins"/>
-                          <a:ea typeface="Poppins"/>
-                          <a:cs typeface="Poppins"/>
-                          <a:sym typeface="Poppins"/>
+                          <a:latin typeface="Arial"/>
+                          <a:ea typeface="Arial"/>
+                          <a:cs typeface="Arial"/>
+                          <a:sym typeface="Arial"/>
                         </a:rPr>
                         <a:t>31.1</a:t>
                       </a:r>
@@ -24229,10 +24229,10 @@
                           <a:solidFill>
                             <a:srgbClr val="707070"/>
                           </a:solidFill>
-                          <a:latin typeface="Poppins"/>
-                          <a:ea typeface="Poppins"/>
-                          <a:cs typeface="Poppins"/>
-                          <a:sym typeface="Poppins"/>
+                          <a:latin typeface="Arial"/>
+                          <a:ea typeface="Arial"/>
+                          <a:cs typeface="Arial"/>
+                          <a:sym typeface="Arial"/>
                         </a:rPr>
                         <a:t>80</a:t>
                       </a:r>
@@ -24264,10 +24264,10 @@
                           <a:solidFill>
                             <a:srgbClr val="707070"/>
                           </a:solidFill>
-                          <a:latin typeface="Poppins"/>
-                          <a:ea typeface="Poppins"/>
-                          <a:cs typeface="Poppins"/>
-                          <a:sym typeface="Poppins"/>
+                          <a:latin typeface="Arial"/>
+                          <a:ea typeface="Arial"/>
+                          <a:cs typeface="Arial"/>
+                          <a:sym typeface="Arial"/>
                         </a:rPr>
                         <a:t>208</a:t>
                       </a:r>
@@ -24299,10 +24299,10 @@
                           <a:solidFill>
                             <a:srgbClr val="707070"/>
                           </a:solidFill>
-                          <a:latin typeface="Poppins"/>
-                          <a:ea typeface="Poppins"/>
-                          <a:cs typeface="Poppins"/>
-                          <a:sym typeface="Poppins"/>
+                          <a:latin typeface="Arial"/>
+                          <a:ea typeface="Arial"/>
+                          <a:cs typeface="Arial"/>
+                          <a:sym typeface="Arial"/>
                         </a:rPr>
                         <a:t>540</a:t>
                       </a:r>
@@ -24336,10 +24336,10 @@
                           <a:solidFill>
                             <a:srgbClr val="000000"/>
                           </a:solidFill>
-                          <a:latin typeface="Poppins"/>
-                          <a:ea typeface="Poppins"/>
-                          <a:cs typeface="Poppins"/>
-                          <a:sym typeface="Poppins"/>
+                          <a:latin typeface="Arial"/>
+                          <a:ea typeface="Arial"/>
+                          <a:cs typeface="Arial"/>
+                          <a:sym typeface="Arial"/>
                         </a:rPr>
                         <a:t>Revenue</a:t>
                       </a:r>
@@ -24371,10 +24371,10 @@
                           <a:solidFill>
                             <a:srgbClr val="707070"/>
                           </a:solidFill>
-                          <a:latin typeface="Poppins"/>
-                          <a:ea typeface="Poppins"/>
-                          <a:cs typeface="Poppins"/>
-                          <a:sym typeface="Poppins"/>
+                          <a:latin typeface="Arial"/>
+                          <a:ea typeface="Arial"/>
+                          <a:cs typeface="Arial"/>
+                          <a:sym typeface="Arial"/>
                         </a:rPr>
                         <a:t>0</a:t>
                       </a:r>
@@ -24406,10 +24406,10 @@
                           <a:solidFill>
                             <a:srgbClr val="707070"/>
                           </a:solidFill>
-                          <a:latin typeface="Poppins"/>
-                          <a:ea typeface="Poppins"/>
-                          <a:cs typeface="Poppins"/>
-                          <a:sym typeface="Poppins"/>
+                          <a:latin typeface="Arial"/>
+                          <a:ea typeface="Arial"/>
+                          <a:cs typeface="Arial"/>
+                          <a:sym typeface="Arial"/>
                         </a:rPr>
                         <a:t>0</a:t>
                       </a:r>
@@ -24441,10 +24441,10 @@
                           <a:solidFill>
                             <a:srgbClr val="707070"/>
                           </a:solidFill>
-                          <a:latin typeface="Poppins"/>
-                          <a:ea typeface="Poppins"/>
-                          <a:cs typeface="Poppins"/>
-                          <a:sym typeface="Poppins"/>
+                          <a:latin typeface="Arial"/>
+                          <a:ea typeface="Arial"/>
+                          <a:cs typeface="Arial"/>
+                          <a:sym typeface="Arial"/>
                         </a:rPr>
                         <a:t>0</a:t>
                       </a:r>
@@ -24476,10 +24476,10 @@
                           <a:solidFill>
                             <a:srgbClr val="707070"/>
                           </a:solidFill>
-                          <a:latin typeface="Poppins"/>
-                          <a:ea typeface="Poppins"/>
-                          <a:cs typeface="Poppins"/>
-                          <a:sym typeface="Poppins"/>
+                          <a:latin typeface="Arial"/>
+                          <a:ea typeface="Arial"/>
+                          <a:cs typeface="Arial"/>
+                          <a:sym typeface="Arial"/>
                         </a:rPr>
                         <a:t>0</a:t>
                       </a:r>
@@ -24511,10 +24511,10 @@
                           <a:solidFill>
                             <a:srgbClr val="000000"/>
                           </a:solidFill>
-                          <a:latin typeface="Poppins"/>
-                          <a:ea typeface="Poppins"/>
-                          <a:cs typeface="Poppins"/>
-                          <a:sym typeface="Poppins"/>
+                          <a:latin typeface="Arial"/>
+                          <a:ea typeface="Arial"/>
+                          <a:cs typeface="Arial"/>
+                          <a:sym typeface="Arial"/>
                         </a:rPr>
                         <a:t>2.0</a:t>
                       </a:r>
@@ -24546,10 +24546,10 @@
                           <a:solidFill>
                             <a:srgbClr val="707070"/>
                           </a:solidFill>
-                          <a:latin typeface="Poppins"/>
-                          <a:ea typeface="Poppins"/>
-                          <a:cs typeface="Poppins"/>
-                          <a:sym typeface="Poppins"/>
+                          <a:latin typeface="Arial"/>
+                          <a:ea typeface="Arial"/>
+                          <a:cs typeface="Arial"/>
+                          <a:sym typeface="Arial"/>
                         </a:rPr>
                         <a:t>2.6</a:t>
                       </a:r>
@@ -24581,10 +24581,10 @@
                           <a:solidFill>
                             <a:srgbClr val="707070"/>
                           </a:solidFill>
-                          <a:latin typeface="Poppins"/>
-                          <a:ea typeface="Poppins"/>
-                          <a:cs typeface="Poppins"/>
-                          <a:sym typeface="Poppins"/>
+                          <a:latin typeface="Arial"/>
+                          <a:ea typeface="Arial"/>
+                          <a:cs typeface="Arial"/>
+                          <a:sym typeface="Arial"/>
                         </a:rPr>
                         <a:t>3.3</a:t>
                       </a:r>
@@ -24616,10 +24616,10 @@
                           <a:solidFill>
                             <a:srgbClr val="707070"/>
                           </a:solidFill>
-                          <a:latin typeface="Poppins"/>
-                          <a:ea typeface="Poppins"/>
-                          <a:cs typeface="Poppins"/>
-                          <a:sym typeface="Poppins"/>
+                          <a:latin typeface="Arial"/>
+                          <a:ea typeface="Arial"/>
+                          <a:cs typeface="Arial"/>
+                          <a:sym typeface="Arial"/>
                         </a:rPr>
                         <a:t>4.2</a:t>
                       </a:r>
@@ -24651,10 +24651,10 @@
                           <a:solidFill>
                             <a:srgbClr val="707070"/>
                           </a:solidFill>
-                          <a:latin typeface="Poppins"/>
-                          <a:ea typeface="Poppins"/>
-                          <a:cs typeface="Poppins"/>
-                          <a:sym typeface="Poppins"/>
+                          <a:latin typeface="Arial"/>
+                          <a:ea typeface="Arial"/>
+                          <a:cs typeface="Arial"/>
+                          <a:sym typeface="Arial"/>
                         </a:rPr>
                         <a:t>50</a:t>
                       </a:r>
@@ -24686,10 +24686,10 @@
                           <a:solidFill>
                             <a:srgbClr val="707070"/>
                           </a:solidFill>
-                          <a:latin typeface="Poppins"/>
-                          <a:ea typeface="Poppins"/>
-                          <a:cs typeface="Poppins"/>
-                          <a:sym typeface="Poppins"/>
+                          <a:latin typeface="Arial"/>
+                          <a:ea typeface="Arial"/>
+                          <a:cs typeface="Arial"/>
+                          <a:sym typeface="Arial"/>
                         </a:rPr>
                         <a:t>140</a:t>
                       </a:r>
@@ -24721,10 +24721,10 @@
                           <a:solidFill>
                             <a:srgbClr val="707070"/>
                           </a:solidFill>
-                          <a:latin typeface="Poppins"/>
-                          <a:ea typeface="Poppins"/>
-                          <a:cs typeface="Poppins"/>
-                          <a:sym typeface="Poppins"/>
+                          <a:latin typeface="Arial"/>
+                          <a:ea typeface="Arial"/>
+                          <a:cs typeface="Arial"/>
+                          <a:sym typeface="Arial"/>
                         </a:rPr>
                         <a:t>356</a:t>
                       </a:r>
@@ -24758,10 +24758,10 @@
                           <a:solidFill>
                             <a:srgbClr val="434343"/>
                           </a:solidFill>
-                          <a:latin typeface="Poppins"/>
-                          <a:ea typeface="Poppins"/>
-                          <a:cs typeface="Poppins"/>
-                          <a:sym typeface="Poppins"/>
+                          <a:latin typeface="Arial"/>
+                          <a:ea typeface="Arial"/>
+                          <a:cs typeface="Arial"/>
+                          <a:sym typeface="Arial"/>
                         </a:rPr>
                         <a:t>Spending</a:t>
                       </a:r>
@@ -24793,10 +24793,10 @@
                           <a:solidFill>
                             <a:srgbClr val="707070"/>
                           </a:solidFill>
-                          <a:latin typeface="Poppins"/>
-                          <a:ea typeface="Poppins"/>
-                          <a:cs typeface="Poppins"/>
-                          <a:sym typeface="Poppins"/>
+                          <a:latin typeface="Arial"/>
+                          <a:ea typeface="Arial"/>
+                          <a:cs typeface="Arial"/>
+                          <a:sym typeface="Arial"/>
                         </a:rPr>
                         <a:t>10.6</a:t>
                       </a:r>
@@ -24828,10 +24828,10 @@
                           <a:solidFill>
                             <a:srgbClr val="707070"/>
                           </a:solidFill>
-                          <a:latin typeface="Poppins"/>
-                          <a:ea typeface="Poppins"/>
-                          <a:cs typeface="Poppins"/>
-                          <a:sym typeface="Poppins"/>
+                          <a:latin typeface="Arial"/>
+                          <a:ea typeface="Arial"/>
+                          <a:cs typeface="Arial"/>
+                          <a:sym typeface="Arial"/>
                         </a:rPr>
                         <a:t>10.6</a:t>
                       </a:r>
@@ -24863,10 +24863,10 @@
                           <a:solidFill>
                             <a:srgbClr val="707070"/>
                           </a:solidFill>
-                          <a:latin typeface="Poppins"/>
-                          <a:ea typeface="Poppins"/>
-                          <a:cs typeface="Poppins"/>
-                          <a:sym typeface="Poppins"/>
+                          <a:latin typeface="Arial"/>
+                          <a:ea typeface="Arial"/>
+                          <a:cs typeface="Arial"/>
+                          <a:sym typeface="Arial"/>
                         </a:rPr>
                         <a:t>10.6</a:t>
                       </a:r>
@@ -24898,10 +24898,10 @@
                           <a:solidFill>
                             <a:srgbClr val="707070"/>
                           </a:solidFill>
-                          <a:latin typeface="Poppins"/>
-                          <a:ea typeface="Poppins"/>
-                          <a:cs typeface="Poppins"/>
-                          <a:sym typeface="Poppins"/>
+                          <a:latin typeface="Arial"/>
+                          <a:ea typeface="Arial"/>
+                          <a:cs typeface="Arial"/>
+                          <a:sym typeface="Arial"/>
                         </a:rPr>
                         <a:t>10.7</a:t>
                       </a:r>
@@ -24933,10 +24933,10 @@
                           <a:solidFill>
                             <a:srgbClr val="707070"/>
                           </a:solidFill>
-                          <a:latin typeface="Poppins"/>
-                          <a:ea typeface="Poppins"/>
-                          <a:cs typeface="Poppins"/>
-                          <a:sym typeface="Poppins"/>
+                          <a:latin typeface="Arial"/>
+                          <a:ea typeface="Arial"/>
+                          <a:cs typeface="Arial"/>
+                          <a:sym typeface="Arial"/>
                         </a:rPr>
                         <a:t>10.8</a:t>
                       </a:r>
@@ -24968,10 +24968,10 @@
                           <a:solidFill>
                             <a:srgbClr val="707070"/>
                           </a:solidFill>
-                          <a:latin typeface="Poppins"/>
-                          <a:ea typeface="Poppins"/>
-                          <a:cs typeface="Poppins"/>
-                          <a:sym typeface="Poppins"/>
+                          <a:latin typeface="Arial"/>
+                          <a:ea typeface="Arial"/>
+                          <a:cs typeface="Arial"/>
+                          <a:sym typeface="Arial"/>
                         </a:rPr>
                         <a:t>10.9</a:t>
                       </a:r>
@@ -25003,10 +25003,10 @@
                           <a:solidFill>
                             <a:srgbClr val="707070"/>
                           </a:solidFill>
-                          <a:latin typeface="Poppins"/>
-                          <a:ea typeface="Poppins"/>
-                          <a:cs typeface="Poppins"/>
-                          <a:sym typeface="Poppins"/>
+                          <a:latin typeface="Arial"/>
+                          <a:ea typeface="Arial"/>
+                          <a:cs typeface="Arial"/>
+                          <a:sym typeface="Arial"/>
                         </a:rPr>
                         <a:t>11.0</a:t>
                       </a:r>
@@ -25038,10 +25038,10 @@
                           <a:solidFill>
                             <a:srgbClr val="707070"/>
                           </a:solidFill>
-                          <a:latin typeface="Poppins"/>
-                          <a:ea typeface="Poppins"/>
-                          <a:cs typeface="Poppins"/>
-                          <a:sym typeface="Poppins"/>
+                          <a:latin typeface="Arial"/>
+                          <a:ea typeface="Arial"/>
+                          <a:cs typeface="Arial"/>
+                          <a:sym typeface="Arial"/>
                         </a:rPr>
                         <a:t>11.1</a:t>
                       </a:r>
@@ -25073,10 +25073,10 @@
                           <a:solidFill>
                             <a:srgbClr val="707070"/>
                           </a:solidFill>
-                          <a:latin typeface="Poppins"/>
-                          <a:ea typeface="Poppins"/>
-                          <a:cs typeface="Poppins"/>
-                          <a:sym typeface="Poppins"/>
+                          <a:latin typeface="Arial"/>
+                          <a:ea typeface="Arial"/>
+                          <a:cs typeface="Arial"/>
+                          <a:sym typeface="Arial"/>
                         </a:rPr>
                         <a:t>117</a:t>
                       </a:r>
@@ -25108,10 +25108,10 @@
                           <a:solidFill>
                             <a:srgbClr val="707070"/>
                           </a:solidFill>
-                          <a:latin typeface="Poppins"/>
-                          <a:ea typeface="Poppins"/>
-                          <a:cs typeface="Poppins"/>
-                          <a:sym typeface="Poppins"/>
+                          <a:latin typeface="Arial"/>
+                          <a:ea typeface="Arial"/>
+                          <a:cs typeface="Arial"/>
+                          <a:sym typeface="Arial"/>
                         </a:rPr>
                         <a:t>191</a:t>
                       </a:r>
@@ -25143,10 +25143,10 @@
                           <a:solidFill>
                             <a:srgbClr val="707070"/>
                           </a:solidFill>
-                          <a:latin typeface="Poppins"/>
-                          <a:ea typeface="Poppins"/>
-                          <a:cs typeface="Poppins"/>
-                          <a:sym typeface="Poppins"/>
+                          <a:latin typeface="Arial"/>
+                          <a:ea typeface="Arial"/>
+                          <a:cs typeface="Arial"/>
+                          <a:sym typeface="Arial"/>
                         </a:rPr>
                         <a:t>283</a:t>
                       </a:r>
@@ -25180,10 +25180,10 @@
                           <a:solidFill>
                             <a:srgbClr val="000000"/>
                           </a:solidFill>
-                          <a:latin typeface="Poppins"/>
-                          <a:ea typeface="Poppins"/>
-                          <a:cs typeface="Poppins"/>
-                          <a:sym typeface="Poppins"/>
+                          <a:latin typeface="Arial"/>
+                          <a:ea typeface="Arial"/>
+                          <a:cs typeface="Arial"/>
+                          <a:sym typeface="Arial"/>
                         </a:rPr>
                         <a:t>Profit or loss</a:t>
                       </a:r>
@@ -25215,10 +25215,10 @@
                           <a:solidFill>
                             <a:srgbClr val="707070"/>
                           </a:solidFill>
-                          <a:latin typeface="Poppins"/>
-                          <a:ea typeface="Poppins"/>
-                          <a:cs typeface="Poppins"/>
-                          <a:sym typeface="Poppins"/>
+                          <a:latin typeface="Arial"/>
+                          <a:ea typeface="Arial"/>
+                          <a:cs typeface="Arial"/>
+                          <a:sym typeface="Arial"/>
                         </a:rPr>
                         <a:t>(10.6)</a:t>
                       </a:r>
@@ -25250,10 +25250,10 @@
                           <a:solidFill>
                             <a:srgbClr val="707070"/>
                           </a:solidFill>
-                          <a:latin typeface="Poppins"/>
-                          <a:ea typeface="Poppins"/>
-                          <a:cs typeface="Poppins"/>
-                          <a:sym typeface="Poppins"/>
+                          <a:latin typeface="Arial"/>
+                          <a:ea typeface="Arial"/>
+                          <a:cs typeface="Arial"/>
+                          <a:sym typeface="Arial"/>
                         </a:rPr>
                         <a:t>(10.6)</a:t>
                       </a:r>
@@ -25285,10 +25285,10 @@
                           <a:solidFill>
                             <a:srgbClr val="707070"/>
                           </a:solidFill>
-                          <a:latin typeface="Poppins"/>
-                          <a:ea typeface="Poppins"/>
-                          <a:cs typeface="Poppins"/>
-                          <a:sym typeface="Poppins"/>
+                          <a:latin typeface="Arial"/>
+                          <a:ea typeface="Arial"/>
+                          <a:cs typeface="Arial"/>
+                          <a:sym typeface="Arial"/>
                         </a:rPr>
                         <a:t>(10.6)</a:t>
                       </a:r>
@@ -25320,10 +25320,10 @@
                           <a:solidFill>
                             <a:srgbClr val="707070"/>
                           </a:solidFill>
-                          <a:latin typeface="Poppins"/>
-                          <a:ea typeface="Poppins"/>
-                          <a:cs typeface="Poppins"/>
-                          <a:sym typeface="Poppins"/>
+                          <a:latin typeface="Arial"/>
+                          <a:ea typeface="Arial"/>
+                          <a:cs typeface="Arial"/>
+                          <a:sym typeface="Arial"/>
                         </a:rPr>
                         <a:t>(10.7)</a:t>
                       </a:r>
@@ -25355,10 +25355,10 @@
                           <a:solidFill>
                             <a:srgbClr val="707070"/>
                           </a:solidFill>
-                          <a:latin typeface="Poppins"/>
-                          <a:ea typeface="Poppins"/>
-                          <a:cs typeface="Poppins"/>
-                          <a:sym typeface="Poppins"/>
+                          <a:latin typeface="Arial"/>
+                          <a:ea typeface="Arial"/>
+                          <a:cs typeface="Arial"/>
+                          <a:sym typeface="Arial"/>
                         </a:rPr>
                         <a:t>(8.8)</a:t>
                       </a:r>
@@ -25390,10 +25390,10 @@
                           <a:solidFill>
                             <a:srgbClr val="707070"/>
                           </a:solidFill>
-                          <a:latin typeface="Poppins"/>
-                          <a:ea typeface="Poppins"/>
-                          <a:cs typeface="Poppins"/>
-                          <a:sym typeface="Poppins"/>
+                          <a:latin typeface="Arial"/>
+                          <a:ea typeface="Arial"/>
+                          <a:cs typeface="Arial"/>
+                          <a:sym typeface="Arial"/>
                         </a:rPr>
                         <a:t>(8.3)</a:t>
                       </a:r>
@@ -25425,10 +25425,10 @@
                           <a:solidFill>
                             <a:srgbClr val="707070"/>
                           </a:solidFill>
-                          <a:latin typeface="Poppins"/>
-                          <a:ea typeface="Poppins"/>
-                          <a:cs typeface="Poppins"/>
-                          <a:sym typeface="Poppins"/>
+                          <a:latin typeface="Arial"/>
+                          <a:ea typeface="Arial"/>
+                          <a:cs typeface="Arial"/>
+                          <a:sym typeface="Arial"/>
                         </a:rPr>
                         <a:t>(7.7)</a:t>
                       </a:r>
@@ -25460,10 +25460,10 @@
                           <a:solidFill>
                             <a:srgbClr val="707070"/>
                           </a:solidFill>
-                          <a:latin typeface="Poppins"/>
-                          <a:ea typeface="Poppins"/>
-                          <a:cs typeface="Poppins"/>
-                          <a:sym typeface="Poppins"/>
+                          <a:latin typeface="Arial"/>
+                          <a:ea typeface="Arial"/>
+                          <a:cs typeface="Arial"/>
+                          <a:sym typeface="Arial"/>
                         </a:rPr>
                         <a:t>(7.0)</a:t>
                       </a:r>
@@ -25495,10 +25495,10 @@
                           <a:solidFill>
                             <a:srgbClr val="707070"/>
                           </a:solidFill>
-                          <a:latin typeface="Poppins"/>
-                          <a:ea typeface="Poppins"/>
-                          <a:cs typeface="Poppins"/>
-                          <a:sym typeface="Poppins"/>
+                          <a:latin typeface="Arial"/>
+                          <a:ea typeface="Arial"/>
+                          <a:cs typeface="Arial"/>
+                          <a:sym typeface="Arial"/>
                         </a:rPr>
                         <a:t>(67)</a:t>
                       </a:r>
@@ -25530,10 +25530,10 @@
                           <a:solidFill>
                             <a:srgbClr val="707070"/>
                           </a:solidFill>
-                          <a:latin typeface="Poppins"/>
-                          <a:ea typeface="Poppins"/>
-                          <a:cs typeface="Poppins"/>
-                          <a:sym typeface="Poppins"/>
+                          <a:latin typeface="Arial"/>
+                          <a:ea typeface="Arial"/>
+                          <a:cs typeface="Arial"/>
+                          <a:sym typeface="Arial"/>
                         </a:rPr>
                         <a:t>(51)</a:t>
                       </a:r>
@@ -25565,10 +25565,10 @@
                           <a:solidFill>
                             <a:srgbClr val="000000"/>
                           </a:solidFill>
-                          <a:latin typeface="Poppins"/>
-                          <a:ea typeface="Poppins"/>
-                          <a:cs typeface="Poppins"/>
-                          <a:sym typeface="Poppins"/>
+                          <a:latin typeface="Arial"/>
+                          <a:ea typeface="Arial"/>
+                          <a:cs typeface="Arial"/>
+                          <a:sym typeface="Arial"/>
                         </a:rPr>
                         <a:t>72</a:t>
                       </a:r>
@@ -25602,10 +25602,10 @@
                           <a:solidFill>
                             <a:srgbClr val="434343"/>
                           </a:solidFill>
-                          <a:latin typeface="Poppins"/>
-                          <a:ea typeface="Poppins"/>
-                          <a:cs typeface="Poppins"/>
-                          <a:sym typeface="Poppins"/>
+                          <a:latin typeface="Arial"/>
+                          <a:ea typeface="Arial"/>
+                          <a:cs typeface="Arial"/>
+                          <a:sym typeface="Arial"/>
                         </a:rPr>
                         <a:t>Cumulative</a:t>
                       </a:r>
@@ -25637,10 +25637,10 @@
                           <a:solidFill>
                             <a:srgbClr val="707070"/>
                           </a:solidFill>
-                          <a:latin typeface="Poppins"/>
-                          <a:ea typeface="Poppins"/>
-                          <a:cs typeface="Poppins"/>
-                          <a:sym typeface="Poppins"/>
+                          <a:latin typeface="Arial"/>
+                          <a:ea typeface="Arial"/>
+                          <a:cs typeface="Arial"/>
+                          <a:sym typeface="Arial"/>
                         </a:rPr>
                         <a:t>(11)</a:t>
                       </a:r>
@@ -25672,10 +25672,10 @@
                           <a:solidFill>
                             <a:srgbClr val="707070"/>
                           </a:solidFill>
-                          <a:latin typeface="Poppins"/>
-                          <a:ea typeface="Poppins"/>
-                          <a:cs typeface="Poppins"/>
-                          <a:sym typeface="Poppins"/>
+                          <a:latin typeface="Arial"/>
+                          <a:ea typeface="Arial"/>
+                          <a:cs typeface="Arial"/>
+                          <a:sym typeface="Arial"/>
                         </a:rPr>
                         <a:t>(21)</a:t>
                       </a:r>
@@ -25707,10 +25707,10 @@
                           <a:solidFill>
                             <a:srgbClr val="707070"/>
                           </a:solidFill>
-                          <a:latin typeface="Poppins"/>
-                          <a:ea typeface="Poppins"/>
-                          <a:cs typeface="Poppins"/>
-                          <a:sym typeface="Poppins"/>
+                          <a:latin typeface="Arial"/>
+                          <a:ea typeface="Arial"/>
+                          <a:cs typeface="Arial"/>
+                          <a:sym typeface="Arial"/>
                         </a:rPr>
                         <a:t>(32)</a:t>
                       </a:r>
@@ -25742,10 +25742,10 @@
                           <a:solidFill>
                             <a:srgbClr val="707070"/>
                           </a:solidFill>
-                          <a:latin typeface="Poppins"/>
-                          <a:ea typeface="Poppins"/>
-                          <a:cs typeface="Poppins"/>
-                          <a:sym typeface="Poppins"/>
+                          <a:latin typeface="Arial"/>
+                          <a:ea typeface="Arial"/>
+                          <a:cs typeface="Arial"/>
+                          <a:sym typeface="Arial"/>
                         </a:rPr>
                         <a:t>(43)</a:t>
                       </a:r>
@@ -25777,10 +25777,10 @@
                           <a:solidFill>
                             <a:srgbClr val="707070"/>
                           </a:solidFill>
-                          <a:latin typeface="Poppins"/>
-                          <a:ea typeface="Poppins"/>
-                          <a:cs typeface="Poppins"/>
-                          <a:sym typeface="Poppins"/>
+                          <a:latin typeface="Arial"/>
+                          <a:ea typeface="Arial"/>
+                          <a:cs typeface="Arial"/>
+                          <a:sym typeface="Arial"/>
                         </a:rPr>
                         <a:t>(51)</a:t>
                       </a:r>
@@ -25812,10 +25812,10 @@
                           <a:solidFill>
                             <a:srgbClr val="707070"/>
                           </a:solidFill>
-                          <a:latin typeface="Poppins"/>
-                          <a:ea typeface="Poppins"/>
-                          <a:cs typeface="Poppins"/>
-                          <a:sym typeface="Poppins"/>
+                          <a:latin typeface="Arial"/>
+                          <a:ea typeface="Arial"/>
+                          <a:cs typeface="Arial"/>
+                          <a:sym typeface="Arial"/>
                         </a:rPr>
                         <a:t>(60)</a:t>
                       </a:r>
@@ -25847,10 +25847,10 @@
                           <a:solidFill>
                             <a:srgbClr val="707070"/>
                           </a:solidFill>
-                          <a:latin typeface="Poppins"/>
-                          <a:ea typeface="Poppins"/>
-                          <a:cs typeface="Poppins"/>
-                          <a:sym typeface="Poppins"/>
+                          <a:latin typeface="Arial"/>
+                          <a:ea typeface="Arial"/>
+                          <a:cs typeface="Arial"/>
+                          <a:sym typeface="Arial"/>
                         </a:rPr>
                         <a:t>(67)</a:t>
                       </a:r>
@@ -25882,10 +25882,10 @@
                           <a:solidFill>
                             <a:srgbClr val="707070"/>
                           </a:solidFill>
-                          <a:latin typeface="Poppins"/>
-                          <a:ea typeface="Poppins"/>
-                          <a:cs typeface="Poppins"/>
-                          <a:sym typeface="Poppins"/>
+                          <a:latin typeface="Arial"/>
+                          <a:ea typeface="Arial"/>
+                          <a:cs typeface="Arial"/>
+                          <a:sym typeface="Arial"/>
                         </a:rPr>
                         <a:t>(74)</a:t>
                       </a:r>
@@ -25917,10 +25917,10 @@
                           <a:solidFill>
                             <a:srgbClr val="707070"/>
                           </a:solidFill>
-                          <a:latin typeface="Poppins"/>
-                          <a:ea typeface="Poppins"/>
-                          <a:cs typeface="Poppins"/>
-                          <a:sym typeface="Poppins"/>
+                          <a:latin typeface="Arial"/>
+                          <a:ea typeface="Arial"/>
+                          <a:cs typeface="Arial"/>
+                          <a:sym typeface="Arial"/>
                         </a:rPr>
                         <a:t>(141)</a:t>
                       </a:r>
@@ -25952,10 +25952,10 @@
                           <a:solidFill>
                             <a:srgbClr val="000000"/>
                           </a:solidFill>
-                          <a:latin typeface="Poppins"/>
-                          <a:ea typeface="Poppins"/>
-                          <a:cs typeface="Poppins"/>
-                          <a:sym typeface="Poppins"/>
+                          <a:latin typeface="Arial"/>
+                          <a:ea typeface="Arial"/>
+                          <a:cs typeface="Arial"/>
+                          <a:sym typeface="Arial"/>
                         </a:rPr>
                         <a:t>(192)</a:t>
                       </a:r>
@@ -25987,10 +25987,10 @@
                           <a:solidFill>
                             <a:srgbClr val="707070"/>
                           </a:solidFill>
-                          <a:latin typeface="Poppins"/>
-                          <a:ea typeface="Poppins"/>
-                          <a:cs typeface="Poppins"/>
-                          <a:sym typeface="Poppins"/>
+                          <a:latin typeface="Arial"/>
+                          <a:ea typeface="Arial"/>
+                          <a:cs typeface="Arial"/>
+                          <a:sym typeface="Arial"/>
                         </a:rPr>
                         <a:t>(120)</a:t>
                       </a:r>
@@ -26108,10 +26108,10 @@
                 <a:solidFill>
                   <a:srgbClr val="6F6B34"/>
                 </a:solidFill>
-                <a:latin typeface="Poppins"/>
-                <a:ea typeface="Poppins"/>
-                <a:cs typeface="Poppins"/>
-                <a:sym typeface="Poppins"/>
+                <a:latin typeface="Arial"/>
+                <a:ea typeface="Arial"/>
+                <a:cs typeface="Arial"/>
+                <a:sym typeface="Arial"/>
               </a:rPr>
               <a:t>What happens</a:t>
             </a:r>
@@ -26161,10 +26161,10 @@
                 <a:solidFill>
                   <a:srgbClr val="434343"/>
                 </a:solidFill>
-                <a:latin typeface="Poppins"/>
-                <a:ea typeface="Poppins"/>
-                <a:cs typeface="Poppins"/>
-                <a:sym typeface="Poppins"/>
+                <a:latin typeface="Arial"/>
+                <a:ea typeface="Arial"/>
+                <a:cs typeface="Arial"/>
+                <a:sym typeface="Arial"/>
               </a:rPr>
               <a:t>Build the app</a:t>
             </a:r>
@@ -26214,10 +26214,10 @@
                 <a:solidFill>
                   <a:srgbClr val="434343"/>
                 </a:solidFill>
-                <a:latin typeface="Poppins"/>
-                <a:ea typeface="Poppins"/>
-                <a:cs typeface="Poppins"/>
-                <a:sym typeface="Poppins"/>
+                <a:latin typeface="Arial"/>
+                <a:ea typeface="Arial"/>
+                <a:cs typeface="Arial"/>
+                <a:sym typeface="Arial"/>
               </a:rPr>
               <a:t>Launch in Boston</a:t>
             </a:r>
@@ -26267,10 +26267,10 @@
                 <a:solidFill>
                   <a:srgbClr val="434343"/>
                 </a:solidFill>
-                <a:latin typeface="Poppins"/>
-                <a:ea typeface="Poppins"/>
-                <a:cs typeface="Poppins"/>
-                <a:sym typeface="Poppins"/>
+                <a:latin typeface="Arial"/>
+                <a:ea typeface="Arial"/>
+                <a:cs typeface="Arial"/>
+                <a:sym typeface="Arial"/>
               </a:rPr>
               <a:t>Grow by referral</a:t>
             </a:r>
@@ -26320,10 +26320,10 @@
                 <a:solidFill>
                   <a:srgbClr val="434343"/>
                 </a:solidFill>
-                <a:latin typeface="Poppins"/>
-                <a:ea typeface="Poppins"/>
-                <a:cs typeface="Poppins"/>
-                <a:sym typeface="Poppins"/>
+                <a:latin typeface="Arial"/>
+                <a:ea typeface="Arial"/>
+                <a:cs typeface="Arial"/>
+                <a:sym typeface="Arial"/>
               </a:rPr>
               <a:t>12K users</a:t>
             </a:r>
@@ -26373,10 +26373,10 @@
                 <a:solidFill>
                   <a:srgbClr val="434343"/>
                 </a:solidFill>
-                <a:latin typeface="Poppins"/>
-                <a:ea typeface="Poppins"/>
-                <a:cs typeface="Poppins"/>
-                <a:sym typeface="Poppins"/>
+                <a:latin typeface="Arial"/>
+                <a:ea typeface="Arial"/>
+                <a:cs typeface="Arial"/>
+                <a:sym typeface="Arial"/>
               </a:rPr>
               <a:t>First revenue</a:t>
             </a:r>
@@ -26426,10 +26426,10 @@
                 <a:solidFill>
                   <a:srgbClr val="434343"/>
                 </a:solidFill>
-                <a:latin typeface="Poppins"/>
-                <a:ea typeface="Poppins"/>
-                <a:cs typeface="Poppins"/>
-                <a:sym typeface="Poppins"/>
+                <a:latin typeface="Arial"/>
+                <a:ea typeface="Arial"/>
+                <a:cs typeface="Arial"/>
+                <a:sym typeface="Arial"/>
               </a:rPr>
               <a:t>More restaurants</a:t>
             </a:r>
@@ -26479,10 +26479,10 @@
                 <a:solidFill>
                   <a:srgbClr val="434343"/>
                 </a:solidFill>
-                <a:latin typeface="Poppins"/>
-                <a:ea typeface="Poppins"/>
-                <a:cs typeface="Poppins"/>
-                <a:sym typeface="Poppins"/>
+                <a:latin typeface="Arial"/>
+                <a:ea typeface="Arial"/>
+                <a:cs typeface="Arial"/>
+                <a:sym typeface="Arial"/>
               </a:rPr>
               <a:t>Pitch chains</a:t>
             </a:r>
@@ -26532,10 +26532,10 @@
                 <a:solidFill>
                   <a:srgbClr val="434343"/>
                 </a:solidFill>
-                <a:latin typeface="Poppins"/>
-                <a:ea typeface="Poppins"/>
-                <a:cs typeface="Poppins"/>
-                <a:sym typeface="Poppins"/>
+                <a:latin typeface="Arial"/>
+                <a:ea typeface="Arial"/>
+                <a:cs typeface="Arial"/>
+                <a:sym typeface="Arial"/>
               </a:rPr>
               <a:t>Hire co-op</a:t>
             </a:r>
@@ -26585,10 +26585,10 @@
                 <a:solidFill>
                   <a:srgbClr val="434343"/>
                 </a:solidFill>
-                <a:latin typeface="Poppins"/>
-                <a:ea typeface="Poppins"/>
-                <a:cs typeface="Poppins"/>
-                <a:sym typeface="Poppins"/>
+                <a:latin typeface="Arial"/>
+                <a:ea typeface="Arial"/>
+                <a:cs typeface="Arial"/>
+                <a:sym typeface="Arial"/>
               </a:rPr>
               <a:t>Co-op students: 1, 2 and 3 in Years 3 to 5.</a:t>
             </a:r>
@@ -26638,10 +26638,10 @@
                 <a:solidFill>
                   <a:srgbClr val="434343"/>
                 </a:solidFill>
-                <a:latin typeface="Poppins"/>
-                <a:ea typeface="Poppins"/>
-                <a:cs typeface="Poppins"/>
-                <a:sym typeface="Poppins"/>
+                <a:latin typeface="Arial"/>
+                <a:ea typeface="Arial"/>
+                <a:cs typeface="Arial"/>
+                <a:sym typeface="Arial"/>
               </a:rPr>
               <a:t>Highlighted: first revenue, the $192K low, and first profit. That low plus a 25% cushion sets the $240K total. Each quarter of Years 1 and 2: $7,500 developer, $1,500 marketing, $1,500 legal and insurance, plus hosting. Nobody else is paid until the angel round funds Year 3.</a:t>
             </a:r>

</xml_diff>